<commit_message>
Fix deck table cells that made PowerPoint offer repair
pptxgenjs does not recognise valign "mid" and emitted anchor="mid" on the
slide-4 table cells, which is invalid OOXML. Use "middle" (anchor="ctr")
and rebuild the deck.

Co-Authored-By: Claude Opus 5.5 <noreply@anthropic.com>
</commit_message>
<xml_diff>
--- a/design/atm-deck.pptx
+++ b/design/atm-deck.pptx
@@ -3410,7 +3410,7 @@
                       </a:endParaRPr>
                     </a:p>
                   </a:txBody>
-                  <a:tcPr marL="91440" marR="91440" marT="91440" marB="91440" anchor="mid">
+                  <a:tcPr marL="91440" marR="91440" marT="91440" marB="91440" anchor="ctr">
                     <a:lnL w="9525" cap="flat" cmpd="sng" algn="ctr">
                       <a:solidFill>
                         <a:srgbClr val="333333"/>
@@ -3478,7 +3478,7 @@
                       </a:endParaRPr>
                     </a:p>
                   </a:txBody>
-                  <a:tcPr marL="91440" marR="91440" marT="91440" marB="91440" anchor="mid">
+                  <a:tcPr marL="91440" marR="91440" marT="91440" marB="91440" anchor="ctr">
                     <a:lnL w="9525" cap="flat" cmpd="sng" algn="ctr">
                       <a:solidFill>
                         <a:srgbClr val="333333"/>
@@ -3548,7 +3548,7 @@
                       </a:endParaRPr>
                     </a:p>
                   </a:txBody>
-                  <a:tcPr marL="91440" marR="91440" marT="91440" marB="91440" anchor="mid">
+                  <a:tcPr marL="91440" marR="91440" marT="91440" marB="91440" anchor="ctr">
                     <a:lnL w="9525" cap="flat" cmpd="sng" algn="ctr">
                       <a:solidFill>
                         <a:srgbClr val="333333"/>
@@ -3616,7 +3616,7 @@
                       </a:endParaRPr>
                     </a:p>
                   </a:txBody>
-                  <a:tcPr marL="91440" marR="91440" marT="91440" marB="91440" anchor="mid">
+                  <a:tcPr marL="91440" marR="91440" marT="91440" marB="91440" anchor="ctr">
                     <a:lnL w="9525" cap="flat" cmpd="sng" algn="ctr">
                       <a:solidFill>
                         <a:srgbClr val="333333"/>
@@ -3686,7 +3686,7 @@
                       </a:endParaRPr>
                     </a:p>
                   </a:txBody>
-                  <a:tcPr marL="91440" marR="91440" marT="91440" marB="91440" anchor="mid">
+                  <a:tcPr marL="91440" marR="91440" marT="91440" marB="91440" anchor="ctr">
                     <a:lnL w="9525" cap="flat" cmpd="sng" algn="ctr">
                       <a:solidFill>
                         <a:srgbClr val="333333"/>
@@ -3754,7 +3754,7 @@
                       </a:endParaRPr>
                     </a:p>
                   </a:txBody>
-                  <a:tcPr marL="91440" marR="91440" marT="91440" marB="91440" anchor="mid">
+                  <a:tcPr marL="91440" marR="91440" marT="91440" marB="91440" anchor="ctr">
                     <a:lnL w="9525" cap="flat" cmpd="sng" algn="ctr">
                       <a:solidFill>
                         <a:srgbClr val="333333"/>
@@ -3824,7 +3824,7 @@
                       </a:endParaRPr>
                     </a:p>
                   </a:txBody>
-                  <a:tcPr marL="91440" marR="91440" marT="91440" marB="91440" anchor="mid">
+                  <a:tcPr marL="91440" marR="91440" marT="91440" marB="91440" anchor="ctr">
                     <a:lnL w="9525" cap="flat" cmpd="sng" algn="ctr">
                       <a:solidFill>
                         <a:srgbClr val="333333"/>
@@ -3892,7 +3892,7 @@
                       </a:endParaRPr>
                     </a:p>
                   </a:txBody>
-                  <a:tcPr marL="91440" marR="91440" marT="91440" marB="91440" anchor="mid">
+                  <a:tcPr marL="91440" marR="91440" marT="91440" marB="91440" anchor="ctr">
                     <a:lnL w="9525" cap="flat" cmpd="sng" algn="ctr">
                       <a:solidFill>
                         <a:srgbClr val="333333"/>
@@ -3962,7 +3962,7 @@
                       </a:endParaRPr>
                     </a:p>
                   </a:txBody>
-                  <a:tcPr marL="91440" marR="91440" marT="91440" marB="91440" anchor="mid">
+                  <a:tcPr marL="91440" marR="91440" marT="91440" marB="91440" anchor="ctr">
                     <a:lnL w="9525" cap="flat" cmpd="sng" algn="ctr">
                       <a:solidFill>
                         <a:srgbClr val="333333"/>
@@ -4030,7 +4030,7 @@
                       </a:endParaRPr>
                     </a:p>
                   </a:txBody>
-                  <a:tcPr marL="91440" marR="91440" marT="91440" marB="91440" anchor="mid">
+                  <a:tcPr marL="91440" marR="91440" marT="91440" marB="91440" anchor="ctr">
                     <a:lnL w="9525" cap="flat" cmpd="sng" algn="ctr">
                       <a:solidFill>
                         <a:srgbClr val="333333"/>

</xml_diff>

<commit_message>
Rework deck to six slides and relabel money decision as 2-decimal USD
Replace the framing and architecture slides with a technology-stack slide,
fix accent roles (green primary, orange secondary, blue tertiary), drop
slide footers, split speaker notes into paragraphs with ADR links, and
fit the notes page to US Letter. The decisions ledger now reads
"2-decimal USD" with the cost "Single-currency support".

Co-Authored-By: Claude Sonnet 5 <noreply@anthropic.com>
</commit_message>
<xml_diff>
--- a/design/atm-deck.pptx
+++ b/design/atm-deck.pptx
@@ -11,13 +11,12 @@
     <p:sldId id="259" r:id="rId5"/>
     <p:sldId id="260" r:id="rId6"/>
     <p:sldId id="261" r:id="rId7"/>
-    <p:sldId id="262" r:id="rId8"/>
   </p:sldIdLst>
   <p:notesMasterIdLst>
-    <p:notesMasterId r:id="rId9"/>
+    <p:notesMasterId r:id="rId8"/>
   </p:notesMasterIdLst>
   <p:sldSz cx="9144000" cy="5143500"/>
-  <p:notesSz cx="5143500" cy="9144000"/>
+  <p:notesSz cx="7772400" cy="10058400"/>
   <p:defaultTextStyle>
     <a:lvl1pPr marL="0" algn="l" defTabSz="914400" rtl="0" eaLnBrk="1" latinLnBrk="0" hangingPunct="1">
       <a:defRPr sz="1800" kern="1200">
@@ -147,8 +146,8 @@
         </p:nvSpPr>
         <p:spPr>
           <a:xfrm>
-            <a:off x="0" y="0"/>
-            <a:ext cx="2971800" cy="458788"/>
+            <a:off x="457200" y="228600"/>
+            <a:ext cx="3429000" cy="458788"/>
           </a:xfrm>
           <a:prstGeom prst="rect">
             <a:avLst/>
@@ -178,8 +177,8 @@
         </p:nvSpPr>
         <p:spPr>
           <a:xfrm>
-            <a:off x="3884613" y="0"/>
-            <a:ext cx="2971800" cy="458788"/>
+            <a:off x="3886200" y="228600"/>
+            <a:ext cx="3429000" cy="458788"/>
           </a:xfrm>
           <a:prstGeom prst="rect">
             <a:avLst/>
@@ -213,8 +212,8 @@
         </p:nvSpPr>
         <p:spPr>
           <a:xfrm>
-            <a:off x="685800" y="1143000"/>
-            <a:ext cx="5486400" cy="3086100"/>
+            <a:off x="457200" y="685800"/>
+            <a:ext cx="6858000" cy="3857625"/>
           </a:xfrm>
           <a:prstGeom prst="rect">
             <a:avLst/>
@@ -246,8 +245,8 @@
         </p:nvSpPr>
         <p:spPr>
           <a:xfrm>
-            <a:off x="685800" y="4400550"/>
-            <a:ext cx="5486400" cy="3600450"/>
+            <a:off x="457200" y="4800600"/>
+            <a:ext cx="6858000" cy="4480560"/>
           </a:xfrm>
           <a:prstGeom prst="rect">
             <a:avLst/>
@@ -305,8 +304,8 @@
         </p:nvSpPr>
         <p:spPr>
           <a:xfrm>
-            <a:off x="0" y="8685213"/>
-            <a:ext cx="2971800" cy="458787"/>
+            <a:off x="457200" y="9371013"/>
+            <a:ext cx="3429000" cy="458787"/>
           </a:xfrm>
           <a:prstGeom prst="rect">
             <a:avLst/>
@@ -336,8 +335,8 @@
         </p:nvSpPr>
         <p:spPr>
           <a:xfrm>
-            <a:off x="3884613" y="8685213"/>
-            <a:ext cx="2971800" cy="458787"/>
+            <a:off x="3886200" y="9371013"/>
+            <a:ext cx="3429000" cy="458787"/>
           </a:xfrm>
           <a:prstGeom prst="rect">
             <a:avLst/>
@@ -508,7 +507,7 @@
           <a:p>
             <a:r>
               <a:rPr lang="en-US" dirty="0"/>
-              <a:t>Open with the finished product. This is the real application using a scratch SQLite database, not a mock. The intentionally narrow scope keeps the review on correctness, architectural boundaries, and evidence.</a:t>
+              <a:t>Open with the finished product, running against a scratch SQLite database. The intentionally narrow scope keeps the review on correctness, architectural boundaries, and evidence. The hint points at an opt-in easter egg: the Konami code (up, up, down, down, left, right, left, right, B, A) toggles a Matrix theme; Esc, the blue pill, or the code again exits it.</a:t>
             </a:r>
             <a:endParaRPr lang="en-US" dirty="0"/>
           </a:p>
@@ -596,7 +595,51 @@
           <a:p>
             <a:r>
               <a:rPr lang="en-US" dirty="0"/>
-              <a:t>The exercise is deliberately smaller than a retail bank. Two accounts and three operations are enough to expose the financial rules. Everything else is excluded until a real requirement earns the complexity.</a:t>
+              <a:t>No client-side framework or npm packages ship with the app.</a:t>
+            </a:r>
+            <a:endParaRPr lang="en-US" dirty="0"/>
+          </a:p>
+          <a:p>
+            <a:r>
+              <a:rPr lang="en-US" dirty="0"/>
+              <a:t>Pages are server-rendered Razor Pages with a small amount of vanilla JavaScript and one “hand-written” stylesheet.</a:t>
+            </a:r>
+            <a:endParaRPr lang="en-US" dirty="0"/>
+          </a:p>
+          <a:p>
+            <a:endParaRPr lang="en-US" dirty="0"/>
+          </a:p>
+          <a:p>
+            <a:r>
+              <a:rPr lang="en-US" dirty="0"/>
+              <a:t>The solution is a modular monolith of four projects (Domain, Application, Infrastructure, Web) with dependencies pointing inward, recorded in </a:t>
+            </a:r>
+            <a:r>
+              <a:rPr lang="en-US" dirty="0">
+                <a:hlinkClick r:id="rId3"/>
+              </a:rPr>
+              <a:t>ADR-0002</a:t>
+            </a:r>
+            <a:r>
+              <a:rPr lang="en-US" dirty="0"/>
+              <a:t>.</a:t>
+            </a:r>
+            <a:endParaRPr lang="en-US" dirty="0"/>
+          </a:p>
+          <a:p>
+            <a:r>
+              <a:rPr lang="en-US" dirty="0"/>
+              <a:t>EF Core and SQLite live only in the Infrastructure project.</a:t>
+            </a:r>
+            <a:endParaRPr lang="en-US" dirty="0"/>
+          </a:p>
+          <a:p>
+            <a:endParaRPr lang="en-US" dirty="0"/>
+          </a:p>
+          <a:p>
+            <a:r>
+              <a:rPr lang="en-US" dirty="0"/>
+              <a:t>Tests use xUnit, WebApplicationFactory for in-process HTTP, and coverlet for coverage.</a:t>
             </a:r>
             <a:endParaRPr lang="en-US" dirty="0"/>
           </a:p>
@@ -684,7 +727,142 @@
           <a:p>
             <a:r>
               <a:rPr lang="en-US" dirty="0"/>
-              <a:t>Solid arrows show dependencies pointing inward. Infrastructure implements Application ports. Web references Infrastructure only in the composition root. ADR-0002 records this modular-monolith boundary.</a:t>
+              <a:t>The </a:t>
+            </a:r>
+            <a:r>
+              <a:rPr lang="en-US" dirty="0">
+                <a:hlinkClick r:id="rId3"/>
+              </a:rPr>
+              <a:t>ADRs</a:t>
+            </a:r>
+            <a:r>
+              <a:rPr lang="en-US" dirty="0"/>
+              <a:t> explain why each choice fits the exercise.</a:t>
+            </a:r>
+            <a:endParaRPr lang="en-US" dirty="0"/>
+          </a:p>
+          <a:p>
+            <a:endParaRPr lang="en-US" dirty="0"/>
+          </a:p>
+          <a:p>
+            <a:r>
+              <a:rPr lang="en-US" dirty="0"/>
+              <a:t>Razor Pages (</a:t>
+            </a:r>
+            <a:r>
+              <a:rPr lang="en-US" dirty="0">
+                <a:hlinkClick r:id="rId4"/>
+              </a:rPr>
+              <a:t>ADR-0001</a:t>
+            </a:r>
+            <a:r>
+              <a:rPr lang="en-US" dirty="0"/>
+              <a:t>). Cost: a full page reload per action. The server renders HTML with minimal JavaScript, so the whole app is written in C# and ships as a single unit. A separate JavaScript front end (e.g., a React single-page app) would add its own npm build and a JSON API for the browser to call, because the browser would fetch data instead of receiving finished pages.</a:t>
+            </a:r>
+            <a:endParaRPr lang="en-US" dirty="0"/>
+          </a:p>
+          <a:p>
+            <a:endParaRPr lang="en-US" dirty="0"/>
+          </a:p>
+          <a:p>
+            <a:r>
+              <a:rPr lang="en-US" dirty="0"/>
+              <a:t>Modular monolith (</a:t>
+            </a:r>
+            <a:r>
+              <a:rPr lang="en-US" dirty="0">
+                <a:hlinkClick r:id="rId5"/>
+              </a:rPr>
+              <a:t>ADR-0002</a:t>
+            </a:r>
+            <a:r>
+              <a:rPr lang="en-US" dirty="0"/>
+              <a:t>). Cost: one feature spans four projects, so adding a transaction type touches Domain, Application, Infrastructure, and Web. The payoff is that business rules can be tested without the web host or the database. Microservices would add operational complexity with no payoff at this scope.</a:t>
+            </a:r>
+            <a:endParaRPr lang="en-US" dirty="0"/>
+          </a:p>
+          <a:p>
+            <a:endParaRPr lang="en-US" dirty="0"/>
+          </a:p>
+          <a:p>
+            <a:r>
+              <a:rPr lang="en-US" dirty="0"/>
+              <a:t>SQLite + EF Core (</a:t>
+            </a:r>
+            <a:r>
+              <a:rPr lang="en-US" dirty="0">
+                <a:hlinkClick r:id="rId6"/>
+              </a:rPr>
+              <a:t>ADR-0003</a:t>
+            </a:r>
+            <a:r>
+              <a:rPr lang="en-US" dirty="0"/>
+              <a:t>). Cost: single-writer ceiling.</a:t>
+            </a:r>
+            <a:endParaRPr lang="en-US" dirty="0"/>
+          </a:p>
+          <a:p>
+            <a:r>
+              <a:rPr lang="en-US" dirty="0"/>
+              <a:t>• SQLite – single-file DB with near-zero setup; balances survive restarts.</a:t>
+            </a:r>
+            <a:endParaRPr lang="en-US" dirty="0"/>
+          </a:p>
+          <a:p>
+            <a:r>
+              <a:rPr lang="en-US" dirty="0"/>
+              <a:t>• EF Core – the ORM (the .NET counterpart to Hibernate).</a:t>
+            </a:r>
+            <a:endParaRPr lang="en-US" dirty="0"/>
+          </a:p>
+          <a:p>
+            <a:r>
+              <a:rPr lang="en-US" dirty="0"/>
+              <a:t>   – Transactions: saves a transfer's debit, credit, and history rows in a single DB transaction, so they either commit or roll back as a unit.</a:t>
+            </a:r>
+            <a:endParaRPr lang="en-US" dirty="0"/>
+          </a:p>
+          <a:p>
+            <a:r>
+              <a:rPr lang="en-US" dirty="0"/>
+              <a:t>   – Optimistic concurrency: rejects a write based on an outdated balance, e.g., two tabs withdrawing against the same $1,000 and overdrawing it. Doesn't lock account rows; assumes conflicts are rare.</a:t>
+            </a:r>
+            <a:endParaRPr lang="en-US" dirty="0"/>
+          </a:p>
+          <a:p>
+            <a:r>
+              <a:rPr lang="en-US" dirty="0"/>
+              <a:t>A server database is the upgrade path if concurrent load ever matters.</a:t>
+            </a:r>
+            <a:endParaRPr lang="en-US" dirty="0"/>
+          </a:p>
+          <a:p>
+            <a:endParaRPr lang="en-US" dirty="0"/>
+          </a:p>
+          <a:p>
+            <a:r>
+              <a:rPr lang="en-US" dirty="0"/>
+              <a:t>2-decimal USD (</a:t>
+            </a:r>
+            <a:r>
+              <a:rPr lang="en-US" dirty="0">
+                <a:hlinkClick r:id="rId7"/>
+              </a:rPr>
+              <a:t>ADR-0005</a:t>
+            </a:r>
+            <a:r>
+              <a:rPr lang="en-US" dirty="0"/>
+              <a:t>). Cost: single-currency support. Amounts are decimal with at most two fractional digits, which rules out floating-point error. The two-digit rule fits USD only, and there is no currency field, so supporting another currency (e.g., JPY with 0 places or KWD with 3) would change the Money type.</a:t>
+            </a:r>
+            <a:endParaRPr lang="en-US" dirty="0"/>
+          </a:p>
+          <a:p>
+            <a:endParaRPr lang="en-US" dirty="0"/>
+          </a:p>
+          <a:p>
+            <a:r>
+              <a:rPr lang="en-US" dirty="0"/>
+              <a:t>Single user (SPEC). Cost: no user isolation. The spec defines one local user, so there is no login, session, or per-user data. Authentication is on the roadmap after idempotency and auditing.</a:t>
             </a:r>
             <a:endParaRPr lang="en-US" dirty="0"/>
           </a:p>
@@ -772,7 +950,7 @@
           <a:p>
             <a:r>
               <a:rPr lang="en-US" dirty="0"/>
-              <a:t>The ADRs explain why each choice fits the exercise. This slide keeps the tradeoff visible: every simplification accepts a constraint. The common choice is the smallest architecture that keeps rules and boundaries legible.</a:t>
+              <a:t>The screenshot is a real rejected overdraft. The typed value stays visible, the error names the available balance, and persisted state is unchanged. Account versions turn stale writes into a safe retry instead of lost data.</a:t>
             </a:r>
             <a:endParaRPr lang="en-US" dirty="0"/>
           </a:p>
@@ -860,7 +1038,7 @@
           <a:p>
             <a:r>
               <a:rPr lang="en-US" dirty="0"/>
-              <a:t>The screenshot is a real rejected overdraft. The typed value stays visible, the error names the available balance, and persisted state is unchanged. Account versions turn stale writes into a safe retry instead of lost data.</a:t>
+              <a:t>Domain tests are pure. Application tests use hand-written fakes. Integration and HTTP tests exercise the real host with an isolated SQLite file per test, including concurrency conflicts, atomic rollback, Post/Redirect/Get, security, and accessibility structure. Commands: dotnet restore Atm.sln; dotnet build Atm.sln --no-restore; dotnet test Atm.sln --no-build.</a:t>
             </a:r>
             <a:endParaRPr lang="en-US" dirty="0"/>
           </a:p>
@@ -948,7 +1126,17 @@
           <a:p>
             <a:r>
               <a:rPr lang="en-US" dirty="0"/>
-              <a:t>Domain tests are pure. Application tests use hand-written fakes. Integration and HTTP tests exercise the real host with an isolated SQLite file per test, including concurrency conflicts, atomic rollback, Post/Redirect/Get, security, and accessibility structure. Commands: dotnet restore Atm.sln; dotnet build Atm.sln --no-restore; dotnet test Atm.sln --no-build.</a:t>
+              <a:t>The omissions are conscious. The roadmap begins with the correctness gap that Post/Redirect/Get does not solve: a retried network request. The phone capture proves the existing presentation adapter already reflows at 380 pixels.</a:t>
+            </a:r>
+            <a:endParaRPr lang="en-US" dirty="0"/>
+          </a:p>
+          <a:p>
+            <a:endParaRPr lang="en-US" dirty="0"/>
+          </a:p>
+          <a:p>
+            <a:r>
+              <a:rPr lang="en-US" dirty="0"/>
+              <a:t>In a real bank, the Domain and Application layers would become a backend service behind an API that every channel (ATM, mobile, web, branch) shares, so the rules live in one place. This ATM would be one thin client. Splitting that backend into microservices becomes worthwhile once separate teams own accounts, transfers, and fraud and need to deploy independently. The inward dependencies here are what make that extraction straightforward.</a:t>
             </a:r>
             <a:endParaRPr lang="en-US" dirty="0"/>
           </a:p>
@@ -972,94 +1160,6 @@
             <a:fld id="{F7021451-1387-4CA6-816F-3879F97B5CBC}" type="slidenum">
               <a:rPr lang="en-US"/>
               <a:t>6</a:t>
-            </a:fld>
-            <a:endParaRPr lang="en-US"/>
-          </a:p>
-        </p:txBody>
-      </p:sp>
-    </p:spTree>
-    <p:extLst>
-      <p:ext uri="{BB962C8B-B14F-4D97-AF65-F5344CB8AC3E}">
-        <p14:creationId xmlns:p14="http://schemas.microsoft.com/office/powerpoint/2010/main" val="1024086991"/>
-      </p:ext>
-    </p:extLst>
-  </p:cSld>
-  <p:clrMapOvr>
-    <a:masterClrMapping/>
-  </p:clrMapOvr>
-</p:notes>
-</file>
-
-<file path=ppt/notesSlides/notesSlide7.xml><?xml version="1.0" encoding="utf-8"?>
-<p:notes xmlns:a="http://schemas.openxmlformats.org/drawingml/2006/main" xmlns:r="http://schemas.openxmlformats.org/officeDocument/2006/relationships" xmlns:p="http://schemas.openxmlformats.org/presentationml/2006/main">
-  <p:cSld>
-    <p:spTree>
-      <p:nvGrpSpPr>
-        <p:cNvPr id="1" name=""/>
-        <p:cNvGrpSpPr/>
-        <p:nvPr/>
-      </p:nvGrpSpPr>
-      <p:grpSpPr>
-        <a:xfrm>
-          <a:off x="0" y="0"/>
-          <a:ext cx="0" cy="0"/>
-          <a:chOff x="0" y="0"/>
-          <a:chExt cx="0" cy="0"/>
-        </a:xfrm>
-      </p:grpSpPr>
-      <p:sp>
-        <p:nvSpPr>
-          <p:cNvPr id="2" name="Slide Image Placeholder 1"/>
-          <p:cNvSpPr>
-            <a:spLocks noGrp="1" noRot="1" noChangeAspect="1"/>
-          </p:cNvSpPr>
-          <p:nvPr>
-            <p:ph type="sldImg"/>
-          </p:nvPr>
-        </p:nvSpPr>
-        <p:spPr/>
-      </p:sp>
-      <p:sp>
-        <p:nvSpPr>
-          <p:cNvPr id="3" name="Notes Placeholder 2"/>
-          <p:cNvSpPr>
-            <a:spLocks noGrp="1"/>
-          </p:cNvSpPr>
-          <p:nvPr>
-            <p:ph type="body" idx="1"/>
-          </p:nvPr>
-        </p:nvSpPr>
-        <p:spPr/>
-        <p:txBody>
-          <a:bodyPr/>
-          <a:lstStyle/>
-          <a:p>
-            <a:r>
-              <a:rPr lang="en-US" dirty="0"/>
-              <a:t>The omissions are conscious. The roadmap begins with the correctness gap that Post/Redirect/Get does not solve: a retried network request. The phone capture proves the existing presentation adapter already reflows at 380 pixels.</a:t>
-            </a:r>
-            <a:endParaRPr lang="en-US" dirty="0"/>
-          </a:p>
-        </p:txBody>
-      </p:sp>
-      <p:sp>
-        <p:nvSpPr>
-          <p:cNvPr id="4" name="Slide Number Placeholder 3"/>
-          <p:cNvSpPr>
-            <a:spLocks noGrp="1"/>
-          </p:cNvSpPr>
-          <p:nvPr>
-            <p:ph type="sldNum" sz="quarter" idx="10"/>
-          </p:nvPr>
-        </p:nvSpPr>
-        <p:spPr/>
-        <p:txBody>
-          <a:bodyPr/>
-          <a:lstStyle/>
-          <a:p>
-            <a:fld id="{F7021451-1387-4CA6-816F-3879F97B5CBC}" type="slidenum">
-              <a:rPr lang="en-US"/>
-              <a:t>7</a:t>
             </a:fld>
             <a:endParaRPr lang="en-US"/>
           </a:p>
@@ -1539,64 +1639,6 @@
         <p:spPr>
           <a:xfrm>
             <a:off x="585216" y="2267712"/>
-            <a:ext cx="2926080" cy="932688"/>
-          </a:xfrm>
-          <a:prstGeom prst="rect">
-            <a:avLst/>
-          </a:prstGeom>
-          <a:noFill/>
-          <a:ln/>
-        </p:spPr>
-        <p:txBody>
-          <a:bodyPr wrap="square" lIns="0" tIns="0" rIns="0" bIns="0" rtlCol="0" anchor="t">
-            <a:normAutofit/>
-          </a:bodyPr>
-          <a:lstStyle/>
-          <a:p>
-            <a:pPr indent="0" marL="0">
-              <a:buNone/>
-            </a:pPr>
-            <a:r>
-              <a:rPr lang="en-US" sz="2400" b="1" dirty="0">
-                <a:solidFill>
-                  <a:srgbClr val="F5F5F5"/>
-                </a:solidFill>
-                <a:latin typeface="Avenir Next" pitchFamily="34" charset="0"/>
-                <a:ea typeface="Avenir Next" pitchFamily="34" charset="-122"/>
-                <a:cs typeface="Avenir Next" pitchFamily="34" charset="-120"/>
-              </a:rPr>
-              <a:t>Financial correctness,</a:t>
-            </a:r>
-            <a:endParaRPr lang="en-US" sz="2400" dirty="0"/>
-          </a:p>
-          <a:p>
-            <a:pPr indent="0" marL="0">
-              <a:buNone/>
-            </a:pPr>
-            <a:r>
-              <a:rPr lang="en-US" sz="2400" b="1" dirty="0">
-                <a:solidFill>
-                  <a:srgbClr val="F5F5F5"/>
-                </a:solidFill>
-                <a:latin typeface="Avenir Next" pitchFamily="34" charset="0"/>
-                <a:ea typeface="Avenir Next" pitchFamily="34" charset="-122"/>
-                <a:cs typeface="Avenir Next" pitchFamily="34" charset="-120"/>
-              </a:rPr>
-              <a:t>made inspectable.</a:t>
-            </a:r>
-            <a:endParaRPr lang="en-US" sz="2400" dirty="0"/>
-          </a:p>
-        </p:txBody>
-      </p:sp>
-      <p:sp>
-        <p:nvSpPr>
-          <p:cNvPr id="6" name="Text 4"/>
-          <p:cNvSpPr txBox="1"/>
-          <p:nvPr/>
-        </p:nvSpPr>
-        <p:spPr>
-          <a:xfrm>
-            <a:off x="585216" y="3493008"/>
             <a:ext cx="2907792" cy="566928"/>
           </a:xfrm>
           <a:prstGeom prst="rect">
@@ -1646,7 +1688,7 @@
       </p:sp>
       <p:sp>
         <p:nvSpPr>
-          <p:cNvPr id="7" name="Shape 5"/>
+          <p:cNvPr id="6" name="Shape 4"/>
           <p:cNvSpPr/>
           <p:nvPr/>
         </p:nvSpPr>
@@ -1671,7 +1713,7 @@
       </p:sp>
       <p:pic>
         <p:nvPicPr>
-          <p:cNvPr id="8" name="Image 0" descr="/Users/john/theborg/repos/atm/design/screenshots/dashboard.png">    </p:cNvPr>
+          <p:cNvPr id="7" name="Image 0" descr="/Users/john/theborg/repos/atm/design/screenshots/dashboard.png">    </p:cNvPr>
           <p:cNvPicPr>
             <a:picLocks noChangeAspect="1"/>
           </p:cNvPicPr>
@@ -1695,7 +1737,7 @@
       </p:pic>
       <p:sp>
         <p:nvSpPr>
-          <p:cNvPr id="9" name="Text 6"/>
+          <p:cNvPr id="8" name="Text 5"/>
           <p:cNvSpPr txBox="1"/>
           <p:nvPr/>
         </p:nvSpPr>
@@ -1726,71 +1768,9 @@
                 <a:ea typeface="Avenir Next" pitchFamily="34" charset="-122"/>
                 <a:cs typeface="Avenir Next" pitchFamily="34" charset="-120"/>
               </a:rPr>
-              <a:t>Real application. Real transactions.</a:t>
+              <a:t>Hint: try the Konami code.</a:t>
             </a:r>
             <a:endParaRPr lang="en-US" sz="1150" dirty="0"/>
-          </a:p>
-        </p:txBody>
-      </p:sp>
-      <p:sp>
-        <p:nvSpPr>
-          <p:cNvPr id="10" name="Shape 7"/>
-          <p:cNvSpPr/>
-          <p:nvPr/>
-        </p:nvSpPr>
-        <p:spPr>
-          <a:xfrm>
-            <a:off x="585216" y="4745736"/>
-            <a:ext cx="7973568" cy="0"/>
-          </a:xfrm>
-          <a:prstGeom prst="line">
-            <a:avLst/>
-          </a:prstGeom>
-          <a:noFill/>
-          <a:ln w="9525">
-            <a:solidFill>
-              <a:srgbClr val="333333"/>
-            </a:solidFill>
-            <a:prstDash val="solid"/>
-          </a:ln>
-        </p:spPr>
-      </p:sp>
-      <p:sp>
-        <p:nvSpPr>
-          <p:cNvPr id="11" name="Text 8"/>
-          <p:cNvSpPr txBox="1"/>
-          <p:nvPr/>
-        </p:nvSpPr>
-        <p:spPr>
-          <a:xfrm>
-            <a:off x="8156448" y="4791456"/>
-            <a:ext cx="402336" cy="164592"/>
-          </a:xfrm>
-          <a:prstGeom prst="rect">
-            <a:avLst/>
-          </a:prstGeom>
-          <a:noFill/>
-          <a:ln/>
-        </p:spPr>
-        <p:txBody>
-          <a:bodyPr wrap="square" lIns="0" tIns="0" rIns="0" bIns="0" rtlCol="0" anchor="t"/>
-          <a:lstStyle/>
-          <a:p>
-            <a:pPr algn="r" indent="0" marL="0">
-              <a:buNone/>
-            </a:pPr>
-            <a:r>
-              <a:rPr lang="en-US" sz="1000" dirty="0">
-                <a:solidFill>
-                  <a:srgbClr val="A9ADB3"/>
-                </a:solidFill>
-                <a:latin typeface="Avenir Next" pitchFamily="34" charset="0"/>
-                <a:ea typeface="Avenir Next" pitchFamily="34" charset="-122"/>
-                <a:cs typeface="Avenir Next" pitchFamily="34" charset="-120"/>
-              </a:rPr>
-              <a:t>01</a:t>
-            </a:r>
-            <a:endParaRPr lang="en-US" sz="1000" dirty="0"/>
           </a:p>
         </p:txBody>
       </p:sp>
@@ -1841,11 +1821,11 @@
             <a:avLst/>
           </a:prstGeom>
           <a:solidFill>
-            <a:srgbClr val="F67F00"/>
+            <a:srgbClr val="00F604"/>
           </a:solidFill>
           <a:ln w="12700">
             <a:solidFill>
-              <a:srgbClr val="F67F00">
+              <a:srgbClr val="00F604">
                 <a:alpha val="0"/>
               </a:srgbClr>
             </a:solidFill>
@@ -1888,7 +1868,7 @@
                 <a:ea typeface="Avenir Next" pitchFamily="34" charset="-122"/>
                 <a:cs typeface="Avenir Next" pitchFamily="34" charset="-120"/>
               </a:rPr>
-              <a:t>Problem framing</a:t>
+              <a:t>Technology stack</a:t>
             </a:r>
             <a:endParaRPr lang="en-US" sz="3200" dirty="0"/>
           </a:p>
@@ -1896,37 +1876,14 @@
       </p:sp>
       <p:sp>
         <p:nvSpPr>
-          <p:cNvPr id="4" name="Shape 2"/>
-          <p:cNvSpPr/>
-          <p:nvPr/>
-        </p:nvSpPr>
-        <p:spPr>
-          <a:xfrm>
-            <a:off x="585216" y="4745736"/>
-            <a:ext cx="7973568" cy="0"/>
-          </a:xfrm>
-          <a:prstGeom prst="line">
-            <a:avLst/>
-          </a:prstGeom>
-          <a:noFill/>
-          <a:ln w="9525">
-            <a:solidFill>
-              <a:srgbClr val="333333"/>
-            </a:solidFill>
-            <a:prstDash val="solid"/>
-          </a:ln>
-        </p:spPr>
-      </p:sp>
-      <p:sp>
-        <p:nvSpPr>
-          <p:cNvPr id="5" name="Text 3"/>
+          <p:cNvPr id="5" name="Text 2"/>
           <p:cNvSpPr txBox="1"/>
           <p:nvPr/>
         </p:nvSpPr>
         <p:spPr>
           <a:xfrm>
-            <a:off x="8156448" y="4791456"/>
-            <a:ext cx="402336" cy="164592"/>
+            <a:off x="585216" y="1316736"/>
+            <a:ext cx="1737360" cy="228600"/>
           </a:xfrm>
           <a:prstGeom prst="rect">
             <a:avLst/>
@@ -1935,265 +1892,39 @@
           <a:ln/>
         </p:spPr>
         <p:txBody>
-          <a:bodyPr wrap="square" lIns="0" tIns="0" rIns="0" bIns="0" rtlCol="0" anchor="t"/>
-          <a:lstStyle/>
-          <a:p>
-            <a:pPr algn="r" indent="0" marL="0">
+          <a:bodyPr wrap="square" lIns="0" tIns="0" rIns="0" bIns="0" rtlCol="0" anchor="t">
+            <a:normAutofit/>
+          </a:bodyPr>
+          <a:lstStyle/>
+          <a:p>
+            <a:pPr indent="0" marL="0">
               <a:buNone/>
             </a:pPr>
             <a:r>
-              <a:rPr lang="en-US" sz="1000" dirty="0">
+              <a:rPr lang="en-US" sz="1100" b="1" spc="160" kern="0" dirty="0">
                 <a:solidFill>
-                  <a:srgbClr val="A9ADB3"/>
+                  <a:srgbClr val="00F604"/>
                 </a:solidFill>
                 <a:latin typeface="Avenir Next" pitchFamily="34" charset="0"/>
                 <a:ea typeface="Avenir Next" pitchFamily="34" charset="-122"/>
                 <a:cs typeface="Avenir Next" pitchFamily="34" charset="-120"/>
               </a:rPr>
-              <a:t>02</a:t>
-            </a:r>
-            <a:endParaRPr lang="en-US" sz="1000" dirty="0"/>
-          </a:p>
-        </p:txBody>
-      </p:sp>
-      <p:sp>
-        <p:nvSpPr>
-          <p:cNvPr id="7" name="Text 4"/>
+              <a:t>FRONTEND</a:t>
+            </a:r>
+            <a:endParaRPr lang="en-US" sz="1100" dirty="0"/>
+          </a:p>
+        </p:txBody>
+      </p:sp>
+      <p:sp>
+        <p:nvSpPr>
+          <p:cNvPr id="6" name="Text 3"/>
           <p:cNvSpPr txBox="1"/>
           <p:nvPr/>
         </p:nvSpPr>
         <p:spPr>
           <a:xfrm>
-            <a:off x="585216" y="1225296"/>
-            <a:ext cx="3429000" cy="228600"/>
-          </a:xfrm>
-          <a:prstGeom prst="rect">
-            <a:avLst/>
-          </a:prstGeom>
-          <a:noFill/>
-          <a:ln/>
-        </p:spPr>
-        <p:txBody>
-          <a:bodyPr wrap="square" lIns="0" tIns="0" rIns="0" bIns="0" rtlCol="0" anchor="t">
-            <a:normAutofit/>
-          </a:bodyPr>
-          <a:lstStyle/>
-          <a:p>
-            <a:pPr indent="0" marL="0">
-              <a:buNone/>
-            </a:pPr>
-            <a:r>
-              <a:rPr lang="en-US" sz="1100" b="1" spc="160" kern="0" dirty="0">
-                <a:solidFill>
-                  <a:srgbClr val="F67F00"/>
-                </a:solidFill>
-                <a:latin typeface="Avenir Next" pitchFamily="34" charset="0"/>
-                <a:ea typeface="Avenir Next" pitchFamily="34" charset="-122"/>
-                <a:cs typeface="Avenir Next" pitchFamily="34" charset="-120"/>
-              </a:rPr>
-              <a:t>GOALS</a:t>
-            </a:r>
-            <a:endParaRPr lang="en-US" sz="1100" dirty="0"/>
-          </a:p>
-        </p:txBody>
-      </p:sp>
-      <p:sp>
-        <p:nvSpPr>
-          <p:cNvPr id="8" name="Text 5"/>
-          <p:cNvSpPr txBox="1"/>
-          <p:nvPr/>
-        </p:nvSpPr>
-        <p:spPr>
-          <a:xfrm>
-            <a:off x="4645152" y="1225296"/>
-            <a:ext cx="3429000" cy="228600"/>
-          </a:xfrm>
-          <a:prstGeom prst="rect">
-            <a:avLst/>
-          </a:prstGeom>
-          <a:noFill/>
-          <a:ln/>
-        </p:spPr>
-        <p:txBody>
-          <a:bodyPr wrap="square" lIns="0" tIns="0" rIns="0" bIns="0" rtlCol="0" anchor="t">
-            <a:normAutofit/>
-          </a:bodyPr>
-          <a:lstStyle/>
-          <a:p>
-            <a:pPr indent="0" marL="0">
-              <a:buNone/>
-            </a:pPr>
-            <a:r>
-              <a:rPr lang="en-US" sz="1100" b="1" spc="160" kern="0" dirty="0">
-                <a:solidFill>
-                  <a:srgbClr val="F67F00"/>
-                </a:solidFill>
-                <a:latin typeface="Avenir Next" pitchFamily="34" charset="0"/>
-                <a:ea typeface="Avenir Next" pitchFamily="34" charset="-122"/>
-                <a:cs typeface="Avenir Next" pitchFamily="34" charset="-120"/>
-              </a:rPr>
-              <a:t>BOUNDARIES</a:t>
-            </a:r>
-            <a:endParaRPr lang="en-US" sz="1100" dirty="0"/>
-          </a:p>
-        </p:txBody>
-      </p:sp>
-      <p:sp>
-        <p:nvSpPr>
-          <p:cNvPr id="9" name="Shape 6"/>
-          <p:cNvSpPr/>
-          <p:nvPr/>
-        </p:nvSpPr>
-        <p:spPr>
-          <a:xfrm>
-            <a:off x="4315968" y="1197864"/>
-            <a:ext cx="0" cy="2560320"/>
-          </a:xfrm>
-          <a:prstGeom prst="line">
-            <a:avLst/>
-          </a:prstGeom>
-          <a:noFill/>
-          <a:ln w="12700">
-            <a:solidFill>
-              <a:srgbClr val="333333"/>
-            </a:solidFill>
-            <a:prstDash val="solid"/>
-          </a:ln>
-        </p:spPr>
-      </p:sp>
-      <p:sp>
-        <p:nvSpPr>
-          <p:cNvPr id="10" name="Text 7"/>
-          <p:cNvSpPr txBox="1"/>
-          <p:nvPr/>
-        </p:nvSpPr>
-        <p:spPr>
-          <a:xfrm>
-            <a:off x="585216" y="1764792"/>
-            <a:ext cx="3493008" cy="329184"/>
-          </a:xfrm>
-          <a:prstGeom prst="rect">
-            <a:avLst/>
-          </a:prstGeom>
-          <a:noFill/>
-          <a:ln/>
-        </p:spPr>
-        <p:txBody>
-          <a:bodyPr wrap="square" lIns="0" tIns="0" rIns="0" bIns="0" rtlCol="0" anchor="t">
-            <a:normAutofit/>
-          </a:bodyPr>
-          <a:lstStyle/>
-          <a:p>
-            <a:pPr indent="0" marL="0">
-              <a:buNone/>
-            </a:pPr>
-            <a:r>
-              <a:rPr lang="en-US" sz="1850" b="1" dirty="0">
-                <a:solidFill>
-                  <a:srgbClr val="F5F5F5"/>
-                </a:solidFill>
-                <a:latin typeface="Avenir Next" pitchFamily="34" charset="0"/>
-                <a:ea typeface="Avenir Next" pitchFamily="34" charset="-122"/>
-                <a:cs typeface="Avenir Next" pitchFamily="34" charset="-120"/>
-              </a:rPr>
-              <a:t>Two persistent accounts</a:t>
-            </a:r>
-            <a:endParaRPr lang="en-US" sz="1850" dirty="0"/>
-          </a:p>
-        </p:txBody>
-      </p:sp>
-      <p:sp>
-        <p:nvSpPr>
-          <p:cNvPr id="11" name="Text 8"/>
-          <p:cNvSpPr txBox="1"/>
-          <p:nvPr/>
-        </p:nvSpPr>
-        <p:spPr>
-          <a:xfrm>
-            <a:off x="585216" y="2404872"/>
-            <a:ext cx="3493008" cy="329184"/>
-          </a:xfrm>
-          <a:prstGeom prst="rect">
-            <a:avLst/>
-          </a:prstGeom>
-          <a:noFill/>
-          <a:ln/>
-        </p:spPr>
-        <p:txBody>
-          <a:bodyPr wrap="square" lIns="0" tIns="0" rIns="0" bIns="0" rtlCol="0" anchor="t">
-            <a:normAutofit/>
-          </a:bodyPr>
-          <a:lstStyle/>
-          <a:p>
-            <a:pPr indent="0" marL="0">
-              <a:buNone/>
-            </a:pPr>
-            <a:r>
-              <a:rPr lang="en-US" sz="1850" b="1" dirty="0">
-                <a:solidFill>
-                  <a:srgbClr val="F5F5F5"/>
-                </a:solidFill>
-                <a:latin typeface="Avenir Next" pitchFamily="34" charset="0"/>
-                <a:ea typeface="Avenir Next" pitchFamily="34" charset="-122"/>
-                <a:cs typeface="Avenir Next" pitchFamily="34" charset="-120"/>
-              </a:rPr>
-              <a:t>Deposit, withdraw, transfer</a:t>
-            </a:r>
-            <a:endParaRPr lang="en-US" sz="1850" dirty="0"/>
-          </a:p>
-        </p:txBody>
-      </p:sp>
-      <p:sp>
-        <p:nvSpPr>
-          <p:cNvPr id="12" name="Text 9"/>
-          <p:cNvSpPr txBox="1"/>
-          <p:nvPr/>
-        </p:nvSpPr>
-        <p:spPr>
-          <a:xfrm>
-            <a:off x="585216" y="3044952"/>
-            <a:ext cx="3493008" cy="329184"/>
-          </a:xfrm>
-          <a:prstGeom prst="rect">
-            <a:avLst/>
-          </a:prstGeom>
-          <a:noFill/>
-          <a:ln/>
-        </p:spPr>
-        <p:txBody>
-          <a:bodyPr wrap="square" lIns="0" tIns="0" rIns="0" bIns="0" rtlCol="0" anchor="t">
-            <a:normAutofit/>
-          </a:bodyPr>
-          <a:lstStyle/>
-          <a:p>
-            <a:pPr indent="0" marL="0">
-              <a:buNone/>
-            </a:pPr>
-            <a:r>
-              <a:rPr lang="en-US" sz="1850" b="1" dirty="0">
-                <a:solidFill>
-                  <a:srgbClr val="F5F5F5"/>
-                </a:solidFill>
-                <a:latin typeface="Avenir Next" pitchFamily="34" charset="0"/>
-                <a:ea typeface="Avenir Next" pitchFamily="34" charset="-122"/>
-                <a:cs typeface="Avenir Next" pitchFamily="34" charset="-120"/>
-              </a:rPr>
-              <a:t>Explain every balance</a:t>
-            </a:r>
-            <a:endParaRPr lang="en-US" sz="1850" dirty="0"/>
-          </a:p>
-        </p:txBody>
-      </p:sp>
-      <p:sp>
-        <p:nvSpPr>
-          <p:cNvPr id="13" name="Text 10"/>
-          <p:cNvSpPr txBox="1"/>
-          <p:nvPr/>
-        </p:nvSpPr>
-        <p:spPr>
-          <a:xfrm>
-            <a:off x="4645152" y="1764792"/>
-            <a:ext cx="3694176" cy="438912"/>
+            <a:off x="2468880" y="1261872"/>
+            <a:ext cx="6089904" cy="329184"/>
           </a:xfrm>
           <a:prstGeom prst="rect">
             <a:avLst/>
@@ -2219,7 +1950,7 @@
                 <a:ea typeface="Avenir Next" pitchFamily="34" charset="-122"/>
                 <a:cs typeface="Avenir Next" pitchFamily="34" charset="-120"/>
               </a:rPr>
-              <a:t>One local user</a:t>
+              <a:t>Razor Pages, vanilla JavaScript, CSS</a:t>
             </a:r>
             <a:endParaRPr lang="en-US" sz="2000" dirty="0"/>
           </a:p>
@@ -2227,14 +1958,119 @@
       </p:sp>
       <p:sp>
         <p:nvSpPr>
-          <p:cNvPr id="14" name="Text 11"/>
+          <p:cNvPr id="7" name="Text 4"/>
           <p:cNvSpPr txBox="1"/>
           <p:nvPr/>
         </p:nvSpPr>
         <p:spPr>
           <a:xfrm>
-            <a:off x="4645152" y="2624328"/>
-            <a:ext cx="3694176" cy="438912"/>
+            <a:off x="2468880" y="1609344"/>
+            <a:ext cx="6089904" cy="219456"/>
+          </a:xfrm>
+          <a:prstGeom prst="rect">
+            <a:avLst/>
+          </a:prstGeom>
+          <a:noFill/>
+          <a:ln/>
+        </p:spPr>
+        <p:txBody>
+          <a:bodyPr wrap="square" lIns="0" tIns="0" rIns="0" bIns="0" rtlCol="0" anchor="t">
+            <a:normAutofit/>
+          </a:bodyPr>
+          <a:lstStyle/>
+          <a:p>
+            <a:pPr indent="0" marL="0">
+              <a:buNone/>
+            </a:pPr>
+            <a:r>
+              <a:rPr lang="en-US" sz="1250" dirty="0">
+                <a:solidFill>
+                  <a:srgbClr val="A9ADB3"/>
+                </a:solidFill>
+                <a:latin typeface="Avenir Next" pitchFamily="34" charset="0"/>
+                <a:ea typeface="Avenir Next" pitchFamily="34" charset="-122"/>
+                <a:cs typeface="Avenir Next" pitchFamily="34" charset="-120"/>
+              </a:rPr>
+              <a:t>No client framework or packages</a:t>
+            </a:r>
+            <a:endParaRPr lang="en-US" sz="1250" dirty="0"/>
+          </a:p>
+        </p:txBody>
+      </p:sp>
+      <p:sp>
+        <p:nvSpPr>
+          <p:cNvPr id="8" name="Shape 5"/>
+          <p:cNvSpPr/>
+          <p:nvPr/>
+        </p:nvSpPr>
+        <p:spPr>
+          <a:xfrm>
+            <a:off x="585216" y="1993392"/>
+            <a:ext cx="7973568" cy="0"/>
+          </a:xfrm>
+          <a:prstGeom prst="line">
+            <a:avLst/>
+          </a:prstGeom>
+          <a:noFill/>
+          <a:ln w="9525">
+            <a:solidFill>
+              <a:srgbClr val="333333"/>
+            </a:solidFill>
+            <a:prstDash val="solid"/>
+          </a:ln>
+        </p:spPr>
+      </p:sp>
+      <p:sp>
+        <p:nvSpPr>
+          <p:cNvPr id="9" name="Text 6"/>
+          <p:cNvSpPr txBox="1"/>
+          <p:nvPr/>
+        </p:nvSpPr>
+        <p:spPr>
+          <a:xfrm>
+            <a:off x="585216" y="2231136"/>
+            <a:ext cx="1737360" cy="228600"/>
+          </a:xfrm>
+          <a:prstGeom prst="rect">
+            <a:avLst/>
+          </a:prstGeom>
+          <a:noFill/>
+          <a:ln/>
+        </p:spPr>
+        <p:txBody>
+          <a:bodyPr wrap="square" lIns="0" tIns="0" rIns="0" bIns="0" rtlCol="0" anchor="t">
+            <a:normAutofit/>
+          </a:bodyPr>
+          <a:lstStyle/>
+          <a:p>
+            <a:pPr indent="0" marL="0">
+              <a:buNone/>
+            </a:pPr>
+            <a:r>
+              <a:rPr lang="en-US" sz="1100" b="1" spc="160" kern="0" dirty="0">
+                <a:solidFill>
+                  <a:srgbClr val="00F604"/>
+                </a:solidFill>
+                <a:latin typeface="Avenir Next" pitchFamily="34" charset="0"/>
+                <a:ea typeface="Avenir Next" pitchFamily="34" charset="-122"/>
+                <a:cs typeface="Avenir Next" pitchFamily="34" charset="-120"/>
+              </a:rPr>
+              <a:t>BACKEND</a:t>
+            </a:r>
+            <a:endParaRPr lang="en-US" sz="1100" dirty="0"/>
+          </a:p>
+        </p:txBody>
+      </p:sp>
+      <p:sp>
+        <p:nvSpPr>
+          <p:cNvPr id="10" name="Text 7"/>
+          <p:cNvSpPr txBox="1"/>
+          <p:nvPr/>
+        </p:nvSpPr>
+        <p:spPr>
+          <a:xfrm>
+            <a:off x="2468880" y="2176272"/>
+            <a:ext cx="6089904" cy="329184"/>
           </a:xfrm>
           <a:prstGeom prst="rect">
             <a:avLst/>
@@ -2260,7 +2096,7 @@
                 <a:ea typeface="Avenir Next" pitchFamily="34" charset="-122"/>
                 <a:cs typeface="Avenir Next" pitchFamily="34" charset="-120"/>
               </a:rPr>
-              <a:t>No speculative infrastructure</a:t>
+              <a:t>C# 14 on .NET 10</a:t>
             </a:r>
             <a:endParaRPr lang="en-US" sz="2000" dirty="0"/>
           </a:p>
@@ -2268,37 +2104,14 @@
       </p:sp>
       <p:sp>
         <p:nvSpPr>
-          <p:cNvPr id="15" name="Shape 12"/>
-          <p:cNvSpPr/>
-          <p:nvPr/>
-        </p:nvSpPr>
-        <p:spPr>
-          <a:xfrm>
-            <a:off x="585216" y="3913632"/>
-            <a:ext cx="7973568" cy="0"/>
-          </a:xfrm>
-          <a:prstGeom prst="line">
-            <a:avLst/>
-          </a:prstGeom>
-          <a:noFill/>
-          <a:ln w="27940">
-            <a:solidFill>
-              <a:srgbClr val="F67F00"/>
-            </a:solidFill>
-            <a:prstDash val="solid"/>
-          </a:ln>
-        </p:spPr>
-      </p:sp>
-      <p:sp>
-        <p:nvSpPr>
-          <p:cNvPr id="16" name="Text 13"/>
+          <p:cNvPr id="11" name="Text 8"/>
           <p:cNvSpPr txBox="1"/>
           <p:nvPr/>
         </p:nvSpPr>
         <p:spPr>
           <a:xfrm>
-            <a:off x="585216" y="4096512"/>
-            <a:ext cx="7973568" cy="338328"/>
+            <a:off x="2468880" y="2523744"/>
+            <a:ext cx="6089904" cy="219456"/>
           </a:xfrm>
           <a:prstGeom prst="rect">
             <a:avLst/>
@@ -2307,24 +2120,277 @@
           <a:ln/>
         </p:spPr>
         <p:txBody>
-          <a:bodyPr wrap="square" lIns="0" tIns="0" rIns="0" bIns="0" rtlCol="0" anchor="t"/>
+          <a:bodyPr wrap="square" lIns="0" tIns="0" rIns="0" bIns="0" rtlCol="0" anchor="t">
+            <a:normAutofit/>
+          </a:bodyPr>
           <a:lstStyle/>
           <a:p>
             <a:pPr indent="0" marL="0">
               <a:buNone/>
             </a:pPr>
             <a:r>
-              <a:rPr lang="en-US" sz="2400" b="1" dirty="0">
+              <a:rPr lang="en-US" sz="1250" dirty="0">
                 <a:solidFill>
-                  <a:srgbClr val="F67F00"/>
+                  <a:srgbClr val="A9ADB3"/>
                 </a:solidFill>
                 <a:latin typeface="Avenir Next" pitchFamily="34" charset="0"/>
                 <a:ea typeface="Avenir Next" pitchFamily="34" charset="-122"/>
                 <a:cs typeface="Avenir Next" pitchFamily="34" charset="-120"/>
               </a:rPr>
-              <a:t>Clarity is the quality bar.</a:t>
-            </a:r>
-            <a:endParaRPr lang="en-US" sz="2400" dirty="0"/>
+              <a:t>ASP.NET Core</a:t>
+            </a:r>
+            <a:endParaRPr lang="en-US" sz="1250" dirty="0"/>
+          </a:p>
+        </p:txBody>
+      </p:sp>
+      <p:sp>
+        <p:nvSpPr>
+          <p:cNvPr id="12" name="Shape 9"/>
+          <p:cNvSpPr/>
+          <p:nvPr/>
+        </p:nvSpPr>
+        <p:spPr>
+          <a:xfrm>
+            <a:off x="585216" y="2907792"/>
+            <a:ext cx="7973568" cy="0"/>
+          </a:xfrm>
+          <a:prstGeom prst="line">
+            <a:avLst/>
+          </a:prstGeom>
+          <a:noFill/>
+          <a:ln w="9525">
+            <a:solidFill>
+              <a:srgbClr val="333333"/>
+            </a:solidFill>
+            <a:prstDash val="solid"/>
+          </a:ln>
+        </p:spPr>
+      </p:sp>
+      <p:sp>
+        <p:nvSpPr>
+          <p:cNvPr id="13" name="Text 10"/>
+          <p:cNvSpPr txBox="1"/>
+          <p:nvPr/>
+        </p:nvSpPr>
+        <p:spPr>
+          <a:xfrm>
+            <a:off x="585216" y="3145536"/>
+            <a:ext cx="1737360" cy="228600"/>
+          </a:xfrm>
+          <a:prstGeom prst="rect">
+            <a:avLst/>
+          </a:prstGeom>
+          <a:noFill/>
+          <a:ln/>
+        </p:spPr>
+        <p:txBody>
+          <a:bodyPr wrap="square" lIns="0" tIns="0" rIns="0" bIns="0" rtlCol="0" anchor="t">
+            <a:normAutofit/>
+          </a:bodyPr>
+          <a:lstStyle/>
+          <a:p>
+            <a:pPr indent="0" marL="0">
+              <a:buNone/>
+            </a:pPr>
+            <a:r>
+              <a:rPr lang="en-US" sz="1100" b="1" spc="160" kern="0" dirty="0">
+                <a:solidFill>
+                  <a:srgbClr val="00F604"/>
+                </a:solidFill>
+                <a:latin typeface="Avenir Next" pitchFamily="34" charset="0"/>
+                <a:ea typeface="Avenir Next" pitchFamily="34" charset="-122"/>
+                <a:cs typeface="Avenir Next" pitchFamily="34" charset="-120"/>
+              </a:rPr>
+              <a:t>DATABASE</a:t>
+            </a:r>
+            <a:endParaRPr lang="en-US" sz="1100" dirty="0"/>
+          </a:p>
+        </p:txBody>
+      </p:sp>
+      <p:sp>
+        <p:nvSpPr>
+          <p:cNvPr id="14" name="Text 11"/>
+          <p:cNvSpPr txBox="1"/>
+          <p:nvPr/>
+        </p:nvSpPr>
+        <p:spPr>
+          <a:xfrm>
+            <a:off x="2468880" y="3090672"/>
+            <a:ext cx="6089904" cy="329184"/>
+          </a:xfrm>
+          <a:prstGeom prst="rect">
+            <a:avLst/>
+          </a:prstGeom>
+          <a:noFill/>
+          <a:ln/>
+        </p:spPr>
+        <p:txBody>
+          <a:bodyPr wrap="square" lIns="0" tIns="0" rIns="0" bIns="0" rtlCol="0" anchor="t">
+            <a:normAutofit/>
+          </a:bodyPr>
+          <a:lstStyle/>
+          <a:p>
+            <a:pPr indent="0" marL="0">
+              <a:buNone/>
+            </a:pPr>
+            <a:r>
+              <a:rPr lang="en-US" sz="2000" b="1" dirty="0">
+                <a:solidFill>
+                  <a:srgbClr val="F5F5F5"/>
+                </a:solidFill>
+                <a:latin typeface="Avenir Next" pitchFamily="34" charset="0"/>
+                <a:ea typeface="Avenir Next" pitchFamily="34" charset="-122"/>
+                <a:cs typeface="Avenir Next" pitchFamily="34" charset="-120"/>
+              </a:rPr>
+              <a:t>SQLite via EF Core 10</a:t>
+            </a:r>
+            <a:endParaRPr lang="en-US" sz="2000" dirty="0"/>
+          </a:p>
+        </p:txBody>
+      </p:sp>
+      <p:sp>
+        <p:nvSpPr>
+          <p:cNvPr id="15" name="Text 12"/>
+          <p:cNvSpPr txBox="1"/>
+          <p:nvPr/>
+        </p:nvSpPr>
+        <p:spPr>
+          <a:xfrm>
+            <a:off x="2468880" y="3438144"/>
+            <a:ext cx="6089904" cy="219456"/>
+          </a:xfrm>
+          <a:prstGeom prst="rect">
+            <a:avLst/>
+          </a:prstGeom>
+          <a:noFill/>
+          <a:ln/>
+        </p:spPr>
+        <p:txBody>
+          <a:bodyPr wrap="square" lIns="0" tIns="0" rIns="0" bIns="0" rtlCol="0" anchor="t">
+            <a:normAutofit/>
+          </a:bodyPr>
+          <a:lstStyle/>
+          <a:p>
+            <a:pPr indent="0" marL="0">
+              <a:buNone/>
+            </a:pPr>
+            <a:r>
+              <a:rPr lang="en-US" sz="1250" dirty="0">
+                <a:solidFill>
+                  <a:srgbClr val="A9ADB3"/>
+                </a:solidFill>
+                <a:latin typeface="Avenir Next" pitchFamily="34" charset="0"/>
+                <a:ea typeface="Avenir Next" pitchFamily="34" charset="-122"/>
+                <a:cs typeface="Avenir Next" pitchFamily="34" charset="-120"/>
+              </a:rPr>
+              <a:t>Code-first migrations</a:t>
+            </a:r>
+            <a:endParaRPr lang="en-US" sz="1250" dirty="0"/>
+          </a:p>
+        </p:txBody>
+      </p:sp>
+      <p:sp>
+        <p:nvSpPr>
+          <p:cNvPr id="16" name="Shape 13"/>
+          <p:cNvSpPr/>
+          <p:nvPr/>
+        </p:nvSpPr>
+        <p:spPr>
+          <a:xfrm>
+            <a:off x="585216" y="3822192"/>
+            <a:ext cx="7973568" cy="0"/>
+          </a:xfrm>
+          <a:prstGeom prst="line">
+            <a:avLst/>
+          </a:prstGeom>
+          <a:noFill/>
+          <a:ln w="9525">
+            <a:solidFill>
+              <a:srgbClr val="333333"/>
+            </a:solidFill>
+            <a:prstDash val="solid"/>
+          </a:ln>
+        </p:spPr>
+      </p:sp>
+      <p:sp>
+        <p:nvSpPr>
+          <p:cNvPr id="17" name="Text 14"/>
+          <p:cNvSpPr txBox="1"/>
+          <p:nvPr/>
+        </p:nvSpPr>
+        <p:spPr>
+          <a:xfrm>
+            <a:off x="585216" y="4059936"/>
+            <a:ext cx="1737360" cy="228600"/>
+          </a:xfrm>
+          <a:prstGeom prst="rect">
+            <a:avLst/>
+          </a:prstGeom>
+          <a:noFill/>
+          <a:ln/>
+        </p:spPr>
+        <p:txBody>
+          <a:bodyPr wrap="square" lIns="0" tIns="0" rIns="0" bIns="0" rtlCol="0" anchor="t">
+            <a:normAutofit/>
+          </a:bodyPr>
+          <a:lstStyle/>
+          <a:p>
+            <a:pPr indent="0" marL="0">
+              <a:buNone/>
+            </a:pPr>
+            <a:r>
+              <a:rPr lang="en-US" sz="1100" b="1" spc="160" kern="0" dirty="0">
+                <a:solidFill>
+                  <a:srgbClr val="00F604"/>
+                </a:solidFill>
+                <a:latin typeface="Avenir Next" pitchFamily="34" charset="0"/>
+                <a:ea typeface="Avenir Next" pitchFamily="34" charset="-122"/>
+                <a:cs typeface="Avenir Next" pitchFamily="34" charset="-120"/>
+              </a:rPr>
+              <a:t>TESTING</a:t>
+            </a:r>
+            <a:endParaRPr lang="en-US" sz="1100" dirty="0"/>
+          </a:p>
+        </p:txBody>
+      </p:sp>
+      <p:sp>
+        <p:nvSpPr>
+          <p:cNvPr id="18" name="Text 15"/>
+          <p:cNvSpPr txBox="1"/>
+          <p:nvPr/>
+        </p:nvSpPr>
+        <p:spPr>
+          <a:xfrm>
+            <a:off x="2468880" y="4005072"/>
+            <a:ext cx="6089904" cy="329184"/>
+          </a:xfrm>
+          <a:prstGeom prst="rect">
+            <a:avLst/>
+          </a:prstGeom>
+          <a:noFill/>
+          <a:ln/>
+        </p:spPr>
+        <p:txBody>
+          <a:bodyPr wrap="square" lIns="0" tIns="0" rIns="0" bIns="0" rtlCol="0" anchor="t">
+            <a:normAutofit/>
+          </a:bodyPr>
+          <a:lstStyle/>
+          <a:p>
+            <a:pPr indent="0" marL="0">
+              <a:buNone/>
+            </a:pPr>
+            <a:r>
+              <a:rPr lang="en-US" sz="2000" b="1" dirty="0">
+                <a:solidFill>
+                  <a:srgbClr val="F5F5F5"/>
+                </a:solidFill>
+                <a:latin typeface="Avenir Next" pitchFamily="34" charset="0"/>
+                <a:ea typeface="Avenir Next" pitchFamily="34" charset="-122"/>
+                <a:cs typeface="Avenir Next" pitchFamily="34" charset="-120"/>
+              </a:rPr>
+              <a:t>xUnit, WebApplicationFactory, coverlet</a:t>
+            </a:r>
+            <a:endParaRPr lang="en-US" sz="2000" dirty="0"/>
           </a:p>
         </p:txBody>
       </p:sp>
@@ -2375,740 +2441,11 @@
             <a:avLst/>
           </a:prstGeom>
           <a:solidFill>
-            <a:srgbClr val="0077F6"/>
+            <a:srgbClr val="00F604"/>
           </a:solidFill>
           <a:ln w="12700">
             <a:solidFill>
-              <a:srgbClr val="0077F6">
-                <a:alpha val="0"/>
-              </a:srgbClr>
-            </a:solidFill>
-            <a:prstDash val="solid"/>
-          </a:ln>
-        </p:spPr>
-      </p:sp>
-      <p:sp>
-        <p:nvSpPr>
-          <p:cNvPr id="3" name="Text 1"/>
-          <p:cNvSpPr txBox="1"/>
-          <p:nvPr/>
-        </p:nvSpPr>
-        <p:spPr>
-          <a:xfrm>
-            <a:off x="832104" y="356616"/>
-            <a:ext cx="7726680" cy="512064"/>
-          </a:xfrm>
-          <a:prstGeom prst="rect">
-            <a:avLst/>
-          </a:prstGeom>
-          <a:noFill/>
-          <a:ln/>
-        </p:spPr>
-        <p:txBody>
-          <a:bodyPr wrap="square" lIns="0" tIns="0" rIns="0" bIns="0" rtlCol="0" anchor="t">
-            <a:normAutofit/>
-          </a:bodyPr>
-          <a:lstStyle/>
-          <a:p>
-            <a:pPr indent="0" marL="0">
-              <a:buNone/>
-            </a:pPr>
-            <a:r>
-              <a:rPr lang="en-US" sz="2900" b="1" dirty="0">
-                <a:solidFill>
-                  <a:srgbClr val="F5F5F5"/>
-                </a:solidFill>
-                <a:latin typeface="Avenir Next" pitchFamily="34" charset="0"/>
-                <a:ea typeface="Avenir Next" pitchFamily="34" charset="-122"/>
-                <a:cs typeface="Avenir Next" pitchFamily="34" charset="-120"/>
-              </a:rPr>
-              <a:t>Architecture and dependency direction</a:t>
-            </a:r>
-            <a:endParaRPr lang="en-US" sz="2900" dirty="0"/>
-          </a:p>
-        </p:txBody>
-      </p:sp>
-      <p:sp>
-        <p:nvSpPr>
-          <p:cNvPr id="4" name="Shape 2"/>
-          <p:cNvSpPr/>
-          <p:nvPr/>
-        </p:nvSpPr>
-        <p:spPr>
-          <a:xfrm>
-            <a:off x="585216" y="4745736"/>
-            <a:ext cx="7973568" cy="0"/>
-          </a:xfrm>
-          <a:prstGeom prst="line">
-            <a:avLst/>
-          </a:prstGeom>
-          <a:noFill/>
-          <a:ln w="9525">
-            <a:solidFill>
-              <a:srgbClr val="333333"/>
-            </a:solidFill>
-            <a:prstDash val="solid"/>
-          </a:ln>
-        </p:spPr>
-      </p:sp>
-      <p:sp>
-        <p:nvSpPr>
-          <p:cNvPr id="5" name="Text 3"/>
-          <p:cNvSpPr txBox="1"/>
-          <p:nvPr/>
-        </p:nvSpPr>
-        <p:spPr>
-          <a:xfrm>
-            <a:off x="8156448" y="4791456"/>
-            <a:ext cx="402336" cy="164592"/>
-          </a:xfrm>
-          <a:prstGeom prst="rect">
-            <a:avLst/>
-          </a:prstGeom>
-          <a:noFill/>
-          <a:ln/>
-        </p:spPr>
-        <p:txBody>
-          <a:bodyPr wrap="square" lIns="0" tIns="0" rIns="0" bIns="0" rtlCol="0" anchor="t"/>
-          <a:lstStyle/>
-          <a:p>
-            <a:pPr algn="r" indent="0" marL="0">
-              <a:buNone/>
-            </a:pPr>
-            <a:r>
-              <a:rPr lang="en-US" sz="1000" dirty="0">
-                <a:solidFill>
-                  <a:srgbClr val="A9ADB3"/>
-                </a:solidFill>
-                <a:latin typeface="Avenir Next" pitchFamily="34" charset="0"/>
-                <a:ea typeface="Avenir Next" pitchFamily="34" charset="-122"/>
-                <a:cs typeface="Avenir Next" pitchFamily="34" charset="-120"/>
-              </a:rPr>
-              <a:t>03</a:t>
-            </a:r>
-            <a:endParaRPr lang="en-US" sz="1000" dirty="0"/>
-          </a:p>
-        </p:txBody>
-      </p:sp>
-      <p:sp>
-        <p:nvSpPr>
-          <p:cNvPr id="7" name="Shape 4"/>
-          <p:cNvSpPr/>
-          <p:nvPr/>
-        </p:nvSpPr>
-        <p:spPr>
-          <a:xfrm>
-            <a:off x="585216" y="1572768"/>
-            <a:ext cx="1280160" cy="1005840"/>
-          </a:xfrm>
-          <a:prstGeom prst="rect">
-            <a:avLst/>
-          </a:prstGeom>
-          <a:solidFill>
-            <a:srgbClr val="1B1B1B"/>
-          </a:solidFill>
-          <a:ln w="10160">
-            <a:solidFill>
-              <a:srgbClr val="333333"/>
-            </a:solidFill>
-            <a:prstDash val="solid"/>
-          </a:ln>
-        </p:spPr>
-      </p:sp>
-      <p:sp>
-        <p:nvSpPr>
-          <p:cNvPr id="8" name="Text 5"/>
-          <p:cNvSpPr txBox="1"/>
-          <p:nvPr/>
-        </p:nvSpPr>
-        <p:spPr>
-          <a:xfrm>
-            <a:off x="676656" y="1901952"/>
-            <a:ext cx="1097280" cy="274320"/>
-          </a:xfrm>
-          <a:prstGeom prst="rect">
-            <a:avLst/>
-          </a:prstGeom>
-          <a:noFill/>
-          <a:ln/>
-        </p:spPr>
-        <p:txBody>
-          <a:bodyPr wrap="square" lIns="0" tIns="0" rIns="0" bIns="0" rtlCol="0" anchor="t">
-            <a:normAutofit/>
-          </a:bodyPr>
-          <a:lstStyle/>
-          <a:p>
-            <a:pPr algn="ctr" indent="0" marL="0">
-              <a:buNone/>
-            </a:pPr>
-            <a:r>
-              <a:rPr lang="en-US" sz="1600" b="1" dirty="0">
-                <a:solidFill>
-                  <a:srgbClr val="A9ADB3"/>
-                </a:solidFill>
-                <a:latin typeface="Avenir Next" pitchFamily="34" charset="0"/>
-                <a:ea typeface="Avenir Next" pitchFamily="34" charset="-122"/>
-                <a:cs typeface="Avenir Next" pitchFamily="34" charset="-120"/>
-              </a:rPr>
-              <a:t>Browser</a:t>
-            </a:r>
-            <a:endParaRPr lang="en-US" sz="1600" dirty="0"/>
-          </a:p>
-        </p:txBody>
-      </p:sp>
-      <p:sp>
-        <p:nvSpPr>
-          <p:cNvPr id="9" name="Shape 6"/>
-          <p:cNvSpPr/>
-          <p:nvPr/>
-        </p:nvSpPr>
-        <p:spPr>
-          <a:xfrm>
-            <a:off x="2139696" y="1572768"/>
-            <a:ext cx="1426464" cy="1005840"/>
-          </a:xfrm>
-          <a:prstGeom prst="rect">
-            <a:avLst/>
-          </a:prstGeom>
-          <a:solidFill>
-            <a:srgbClr val="1B1B1B"/>
-          </a:solidFill>
-          <a:ln w="10160">
-            <a:solidFill>
-              <a:srgbClr val="333333"/>
-            </a:solidFill>
-            <a:prstDash val="solid"/>
-          </a:ln>
-        </p:spPr>
-      </p:sp>
-      <p:sp>
-        <p:nvSpPr>
-          <p:cNvPr id="10" name="Text 7"/>
-          <p:cNvSpPr txBox="1"/>
-          <p:nvPr/>
-        </p:nvSpPr>
-        <p:spPr>
-          <a:xfrm>
-            <a:off x="2231136" y="1901952"/>
-            <a:ext cx="1243584" cy="274320"/>
-          </a:xfrm>
-          <a:prstGeom prst="rect">
-            <a:avLst/>
-          </a:prstGeom>
-          <a:noFill/>
-          <a:ln/>
-        </p:spPr>
-        <p:txBody>
-          <a:bodyPr wrap="square" lIns="0" tIns="0" rIns="0" bIns="0" rtlCol="0" anchor="t">
-            <a:normAutofit/>
-          </a:bodyPr>
-          <a:lstStyle/>
-          <a:p>
-            <a:pPr algn="ctr" indent="0" marL="0">
-              <a:buNone/>
-            </a:pPr>
-            <a:r>
-              <a:rPr lang="en-US" sz="1600" b="1" dirty="0">
-                <a:solidFill>
-                  <a:srgbClr val="A9ADB3"/>
-                </a:solidFill>
-                <a:latin typeface="Avenir Next" pitchFamily="34" charset="0"/>
-                <a:ea typeface="Avenir Next" pitchFamily="34" charset="-122"/>
-                <a:cs typeface="Avenir Next" pitchFamily="34" charset="-120"/>
-              </a:rPr>
-              <a:t>Web</a:t>
-            </a:r>
-            <a:endParaRPr lang="en-US" sz="1600" dirty="0"/>
-          </a:p>
-        </p:txBody>
-      </p:sp>
-      <p:sp>
-        <p:nvSpPr>
-          <p:cNvPr id="11" name="Shape 8"/>
-          <p:cNvSpPr/>
-          <p:nvPr/>
-        </p:nvSpPr>
-        <p:spPr>
-          <a:xfrm>
-            <a:off x="3931920" y="1572768"/>
-            <a:ext cx="1627632" cy="1005840"/>
-          </a:xfrm>
-          <a:prstGeom prst="rect">
-            <a:avLst/>
-          </a:prstGeom>
-          <a:solidFill>
-            <a:srgbClr val="1B1B1B"/>
-          </a:solidFill>
-          <a:ln w="10160">
-            <a:solidFill>
-              <a:srgbClr val="333333"/>
-            </a:solidFill>
-            <a:prstDash val="solid"/>
-          </a:ln>
-        </p:spPr>
-      </p:sp>
-      <p:sp>
-        <p:nvSpPr>
-          <p:cNvPr id="12" name="Text 9"/>
-          <p:cNvSpPr txBox="1"/>
-          <p:nvPr/>
-        </p:nvSpPr>
-        <p:spPr>
-          <a:xfrm>
-            <a:off x="4023360" y="1901952"/>
-            <a:ext cx="1444752" cy="274320"/>
-          </a:xfrm>
-          <a:prstGeom prst="rect">
-            <a:avLst/>
-          </a:prstGeom>
-          <a:noFill/>
-          <a:ln/>
-        </p:spPr>
-        <p:txBody>
-          <a:bodyPr wrap="square" lIns="0" tIns="0" rIns="0" bIns="0" rtlCol="0" anchor="t">
-            <a:normAutofit/>
-          </a:bodyPr>
-          <a:lstStyle/>
-          <a:p>
-            <a:pPr algn="ctr" indent="0" marL="0">
-              <a:buNone/>
-            </a:pPr>
-            <a:r>
-              <a:rPr lang="en-US" sz="1600" b="1" dirty="0">
-                <a:solidFill>
-                  <a:srgbClr val="A9ADB3"/>
-                </a:solidFill>
-                <a:latin typeface="Avenir Next" pitchFamily="34" charset="0"/>
-                <a:ea typeface="Avenir Next" pitchFamily="34" charset="-122"/>
-                <a:cs typeface="Avenir Next" pitchFamily="34" charset="-120"/>
-              </a:rPr>
-              <a:t>Application</a:t>
-            </a:r>
-            <a:endParaRPr lang="en-US" sz="1600" dirty="0"/>
-          </a:p>
-        </p:txBody>
-      </p:sp>
-      <p:sp>
-        <p:nvSpPr>
-          <p:cNvPr id="13" name="Shape 10"/>
-          <p:cNvSpPr/>
-          <p:nvPr/>
-        </p:nvSpPr>
-        <p:spPr>
-          <a:xfrm>
-            <a:off x="5934456" y="1572768"/>
-            <a:ext cx="2624328" cy="1005840"/>
-          </a:xfrm>
-          <a:prstGeom prst="rect">
-            <a:avLst/>
-          </a:prstGeom>
-          <a:solidFill>
-            <a:srgbClr val="0077F6"/>
-          </a:solidFill>
-          <a:ln w="16510">
-            <a:solidFill>
-              <a:srgbClr val="0077F6"/>
-            </a:solidFill>
-            <a:prstDash val="solid"/>
-          </a:ln>
-        </p:spPr>
-      </p:sp>
-      <p:sp>
-        <p:nvSpPr>
-          <p:cNvPr id="14" name="Text 11"/>
-          <p:cNvSpPr txBox="1"/>
-          <p:nvPr/>
-        </p:nvSpPr>
-        <p:spPr>
-          <a:xfrm>
-            <a:off x="6025896" y="1901952"/>
-            <a:ext cx="2441448" cy="274320"/>
-          </a:xfrm>
-          <a:prstGeom prst="rect">
-            <a:avLst/>
-          </a:prstGeom>
-          <a:noFill/>
-          <a:ln/>
-        </p:spPr>
-        <p:txBody>
-          <a:bodyPr wrap="square" lIns="0" tIns="0" rIns="0" bIns="0" rtlCol="0" anchor="t">
-            <a:normAutofit/>
-          </a:bodyPr>
-          <a:lstStyle/>
-          <a:p>
-            <a:pPr algn="ctr" indent="0" marL="0">
-              <a:buNone/>
-            </a:pPr>
-            <a:r>
-              <a:rPr lang="en-US" sz="1600" b="1" dirty="0">
-                <a:solidFill>
-                  <a:srgbClr val="F5F5F5"/>
-                </a:solidFill>
-                <a:latin typeface="Avenir Next" pitchFamily="34" charset="0"/>
-                <a:ea typeface="Avenir Next" pitchFamily="34" charset="-122"/>
-                <a:cs typeface="Avenir Next" pitchFamily="34" charset="-120"/>
-              </a:rPr>
-              <a:t>Domain</a:t>
-            </a:r>
-            <a:endParaRPr lang="en-US" sz="1600" dirty="0"/>
-          </a:p>
-        </p:txBody>
-      </p:sp>
-      <p:sp>
-        <p:nvSpPr>
-          <p:cNvPr id="15" name="Shape 12"/>
-          <p:cNvSpPr/>
-          <p:nvPr/>
-        </p:nvSpPr>
-        <p:spPr>
-          <a:xfrm>
-            <a:off x="1865376" y="2075688"/>
-            <a:ext cx="274320" cy="914"/>
-          </a:xfrm>
-          <a:prstGeom prst="line">
-            <a:avLst/>
-          </a:prstGeom>
-          <a:noFill/>
-          <a:ln w="19050">
-            <a:solidFill>
-              <a:srgbClr val="0077F6"/>
-            </a:solidFill>
-            <a:prstDash val="solid"/>
-            <a:tailEnd type="triangle"/>
-          </a:ln>
-        </p:spPr>
-      </p:sp>
-      <p:sp>
-        <p:nvSpPr>
-          <p:cNvPr id="16" name="Shape 13"/>
-          <p:cNvSpPr/>
-          <p:nvPr/>
-        </p:nvSpPr>
-        <p:spPr>
-          <a:xfrm>
-            <a:off x="3566160" y="2075688"/>
-            <a:ext cx="365760" cy="914"/>
-          </a:xfrm>
-          <a:prstGeom prst="line">
-            <a:avLst/>
-          </a:prstGeom>
-          <a:noFill/>
-          <a:ln w="19050">
-            <a:solidFill>
-              <a:srgbClr val="0077F6"/>
-            </a:solidFill>
-            <a:prstDash val="solid"/>
-            <a:tailEnd type="triangle"/>
-          </a:ln>
-        </p:spPr>
-      </p:sp>
-      <p:sp>
-        <p:nvSpPr>
-          <p:cNvPr id="17" name="Shape 14"/>
-          <p:cNvSpPr/>
-          <p:nvPr/>
-        </p:nvSpPr>
-        <p:spPr>
-          <a:xfrm>
-            <a:off x="5559552" y="2075688"/>
-            <a:ext cx="374904" cy="914"/>
-          </a:xfrm>
-          <a:prstGeom prst="line">
-            <a:avLst/>
-          </a:prstGeom>
-          <a:noFill/>
-          <a:ln w="19050">
-            <a:solidFill>
-              <a:srgbClr val="0077F6"/>
-            </a:solidFill>
-            <a:prstDash val="solid"/>
-            <a:tailEnd type="triangle"/>
-          </a:ln>
-        </p:spPr>
-      </p:sp>
-      <p:sp>
-        <p:nvSpPr>
-          <p:cNvPr id="18" name="Shape 15"/>
-          <p:cNvSpPr/>
-          <p:nvPr/>
-        </p:nvSpPr>
-        <p:spPr>
-          <a:xfrm>
-            <a:off x="3931920" y="3154680"/>
-            <a:ext cx="1627632" cy="731520"/>
-          </a:xfrm>
-          <a:prstGeom prst="rect">
-            <a:avLst/>
-          </a:prstGeom>
-          <a:solidFill>
-            <a:srgbClr val="1B1B1B"/>
-          </a:solidFill>
-          <a:ln w="10160">
-            <a:solidFill>
-              <a:srgbClr val="333333"/>
-            </a:solidFill>
-            <a:prstDash val="solid"/>
-          </a:ln>
-        </p:spPr>
-      </p:sp>
-      <p:sp>
-        <p:nvSpPr>
-          <p:cNvPr id="19" name="Text 16"/>
-          <p:cNvSpPr txBox="1"/>
-          <p:nvPr/>
-        </p:nvSpPr>
-        <p:spPr>
-          <a:xfrm>
-            <a:off x="4041648" y="3383280"/>
-            <a:ext cx="1408176" cy="237744"/>
-          </a:xfrm>
-          <a:prstGeom prst="rect">
-            <a:avLst/>
-          </a:prstGeom>
-          <a:noFill/>
-          <a:ln/>
-        </p:spPr>
-        <p:txBody>
-          <a:bodyPr wrap="square" lIns="0" tIns="0" rIns="0" bIns="0" rtlCol="0" anchor="t">
-            <a:normAutofit/>
-          </a:bodyPr>
-          <a:lstStyle/>
-          <a:p>
-            <a:pPr algn="ctr" indent="0" marL="0">
-              <a:buNone/>
-            </a:pPr>
-            <a:r>
-              <a:rPr lang="en-US" sz="1400" b="1" dirty="0">
-                <a:solidFill>
-                  <a:srgbClr val="A9ADB3"/>
-                </a:solidFill>
-                <a:latin typeface="Avenir Next" pitchFamily="34" charset="0"/>
-                <a:ea typeface="Avenir Next" pitchFamily="34" charset="-122"/>
-                <a:cs typeface="Avenir Next" pitchFamily="34" charset="-120"/>
-              </a:rPr>
-              <a:t>Infrastructure</a:t>
-            </a:r>
-            <a:endParaRPr lang="en-US" sz="1400" dirty="0"/>
-          </a:p>
-        </p:txBody>
-      </p:sp>
-      <p:sp>
-        <p:nvSpPr>
-          <p:cNvPr id="20" name="Shape 17"/>
-          <p:cNvSpPr/>
-          <p:nvPr/>
-        </p:nvSpPr>
-        <p:spPr>
-          <a:xfrm flipV="1">
-            <a:off x="4745736" y="2578608"/>
-            <a:ext cx="914" cy="576072"/>
-          </a:xfrm>
-          <a:prstGeom prst="line">
-            <a:avLst/>
-          </a:prstGeom>
-          <a:noFill/>
-          <a:ln w="19050">
-            <a:solidFill>
-              <a:srgbClr val="0077F6"/>
-            </a:solidFill>
-            <a:prstDash val="solid"/>
-            <a:tailEnd type="triangle"/>
-          </a:ln>
-        </p:spPr>
-      </p:sp>
-      <p:sp>
-        <p:nvSpPr>
-          <p:cNvPr id="21" name="Text 18"/>
-          <p:cNvSpPr txBox="1"/>
-          <p:nvPr/>
-        </p:nvSpPr>
-        <p:spPr>
-          <a:xfrm>
-            <a:off x="4919472" y="2779776"/>
-            <a:ext cx="1097280" cy="182880"/>
-          </a:xfrm>
-          <a:prstGeom prst="rect">
-            <a:avLst/>
-          </a:prstGeom>
-          <a:noFill/>
-          <a:ln/>
-        </p:spPr>
-        <p:txBody>
-          <a:bodyPr wrap="square" lIns="0" tIns="0" rIns="0" bIns="0" rtlCol="0" anchor="t"/>
-          <a:lstStyle/>
-          <a:p>
-            <a:pPr indent="0" marL="0">
-              <a:buNone/>
-            </a:pPr>
-            <a:r>
-              <a:rPr lang="en-US" sz="1050" dirty="0">
-                <a:solidFill>
-                  <a:srgbClr val="A9ADB3"/>
-                </a:solidFill>
-                <a:latin typeface="Avenir Next" pitchFamily="34" charset="0"/>
-                <a:ea typeface="Avenir Next" pitchFamily="34" charset="-122"/>
-                <a:cs typeface="Avenir Next" pitchFamily="34" charset="-120"/>
-              </a:rPr>
-              <a:t>implements ports</a:t>
-            </a:r>
-            <a:endParaRPr lang="en-US" sz="1050" dirty="0"/>
-          </a:p>
-        </p:txBody>
-      </p:sp>
-      <p:sp>
-        <p:nvSpPr>
-          <p:cNvPr id="22" name="Shape 19"/>
-          <p:cNvSpPr/>
-          <p:nvPr/>
-        </p:nvSpPr>
-        <p:spPr>
-          <a:xfrm>
-            <a:off x="2871216" y="2578608"/>
-            <a:ext cx="1060704" cy="932688"/>
-          </a:xfrm>
-          <a:prstGeom prst="line">
-            <a:avLst/>
-          </a:prstGeom>
-          <a:noFill/>
-          <a:ln w="19050">
-            <a:solidFill>
-              <a:srgbClr val="A9ADB3"/>
-            </a:solidFill>
-            <a:prstDash val="dash"/>
-            <a:tailEnd type="triangle"/>
-          </a:ln>
-        </p:spPr>
-      </p:sp>
-      <p:sp>
-        <p:nvSpPr>
-          <p:cNvPr id="23" name="Text 20"/>
-          <p:cNvSpPr txBox="1"/>
-          <p:nvPr/>
-        </p:nvSpPr>
-        <p:spPr>
-          <a:xfrm>
-            <a:off x="2633472" y="3127248"/>
-            <a:ext cx="1133856" cy="182880"/>
-          </a:xfrm>
-          <a:prstGeom prst="rect">
-            <a:avLst/>
-          </a:prstGeom>
-          <a:noFill/>
-          <a:ln/>
-        </p:spPr>
-        <p:txBody>
-          <a:bodyPr wrap="square" lIns="0" tIns="0" rIns="0" bIns="0" rtlCol="0" anchor="t"/>
-          <a:lstStyle/>
-          <a:p>
-            <a:pPr indent="0" marL="0">
-              <a:buNone/>
-            </a:pPr>
-            <a:r>
-              <a:rPr lang="en-US" sz="1050" dirty="0">
-                <a:solidFill>
-                  <a:srgbClr val="A9ADB3"/>
-                </a:solidFill>
-                <a:latin typeface="Avenir Next" pitchFamily="34" charset="0"/>
-                <a:ea typeface="Avenir Next" pitchFamily="34" charset="-122"/>
-                <a:cs typeface="Avenir Next" pitchFamily="34" charset="-120"/>
-              </a:rPr>
-              <a:t>composition only</a:t>
-            </a:r>
-            <a:endParaRPr lang="en-US" sz="1050" dirty="0"/>
-          </a:p>
-        </p:txBody>
-      </p:sp>
-      <p:sp>
-        <p:nvSpPr>
-          <p:cNvPr id="24" name="Text 21"/>
-          <p:cNvSpPr txBox="1"/>
-          <p:nvPr/>
-        </p:nvSpPr>
-        <p:spPr>
-          <a:xfrm>
-            <a:off x="585216" y="4242816"/>
-            <a:ext cx="7973568" cy="283464"/>
-          </a:xfrm>
-          <a:prstGeom prst="rect">
-            <a:avLst/>
-          </a:prstGeom>
-          <a:noFill/>
-          <a:ln/>
-        </p:spPr>
-        <p:txBody>
-          <a:bodyPr wrap="square" lIns="0" tIns="0" rIns="0" bIns="0" rtlCol="0" anchor="t"/>
-          <a:lstStyle/>
-          <a:p>
-            <a:pPr algn="ctr" indent="0" marL="0">
-              <a:buNone/>
-            </a:pPr>
-            <a:r>
-              <a:rPr lang="en-US" sz="2000" b="1" dirty="0">
-                <a:solidFill>
-                  <a:srgbClr val="0077F6"/>
-                </a:solidFill>
-                <a:latin typeface="Avenir Next" pitchFamily="34" charset="0"/>
-                <a:ea typeface="Avenir Next" pitchFamily="34" charset="-122"/>
-                <a:cs typeface="Avenir Next" pitchFamily="34" charset="-120"/>
-              </a:rPr>
-              <a:t>Business rules depend on nothing external.</a:t>
-            </a:r>
-            <a:endParaRPr lang="en-US" sz="2000" dirty="0"/>
-          </a:p>
-        </p:txBody>
-      </p:sp>
-    </p:spTree>
-  </p:cSld>
-  <p:clrMapOvr>
-    <a:masterClrMapping/>
-  </p:clrMapOvr>
-</p:sld>
-</file>
-
-<file path=ppt/slides/slide4.xml><?xml version="1.0" encoding="utf-8"?>
-<p:sld xmlns:a="http://schemas.openxmlformats.org/drawingml/2006/main" xmlns:r="http://schemas.openxmlformats.org/officeDocument/2006/relationships" xmlns:p="http://schemas.openxmlformats.org/presentationml/2006/main">
-  <p:cSld name="Slide 4">
-    <p:bg>
-      <p:bgPr>
-        <a:solidFill>
-          <a:srgbClr val="121212"/>
-        </a:solidFill>
-      </p:bgPr>
-    </p:bg>
-    <p:spTree>
-      <p:nvGrpSpPr>
-        <p:cNvPr id="1" name=""/>
-        <p:cNvGrpSpPr/>
-        <p:nvPr/>
-      </p:nvGrpSpPr>
-      <p:grpSpPr>
-        <a:xfrm>
-          <a:off x="0" y="0"/>
-          <a:ext cx="0" cy="0"/>
-          <a:chOff x="0" y="0"/>
-          <a:chExt cx="0" cy="0"/>
-        </a:xfrm>
-      </p:grpSpPr>
-      <p:sp>
-        <p:nvSpPr>
-          <p:cNvPr id="2" name="Shape 0"/>
-          <p:cNvSpPr/>
-          <p:nvPr/>
-        </p:nvSpPr>
-        <p:spPr>
-          <a:xfrm>
-            <a:off x="585216" y="356616"/>
-            <a:ext cx="91440" cy="438912"/>
-          </a:xfrm>
-          <a:prstGeom prst="rect">
-            <a:avLst/>
-          </a:prstGeom>
-          <a:solidFill>
-            <a:srgbClr val="F67F00"/>
-          </a:solidFill>
-          <a:ln w="12700">
-            <a:solidFill>
-              <a:srgbClr val="F67F00">
+              <a:srgbClr val="00F604">
                 <a:alpha val="0"/>
               </a:srgbClr>
             </a:solidFill>
@@ -3157,71 +2494,9 @@
           </a:p>
         </p:txBody>
       </p:sp>
-      <p:sp>
-        <p:nvSpPr>
-          <p:cNvPr id="4" name="Shape 2"/>
-          <p:cNvSpPr/>
-          <p:nvPr/>
-        </p:nvSpPr>
-        <p:spPr>
-          <a:xfrm>
-            <a:off x="585216" y="4745736"/>
-            <a:ext cx="7973568" cy="0"/>
-          </a:xfrm>
-          <a:prstGeom prst="line">
-            <a:avLst/>
-          </a:prstGeom>
-          <a:noFill/>
-          <a:ln w="9525">
-            <a:solidFill>
-              <a:srgbClr val="333333"/>
-            </a:solidFill>
-            <a:prstDash val="solid"/>
-          </a:ln>
-        </p:spPr>
-      </p:sp>
-      <p:sp>
-        <p:nvSpPr>
-          <p:cNvPr id="5" name="Text 3"/>
-          <p:cNvSpPr txBox="1"/>
-          <p:nvPr/>
-        </p:nvSpPr>
-        <p:spPr>
-          <a:xfrm>
-            <a:off x="8156448" y="4791456"/>
-            <a:ext cx="402336" cy="164592"/>
-          </a:xfrm>
-          <a:prstGeom prst="rect">
-            <a:avLst/>
-          </a:prstGeom>
-          <a:noFill/>
-          <a:ln/>
-        </p:spPr>
-        <p:txBody>
-          <a:bodyPr wrap="square" lIns="0" tIns="0" rIns="0" bIns="0" rtlCol="0" anchor="t"/>
-          <a:lstStyle/>
-          <a:p>
-            <a:pPr algn="r" indent="0" marL="0">
-              <a:buNone/>
-            </a:pPr>
-            <a:r>
-              <a:rPr lang="en-US" sz="1000" dirty="0">
-                <a:solidFill>
-                  <a:srgbClr val="A9ADB3"/>
-                </a:solidFill>
-                <a:latin typeface="Avenir Next" pitchFamily="34" charset="0"/>
-                <a:ea typeface="Avenir Next" pitchFamily="34" charset="-122"/>
-                <a:cs typeface="Avenir Next" pitchFamily="34" charset="-120"/>
-              </a:rPr>
-              <a:t>04</a:t>
-            </a:r>
-            <a:endParaRPr lang="en-US" sz="1000" dirty="0"/>
-          </a:p>
-        </p:txBody>
-      </p:sp>
       <p:graphicFrame>
         <p:nvGraphicFramePr>
-          <p:cNvPr id="5" name="Table 0"/>
+          <p:cNvPr id="4" name="Table 0"/>
           <p:cNvGraphicFramePr>
             <a:graphicFrameLocks noGrp="1"/>
           </p:cNvGraphicFramePr>
@@ -3257,7 +2532,7 @@
                       <a:r>
                         <a:rPr lang="en-US" sz="1250" b="1" dirty="0">
                           <a:solidFill>
-                            <a:srgbClr val="F67F00"/>
+                            <a:srgbClr val="00F604"/>
                           </a:solidFill>
                           <a:latin typeface="Avenir Next" pitchFamily="34" charset="0"/>
                           <a:ea typeface="Avenir Next" pitchFamily="34" charset="-122"/>
@@ -3469,7 +2744,7 @@
                           <a:ea typeface="Avenir Next" pitchFamily="34" charset="-122"/>
                           <a:cs typeface="Avenir Next" pitchFamily="34" charset="-120"/>
                         </a:rPr>
-                        <a:t>Less client interactivity</a:t>
+                        <a:t>Full page reload per action</a:t>
                       </a:r>
                       <a:endParaRPr lang="en-US" sz="1700" dirty="0">
                         <a:latin typeface="Avenir Next" charset="0"/>
@@ -3607,7 +2882,7 @@
                           <a:ea typeface="Avenir Next" pitchFamily="34" charset="-122"/>
                           <a:cs typeface="Avenir Next" pitchFamily="34" charset="-120"/>
                         </a:rPr>
-                        <a:t>Extra project structure</a:t>
+                        <a:t>One feature spans four projects</a:t>
                       </a:r>
                       <a:endParaRPr lang="en-US" sz="1700" dirty="0">
                         <a:latin typeface="Avenir Next" charset="0"/>
@@ -3815,7 +3090,7 @@
                           <a:ea typeface="Avenir Next" pitchFamily="34" charset="-122"/>
                           <a:cs typeface="Avenir Next" pitchFamily="34" charset="-120"/>
                         </a:rPr>
-                        <a:t>decimal Money</a:t>
+                        <a:t>2-decimal USD</a:t>
                       </a:r>
                       <a:endParaRPr lang="en-US" sz="1700" dirty="0">
                         <a:latin typeface="Avenir Next" charset="0"/>
@@ -3883,7 +3158,7 @@
                           <a:ea typeface="Avenir Next" pitchFamily="34" charset="-122"/>
                           <a:cs typeface="Avenir Next" pitchFamily="34" charset="-120"/>
                         </a:rPr>
-                        <a:t>USD remains implicit</a:t>
+                        <a:t>Single-currency support</a:t>
                       </a:r>
                       <a:endParaRPr lang="en-US" sz="1700" dirty="0">
                         <a:latin typeface="Avenir Next" charset="0"/>
@@ -4085,6 +3360,436 @@
 </p:sld>
 </file>
 
+<file path=ppt/slides/slide4.xml><?xml version="1.0" encoding="utf-8"?>
+<p:sld xmlns:a="http://schemas.openxmlformats.org/drawingml/2006/main" xmlns:r="http://schemas.openxmlformats.org/officeDocument/2006/relationships" xmlns:p="http://schemas.openxmlformats.org/presentationml/2006/main">
+  <p:cSld name="Slide 4">
+    <p:bg>
+      <p:bgPr>
+        <a:solidFill>
+          <a:srgbClr val="121212"/>
+        </a:solidFill>
+      </p:bgPr>
+    </p:bg>
+    <p:spTree>
+      <p:nvGrpSpPr>
+        <p:cNvPr id="1" name=""/>
+        <p:cNvGrpSpPr/>
+        <p:nvPr/>
+      </p:nvGrpSpPr>
+      <p:grpSpPr>
+        <a:xfrm>
+          <a:off x="0" y="0"/>
+          <a:ext cx="0" cy="0"/>
+          <a:chOff x="0" y="0"/>
+          <a:chExt cx="0" cy="0"/>
+        </a:xfrm>
+      </p:grpSpPr>
+      <p:sp>
+        <p:nvSpPr>
+          <p:cNvPr id="2" name="Shape 0"/>
+          <p:cNvSpPr/>
+          <p:nvPr/>
+        </p:nvSpPr>
+        <p:spPr>
+          <a:xfrm>
+            <a:off x="585216" y="356616"/>
+            <a:ext cx="91440" cy="438912"/>
+          </a:xfrm>
+          <a:prstGeom prst="rect">
+            <a:avLst/>
+          </a:prstGeom>
+          <a:solidFill>
+            <a:srgbClr val="00F604"/>
+          </a:solidFill>
+          <a:ln w="12700">
+            <a:solidFill>
+              <a:srgbClr val="00F604">
+                <a:alpha val="0"/>
+              </a:srgbClr>
+            </a:solidFill>
+            <a:prstDash val="solid"/>
+          </a:ln>
+        </p:spPr>
+      </p:sp>
+      <p:sp>
+        <p:nvSpPr>
+          <p:cNvPr id="3" name="Text 1"/>
+          <p:cNvSpPr txBox="1"/>
+          <p:nvPr/>
+        </p:nvSpPr>
+        <p:spPr>
+          <a:xfrm>
+            <a:off x="832104" y="356616"/>
+            <a:ext cx="7726680" cy="512064"/>
+          </a:xfrm>
+          <a:prstGeom prst="rect">
+            <a:avLst/>
+          </a:prstGeom>
+          <a:noFill/>
+          <a:ln/>
+        </p:spPr>
+        <p:txBody>
+          <a:bodyPr wrap="square" lIns="0" tIns="0" rIns="0" bIns="0" rtlCol="0" anchor="t">
+            <a:normAutofit/>
+          </a:bodyPr>
+          <a:lstStyle/>
+          <a:p>
+            <a:pPr indent="0" marL="0">
+              <a:buNone/>
+            </a:pPr>
+            <a:r>
+              <a:rPr lang="en-US" sz="3200" b="1" dirty="0">
+                <a:solidFill>
+                  <a:srgbClr val="F5F5F5"/>
+                </a:solidFill>
+                <a:latin typeface="Avenir Next" pitchFamily="34" charset="0"/>
+                <a:ea typeface="Avenir Next" pitchFamily="34" charset="-122"/>
+                <a:cs typeface="Avenir Next" pitchFamily="34" charset="-120"/>
+              </a:rPr>
+              <a:t>Failure leaves no partial state</a:t>
+            </a:r>
+            <a:endParaRPr lang="en-US" sz="3200" dirty="0"/>
+          </a:p>
+        </p:txBody>
+      </p:sp>
+      <p:sp>
+        <p:nvSpPr>
+          <p:cNvPr id="5" name="Text 2"/>
+          <p:cNvSpPr txBox="1"/>
+          <p:nvPr/>
+        </p:nvSpPr>
+        <p:spPr>
+          <a:xfrm>
+            <a:off x="585216" y="1307592"/>
+            <a:ext cx="411480" cy="274320"/>
+          </a:xfrm>
+          <a:prstGeom prst="rect">
+            <a:avLst/>
+          </a:prstGeom>
+          <a:noFill/>
+          <a:ln/>
+        </p:spPr>
+        <p:txBody>
+          <a:bodyPr wrap="square" lIns="0" tIns="0" rIns="0" bIns="0" rtlCol="0" anchor="t"/>
+          <a:lstStyle/>
+          <a:p>
+            <a:pPr indent="0" marL="0">
+              <a:buNone/>
+            </a:pPr>
+            <a:r>
+              <a:rPr lang="en-US" sz="1300" b="1" dirty="0">
+                <a:solidFill>
+                  <a:srgbClr val="00F604"/>
+                </a:solidFill>
+                <a:latin typeface="Avenir Next" pitchFamily="34" charset="0"/>
+                <a:ea typeface="Avenir Next" pitchFamily="34" charset="-122"/>
+                <a:cs typeface="Avenir Next" pitchFamily="34" charset="-120"/>
+              </a:rPr>
+              <a:t>01</a:t>
+            </a:r>
+            <a:endParaRPr lang="en-US" sz="1300" dirty="0"/>
+          </a:p>
+        </p:txBody>
+      </p:sp>
+      <p:sp>
+        <p:nvSpPr>
+          <p:cNvPr id="6" name="Text 3"/>
+          <p:cNvSpPr txBox="1"/>
+          <p:nvPr/>
+        </p:nvSpPr>
+        <p:spPr>
+          <a:xfrm>
+            <a:off x="1115568" y="1261872"/>
+            <a:ext cx="2743200" cy="512064"/>
+          </a:xfrm>
+          <a:prstGeom prst="rect">
+            <a:avLst/>
+          </a:prstGeom>
+          <a:noFill/>
+          <a:ln/>
+        </p:spPr>
+        <p:txBody>
+          <a:bodyPr wrap="square" lIns="0" tIns="0" rIns="0" bIns="0" rtlCol="0" anchor="t">
+            <a:normAutofit/>
+          </a:bodyPr>
+          <a:lstStyle/>
+          <a:p>
+            <a:pPr indent="0" marL="0">
+              <a:buNone/>
+            </a:pPr>
+            <a:r>
+              <a:rPr lang="en-US" sz="2000" b="1" dirty="0">
+                <a:solidFill>
+                  <a:srgbClr val="F5F5F5"/>
+                </a:solidFill>
+                <a:latin typeface="Avenir Next" pitchFamily="34" charset="0"/>
+                <a:ea typeface="Avenir Next" pitchFamily="34" charset="-122"/>
+                <a:cs typeface="Avenir Next" pitchFamily="34" charset="-120"/>
+              </a:rPr>
+              <a:t>Validate before mutation</a:t>
+            </a:r>
+            <a:endParaRPr lang="en-US" sz="2000" dirty="0"/>
+          </a:p>
+        </p:txBody>
+      </p:sp>
+      <p:sp>
+        <p:nvSpPr>
+          <p:cNvPr id="7" name="Text 4"/>
+          <p:cNvSpPr txBox="1"/>
+          <p:nvPr/>
+        </p:nvSpPr>
+        <p:spPr>
+          <a:xfrm>
+            <a:off x="585216" y="2313432"/>
+            <a:ext cx="411480" cy="274320"/>
+          </a:xfrm>
+          <a:prstGeom prst="rect">
+            <a:avLst/>
+          </a:prstGeom>
+          <a:noFill/>
+          <a:ln/>
+        </p:spPr>
+        <p:txBody>
+          <a:bodyPr wrap="square" lIns="0" tIns="0" rIns="0" bIns="0" rtlCol="0" anchor="t"/>
+          <a:lstStyle/>
+          <a:p>
+            <a:pPr indent="0" marL="0">
+              <a:buNone/>
+            </a:pPr>
+            <a:r>
+              <a:rPr lang="en-US" sz="1300" b="1" dirty="0">
+                <a:solidFill>
+                  <a:srgbClr val="00F604"/>
+                </a:solidFill>
+                <a:latin typeface="Avenir Next" pitchFamily="34" charset="0"/>
+                <a:ea typeface="Avenir Next" pitchFamily="34" charset="-122"/>
+                <a:cs typeface="Avenir Next" pitchFamily="34" charset="-120"/>
+              </a:rPr>
+              <a:t>02</a:t>
+            </a:r>
+            <a:endParaRPr lang="en-US" sz="1300" dirty="0"/>
+          </a:p>
+        </p:txBody>
+      </p:sp>
+      <p:sp>
+        <p:nvSpPr>
+          <p:cNvPr id="8" name="Text 5"/>
+          <p:cNvSpPr txBox="1"/>
+          <p:nvPr/>
+        </p:nvSpPr>
+        <p:spPr>
+          <a:xfrm>
+            <a:off x="1115568" y="2267712"/>
+            <a:ext cx="2743200" cy="512064"/>
+          </a:xfrm>
+          <a:prstGeom prst="rect">
+            <a:avLst/>
+          </a:prstGeom>
+          <a:noFill/>
+          <a:ln/>
+        </p:spPr>
+        <p:txBody>
+          <a:bodyPr wrap="square" lIns="0" tIns="0" rIns="0" bIns="0" rtlCol="0" anchor="t">
+            <a:normAutofit/>
+          </a:bodyPr>
+          <a:lstStyle/>
+          <a:p>
+            <a:pPr indent="0" marL="0">
+              <a:buNone/>
+            </a:pPr>
+            <a:r>
+              <a:rPr lang="en-US" sz="2000" b="1" dirty="0">
+                <a:solidFill>
+                  <a:srgbClr val="F5F5F5"/>
+                </a:solidFill>
+                <a:latin typeface="Avenir Next" pitchFamily="34" charset="0"/>
+                <a:ea typeface="Avenir Next" pitchFamily="34" charset="-122"/>
+                <a:cs typeface="Avenir Next" pitchFamily="34" charset="-120"/>
+              </a:rPr>
+              <a:t>Commit balance and history together</a:t>
+            </a:r>
+            <a:endParaRPr lang="en-US" sz="2000" dirty="0"/>
+          </a:p>
+        </p:txBody>
+      </p:sp>
+      <p:sp>
+        <p:nvSpPr>
+          <p:cNvPr id="9" name="Text 6"/>
+          <p:cNvSpPr txBox="1"/>
+          <p:nvPr/>
+        </p:nvSpPr>
+        <p:spPr>
+          <a:xfrm>
+            <a:off x="585216" y="3319272"/>
+            <a:ext cx="411480" cy="274320"/>
+          </a:xfrm>
+          <a:prstGeom prst="rect">
+            <a:avLst/>
+          </a:prstGeom>
+          <a:noFill/>
+          <a:ln/>
+        </p:spPr>
+        <p:txBody>
+          <a:bodyPr wrap="square" lIns="0" tIns="0" rIns="0" bIns="0" rtlCol="0" anchor="t"/>
+          <a:lstStyle/>
+          <a:p>
+            <a:pPr indent="0" marL="0">
+              <a:buNone/>
+            </a:pPr>
+            <a:r>
+              <a:rPr lang="en-US" sz="1300" b="1" dirty="0">
+                <a:solidFill>
+                  <a:srgbClr val="00F604"/>
+                </a:solidFill>
+                <a:latin typeface="Avenir Next" pitchFamily="34" charset="0"/>
+                <a:ea typeface="Avenir Next" pitchFamily="34" charset="-122"/>
+                <a:cs typeface="Avenir Next" pitchFamily="34" charset="-120"/>
+              </a:rPr>
+              <a:t>03</a:t>
+            </a:r>
+            <a:endParaRPr lang="en-US" sz="1300" dirty="0"/>
+          </a:p>
+        </p:txBody>
+      </p:sp>
+      <p:sp>
+        <p:nvSpPr>
+          <p:cNvPr id="10" name="Text 7"/>
+          <p:cNvSpPr txBox="1"/>
+          <p:nvPr/>
+        </p:nvSpPr>
+        <p:spPr>
+          <a:xfrm>
+            <a:off x="1115568" y="3273552"/>
+            <a:ext cx="2743200" cy="512064"/>
+          </a:xfrm>
+          <a:prstGeom prst="rect">
+            <a:avLst/>
+          </a:prstGeom>
+          <a:noFill/>
+          <a:ln/>
+        </p:spPr>
+        <p:txBody>
+          <a:bodyPr wrap="square" lIns="0" tIns="0" rIns="0" bIns="0" rtlCol="0" anchor="t">
+            <a:normAutofit/>
+          </a:bodyPr>
+          <a:lstStyle/>
+          <a:p>
+            <a:pPr indent="0" marL="0">
+              <a:buNone/>
+            </a:pPr>
+            <a:r>
+              <a:rPr lang="en-US" sz="2000" b="1" dirty="0">
+                <a:solidFill>
+                  <a:srgbClr val="F5F5F5"/>
+                </a:solidFill>
+                <a:latin typeface="Avenir Next" pitchFamily="34" charset="0"/>
+                <a:ea typeface="Avenir Next" pitchFamily="34" charset="-122"/>
+                <a:cs typeface="Avenir Next" pitchFamily="34" charset="-120"/>
+              </a:rPr>
+              <a:t>Reject stale writes</a:t>
+            </a:r>
+            <a:endParaRPr lang="en-US" sz="2000" dirty="0"/>
+          </a:p>
+        </p:txBody>
+      </p:sp>
+      <p:sp>
+        <p:nvSpPr>
+          <p:cNvPr id="11" name="Shape 8"/>
+          <p:cNvSpPr/>
+          <p:nvPr/>
+        </p:nvSpPr>
+        <p:spPr>
+          <a:xfrm>
+            <a:off x="4233672" y="1133856"/>
+            <a:ext cx="4325112" cy="3282696"/>
+          </a:xfrm>
+          <a:prstGeom prst="rect">
+            <a:avLst/>
+          </a:prstGeom>
+          <a:solidFill>
+            <a:srgbClr val="1B1B1B"/>
+          </a:solidFill>
+          <a:ln w="10160">
+            <a:solidFill>
+              <a:srgbClr val="333333"/>
+            </a:solidFill>
+            <a:prstDash val="solid"/>
+          </a:ln>
+        </p:spPr>
+      </p:sp>
+      <p:pic>
+        <p:nvPicPr>
+          <p:cNvPr id="12" name="Image 0" descr="/Users/john/theborg/repos/atm/design/screenshots/overdraft.png">    </p:cNvPr>
+          <p:cNvPicPr>
+            <a:picLocks noChangeAspect="1"/>
+          </p:cNvPicPr>
+          <p:nvPr/>
+        </p:nvPicPr>
+        <p:blipFill>
+          <a:blip r:embed="rId1"/>
+          <a:stretch>
+            <a:fillRect/>
+          </a:stretch>
+        </p:blipFill>
+        <p:spPr>
+          <a:xfrm>
+            <a:off x="4270248" y="1170432"/>
+            <a:ext cx="4251960" cy="3209544"/>
+          </a:xfrm>
+          <a:prstGeom prst="rect">
+            <a:avLst/>
+          </a:prstGeom>
+        </p:spPr>
+      </p:pic>
+      <p:sp>
+        <p:nvSpPr>
+          <p:cNvPr id="13" name="Text 9"/>
+          <p:cNvSpPr txBox="1"/>
+          <p:nvPr/>
+        </p:nvSpPr>
+        <p:spPr>
+          <a:xfrm>
+            <a:off x="4233672" y="4489704"/>
+            <a:ext cx="4325112" cy="201168"/>
+          </a:xfrm>
+          <a:prstGeom prst="rect">
+            <a:avLst/>
+          </a:prstGeom>
+          <a:noFill/>
+          <a:ln/>
+        </p:spPr>
+        <p:txBody>
+          <a:bodyPr wrap="square" lIns="0" tIns="0" rIns="0" bIns="0" rtlCol="0" anchor="t">
+            <a:normAutofit/>
+          </a:bodyPr>
+          <a:lstStyle/>
+          <a:p>
+            <a:pPr algn="r" indent="0" marL="0">
+              <a:buNone/>
+            </a:pPr>
+            <a:r>
+              <a:rPr lang="en-US" sz="1150" b="1" dirty="0">
+                <a:solidFill>
+                  <a:srgbClr val="00F604"/>
+                </a:solidFill>
+                <a:latin typeface="Avenir Next" pitchFamily="34" charset="0"/>
+                <a:ea typeface="Avenir Next" pitchFamily="34" charset="-122"/>
+                <a:cs typeface="Avenir Next" pitchFamily="34" charset="-120"/>
+              </a:rPr>
+              <a:t>Rejected overdraft. Persisted state stays unchanged.</a:t>
+            </a:r>
+            <a:endParaRPr lang="en-US" sz="1150" dirty="0"/>
+          </a:p>
+        </p:txBody>
+      </p:sp>
+    </p:spTree>
+  </p:cSld>
+  <p:clrMapOvr>
+    <a:masterClrMapping/>
+  </p:clrMapOvr>
+</p:sld>
+</file>
+
 <file path=ppt/slides/slide5.xml><?xml version="1.0" encoding="utf-8"?>
 <p:sld xmlns:a="http://schemas.openxmlformats.org/drawingml/2006/main" xmlns:r="http://schemas.openxmlformats.org/officeDocument/2006/relationships" xmlns:p="http://schemas.openxmlformats.org/presentationml/2006/main">
   <p:cSld name="Slide 5">
@@ -4124,11 +3829,11 @@
             <a:avLst/>
           </a:prstGeom>
           <a:solidFill>
-            <a:srgbClr val="F67F00"/>
+            <a:srgbClr val="00F604"/>
           </a:solidFill>
           <a:ln w="12700">
             <a:solidFill>
-              <a:srgbClr val="F67F00">
+              <a:srgbClr val="00F604">
                 <a:alpha val="0"/>
               </a:srgbClr>
             </a:solidFill>
@@ -4171,7 +3876,7 @@
                 <a:ea typeface="Avenir Next" pitchFamily="34" charset="-122"/>
                 <a:cs typeface="Avenir Next" pitchFamily="34" charset="-120"/>
               </a:rPr>
-              <a:t>Failure leaves no partial state</a:t>
+              <a:t>143 tests by layer</a:t>
             </a:r>
             <a:endParaRPr lang="en-US" sz="3200" dirty="0"/>
           </a:p>
@@ -4179,37 +3884,14 @@
       </p:sp>
       <p:sp>
         <p:nvSpPr>
-          <p:cNvPr id="4" name="Shape 2"/>
-          <p:cNvSpPr/>
-          <p:nvPr/>
-        </p:nvSpPr>
-        <p:spPr>
-          <a:xfrm>
-            <a:off x="585216" y="4745736"/>
-            <a:ext cx="7973568" cy="0"/>
-          </a:xfrm>
-          <a:prstGeom prst="line">
-            <a:avLst/>
-          </a:prstGeom>
-          <a:noFill/>
-          <a:ln w="9525">
-            <a:solidFill>
-              <a:srgbClr val="333333"/>
-            </a:solidFill>
-            <a:prstDash val="solid"/>
-          </a:ln>
-        </p:spPr>
-      </p:sp>
-      <p:sp>
-        <p:nvSpPr>
-          <p:cNvPr id="5" name="Text 3"/>
+          <p:cNvPr id="5" name="Text 2"/>
           <p:cNvSpPr txBox="1"/>
           <p:nvPr/>
         </p:nvSpPr>
         <p:spPr>
           <a:xfrm>
-            <a:off x="8156448" y="4791456"/>
-            <a:ext cx="402336" cy="164592"/>
+            <a:off x="585216" y="1225296"/>
+            <a:ext cx="841248" cy="475488"/>
           </a:xfrm>
           <a:prstGeom prst="rect">
             <a:avLst/>
@@ -4221,11 +3903,93 @@
           <a:bodyPr wrap="square" lIns="0" tIns="0" rIns="0" bIns="0" rtlCol="0" anchor="t"/>
           <a:lstStyle/>
           <a:p>
-            <a:pPr algn="r" indent="0" marL="0">
+            <a:pPr indent="0" marL="0">
               <a:buNone/>
             </a:pPr>
             <a:r>
-              <a:rPr lang="en-US" sz="1000" dirty="0">
+              <a:rPr lang="en-US" sz="3400" b="1" dirty="0">
+                <a:solidFill>
+                  <a:srgbClr val="00F604"/>
+                </a:solidFill>
+                <a:latin typeface="Avenir Next" pitchFamily="34" charset="0"/>
+                <a:ea typeface="Avenir Next" pitchFamily="34" charset="-122"/>
+                <a:cs typeface="Avenir Next" pitchFamily="34" charset="-120"/>
+              </a:rPr>
+              <a:t>75</a:t>
+            </a:r>
+            <a:endParaRPr lang="en-US" sz="3400" dirty="0"/>
+          </a:p>
+        </p:txBody>
+      </p:sp>
+      <p:sp>
+        <p:nvSpPr>
+          <p:cNvPr id="6" name="Text 3"/>
+          <p:cNvSpPr txBox="1"/>
+          <p:nvPr/>
+        </p:nvSpPr>
+        <p:spPr>
+          <a:xfrm>
+            <a:off x="1508760" y="1243584"/>
+            <a:ext cx="2075688" cy="256032"/>
+          </a:xfrm>
+          <a:prstGeom prst="rect">
+            <a:avLst/>
+          </a:prstGeom>
+          <a:noFill/>
+          <a:ln/>
+        </p:spPr>
+        <p:txBody>
+          <a:bodyPr wrap="square" lIns="0" tIns="0" rIns="0" bIns="0" rtlCol="0" anchor="t">
+            <a:normAutofit/>
+          </a:bodyPr>
+          <a:lstStyle/>
+          <a:p>
+            <a:pPr indent="0" marL="0">
+              <a:buNone/>
+            </a:pPr>
+            <a:r>
+              <a:rPr lang="en-US" sz="1600" b="1" dirty="0">
+                <a:solidFill>
+                  <a:srgbClr val="F5F5F5"/>
+                </a:solidFill>
+                <a:latin typeface="Avenir Next" pitchFamily="34" charset="0"/>
+                <a:ea typeface="Avenir Next" pitchFamily="34" charset="-122"/>
+                <a:cs typeface="Avenir Next" pitchFamily="34" charset="-120"/>
+              </a:rPr>
+              <a:t>Domain</a:t>
+            </a:r>
+            <a:endParaRPr lang="en-US" sz="1600" dirty="0"/>
+          </a:p>
+        </p:txBody>
+      </p:sp>
+      <p:sp>
+        <p:nvSpPr>
+          <p:cNvPr id="7" name="Text 4"/>
+          <p:cNvSpPr txBox="1"/>
+          <p:nvPr/>
+        </p:nvSpPr>
+        <p:spPr>
+          <a:xfrm>
+            <a:off x="1508760" y="1572768"/>
+            <a:ext cx="2075688" cy="219456"/>
+          </a:xfrm>
+          <a:prstGeom prst="rect">
+            <a:avLst/>
+          </a:prstGeom>
+          <a:noFill/>
+          <a:ln/>
+        </p:spPr>
+        <p:txBody>
+          <a:bodyPr wrap="square" lIns="0" tIns="0" rIns="0" bIns="0" rtlCol="0" anchor="t">
+            <a:normAutofit/>
+          </a:bodyPr>
+          <a:lstStyle/>
+          <a:p>
+            <a:pPr indent="0" marL="0">
+              <a:buNone/>
+            </a:pPr>
+            <a:r>
+              <a:rPr lang="en-US" sz="1200" dirty="0">
                 <a:solidFill>
                   <a:srgbClr val="A9ADB3"/>
                 </a:solidFill>
@@ -4233,22 +3997,22 @@
                 <a:ea typeface="Avenir Next" pitchFamily="34" charset="-122"/>
                 <a:cs typeface="Avenir Next" pitchFamily="34" charset="-120"/>
               </a:rPr>
-              <a:t>05</a:t>
-            </a:r>
-            <a:endParaRPr lang="en-US" sz="1000" dirty="0"/>
-          </a:p>
-        </p:txBody>
-      </p:sp>
-      <p:sp>
-        <p:nvSpPr>
-          <p:cNvPr id="7" name="Text 4"/>
+              <a:t>Invariants</a:t>
+            </a:r>
+            <a:endParaRPr lang="en-US" sz="1200" dirty="0"/>
+          </a:p>
+        </p:txBody>
+      </p:sp>
+      <p:sp>
+        <p:nvSpPr>
+          <p:cNvPr id="8" name="Text 5"/>
           <p:cNvSpPr txBox="1"/>
           <p:nvPr/>
         </p:nvSpPr>
         <p:spPr>
           <a:xfrm>
-            <a:off x="585216" y="1307592"/>
-            <a:ext cx="411480" cy="274320"/>
+            <a:off x="585216" y="2203704"/>
+            <a:ext cx="841248" cy="475488"/>
           </a:xfrm>
           <a:prstGeom prst="rect">
             <a:avLst/>
@@ -4264,30 +4028,30 @@
               <a:buNone/>
             </a:pPr>
             <a:r>
-              <a:rPr lang="en-US" sz="1300" b="1" dirty="0">
+              <a:rPr lang="en-US" sz="3400" b="1" dirty="0">
                 <a:solidFill>
-                  <a:srgbClr val="F67F00"/>
+                  <a:srgbClr val="00F604"/>
                 </a:solidFill>
                 <a:latin typeface="Avenir Next" pitchFamily="34" charset="0"/>
                 <a:ea typeface="Avenir Next" pitchFamily="34" charset="-122"/>
                 <a:cs typeface="Avenir Next" pitchFamily="34" charset="-120"/>
               </a:rPr>
-              <a:t>01</a:t>
-            </a:r>
-            <a:endParaRPr lang="en-US" sz="1300" dirty="0"/>
-          </a:p>
-        </p:txBody>
-      </p:sp>
-      <p:sp>
-        <p:nvSpPr>
-          <p:cNvPr id="8" name="Text 5"/>
+              <a:t>33</a:t>
+            </a:r>
+            <a:endParaRPr lang="en-US" sz="3400" dirty="0"/>
+          </a:p>
+        </p:txBody>
+      </p:sp>
+      <p:sp>
+        <p:nvSpPr>
+          <p:cNvPr id="9" name="Text 6"/>
           <p:cNvSpPr txBox="1"/>
           <p:nvPr/>
         </p:nvSpPr>
         <p:spPr>
           <a:xfrm>
-            <a:off x="1115568" y="1261872"/>
-            <a:ext cx="2743200" cy="512064"/>
+            <a:off x="1508760" y="2221992"/>
+            <a:ext cx="2075688" cy="256032"/>
           </a:xfrm>
           <a:prstGeom prst="rect">
             <a:avLst/>
@@ -4305,7 +4069,7 @@
               <a:buNone/>
             </a:pPr>
             <a:r>
-              <a:rPr lang="en-US" sz="2000" b="1" dirty="0">
+              <a:rPr lang="en-US" sz="1600" b="1" dirty="0">
                 <a:solidFill>
                   <a:srgbClr val="F5F5F5"/>
                 </a:solidFill>
@@ -4313,22 +4077,22 @@
                 <a:ea typeface="Avenir Next" pitchFamily="34" charset="-122"/>
                 <a:cs typeface="Avenir Next" pitchFamily="34" charset="-120"/>
               </a:rPr>
-              <a:t>Validate before mutation</a:t>
-            </a:r>
-            <a:endParaRPr lang="en-US" sz="2000" dirty="0"/>
-          </a:p>
-        </p:txBody>
-      </p:sp>
-      <p:sp>
-        <p:nvSpPr>
-          <p:cNvPr id="9" name="Text 6"/>
+              <a:t>Application</a:t>
+            </a:r>
+            <a:endParaRPr lang="en-US" sz="1600" dirty="0"/>
+          </a:p>
+        </p:txBody>
+      </p:sp>
+      <p:sp>
+        <p:nvSpPr>
+          <p:cNvPr id="10" name="Text 7"/>
           <p:cNvSpPr txBox="1"/>
           <p:nvPr/>
         </p:nvSpPr>
         <p:spPr>
           <a:xfrm>
-            <a:off x="585216" y="2313432"/>
-            <a:ext cx="411480" cy="274320"/>
+            <a:off x="1508760" y="2551176"/>
+            <a:ext cx="2075688" cy="219456"/>
           </a:xfrm>
           <a:prstGeom prst="rect">
             <a:avLst/>
@@ -4337,37 +4101,78 @@
           <a:ln/>
         </p:spPr>
         <p:txBody>
-          <a:bodyPr wrap="square" lIns="0" tIns="0" rIns="0" bIns="0" rtlCol="0" anchor="t"/>
+          <a:bodyPr wrap="square" lIns="0" tIns="0" rIns="0" bIns="0" rtlCol="0" anchor="t">
+            <a:normAutofit/>
+          </a:bodyPr>
           <a:lstStyle/>
           <a:p>
             <a:pPr indent="0" marL="0">
               <a:buNone/>
             </a:pPr>
             <a:r>
-              <a:rPr lang="en-US" sz="1300" b="1" dirty="0">
+              <a:rPr lang="en-US" sz="1200" dirty="0">
                 <a:solidFill>
-                  <a:srgbClr val="F67F00"/>
+                  <a:srgbClr val="A9ADB3"/>
                 </a:solidFill>
                 <a:latin typeface="Avenir Next" pitchFamily="34" charset="0"/>
                 <a:ea typeface="Avenir Next" pitchFamily="34" charset="-122"/>
                 <a:cs typeface="Avenir Next" pitchFamily="34" charset="-120"/>
               </a:rPr>
-              <a:t>02</a:t>
-            </a:r>
-            <a:endParaRPr lang="en-US" sz="1300" dirty="0"/>
-          </a:p>
-        </p:txBody>
-      </p:sp>
-      <p:sp>
-        <p:nvSpPr>
-          <p:cNvPr id="10" name="Text 7"/>
+              <a:t>Orchestration</a:t>
+            </a:r>
+            <a:endParaRPr lang="en-US" sz="1200" dirty="0"/>
+          </a:p>
+        </p:txBody>
+      </p:sp>
+      <p:sp>
+        <p:nvSpPr>
+          <p:cNvPr id="11" name="Text 8"/>
           <p:cNvSpPr txBox="1"/>
           <p:nvPr/>
         </p:nvSpPr>
         <p:spPr>
           <a:xfrm>
-            <a:off x="1115568" y="2267712"/>
-            <a:ext cx="2743200" cy="512064"/>
+            <a:off x="585216" y="3182112"/>
+            <a:ext cx="841248" cy="475488"/>
+          </a:xfrm>
+          <a:prstGeom prst="rect">
+            <a:avLst/>
+          </a:prstGeom>
+          <a:noFill/>
+          <a:ln/>
+        </p:spPr>
+        <p:txBody>
+          <a:bodyPr wrap="square" lIns="0" tIns="0" rIns="0" bIns="0" rtlCol="0" anchor="t"/>
+          <a:lstStyle/>
+          <a:p>
+            <a:pPr indent="0" marL="0">
+              <a:buNone/>
+            </a:pPr>
+            <a:r>
+              <a:rPr lang="en-US" sz="3400" b="1" dirty="0">
+                <a:solidFill>
+                  <a:srgbClr val="00F604"/>
+                </a:solidFill>
+                <a:latin typeface="Avenir Next" pitchFamily="34" charset="0"/>
+                <a:ea typeface="Avenir Next" pitchFamily="34" charset="-122"/>
+                <a:cs typeface="Avenir Next" pitchFamily="34" charset="-120"/>
+              </a:rPr>
+              <a:t>35</a:t>
+            </a:r>
+            <a:endParaRPr lang="en-US" sz="3400" dirty="0"/>
+          </a:p>
+        </p:txBody>
+      </p:sp>
+      <p:sp>
+        <p:nvSpPr>
+          <p:cNvPr id="12" name="Text 9"/>
+          <p:cNvSpPr txBox="1"/>
+          <p:nvPr/>
+        </p:nvSpPr>
+        <p:spPr>
+          <a:xfrm>
+            <a:off x="1508760" y="3200400"/>
+            <a:ext cx="2075688" cy="256032"/>
           </a:xfrm>
           <a:prstGeom prst="rect">
             <a:avLst/>
@@ -4385,7 +4190,7 @@
               <a:buNone/>
             </a:pPr>
             <a:r>
-              <a:rPr lang="en-US" sz="2000" b="1" dirty="0">
+              <a:rPr lang="en-US" sz="1600" b="1" dirty="0">
                 <a:solidFill>
                   <a:srgbClr val="F5F5F5"/>
                 </a:solidFill>
@@ -4393,22 +4198,22 @@
                 <a:ea typeface="Avenir Next" pitchFamily="34" charset="-122"/>
                 <a:cs typeface="Avenir Next" pitchFamily="34" charset="-120"/>
               </a:rPr>
-              <a:t>Commit balance and history together</a:t>
-            </a:r>
-            <a:endParaRPr lang="en-US" sz="2000" dirty="0"/>
-          </a:p>
-        </p:txBody>
-      </p:sp>
-      <p:sp>
-        <p:nvSpPr>
-          <p:cNvPr id="11" name="Text 8"/>
+              <a:t>Integration + HTTP</a:t>
+            </a:r>
+            <a:endParaRPr lang="en-US" sz="1600" dirty="0"/>
+          </a:p>
+        </p:txBody>
+      </p:sp>
+      <p:sp>
+        <p:nvSpPr>
+          <p:cNvPr id="13" name="Text 10"/>
           <p:cNvSpPr txBox="1"/>
           <p:nvPr/>
         </p:nvSpPr>
         <p:spPr>
           <a:xfrm>
-            <a:off x="585216" y="3319272"/>
-            <a:ext cx="411480" cy="274320"/>
+            <a:off x="1508760" y="3529584"/>
+            <a:ext cx="2075688" cy="219456"/>
           </a:xfrm>
           <a:prstGeom prst="rect">
             <a:avLst/>
@@ -4417,78 +4222,39 @@
           <a:ln/>
         </p:spPr>
         <p:txBody>
-          <a:bodyPr wrap="square" lIns="0" tIns="0" rIns="0" bIns="0" rtlCol="0" anchor="t"/>
+          <a:bodyPr wrap="square" lIns="0" tIns="0" rIns="0" bIns="0" rtlCol="0" anchor="t">
+            <a:normAutofit/>
+          </a:bodyPr>
           <a:lstStyle/>
           <a:p>
             <a:pPr indent="0" marL="0">
               <a:buNone/>
             </a:pPr>
             <a:r>
-              <a:rPr lang="en-US" sz="1300" b="1" dirty="0">
+              <a:rPr lang="en-US" sz="1200" dirty="0">
                 <a:solidFill>
-                  <a:srgbClr val="F67F00"/>
+                  <a:srgbClr val="A9ADB3"/>
                 </a:solidFill>
                 <a:latin typeface="Avenir Next" pitchFamily="34" charset="0"/>
                 <a:ea typeface="Avenir Next" pitchFamily="34" charset="-122"/>
                 <a:cs typeface="Avenir Next" pitchFamily="34" charset="-120"/>
               </a:rPr>
-              <a:t>03</a:t>
-            </a:r>
-            <a:endParaRPr lang="en-US" sz="1300" dirty="0"/>
-          </a:p>
-        </p:txBody>
-      </p:sp>
-      <p:sp>
-        <p:nvSpPr>
-          <p:cNvPr id="12" name="Text 9"/>
-          <p:cNvSpPr txBox="1"/>
-          <p:nvPr/>
-        </p:nvSpPr>
-        <p:spPr>
-          <a:xfrm>
-            <a:off x="1115568" y="3273552"/>
-            <a:ext cx="2743200" cy="512064"/>
-          </a:xfrm>
-          <a:prstGeom prst="rect">
-            <a:avLst/>
-          </a:prstGeom>
-          <a:noFill/>
-          <a:ln/>
-        </p:spPr>
-        <p:txBody>
-          <a:bodyPr wrap="square" lIns="0" tIns="0" rIns="0" bIns="0" rtlCol="0" anchor="t">
-            <a:normAutofit/>
-          </a:bodyPr>
-          <a:lstStyle/>
-          <a:p>
-            <a:pPr indent="0" marL="0">
-              <a:buNone/>
-            </a:pPr>
-            <a:r>
-              <a:rPr lang="en-US" sz="2000" b="1" dirty="0">
-                <a:solidFill>
-                  <a:srgbClr val="F5F5F5"/>
-                </a:solidFill>
-                <a:latin typeface="Avenir Next" pitchFamily="34" charset="0"/>
-                <a:ea typeface="Avenir Next" pitchFamily="34" charset="-122"/>
-                <a:cs typeface="Avenir Next" pitchFamily="34" charset="-120"/>
-              </a:rPr>
-              <a:t>Reject stale writes</a:t>
-            </a:r>
-            <a:endParaRPr lang="en-US" sz="2000" dirty="0"/>
-          </a:p>
-        </p:txBody>
-      </p:sp>
-      <p:sp>
-        <p:nvSpPr>
-          <p:cNvPr id="13" name="Shape 10"/>
+              <a:t>Persistence and HTTP</a:t>
+            </a:r>
+            <a:endParaRPr lang="en-US" sz="1200" dirty="0"/>
+          </a:p>
+        </p:txBody>
+      </p:sp>
+      <p:sp>
+        <p:nvSpPr>
+          <p:cNvPr id="14" name="Shape 11"/>
           <p:cNvSpPr/>
           <p:nvPr/>
         </p:nvSpPr>
         <p:spPr>
           <a:xfrm>
-            <a:off x="4233672" y="1133856"/>
-            <a:ext cx="4325112" cy="3282696"/>
+            <a:off x="4800600" y="1115568"/>
+            <a:ext cx="3758184" cy="2926080"/>
           </a:xfrm>
           <a:prstGeom prst="rect">
             <a:avLst/>
@@ -4506,7 +4272,7 @@
       </p:sp>
       <p:pic>
         <p:nvPicPr>
-          <p:cNvPr id="14" name="Image 0" descr="/Users/john/theborg/repos/atm/design/screenshots/overdraft.png">    </p:cNvPr>
+          <p:cNvPr id="15" name="Image 0" descr="/Users/john/theborg/repos/atm/design/screenshots/receipt.png">    </p:cNvPr>
           <p:cNvPicPr>
             <a:picLocks noChangeAspect="1"/>
           </p:cNvPicPr>
@@ -4520,8 +4286,8 @@
         </p:blipFill>
         <p:spPr>
           <a:xfrm>
-            <a:off x="4270248" y="1170432"/>
-            <a:ext cx="4251960" cy="3209544"/>
+            <a:off x="4837176" y="1152144"/>
+            <a:ext cx="3685032" cy="2852928"/>
           </a:xfrm>
           <a:prstGeom prst="rect">
             <a:avLst/>
@@ -4530,14 +4296,14 @@
       </p:pic>
       <p:sp>
         <p:nvSpPr>
-          <p:cNvPr id="15" name="Text 11"/>
+          <p:cNvPr id="16" name="Text 12"/>
           <p:cNvSpPr txBox="1"/>
           <p:nvPr/>
         </p:nvSpPr>
         <p:spPr>
           <a:xfrm>
-            <a:off x="4233672" y="4489704"/>
-            <a:ext cx="4325112" cy="201168"/>
+            <a:off x="4800600" y="4187952"/>
+            <a:ext cx="3758184" cy="219456"/>
           </a:xfrm>
           <a:prstGeom prst="rect">
             <a:avLst/>
@@ -4546,26 +4312,24 @@
           <a:ln/>
         </p:spPr>
         <p:txBody>
-          <a:bodyPr wrap="square" lIns="0" tIns="0" rIns="0" bIns="0" rtlCol="0" anchor="t">
-            <a:normAutofit/>
-          </a:bodyPr>
+          <a:bodyPr wrap="square" lIns="0" tIns="0" rIns="0" bIns="0" rtlCol="0" anchor="t"/>
           <a:lstStyle/>
           <a:p>
             <a:pPr algn="r" indent="0" marL="0">
               <a:buNone/>
             </a:pPr>
             <a:r>
-              <a:rPr lang="en-US" sz="1150" b="1" dirty="0">
+              <a:rPr lang="en-US" sz="1200" dirty="0">
                 <a:solidFill>
-                  <a:srgbClr val="F67F00"/>
+                  <a:srgbClr val="00F604"/>
                 </a:solidFill>
                 <a:latin typeface="Avenir Next" pitchFamily="34" charset="0"/>
                 <a:ea typeface="Avenir Next" pitchFamily="34" charset="-122"/>
                 <a:cs typeface="Avenir Next" pitchFamily="34" charset="-120"/>
               </a:rPr>
-              <a:t>Rejected overdraft. Persisted state stays unchanged.</a:t>
-            </a:r>
-            <a:endParaRPr lang="en-US" sz="1150" dirty="0"/>
+              <a:t>Success receipt after Post/Redirect/Get.</a:t>
+            </a:r>
+            <a:endParaRPr lang="en-US" sz="1200" dirty="0"/>
           </a:p>
         </p:txBody>
       </p:sp>
@@ -4663,7 +4427,7 @@
                 <a:ea typeface="Avenir Next" pitchFamily="34" charset="-122"/>
                 <a:cs typeface="Avenir Next" pitchFamily="34" charset="-120"/>
               </a:rPr>
-              <a:t>143 tests. Every boundary.</a:t>
+              <a:t>Tradeoffs and roadmap</a:t>
             </a:r>
             <a:endParaRPr lang="en-US" sz="3200" dirty="0"/>
           </a:p>
@@ -4671,20 +4435,184 @@
       </p:sp>
       <p:sp>
         <p:nvSpPr>
-          <p:cNvPr id="4" name="Shape 2"/>
+          <p:cNvPr id="5" name="Text 2"/>
+          <p:cNvSpPr txBox="1"/>
+          <p:nvPr/>
+        </p:nvSpPr>
+        <p:spPr>
+          <a:xfrm>
+            <a:off x="585216" y="1188720"/>
+            <a:ext cx="2240280" cy="228600"/>
+          </a:xfrm>
+          <a:prstGeom prst="rect">
+            <a:avLst/>
+          </a:prstGeom>
+          <a:noFill/>
+          <a:ln/>
+        </p:spPr>
+        <p:txBody>
+          <a:bodyPr wrap="square" lIns="0" tIns="0" rIns="0" bIns="0" rtlCol="0" anchor="t">
+            <a:normAutofit/>
+          </a:bodyPr>
+          <a:lstStyle/>
+          <a:p>
+            <a:pPr indent="0" marL="0">
+              <a:buNone/>
+            </a:pPr>
+            <a:r>
+              <a:rPr lang="en-US" sz="1100" b="1" spc="160" kern="0" dirty="0">
+                <a:solidFill>
+                  <a:srgbClr val="F67F00"/>
+                </a:solidFill>
+                <a:latin typeface="Avenir Next" pitchFamily="34" charset="0"/>
+                <a:ea typeface="Avenir Next" pitchFamily="34" charset="-122"/>
+                <a:cs typeface="Avenir Next" pitchFamily="34" charset="-120"/>
+              </a:rPr>
+              <a:t>OMITTED</a:t>
+            </a:r>
+            <a:endParaRPr lang="en-US" sz="1100" dirty="0"/>
+          </a:p>
+        </p:txBody>
+      </p:sp>
+      <p:sp>
+        <p:nvSpPr>
+          <p:cNvPr id="6" name="Text 3"/>
+          <p:cNvSpPr txBox="1"/>
+          <p:nvPr/>
+        </p:nvSpPr>
+        <p:spPr>
+          <a:xfrm>
+            <a:off x="585216" y="1627632"/>
+            <a:ext cx="2240280" cy="320040"/>
+          </a:xfrm>
+          <a:prstGeom prst="rect">
+            <a:avLst/>
+          </a:prstGeom>
+          <a:noFill/>
+          <a:ln/>
+        </p:spPr>
+        <p:txBody>
+          <a:bodyPr wrap="square" lIns="0" tIns="0" rIns="0" bIns="0" rtlCol="0" anchor="t">
+            <a:normAutofit/>
+          </a:bodyPr>
+          <a:lstStyle/>
+          <a:p>
+            <a:pPr indent="0" marL="0">
+              <a:buNone/>
+            </a:pPr>
+            <a:r>
+              <a:rPr lang="en-US" sz="1900" b="1" dirty="0">
+                <a:solidFill>
+                  <a:srgbClr val="F5F5F5"/>
+                </a:solidFill>
+                <a:latin typeface="Avenir Next" pitchFamily="34" charset="0"/>
+                <a:ea typeface="Avenir Next" pitchFamily="34" charset="-122"/>
+                <a:cs typeface="Avenir Next" pitchFamily="34" charset="-120"/>
+              </a:rPr>
+              <a:t>Identity</a:t>
+            </a:r>
+            <a:endParaRPr lang="en-US" sz="1900" dirty="0"/>
+          </a:p>
+        </p:txBody>
+      </p:sp>
+      <p:sp>
+        <p:nvSpPr>
+          <p:cNvPr id="7" name="Text 4"/>
+          <p:cNvSpPr txBox="1"/>
+          <p:nvPr/>
+        </p:nvSpPr>
+        <p:spPr>
+          <a:xfrm>
+            <a:off x="585216" y="2286000"/>
+            <a:ext cx="2240280" cy="320040"/>
+          </a:xfrm>
+          <a:prstGeom prst="rect">
+            <a:avLst/>
+          </a:prstGeom>
+          <a:noFill/>
+          <a:ln/>
+        </p:spPr>
+        <p:txBody>
+          <a:bodyPr wrap="square" lIns="0" tIns="0" rIns="0" bIns="0" rtlCol="0" anchor="t">
+            <a:normAutofit/>
+          </a:bodyPr>
+          <a:lstStyle/>
+          <a:p>
+            <a:pPr indent="0" marL="0">
+              <a:buNone/>
+            </a:pPr>
+            <a:r>
+              <a:rPr lang="en-US" sz="1900" b="1" dirty="0">
+                <a:solidFill>
+                  <a:srgbClr val="F5F5F5"/>
+                </a:solidFill>
+                <a:latin typeface="Avenir Next" pitchFamily="34" charset="0"/>
+                <a:ea typeface="Avenir Next" pitchFamily="34" charset="-122"/>
+                <a:cs typeface="Avenir Next" pitchFamily="34" charset="-120"/>
+              </a:rPr>
+              <a:t>Banking breadth</a:t>
+            </a:r>
+            <a:endParaRPr lang="en-US" sz="1900" dirty="0"/>
+          </a:p>
+        </p:txBody>
+      </p:sp>
+      <p:sp>
+        <p:nvSpPr>
+          <p:cNvPr id="8" name="Text 5"/>
+          <p:cNvSpPr txBox="1"/>
+          <p:nvPr/>
+        </p:nvSpPr>
+        <p:spPr>
+          <a:xfrm>
+            <a:off x="585216" y="2944368"/>
+            <a:ext cx="2240280" cy="320040"/>
+          </a:xfrm>
+          <a:prstGeom prst="rect">
+            <a:avLst/>
+          </a:prstGeom>
+          <a:noFill/>
+          <a:ln/>
+        </p:spPr>
+        <p:txBody>
+          <a:bodyPr wrap="square" lIns="0" tIns="0" rIns="0" bIns="0" rtlCol="0" anchor="t">
+            <a:normAutofit/>
+          </a:bodyPr>
+          <a:lstStyle/>
+          <a:p>
+            <a:pPr indent="0" marL="0">
+              <a:buNone/>
+            </a:pPr>
+            <a:r>
+              <a:rPr lang="en-US" sz="1900" b="1" dirty="0">
+                <a:solidFill>
+                  <a:srgbClr val="F5F5F5"/>
+                </a:solidFill>
+                <a:latin typeface="Avenir Next" pitchFamily="34" charset="0"/>
+                <a:ea typeface="Avenir Next" pitchFamily="34" charset="-122"/>
+                <a:cs typeface="Avenir Next" pitchFamily="34" charset="-120"/>
+              </a:rPr>
+              <a:t>Distributed operations</a:t>
+            </a:r>
+            <a:endParaRPr lang="en-US" sz="1900" dirty="0"/>
+          </a:p>
+        </p:txBody>
+      </p:sp>
+      <p:sp>
+        <p:nvSpPr>
+          <p:cNvPr id="9" name="Shape 6"/>
           <p:cNvSpPr/>
           <p:nvPr/>
         </p:nvSpPr>
         <p:spPr>
           <a:xfrm>
-            <a:off x="585216" y="4745736"/>
-            <a:ext cx="7973568" cy="0"/>
+            <a:off x="3054096" y="1179576"/>
+            <a:ext cx="0" cy="3054096"/>
           </a:xfrm>
           <a:prstGeom prst="line">
             <a:avLst/>
           </a:prstGeom>
           <a:noFill/>
-          <a:ln w="9525">
+          <a:ln w="12700">
             <a:solidFill>
               <a:srgbClr val="333333"/>
             </a:solidFill>
@@ -4694,14 +4622,14 @@
       </p:sp>
       <p:sp>
         <p:nvSpPr>
-          <p:cNvPr id="5" name="Text 3"/>
+          <p:cNvPr id="10" name="Text 7"/>
           <p:cNvSpPr txBox="1"/>
           <p:nvPr/>
         </p:nvSpPr>
         <p:spPr>
           <a:xfrm>
-            <a:off x="8156448" y="4791456"/>
-            <a:ext cx="402336" cy="164592"/>
+            <a:off x="3383280" y="1188720"/>
+            <a:ext cx="731520" cy="228600"/>
           </a:xfrm>
           <a:prstGeom prst="rect">
             <a:avLst/>
@@ -4710,53 +4638,16 @@
           <a:ln/>
         </p:spPr>
         <p:txBody>
-          <a:bodyPr wrap="square" lIns="0" tIns="0" rIns="0" bIns="0" rtlCol="0" anchor="t"/>
-          <a:lstStyle/>
-          <a:p>
-            <a:pPr algn="r" indent="0" marL="0">
-              <a:buNone/>
-            </a:pPr>
-            <a:r>
-              <a:rPr lang="en-US" sz="1000" dirty="0">
-                <a:solidFill>
-                  <a:srgbClr val="A9ADB3"/>
-                </a:solidFill>
-                <a:latin typeface="Avenir Next" pitchFamily="34" charset="0"/>
-                <a:ea typeface="Avenir Next" pitchFamily="34" charset="-122"/>
-                <a:cs typeface="Avenir Next" pitchFamily="34" charset="-120"/>
-              </a:rPr>
-              <a:t>06</a:t>
-            </a:r>
-            <a:endParaRPr lang="en-US" sz="1000" dirty="0"/>
-          </a:p>
-        </p:txBody>
-      </p:sp>
-      <p:sp>
-        <p:nvSpPr>
-          <p:cNvPr id="7" name="Text 4"/>
-          <p:cNvSpPr txBox="1"/>
-          <p:nvPr/>
-        </p:nvSpPr>
-        <p:spPr>
-          <a:xfrm>
-            <a:off x="585216" y="1225296"/>
-            <a:ext cx="841248" cy="475488"/>
-          </a:xfrm>
-          <a:prstGeom prst="rect">
-            <a:avLst/>
-          </a:prstGeom>
-          <a:noFill/>
-          <a:ln/>
-        </p:spPr>
-        <p:txBody>
-          <a:bodyPr wrap="square" lIns="0" tIns="0" rIns="0" bIns="0" rtlCol="0" anchor="t"/>
+          <a:bodyPr wrap="square" lIns="0" tIns="0" rIns="0" bIns="0" rtlCol="0" anchor="t">
+            <a:normAutofit/>
+          </a:bodyPr>
           <a:lstStyle/>
           <a:p>
             <a:pPr indent="0" marL="0">
               <a:buNone/>
             </a:pPr>
             <a:r>
-              <a:rPr lang="en-US" sz="3400" b="1" dirty="0">
+              <a:rPr lang="en-US" sz="1100" b="1" spc="160" kern="0" dirty="0">
                 <a:solidFill>
                   <a:srgbClr val="00F604"/>
                 </a:solidFill>
@@ -4764,22 +4655,22 @@
                 <a:ea typeface="Avenir Next" pitchFamily="34" charset="-122"/>
                 <a:cs typeface="Avenir Next" pitchFamily="34" charset="-120"/>
               </a:rPr>
-              <a:t>75</a:t>
-            </a:r>
-            <a:endParaRPr lang="en-US" sz="3400" dirty="0"/>
-          </a:p>
-        </p:txBody>
-      </p:sp>
-      <p:sp>
-        <p:nvSpPr>
-          <p:cNvPr id="8" name="Text 5"/>
+              <a:t>NEXT</a:t>
+            </a:r>
+            <a:endParaRPr lang="en-US" sz="1100" dirty="0"/>
+          </a:p>
+        </p:txBody>
+      </p:sp>
+      <p:sp>
+        <p:nvSpPr>
+          <p:cNvPr id="11" name="Text 8"/>
           <p:cNvSpPr txBox="1"/>
           <p:nvPr/>
         </p:nvSpPr>
         <p:spPr>
           <a:xfrm>
-            <a:off x="1508760" y="1243584"/>
-            <a:ext cx="2075688" cy="256032"/>
+            <a:off x="3383280" y="1536192"/>
+            <a:ext cx="2487168" cy="475488"/>
           </a:xfrm>
           <a:prstGeom prst="rect">
             <a:avLst/>
@@ -4805,7 +4696,7 @@
                 <a:ea typeface="Avenir Next" pitchFamily="34" charset="-122"/>
                 <a:cs typeface="Avenir Next" pitchFamily="34" charset="-120"/>
               </a:rPr>
-              <a:t>Domain</a:t>
+              <a:t>Idempotency, auditing, authentication</a:t>
             </a:r>
             <a:endParaRPr lang="en-US" sz="1600" dirty="0"/>
           </a:p>
@@ -4813,14 +4704,14 @@
       </p:sp>
       <p:sp>
         <p:nvSpPr>
-          <p:cNvPr id="9" name="Text 6"/>
+          <p:cNvPr id="12" name="Text 9"/>
           <p:cNvSpPr txBox="1"/>
           <p:nvPr/>
         </p:nvSpPr>
         <p:spPr>
           <a:xfrm>
-            <a:off x="1508760" y="1572768"/>
-            <a:ext cx="2075688" cy="219456"/>
+            <a:off x="3383280" y="2167128"/>
+            <a:ext cx="731520" cy="228600"/>
           </a:xfrm>
           <a:prstGeom prst="rect">
             <a:avLst/>
@@ -4838,46 +4729,7 @@
               <a:buNone/>
             </a:pPr>
             <a:r>
-              <a:rPr lang="en-US" sz="1200" dirty="0">
-                <a:solidFill>
-                  <a:srgbClr val="A9ADB3"/>
-                </a:solidFill>
-                <a:latin typeface="Avenir Next" pitchFamily="34" charset="0"/>
-                <a:ea typeface="Avenir Next" pitchFamily="34" charset="-122"/>
-                <a:cs typeface="Avenir Next" pitchFamily="34" charset="-120"/>
-              </a:rPr>
-              <a:t>Invariants</a:t>
-            </a:r>
-            <a:endParaRPr lang="en-US" sz="1200" dirty="0"/>
-          </a:p>
-        </p:txBody>
-      </p:sp>
-      <p:sp>
-        <p:nvSpPr>
-          <p:cNvPr id="10" name="Text 7"/>
-          <p:cNvSpPr txBox="1"/>
-          <p:nvPr/>
-        </p:nvSpPr>
-        <p:spPr>
-          <a:xfrm>
-            <a:off x="585216" y="2203704"/>
-            <a:ext cx="841248" cy="475488"/>
-          </a:xfrm>
-          <a:prstGeom prst="rect">
-            <a:avLst/>
-          </a:prstGeom>
-          <a:noFill/>
-          <a:ln/>
-        </p:spPr>
-        <p:txBody>
-          <a:bodyPr wrap="square" lIns="0" tIns="0" rIns="0" bIns="0" rtlCol="0" anchor="t"/>
-          <a:lstStyle/>
-          <a:p>
-            <a:pPr indent="0" marL="0">
-              <a:buNone/>
-            </a:pPr>
-            <a:r>
-              <a:rPr lang="en-US" sz="3400" b="1" dirty="0">
+              <a:rPr lang="en-US" sz="1100" b="1" spc="160" kern="0" dirty="0">
                 <a:solidFill>
                   <a:srgbClr val="00F604"/>
                 </a:solidFill>
@@ -4885,22 +4737,22 @@
                 <a:ea typeface="Avenir Next" pitchFamily="34" charset="-122"/>
                 <a:cs typeface="Avenir Next" pitchFamily="34" charset="-120"/>
               </a:rPr>
-              <a:t>33</a:t>
-            </a:r>
-            <a:endParaRPr lang="en-US" sz="3400" dirty="0"/>
-          </a:p>
-        </p:txBody>
-      </p:sp>
-      <p:sp>
-        <p:nvSpPr>
-          <p:cNvPr id="11" name="Text 8"/>
+              <a:t>THEN</a:t>
+            </a:r>
+            <a:endParaRPr lang="en-US" sz="1100" dirty="0"/>
+          </a:p>
+        </p:txBody>
+      </p:sp>
+      <p:sp>
+        <p:nvSpPr>
+          <p:cNvPr id="13" name="Text 10"/>
           <p:cNvSpPr txBox="1"/>
           <p:nvPr/>
         </p:nvSpPr>
         <p:spPr>
           <a:xfrm>
-            <a:off x="1508760" y="2221992"/>
-            <a:ext cx="2075688" cy="256032"/>
+            <a:off x="3383280" y="2514600"/>
+            <a:ext cx="2487168" cy="475488"/>
           </a:xfrm>
           <a:prstGeom prst="rect">
             <a:avLst/>
@@ -4926,7 +4778,7 @@
                 <a:ea typeface="Avenir Next" pitchFamily="34" charset="-122"/>
                 <a:cs typeface="Avenir Next" pitchFamily="34" charset="-120"/>
               </a:rPr>
-              <a:t>Application</a:t>
+              <a:t>Accessibility, observability, load tests</a:t>
             </a:r>
             <a:endParaRPr lang="en-US" sz="1600" dirty="0"/>
           </a:p>
@@ -4934,14 +4786,14 @@
       </p:sp>
       <p:sp>
         <p:nvSpPr>
-          <p:cNvPr id="12" name="Text 9"/>
+          <p:cNvPr id="14" name="Text 11"/>
           <p:cNvSpPr txBox="1"/>
           <p:nvPr/>
         </p:nvSpPr>
         <p:spPr>
           <a:xfrm>
-            <a:off x="1508760" y="2551176"/>
-            <a:ext cx="2075688" cy="219456"/>
+            <a:off x="3383280" y="3145536"/>
+            <a:ext cx="731520" cy="228600"/>
           </a:xfrm>
           <a:prstGeom prst="rect">
             <a:avLst/>
@@ -4959,46 +4811,7 @@
               <a:buNone/>
             </a:pPr>
             <a:r>
-              <a:rPr lang="en-US" sz="1200" dirty="0">
-                <a:solidFill>
-                  <a:srgbClr val="A9ADB3"/>
-                </a:solidFill>
-                <a:latin typeface="Avenir Next" pitchFamily="34" charset="0"/>
-                <a:ea typeface="Avenir Next" pitchFamily="34" charset="-122"/>
-                <a:cs typeface="Avenir Next" pitchFamily="34" charset="-120"/>
-              </a:rPr>
-              <a:t>Orchestration</a:t>
-            </a:r>
-            <a:endParaRPr lang="en-US" sz="1200" dirty="0"/>
-          </a:p>
-        </p:txBody>
-      </p:sp>
-      <p:sp>
-        <p:nvSpPr>
-          <p:cNvPr id="13" name="Text 10"/>
-          <p:cNvSpPr txBox="1"/>
-          <p:nvPr/>
-        </p:nvSpPr>
-        <p:spPr>
-          <a:xfrm>
-            <a:off x="585216" y="3182112"/>
-            <a:ext cx="841248" cy="475488"/>
-          </a:xfrm>
-          <a:prstGeom prst="rect">
-            <a:avLst/>
-          </a:prstGeom>
-          <a:noFill/>
-          <a:ln/>
-        </p:spPr>
-        <p:txBody>
-          <a:bodyPr wrap="square" lIns="0" tIns="0" rIns="0" bIns="0" rtlCol="0" anchor="t"/>
-          <a:lstStyle/>
-          <a:p>
-            <a:pPr indent="0" marL="0">
-              <a:buNone/>
-            </a:pPr>
-            <a:r>
-              <a:rPr lang="en-US" sz="3400" b="1" dirty="0">
+              <a:rPr lang="en-US" sz="1100" b="1" spc="160" kern="0" dirty="0">
                 <a:solidFill>
                   <a:srgbClr val="00F604"/>
                 </a:solidFill>
@@ -5006,22 +4819,22 @@
                 <a:ea typeface="Avenir Next" pitchFamily="34" charset="-122"/>
                 <a:cs typeface="Avenir Next" pitchFamily="34" charset="-120"/>
               </a:rPr>
-              <a:t>35</a:t>
-            </a:r>
-            <a:endParaRPr lang="en-US" sz="3400" dirty="0"/>
-          </a:p>
-        </p:txBody>
-      </p:sp>
-      <p:sp>
-        <p:nvSpPr>
-          <p:cNvPr id="14" name="Text 11"/>
+              <a:t>LATER</a:t>
+            </a:r>
+            <a:endParaRPr lang="en-US" sz="1100" dirty="0"/>
+          </a:p>
+        </p:txBody>
+      </p:sp>
+      <p:sp>
+        <p:nvSpPr>
+          <p:cNvPr id="15" name="Text 12"/>
           <p:cNvSpPr txBox="1"/>
           <p:nvPr/>
         </p:nvSpPr>
         <p:spPr>
           <a:xfrm>
-            <a:off x="1508760" y="3200400"/>
-            <a:ext cx="2075688" cy="256032"/>
+            <a:off x="3383280" y="3493008"/>
+            <a:ext cx="2487168" cy="475488"/>
           </a:xfrm>
           <a:prstGeom prst="rect">
             <a:avLst/>
@@ -5047,50 +4860,9 @@
                 <a:ea typeface="Avenir Next" pitchFamily="34" charset="-122"/>
                 <a:cs typeface="Avenir Next" pitchFamily="34" charset="-120"/>
               </a:rPr>
-              <a:t>Integration + HTTP</a:t>
+              <a:t>Deployment, browser coverage</a:t>
             </a:r>
             <a:endParaRPr lang="en-US" sz="1600" dirty="0"/>
-          </a:p>
-        </p:txBody>
-      </p:sp>
-      <p:sp>
-        <p:nvSpPr>
-          <p:cNvPr id="15" name="Text 12"/>
-          <p:cNvSpPr txBox="1"/>
-          <p:nvPr/>
-        </p:nvSpPr>
-        <p:spPr>
-          <a:xfrm>
-            <a:off x="1508760" y="3529584"/>
-            <a:ext cx="2075688" cy="219456"/>
-          </a:xfrm>
-          <a:prstGeom prst="rect">
-            <a:avLst/>
-          </a:prstGeom>
-          <a:noFill/>
-          <a:ln/>
-        </p:spPr>
-        <p:txBody>
-          <a:bodyPr wrap="square" lIns="0" tIns="0" rIns="0" bIns="0" rtlCol="0" anchor="t">
-            <a:normAutofit/>
-          </a:bodyPr>
-          <a:lstStyle/>
-          <a:p>
-            <a:pPr indent="0" marL="0">
-              <a:buNone/>
-            </a:pPr>
-            <a:r>
-              <a:rPr lang="en-US" sz="1200" dirty="0">
-                <a:solidFill>
-                  <a:srgbClr val="A9ADB3"/>
-                </a:solidFill>
-                <a:latin typeface="Avenir Next" pitchFamily="34" charset="0"/>
-                <a:ea typeface="Avenir Next" pitchFamily="34" charset="-122"/>
-                <a:cs typeface="Avenir Next" pitchFamily="34" charset="-120"/>
-              </a:rPr>
-              <a:t>Persistence and HTTP</a:t>
-            </a:r>
-            <a:endParaRPr lang="en-US" sz="1200" dirty="0"/>
           </a:p>
         </p:txBody>
       </p:sp>
@@ -5102,8 +4874,8 @@
         </p:nvSpPr>
         <p:spPr>
           <a:xfrm>
-            <a:off x="4800600" y="1115568"/>
-            <a:ext cx="3758184" cy="2926080"/>
+            <a:off x="6986016" y="1078992"/>
+            <a:ext cx="1005840" cy="3310128"/>
           </a:xfrm>
           <a:prstGeom prst="rect">
             <a:avLst/>
@@ -5121,7 +4893,7 @@
       </p:sp>
       <p:pic>
         <p:nvPicPr>
-          <p:cNvPr id="17" name="Image 0" descr="/Users/john/theborg/repos/atm/design/screenshots/receipt.png">    </p:cNvPr>
+          <p:cNvPr id="17" name="Image 0" descr="/Users/john/theborg/repos/atm/design/screenshots/phone.png">    </p:cNvPr>
           <p:cNvPicPr>
             <a:picLocks noChangeAspect="1"/>
           </p:cNvPicPr>
@@ -5135,8 +4907,8 @@
         </p:blipFill>
         <p:spPr>
           <a:xfrm>
-            <a:off x="4837176" y="1152144"/>
-            <a:ext cx="3685032" cy="2852928"/>
+            <a:off x="7022592" y="1115568"/>
+            <a:ext cx="932688" cy="3236976"/>
           </a:xfrm>
           <a:prstGeom prst="rect">
             <a:avLst/>
@@ -5151,106 +4923,8 @@
         </p:nvSpPr>
         <p:spPr>
           <a:xfrm>
-            <a:off x="4800600" y="4187952"/>
-            <a:ext cx="3758184" cy="219456"/>
-          </a:xfrm>
-          <a:prstGeom prst="rect">
-            <a:avLst/>
-          </a:prstGeom>
-          <a:noFill/>
-          <a:ln/>
-        </p:spPr>
-        <p:txBody>
-          <a:bodyPr wrap="square" lIns="0" tIns="0" rIns="0" bIns="0" rtlCol="0" anchor="t"/>
-          <a:lstStyle/>
-          <a:p>
-            <a:pPr algn="r" indent="0" marL="0">
-              <a:buNone/>
-            </a:pPr>
-            <a:r>
-              <a:rPr lang="en-US" sz="1200" dirty="0">
-                <a:solidFill>
-                  <a:srgbClr val="00F604"/>
-                </a:solidFill>
-                <a:latin typeface="Avenir Next" pitchFamily="34" charset="0"/>
-                <a:ea typeface="Avenir Next" pitchFamily="34" charset="-122"/>
-                <a:cs typeface="Avenir Next" pitchFamily="34" charset="-120"/>
-              </a:rPr>
-              <a:t>A real receipt after redirect.</a:t>
-            </a:r>
-            <a:endParaRPr lang="en-US" sz="1200" dirty="0"/>
-          </a:p>
-        </p:txBody>
-      </p:sp>
-    </p:spTree>
-  </p:cSld>
-  <p:clrMapOvr>
-    <a:masterClrMapping/>
-  </p:clrMapOvr>
-</p:sld>
-</file>
-
-<file path=ppt/slides/slide7.xml><?xml version="1.0" encoding="utf-8"?>
-<p:sld xmlns:a="http://schemas.openxmlformats.org/drawingml/2006/main" xmlns:r="http://schemas.openxmlformats.org/officeDocument/2006/relationships" xmlns:p="http://schemas.openxmlformats.org/presentationml/2006/main">
-  <p:cSld name="Slide 7">
-    <p:bg>
-      <p:bgPr>
-        <a:solidFill>
-          <a:srgbClr val="121212"/>
-        </a:solidFill>
-      </p:bgPr>
-    </p:bg>
-    <p:spTree>
-      <p:nvGrpSpPr>
-        <p:cNvPr id="1" name=""/>
-        <p:cNvGrpSpPr/>
-        <p:nvPr/>
-      </p:nvGrpSpPr>
-      <p:grpSpPr>
-        <a:xfrm>
-          <a:off x="0" y="0"/>
-          <a:ext cx="0" cy="0"/>
-          <a:chOff x="0" y="0"/>
-          <a:chExt cx="0" cy="0"/>
-        </a:xfrm>
-      </p:grpSpPr>
-      <p:sp>
-        <p:nvSpPr>
-          <p:cNvPr id="2" name="Shape 0"/>
-          <p:cNvSpPr/>
-          <p:nvPr/>
-        </p:nvSpPr>
-        <p:spPr>
-          <a:xfrm>
-            <a:off x="585216" y="356616"/>
-            <a:ext cx="91440" cy="438912"/>
-          </a:xfrm>
-          <a:prstGeom prst="rect">
-            <a:avLst/>
-          </a:prstGeom>
-          <a:solidFill>
-            <a:srgbClr val="0077F6"/>
-          </a:solidFill>
-          <a:ln w="12700">
-            <a:solidFill>
-              <a:srgbClr val="0077F6">
-                <a:alpha val="0"/>
-              </a:srgbClr>
-            </a:solidFill>
-            <a:prstDash val="solid"/>
-          </a:ln>
-        </p:spPr>
-      </p:sp>
-      <p:sp>
-        <p:nvSpPr>
-          <p:cNvPr id="3" name="Text 1"/>
-          <p:cNvSpPr txBox="1"/>
-          <p:nvPr/>
-        </p:nvSpPr>
-        <p:spPr>
-          <a:xfrm>
-            <a:off x="832104" y="356616"/>
-            <a:ext cx="7726680" cy="512064"/>
+            <a:off x="6309360" y="4489704"/>
+            <a:ext cx="2359152" cy="164592"/>
           </a:xfrm>
           <a:prstGeom prst="rect">
             <a:avLst/>
@@ -5264,598 +4938,13 @@
           </a:bodyPr>
           <a:lstStyle/>
           <a:p>
-            <a:pPr indent="0" marL="0">
-              <a:buNone/>
-            </a:pPr>
-            <a:r>
-              <a:rPr lang="en-US" sz="3200" b="1" dirty="0">
-                <a:solidFill>
-                  <a:srgbClr val="F5F5F5"/>
-                </a:solidFill>
-                <a:latin typeface="Avenir Next" pitchFamily="34" charset="0"/>
-                <a:ea typeface="Avenir Next" pitchFamily="34" charset="-122"/>
-                <a:cs typeface="Avenir Next" pitchFamily="34" charset="-120"/>
-              </a:rPr>
-              <a:t>Tradeoffs and roadmap</a:t>
-            </a:r>
-            <a:endParaRPr lang="en-US" sz="3200" dirty="0"/>
-          </a:p>
-        </p:txBody>
-      </p:sp>
-      <p:sp>
-        <p:nvSpPr>
-          <p:cNvPr id="4" name="Shape 2"/>
-          <p:cNvSpPr/>
-          <p:nvPr/>
-        </p:nvSpPr>
-        <p:spPr>
-          <a:xfrm>
-            <a:off x="585216" y="4745736"/>
-            <a:ext cx="7973568" cy="0"/>
-          </a:xfrm>
-          <a:prstGeom prst="line">
-            <a:avLst/>
-          </a:prstGeom>
-          <a:noFill/>
-          <a:ln w="9525">
-            <a:solidFill>
-              <a:srgbClr val="333333"/>
-            </a:solidFill>
-            <a:prstDash val="solid"/>
-          </a:ln>
-        </p:spPr>
-      </p:sp>
-      <p:sp>
-        <p:nvSpPr>
-          <p:cNvPr id="5" name="Text 3"/>
-          <p:cNvSpPr txBox="1"/>
-          <p:nvPr/>
-        </p:nvSpPr>
-        <p:spPr>
-          <a:xfrm>
-            <a:off x="8156448" y="4791456"/>
-            <a:ext cx="402336" cy="164592"/>
-          </a:xfrm>
-          <a:prstGeom prst="rect">
-            <a:avLst/>
-          </a:prstGeom>
-          <a:noFill/>
-          <a:ln/>
-        </p:spPr>
-        <p:txBody>
-          <a:bodyPr wrap="square" lIns="0" tIns="0" rIns="0" bIns="0" rtlCol="0" anchor="t"/>
-          <a:lstStyle/>
-          <a:p>
-            <a:pPr algn="r" indent="0" marL="0">
-              <a:buNone/>
-            </a:pPr>
-            <a:r>
-              <a:rPr lang="en-US" sz="1000" dirty="0">
-                <a:solidFill>
-                  <a:srgbClr val="A9ADB3"/>
-                </a:solidFill>
-                <a:latin typeface="Avenir Next" pitchFamily="34" charset="0"/>
-                <a:ea typeface="Avenir Next" pitchFamily="34" charset="-122"/>
-                <a:cs typeface="Avenir Next" pitchFamily="34" charset="-120"/>
-              </a:rPr>
-              <a:t>07</a:t>
-            </a:r>
-            <a:endParaRPr lang="en-US" sz="1000" dirty="0"/>
-          </a:p>
-        </p:txBody>
-      </p:sp>
-      <p:sp>
-        <p:nvSpPr>
-          <p:cNvPr id="7" name="Text 4"/>
-          <p:cNvSpPr txBox="1"/>
-          <p:nvPr/>
-        </p:nvSpPr>
-        <p:spPr>
-          <a:xfrm>
-            <a:off x="585216" y="1188720"/>
-            <a:ext cx="2240280" cy="228600"/>
-          </a:xfrm>
-          <a:prstGeom prst="rect">
-            <a:avLst/>
-          </a:prstGeom>
-          <a:noFill/>
-          <a:ln/>
-        </p:spPr>
-        <p:txBody>
-          <a:bodyPr wrap="square" lIns="0" tIns="0" rIns="0" bIns="0" rtlCol="0" anchor="t">
-            <a:normAutofit/>
-          </a:bodyPr>
-          <a:lstStyle/>
-          <a:p>
-            <a:pPr indent="0" marL="0">
-              <a:buNone/>
-            </a:pPr>
-            <a:r>
-              <a:rPr lang="en-US" sz="1100" b="1" spc="160" kern="0" dirty="0">
-                <a:solidFill>
-                  <a:srgbClr val="0077F6"/>
-                </a:solidFill>
-                <a:latin typeface="Avenir Next" pitchFamily="34" charset="0"/>
-                <a:ea typeface="Avenir Next" pitchFamily="34" charset="-122"/>
-                <a:cs typeface="Avenir Next" pitchFamily="34" charset="-120"/>
-              </a:rPr>
-              <a:t>OMITTED</a:t>
-            </a:r>
-            <a:endParaRPr lang="en-US" sz="1100" dirty="0"/>
-          </a:p>
-        </p:txBody>
-      </p:sp>
-      <p:sp>
-        <p:nvSpPr>
-          <p:cNvPr id="8" name="Text 5"/>
-          <p:cNvSpPr txBox="1"/>
-          <p:nvPr/>
-        </p:nvSpPr>
-        <p:spPr>
-          <a:xfrm>
-            <a:off x="585216" y="1627632"/>
-            <a:ext cx="2240280" cy="320040"/>
-          </a:xfrm>
-          <a:prstGeom prst="rect">
-            <a:avLst/>
-          </a:prstGeom>
-          <a:noFill/>
-          <a:ln/>
-        </p:spPr>
-        <p:txBody>
-          <a:bodyPr wrap="square" lIns="0" tIns="0" rIns="0" bIns="0" rtlCol="0" anchor="t">
-            <a:normAutofit/>
-          </a:bodyPr>
-          <a:lstStyle/>
-          <a:p>
-            <a:pPr indent="0" marL="0">
-              <a:buNone/>
-            </a:pPr>
-            <a:r>
-              <a:rPr lang="en-US" sz="1900" b="1" dirty="0">
-                <a:solidFill>
-                  <a:srgbClr val="F5F5F5"/>
-                </a:solidFill>
-                <a:latin typeface="Avenir Next" pitchFamily="34" charset="0"/>
-                <a:ea typeface="Avenir Next" pitchFamily="34" charset="-122"/>
-                <a:cs typeface="Avenir Next" pitchFamily="34" charset="-120"/>
-              </a:rPr>
-              <a:t>Identity</a:t>
-            </a:r>
-            <a:endParaRPr lang="en-US" sz="1900" dirty="0"/>
-          </a:p>
-        </p:txBody>
-      </p:sp>
-      <p:sp>
-        <p:nvSpPr>
-          <p:cNvPr id="9" name="Text 6"/>
-          <p:cNvSpPr txBox="1"/>
-          <p:nvPr/>
-        </p:nvSpPr>
-        <p:spPr>
-          <a:xfrm>
-            <a:off x="585216" y="2286000"/>
-            <a:ext cx="2240280" cy="320040"/>
-          </a:xfrm>
-          <a:prstGeom prst="rect">
-            <a:avLst/>
-          </a:prstGeom>
-          <a:noFill/>
-          <a:ln/>
-        </p:spPr>
-        <p:txBody>
-          <a:bodyPr wrap="square" lIns="0" tIns="0" rIns="0" bIns="0" rtlCol="0" anchor="t">
-            <a:normAutofit/>
-          </a:bodyPr>
-          <a:lstStyle/>
-          <a:p>
-            <a:pPr indent="0" marL="0">
-              <a:buNone/>
-            </a:pPr>
-            <a:r>
-              <a:rPr lang="en-US" sz="1900" b="1" dirty="0">
-                <a:solidFill>
-                  <a:srgbClr val="F5F5F5"/>
-                </a:solidFill>
-                <a:latin typeface="Avenir Next" pitchFamily="34" charset="0"/>
-                <a:ea typeface="Avenir Next" pitchFamily="34" charset="-122"/>
-                <a:cs typeface="Avenir Next" pitchFamily="34" charset="-120"/>
-              </a:rPr>
-              <a:t>Banking breadth</a:t>
-            </a:r>
-            <a:endParaRPr lang="en-US" sz="1900" dirty="0"/>
-          </a:p>
-        </p:txBody>
-      </p:sp>
-      <p:sp>
-        <p:nvSpPr>
-          <p:cNvPr id="10" name="Text 7"/>
-          <p:cNvSpPr txBox="1"/>
-          <p:nvPr/>
-        </p:nvSpPr>
-        <p:spPr>
-          <a:xfrm>
-            <a:off x="585216" y="2944368"/>
-            <a:ext cx="2240280" cy="320040"/>
-          </a:xfrm>
-          <a:prstGeom prst="rect">
-            <a:avLst/>
-          </a:prstGeom>
-          <a:noFill/>
-          <a:ln/>
-        </p:spPr>
-        <p:txBody>
-          <a:bodyPr wrap="square" lIns="0" tIns="0" rIns="0" bIns="0" rtlCol="0" anchor="t">
-            <a:normAutofit/>
-          </a:bodyPr>
-          <a:lstStyle/>
-          <a:p>
-            <a:pPr indent="0" marL="0">
-              <a:buNone/>
-            </a:pPr>
-            <a:r>
-              <a:rPr lang="en-US" sz="1900" b="1" dirty="0">
-                <a:solidFill>
-                  <a:srgbClr val="F5F5F5"/>
-                </a:solidFill>
-                <a:latin typeface="Avenir Next" pitchFamily="34" charset="0"/>
-                <a:ea typeface="Avenir Next" pitchFamily="34" charset="-122"/>
-                <a:cs typeface="Avenir Next" pitchFamily="34" charset="-120"/>
-              </a:rPr>
-              <a:t>Distributed operations</a:t>
-            </a:r>
-            <a:endParaRPr lang="en-US" sz="1900" dirty="0"/>
-          </a:p>
-        </p:txBody>
-      </p:sp>
-      <p:sp>
-        <p:nvSpPr>
-          <p:cNvPr id="11" name="Shape 8"/>
-          <p:cNvSpPr/>
-          <p:nvPr/>
-        </p:nvSpPr>
-        <p:spPr>
-          <a:xfrm>
-            <a:off x="3054096" y="1179576"/>
-            <a:ext cx="0" cy="3054096"/>
-          </a:xfrm>
-          <a:prstGeom prst="line">
-            <a:avLst/>
-          </a:prstGeom>
-          <a:noFill/>
-          <a:ln w="12700">
-            <a:solidFill>
-              <a:srgbClr val="333333"/>
-            </a:solidFill>
-            <a:prstDash val="solid"/>
-          </a:ln>
-        </p:spPr>
-      </p:sp>
-      <p:sp>
-        <p:nvSpPr>
-          <p:cNvPr id="12" name="Text 9"/>
-          <p:cNvSpPr txBox="1"/>
-          <p:nvPr/>
-        </p:nvSpPr>
-        <p:spPr>
-          <a:xfrm>
-            <a:off x="3383280" y="1188720"/>
-            <a:ext cx="731520" cy="228600"/>
-          </a:xfrm>
-          <a:prstGeom prst="rect">
-            <a:avLst/>
-          </a:prstGeom>
-          <a:noFill/>
-          <a:ln/>
-        </p:spPr>
-        <p:txBody>
-          <a:bodyPr wrap="square" lIns="0" tIns="0" rIns="0" bIns="0" rtlCol="0" anchor="t">
-            <a:normAutofit/>
-          </a:bodyPr>
-          <a:lstStyle/>
-          <a:p>
-            <a:pPr indent="0" marL="0">
-              <a:buNone/>
-            </a:pPr>
-            <a:r>
-              <a:rPr lang="en-US" sz="1100" b="1" spc="160" kern="0" dirty="0">
-                <a:solidFill>
-                  <a:srgbClr val="0077F6"/>
-                </a:solidFill>
-                <a:latin typeface="Avenir Next" pitchFamily="34" charset="0"/>
-                <a:ea typeface="Avenir Next" pitchFamily="34" charset="-122"/>
-                <a:cs typeface="Avenir Next" pitchFamily="34" charset="-120"/>
-              </a:rPr>
-              <a:t>NEXT</a:t>
-            </a:r>
-            <a:endParaRPr lang="en-US" sz="1100" dirty="0"/>
-          </a:p>
-        </p:txBody>
-      </p:sp>
-      <p:sp>
-        <p:nvSpPr>
-          <p:cNvPr id="13" name="Text 10"/>
-          <p:cNvSpPr txBox="1"/>
-          <p:nvPr/>
-        </p:nvSpPr>
-        <p:spPr>
-          <a:xfrm>
-            <a:off x="3383280" y="1536192"/>
-            <a:ext cx="2487168" cy="475488"/>
-          </a:xfrm>
-          <a:prstGeom prst="rect">
-            <a:avLst/>
-          </a:prstGeom>
-          <a:noFill/>
-          <a:ln/>
-        </p:spPr>
-        <p:txBody>
-          <a:bodyPr wrap="square" lIns="0" tIns="0" rIns="0" bIns="0" rtlCol="0" anchor="t">
-            <a:normAutofit/>
-          </a:bodyPr>
-          <a:lstStyle/>
-          <a:p>
-            <a:pPr indent="0" marL="0">
-              <a:buNone/>
-            </a:pPr>
-            <a:r>
-              <a:rPr lang="en-US" sz="1600" b="1" dirty="0">
-                <a:solidFill>
-                  <a:srgbClr val="F5F5F5"/>
-                </a:solidFill>
-                <a:latin typeface="Avenir Next" pitchFamily="34" charset="0"/>
-                <a:ea typeface="Avenir Next" pitchFamily="34" charset="-122"/>
-                <a:cs typeface="Avenir Next" pitchFamily="34" charset="-120"/>
-              </a:rPr>
-              <a:t>Idempotency, auditing, authentication</a:t>
-            </a:r>
-            <a:endParaRPr lang="en-US" sz="1600" dirty="0"/>
-          </a:p>
-        </p:txBody>
-      </p:sp>
-      <p:sp>
-        <p:nvSpPr>
-          <p:cNvPr id="14" name="Text 11"/>
-          <p:cNvSpPr txBox="1"/>
-          <p:nvPr/>
-        </p:nvSpPr>
-        <p:spPr>
-          <a:xfrm>
-            <a:off x="3383280" y="2167128"/>
-            <a:ext cx="731520" cy="228600"/>
-          </a:xfrm>
-          <a:prstGeom prst="rect">
-            <a:avLst/>
-          </a:prstGeom>
-          <a:noFill/>
-          <a:ln/>
-        </p:spPr>
-        <p:txBody>
-          <a:bodyPr wrap="square" lIns="0" tIns="0" rIns="0" bIns="0" rtlCol="0" anchor="t">
-            <a:normAutofit/>
-          </a:bodyPr>
-          <a:lstStyle/>
-          <a:p>
-            <a:pPr indent="0" marL="0">
-              <a:buNone/>
-            </a:pPr>
-            <a:r>
-              <a:rPr lang="en-US" sz="1100" b="1" spc="160" kern="0" dirty="0">
-                <a:solidFill>
-                  <a:srgbClr val="0077F6"/>
-                </a:solidFill>
-                <a:latin typeface="Avenir Next" pitchFamily="34" charset="0"/>
-                <a:ea typeface="Avenir Next" pitchFamily="34" charset="-122"/>
-                <a:cs typeface="Avenir Next" pitchFamily="34" charset="-120"/>
-              </a:rPr>
-              <a:t>THEN</a:t>
-            </a:r>
-            <a:endParaRPr lang="en-US" sz="1100" dirty="0"/>
-          </a:p>
-        </p:txBody>
-      </p:sp>
-      <p:sp>
-        <p:nvSpPr>
-          <p:cNvPr id="15" name="Text 12"/>
-          <p:cNvSpPr txBox="1"/>
-          <p:nvPr/>
-        </p:nvSpPr>
-        <p:spPr>
-          <a:xfrm>
-            <a:off x="3383280" y="2514600"/>
-            <a:ext cx="2487168" cy="475488"/>
-          </a:xfrm>
-          <a:prstGeom prst="rect">
-            <a:avLst/>
-          </a:prstGeom>
-          <a:noFill/>
-          <a:ln/>
-        </p:spPr>
-        <p:txBody>
-          <a:bodyPr wrap="square" lIns="0" tIns="0" rIns="0" bIns="0" rtlCol="0" anchor="t">
-            <a:normAutofit/>
-          </a:bodyPr>
-          <a:lstStyle/>
-          <a:p>
-            <a:pPr indent="0" marL="0">
-              <a:buNone/>
-            </a:pPr>
-            <a:r>
-              <a:rPr lang="en-US" sz="1600" b="1" dirty="0">
-                <a:solidFill>
-                  <a:srgbClr val="F5F5F5"/>
-                </a:solidFill>
-                <a:latin typeface="Avenir Next" pitchFamily="34" charset="0"/>
-                <a:ea typeface="Avenir Next" pitchFamily="34" charset="-122"/>
-                <a:cs typeface="Avenir Next" pitchFamily="34" charset="-120"/>
-              </a:rPr>
-              <a:t>Accessibility, observability, load tests</a:t>
-            </a:r>
-            <a:endParaRPr lang="en-US" sz="1600" dirty="0"/>
-          </a:p>
-        </p:txBody>
-      </p:sp>
-      <p:sp>
-        <p:nvSpPr>
-          <p:cNvPr id="16" name="Text 13"/>
-          <p:cNvSpPr txBox="1"/>
-          <p:nvPr/>
-        </p:nvSpPr>
-        <p:spPr>
-          <a:xfrm>
-            <a:off x="3383280" y="3145536"/>
-            <a:ext cx="731520" cy="228600"/>
-          </a:xfrm>
-          <a:prstGeom prst="rect">
-            <a:avLst/>
-          </a:prstGeom>
-          <a:noFill/>
-          <a:ln/>
-        </p:spPr>
-        <p:txBody>
-          <a:bodyPr wrap="square" lIns="0" tIns="0" rIns="0" bIns="0" rtlCol="0" anchor="t">
-            <a:normAutofit/>
-          </a:bodyPr>
-          <a:lstStyle/>
-          <a:p>
-            <a:pPr indent="0" marL="0">
-              <a:buNone/>
-            </a:pPr>
-            <a:r>
-              <a:rPr lang="en-US" sz="1100" b="1" spc="160" kern="0" dirty="0">
-                <a:solidFill>
-                  <a:srgbClr val="0077F6"/>
-                </a:solidFill>
-                <a:latin typeface="Avenir Next" pitchFamily="34" charset="0"/>
-                <a:ea typeface="Avenir Next" pitchFamily="34" charset="-122"/>
-                <a:cs typeface="Avenir Next" pitchFamily="34" charset="-120"/>
-              </a:rPr>
-              <a:t>LATER</a:t>
-            </a:r>
-            <a:endParaRPr lang="en-US" sz="1100" dirty="0"/>
-          </a:p>
-        </p:txBody>
-      </p:sp>
-      <p:sp>
-        <p:nvSpPr>
-          <p:cNvPr id="17" name="Text 14"/>
-          <p:cNvSpPr txBox="1"/>
-          <p:nvPr/>
-        </p:nvSpPr>
-        <p:spPr>
-          <a:xfrm>
-            <a:off x="3383280" y="3493008"/>
-            <a:ext cx="2487168" cy="475488"/>
-          </a:xfrm>
-          <a:prstGeom prst="rect">
-            <a:avLst/>
-          </a:prstGeom>
-          <a:noFill/>
-          <a:ln/>
-        </p:spPr>
-        <p:txBody>
-          <a:bodyPr wrap="square" lIns="0" tIns="0" rIns="0" bIns="0" rtlCol="0" anchor="t">
-            <a:normAutofit/>
-          </a:bodyPr>
-          <a:lstStyle/>
-          <a:p>
-            <a:pPr indent="0" marL="0">
-              <a:buNone/>
-            </a:pPr>
-            <a:r>
-              <a:rPr lang="en-US" sz="1600" b="1" dirty="0">
-                <a:solidFill>
-                  <a:srgbClr val="F5F5F5"/>
-                </a:solidFill>
-                <a:latin typeface="Avenir Next" pitchFamily="34" charset="0"/>
-                <a:ea typeface="Avenir Next" pitchFamily="34" charset="-122"/>
-                <a:cs typeface="Avenir Next" pitchFamily="34" charset="-120"/>
-              </a:rPr>
-              <a:t>Deployment, browser coverage</a:t>
-            </a:r>
-            <a:endParaRPr lang="en-US" sz="1600" dirty="0"/>
-          </a:p>
-        </p:txBody>
-      </p:sp>
-      <p:sp>
-        <p:nvSpPr>
-          <p:cNvPr id="18" name="Shape 15"/>
-          <p:cNvSpPr/>
-          <p:nvPr/>
-        </p:nvSpPr>
-        <p:spPr>
-          <a:xfrm>
-            <a:off x="6986016" y="1078992"/>
-            <a:ext cx="1005840" cy="3310128"/>
-          </a:xfrm>
-          <a:prstGeom prst="rect">
-            <a:avLst/>
-          </a:prstGeom>
-          <a:solidFill>
-            <a:srgbClr val="1B1B1B"/>
-          </a:solidFill>
-          <a:ln w="10160">
-            <a:solidFill>
-              <a:srgbClr val="333333"/>
-            </a:solidFill>
-            <a:prstDash val="solid"/>
-          </a:ln>
-        </p:spPr>
-      </p:sp>
-      <p:pic>
-        <p:nvPicPr>
-          <p:cNvPr id="19" name="Image 0" descr="/Users/john/theborg/repos/atm/design/screenshots/phone.png">    </p:cNvPr>
-          <p:cNvPicPr>
-            <a:picLocks noChangeAspect="1"/>
-          </p:cNvPicPr>
-          <p:nvPr/>
-        </p:nvPicPr>
-        <p:blipFill>
-          <a:blip r:embed="rId1"/>
-          <a:stretch>
-            <a:fillRect/>
-          </a:stretch>
-        </p:blipFill>
-        <p:spPr>
-          <a:xfrm>
-            <a:off x="7022592" y="1115568"/>
-            <a:ext cx="932688" cy="3236976"/>
-          </a:xfrm>
-          <a:prstGeom prst="rect">
-            <a:avLst/>
-          </a:prstGeom>
-        </p:spPr>
-      </p:pic>
-      <p:sp>
-        <p:nvSpPr>
-          <p:cNvPr id="20" name="Text 16"/>
-          <p:cNvSpPr txBox="1"/>
-          <p:nvPr/>
-        </p:nvSpPr>
-        <p:spPr>
-          <a:xfrm>
-            <a:off x="6309360" y="4489704"/>
-            <a:ext cx="2359152" cy="164592"/>
-          </a:xfrm>
-          <a:prstGeom prst="rect">
-            <a:avLst/>
-          </a:prstGeom>
-          <a:noFill/>
-          <a:ln/>
-        </p:spPr>
-        <p:txBody>
-          <a:bodyPr wrap="square" lIns="0" tIns="0" rIns="0" bIns="0" rtlCol="0" anchor="t">
-            <a:normAutofit/>
-          </a:bodyPr>
-          <a:lstStyle/>
-          <a:p>
             <a:pPr algn="ctr" indent="0" marL="0">
               <a:buNone/>
             </a:pPr>
             <a:r>
               <a:rPr lang="en-US" sz="1050" dirty="0">
                 <a:solidFill>
-                  <a:srgbClr val="0077F6"/>
+                  <a:srgbClr val="00F604"/>
                 </a:solidFill>
                 <a:latin typeface="Avenir Next" pitchFamily="34" charset="0"/>
                 <a:ea typeface="Avenir Next" pitchFamily="34" charset="-122"/>

</xml_diff>

<commit_message>
Replace idempotency wording and drop Single user from decisions
Slide 6's roadmap and slide 3's speaker notes said "idempotency";
relabel as "double-submit protection" and widen the roadmap column
so the longer phrase still wraps to two lines. Also remove
"Single user" from the decision ledger on slide 3 since it was a
spec constraint, not a decision, and update the matching speaker
notes and word budget.

Co-Authored-By: Claude Sonnet 5 <noreply@anthropic.com>
</commit_message>
<xml_diff>
--- a/design/atm-deck.pptx
+++ b/design/atm-deck.pptx
@@ -853,16 +853,6 @@
             <a:r>
               <a:rPr lang="en-US" dirty="0"/>
               <a:t>). Cost: single-currency support. Amounts are decimal with at most two fractional digits, which rules out floating-point error. The two-digit rule fits USD only, and there is no currency field, so supporting another currency (e.g., JPY with 0 places or KWD with 3) would change the Money type.</a:t>
-            </a:r>
-            <a:endParaRPr lang="en-US" dirty="0"/>
-          </a:p>
-          <a:p>
-            <a:endParaRPr lang="en-US" dirty="0"/>
-          </a:p>
-          <a:p>
-            <a:r>
-              <a:rPr lang="en-US" dirty="0"/>
-              <a:t>Single user (SPEC). Cost: no user isolation. The spec defines one local user, so there is no login, session, or per-user data. Authentication is on the roadmap after idempotency and auditing.</a:t>
             </a:r>
             <a:endParaRPr lang="en-US" dirty="0"/>
           </a:p>
@@ -2658,7 +2648,7 @@
                   </a:tcPr>
                 </a:tc>
               </a:tr>
-              <a:tr h="594360">
+              <a:tr h="740664">
                 <a:tc>
                   <a:txBody>
                     <a:bodyPr/>
@@ -2796,7 +2786,7 @@
                   </a:tcPr>
                 </a:tc>
               </a:tr>
-              <a:tr h="594360">
+              <a:tr h="740664">
                 <a:tc>
                   <a:txBody>
                     <a:bodyPr/>
@@ -2934,7 +2924,7 @@
                   </a:tcPr>
                 </a:tc>
               </a:tr>
-              <a:tr h="594360">
+              <a:tr h="740664">
                 <a:tc>
                   <a:txBody>
                     <a:bodyPr/>
@@ -3072,7 +3062,7 @@
                   </a:tcPr>
                 </a:tc>
               </a:tr>
-              <a:tr h="594360">
+              <a:tr h="740664">
                 <a:tc>
                   <a:txBody>
                     <a:bodyPr/>
@@ -3210,144 +3200,6 @@
                   </a:tcPr>
                 </a:tc>
               </a:tr>
-              <a:tr h="585216">
-                <a:tc>
-                  <a:txBody>
-                    <a:bodyPr/>
-                    <a:lstStyle/>
-                    <a:p>
-                      <a:pPr indent="0" marL="0">
-                        <a:buNone/>
-                      </a:pPr>
-                      <a:r>
-                        <a:rPr lang="en-US" sz="1700" b="1" dirty="0">
-                          <a:solidFill>
-                            <a:srgbClr val="F5F5F5"/>
-                          </a:solidFill>
-                          <a:latin typeface="Avenir Next" pitchFamily="34" charset="0"/>
-                          <a:ea typeface="Avenir Next" pitchFamily="34" charset="-122"/>
-                          <a:cs typeface="Avenir Next" pitchFamily="34" charset="-120"/>
-                        </a:rPr>
-                        <a:t>Single user</a:t>
-                      </a:r>
-                      <a:endParaRPr lang="en-US" sz="1700" dirty="0">
-                        <a:latin typeface="Avenir Next" charset="0"/>
-                        <a:ea typeface="Avenir Next" charset="0"/>
-                        <a:cs typeface="Avenir Next" charset="0"/>
-                      </a:endParaRPr>
-                    </a:p>
-                  </a:txBody>
-                  <a:tcPr marL="91440" marR="91440" marT="91440" marB="91440" anchor="ctr">
-                    <a:lnL w="9525" cap="flat" cmpd="sng" algn="ctr">
-                      <a:solidFill>
-                        <a:srgbClr val="333333"/>
-                      </a:solidFill>
-                      <a:prstDash val="solid"/>
-                      <a:round/>
-                      <a:headEnd type="none" w="med" len="med"/>
-                      <a:tailEnd type="none" w="med" len="med"/>
-                    </a:lnL>
-                    <a:lnR w="9525" cap="flat" cmpd="sng" algn="ctr">
-                      <a:solidFill>
-                        <a:srgbClr val="333333"/>
-                      </a:solidFill>
-                      <a:prstDash val="solid"/>
-                      <a:round/>
-                      <a:headEnd type="none" w="med" len="med"/>
-                      <a:tailEnd type="none" w="med" len="med"/>
-                    </a:lnR>
-                    <a:lnT w="9525" cap="flat" cmpd="sng" algn="ctr">
-                      <a:solidFill>
-                        <a:srgbClr val="333333"/>
-                      </a:solidFill>
-                      <a:prstDash val="solid"/>
-                      <a:round/>
-                      <a:headEnd type="none" w="med" len="med"/>
-                      <a:tailEnd type="none" w="med" len="med"/>
-                    </a:lnT>
-                    <a:lnB w="9525" cap="flat" cmpd="sng" algn="ctr">
-                      <a:solidFill>
-                        <a:srgbClr val="333333"/>
-                      </a:solidFill>
-                      <a:prstDash val="solid"/>
-                      <a:round/>
-                      <a:headEnd type="none" w="med" len="med"/>
-                      <a:tailEnd type="none" w="med" len="med"/>
-                    </a:lnB>
-                    <a:solidFill>
-                      <a:srgbClr val="121212"/>
-                    </a:solidFill>
-                  </a:tcPr>
-                </a:tc>
-                <a:tc>
-                  <a:txBody>
-                    <a:bodyPr/>
-                    <a:lstStyle/>
-                    <a:p>
-                      <a:pPr indent="0" marL="0">
-                        <a:buNone/>
-                      </a:pPr>
-                      <a:r>
-                        <a:rPr lang="en-US" sz="1700" dirty="0">
-                          <a:solidFill>
-                            <a:srgbClr val="A9ADB3"/>
-                          </a:solidFill>
-                          <a:latin typeface="Avenir Next" pitchFamily="34" charset="0"/>
-                          <a:ea typeface="Avenir Next" pitchFamily="34" charset="-122"/>
-                          <a:cs typeface="Avenir Next" pitchFamily="34" charset="-120"/>
-                        </a:rPr>
-                        <a:t>No user isolation</a:t>
-                      </a:r>
-                      <a:endParaRPr lang="en-US" sz="1700" dirty="0">
-                        <a:latin typeface="Avenir Next" charset="0"/>
-                        <a:ea typeface="Avenir Next" charset="0"/>
-                        <a:cs typeface="Avenir Next" charset="0"/>
-                      </a:endParaRPr>
-                    </a:p>
-                  </a:txBody>
-                  <a:tcPr marL="91440" marR="91440" marT="91440" marB="91440" anchor="ctr">
-                    <a:lnL w="9525" cap="flat" cmpd="sng" algn="ctr">
-                      <a:solidFill>
-                        <a:srgbClr val="333333"/>
-                      </a:solidFill>
-                      <a:prstDash val="solid"/>
-                      <a:round/>
-                      <a:headEnd type="none" w="med" len="med"/>
-                      <a:tailEnd type="none" w="med" len="med"/>
-                    </a:lnL>
-                    <a:lnR w="9525" cap="flat" cmpd="sng" algn="ctr">
-                      <a:solidFill>
-                        <a:srgbClr val="333333"/>
-                      </a:solidFill>
-                      <a:prstDash val="solid"/>
-                      <a:round/>
-                      <a:headEnd type="none" w="med" len="med"/>
-                      <a:tailEnd type="none" w="med" len="med"/>
-                    </a:lnR>
-                    <a:lnT w="9525" cap="flat" cmpd="sng" algn="ctr">
-                      <a:solidFill>
-                        <a:srgbClr val="333333"/>
-                      </a:solidFill>
-                      <a:prstDash val="solid"/>
-                      <a:round/>
-                      <a:headEnd type="none" w="med" len="med"/>
-                      <a:tailEnd type="none" w="med" len="med"/>
-                    </a:lnT>
-                    <a:lnB w="9525" cap="flat" cmpd="sng" algn="ctr">
-                      <a:solidFill>
-                        <a:srgbClr val="333333"/>
-                      </a:solidFill>
-                      <a:prstDash val="solid"/>
-                      <a:round/>
-                      <a:headEnd type="none" w="med" len="med"/>
-                      <a:tailEnd type="none" w="med" len="med"/>
-                    </a:lnB>
-                    <a:solidFill>
-                      <a:srgbClr val="121212"/>
-                    </a:solidFill>
-                  </a:tcPr>
-                </a:tc>
-              </a:tr>
             </a:tbl>
           </a:graphicData>
         </a:graphic>
@@ -4670,7 +4522,7 @@
         <p:spPr>
           <a:xfrm>
             <a:off x="3383280" y="1536192"/>
-            <a:ext cx="2487168" cy="475488"/>
+            <a:ext cx="2743200" cy="475488"/>
           </a:xfrm>
           <a:prstGeom prst="rect">
             <a:avLst/>
@@ -4696,7 +4548,7 @@
                 <a:ea typeface="Avenir Next" pitchFamily="34" charset="-122"/>
                 <a:cs typeface="Avenir Next" pitchFamily="34" charset="-120"/>
               </a:rPr>
-              <a:t>Idempotency, auditing, authentication</a:t>
+              <a:t>Double-submit protection, auditing, authentication</a:t>
             </a:r>
             <a:endParaRPr lang="en-US" sz="1600" dirty="0"/>
           </a:p>
@@ -4752,7 +4604,7 @@
         <p:spPr>
           <a:xfrm>
             <a:off x="3383280" y="2514600"/>
-            <a:ext cx="2487168" cy="475488"/>
+            <a:ext cx="2743200" cy="475488"/>
           </a:xfrm>
           <a:prstGeom prst="rect">
             <a:avLst/>
@@ -4834,7 +4686,7 @@
         <p:spPr>
           <a:xfrm>
             <a:off x="3383280" y="3493008"/>
-            <a:ext cx="2487168" cy="475488"/>
+            <a:ext cx="2743200" cy="475488"/>
           </a:xfrm>
           <a:prstGeom prst="rect">
             <a:avLst/>

</xml_diff>

<commit_message>
Add datastore choice slide weighing in-memory alternatives
An in-memory store would have been enough; the deck now shows the persistent
SQLite choice on its own slide, with SQLite in-memory, a hand-written store,
EF Core InMemory, and Redis weighed in the speaker notes. The SQLite and EF
Core detail moves there from the decision ledger's notes. The README lists
seven slides and drops the stale single-user scope from slide 3.

Visual QA in PowerPoint is still pending.

Co-Authored-By: Claude Opus 5.5 <noreply@anthropic.com>
</commit_message>
<xml_diff>
--- a/design/atm-deck.pptx
+++ b/design/atm-deck.pptx
@@ -11,9 +11,10 @@
     <p:sldId id="259" r:id="rId5"/>
     <p:sldId id="260" r:id="rId6"/>
     <p:sldId id="261" r:id="rId7"/>
+    <p:sldId id="262" r:id="rId8"/>
   </p:sldIdLst>
   <p:notesMasterIdLst>
-    <p:notesMasterId r:id="rId8"/>
+    <p:notesMasterId r:id="rId9"/>
   </p:notesMasterIdLst>
   <p:sldSz cx="9144000" cy="5143500"/>
   <p:notesSz cx="7772400" cy="10058400"/>
@@ -797,42 +798,7 @@
             </a:r>
             <a:r>
               <a:rPr lang="en-US" dirty="0"/>
-              <a:t>). Cost: single-writer ceiling.</a:t>
-            </a:r>
-            <a:endParaRPr lang="en-US" dirty="0"/>
-          </a:p>
-          <a:p>
-            <a:r>
-              <a:rPr lang="en-US" dirty="0"/>
-              <a:t>• SQLite – single-file DB with near-zero setup; balances survive restarts.</a:t>
-            </a:r>
-            <a:endParaRPr lang="en-US" dirty="0"/>
-          </a:p>
-          <a:p>
-            <a:r>
-              <a:rPr lang="en-US" dirty="0"/>
-              <a:t>• EF Core – the ORM (the .NET counterpart to Hibernate).</a:t>
-            </a:r>
-            <a:endParaRPr lang="en-US" dirty="0"/>
-          </a:p>
-          <a:p>
-            <a:r>
-              <a:rPr lang="en-US" dirty="0"/>
-              <a:t>   – Transactions: saves a transfer's debit, credit, and history rows in a single DB transaction, so they either commit or roll back as a unit.</a:t>
-            </a:r>
-            <a:endParaRPr lang="en-US" dirty="0"/>
-          </a:p>
-          <a:p>
-            <a:r>
-              <a:rPr lang="en-US" dirty="0"/>
-              <a:t>   – Optimistic concurrency: rejects a write based on an outdated balance, e.g., two tabs withdrawing against the same $1,000 and overdrawing it. Doesn't lock account rows; assumes conflicts are rare.</a:t>
-            </a:r>
-            <a:endParaRPr lang="en-US" dirty="0"/>
-          </a:p>
-          <a:p>
-            <a:r>
-              <a:rPr lang="en-US" dirty="0"/>
-              <a:t>A server database is the upgrade path if concurrent load ever matters.</a:t>
+              <a:t>). Cost: single-writer ceiling. A server database is the upgrade path if concurrent load ever matters. The next slide covers the datastore choice.</a:t>
             </a:r>
             <a:endParaRPr lang="en-US" dirty="0"/>
           </a:p>
@@ -940,7 +906,83 @@
           <a:p>
             <a:r>
               <a:rPr lang="en-US" dirty="0"/>
-              <a:t>The screenshot is a real rejected overdraft. The typed value stays visible, the error names the available balance, and persisted state is unchanged. Account versions turn stale writes into a safe retry instead of lost data.</a:t>
+              <a:t>An in-memory store would have been enough. I chose a persistent one so balances and history survive restarts (</a:t>
+            </a:r>
+            <a:r>
+              <a:rPr lang="en-US" dirty="0">
+                <a:hlinkClick r:id="rId3"/>
+              </a:rPr>
+              <a:t>ADR-0003</a:t>
+            </a:r>
+            <a:r>
+              <a:rPr lang="en-US" dirty="0"/>
+              <a:t>).</a:t>
+            </a:r>
+            <a:endParaRPr lang="en-US" dirty="0"/>
+          </a:p>
+          <a:p>
+            <a:r>
+              <a:rPr lang="en-US" dirty="0"/>
+              <a:t>• SQLite – single-file DB with near-zero setup.</a:t>
+            </a:r>
+            <a:endParaRPr lang="en-US" dirty="0"/>
+          </a:p>
+          <a:p>
+            <a:r>
+              <a:rPr lang="en-US" dirty="0"/>
+              <a:t>• EF Core – the ORM (the .NET counterpart to Hibernate).</a:t>
+            </a:r>
+            <a:endParaRPr lang="en-US" dirty="0"/>
+          </a:p>
+          <a:p>
+            <a:r>
+              <a:rPr lang="en-US" dirty="0"/>
+              <a:t>   – Transactions: saves a transfer's debit, credit, and history rows in a single DB transaction, so they either commit or roll back as a unit.</a:t>
+            </a:r>
+            <a:endParaRPr lang="en-US" dirty="0"/>
+          </a:p>
+          <a:p>
+            <a:r>
+              <a:rPr lang="en-US" dirty="0"/>
+              <a:t>   – Optimistic concurrency: rejects a write based on an outdated balance, e.g., two tabs withdrawing against the same $1,000 and overdrawing it. Doesn't lock account rows; assumes conflicts are rare.</a:t>
+            </a:r>
+            <a:endParaRPr lang="en-US" dirty="0"/>
+          </a:p>
+          <a:p>
+            <a:endParaRPr lang="en-US" dirty="0"/>
+          </a:p>
+          <a:p>
+            <a:r>
+              <a:rPr lang="en-US" dirty="0"/>
+              <a:t>Every option sits behind the same Application ports, so switching is an Infrastructure-only change.</a:t>
+            </a:r>
+            <a:endParaRPr lang="en-US" dirty="0"/>
+          </a:p>
+          <a:p>
+            <a:r>
+              <a:rPr lang="en-US" dirty="0"/>
+              <a:t>• SQLite in-memory – an in-memory connection string with one connection held open. Keeps EF Core, migrations, transactions, and constraints, but data is lost on restart. The best in-memory choice, e.g., for a demo mode.</a:t>
+            </a:r>
+            <a:endParaRPr lang="en-US" dirty="0"/>
+          </a:p>
+          <a:p>
+            <a:r>
+              <a:rPr lang="en-US" dirty="0"/>
+              <a:t>• Hand-written store – dictionaries behind a single lock. No dependencies, but the code itself must commit balance and history together instead of relying on a database transaction.</a:t>
+            </a:r>
+            <a:endParaRPr lang="en-US" dirty="0"/>
+          </a:p>
+          <a:p>
+            <a:r>
+              <a:rPr lang="en-US" dirty="0"/>
+              <a:t>• EF Core InMemory provider – discouraged by Microsoft. It isn't relational, ignores transactions, and enforces no constraints, so it can't prove the invariants.</a:t>
+            </a:r>
+            <a:endParaRPr lang="en-US" dirty="0"/>
+          </a:p>
+          <a:p>
+            <a:r>
+              <a:rPr lang="en-US" dirty="0"/>
+              <a:t>• Redis – a separate server process to install and run, and atomic transfers need MULTI/EXEC or Lua scripts. More operational machinery than this exercise needs, and still volatile unless its persistence is configured.</a:t>
             </a:r>
             <a:endParaRPr lang="en-US" dirty="0"/>
           </a:p>
@@ -1028,7 +1070,7 @@
           <a:p>
             <a:r>
               <a:rPr lang="en-US" dirty="0"/>
-              <a:t>Domain tests are pure. Application tests use hand-written fakes. Integration and HTTP tests exercise the real host with an isolated SQLite file per test, including concurrency conflicts, atomic rollback, Post/Redirect/Get, security, and accessibility structure. Commands: dotnet restore Atm.sln; dotnet build Atm.sln --no-restore; dotnet test Atm.sln --no-build.</a:t>
+              <a:t>The screenshot is a real rejected overdraft. The typed value stays visible, the error names the available balance, and persisted state is unchanged. Account versions turn stale writes into a safe retry instead of lost data.</a:t>
             </a:r>
             <a:endParaRPr lang="en-US" dirty="0"/>
           </a:p>
@@ -1116,17 +1158,7 @@
           <a:p>
             <a:r>
               <a:rPr lang="en-US" dirty="0"/>
-              <a:t>The omissions are conscious. The roadmap begins with the correctness gap that Post/Redirect/Get does not solve: a retried network request. The phone capture proves the existing presentation adapter already reflows at 380 pixels.</a:t>
-            </a:r>
-            <a:endParaRPr lang="en-US" dirty="0"/>
-          </a:p>
-          <a:p>
-            <a:endParaRPr lang="en-US" dirty="0"/>
-          </a:p>
-          <a:p>
-            <a:r>
-              <a:rPr lang="en-US" dirty="0"/>
-              <a:t>In a real bank, the Domain and Application layers would become a backend service behind an API that every channel (ATM, mobile, web, branch) shares, so the rules live in one place. This ATM would be one thin client. Splitting that backend into microservices becomes worthwhile once separate teams own accounts, transfers, and fraud and need to deploy independently. The inward dependencies here are what make that extraction straightforward.</a:t>
+              <a:t>Domain tests are pure. Application tests use hand-written fakes. Integration and HTTP tests exercise the real host with an isolated SQLite file per test, including concurrency conflicts, atomic rollback, Post/Redirect/Get, security, and accessibility structure. Commands: dotnet restore Atm.sln; dotnet build Atm.sln --no-restore; dotnet test Atm.sln --no-build.</a:t>
             </a:r>
             <a:endParaRPr lang="en-US" dirty="0"/>
           </a:p>
@@ -1150,6 +1182,104 @@
             <a:fld id="{F7021451-1387-4CA6-816F-3879F97B5CBC}" type="slidenum">
               <a:rPr lang="en-US"/>
               <a:t>6</a:t>
+            </a:fld>
+            <a:endParaRPr lang="en-US"/>
+          </a:p>
+        </p:txBody>
+      </p:sp>
+    </p:spTree>
+    <p:extLst>
+      <p:ext uri="{BB962C8B-B14F-4D97-AF65-F5344CB8AC3E}">
+        <p14:creationId xmlns:p14="http://schemas.microsoft.com/office/powerpoint/2010/main" val="1024086991"/>
+      </p:ext>
+    </p:extLst>
+  </p:cSld>
+  <p:clrMapOvr>
+    <a:masterClrMapping/>
+  </p:clrMapOvr>
+</p:notes>
+</file>
+
+<file path=ppt/notesSlides/notesSlide7.xml><?xml version="1.0" encoding="utf-8"?>
+<p:notes xmlns:a="http://schemas.openxmlformats.org/drawingml/2006/main" xmlns:r="http://schemas.openxmlformats.org/officeDocument/2006/relationships" xmlns:p="http://schemas.openxmlformats.org/presentationml/2006/main">
+  <p:cSld>
+    <p:spTree>
+      <p:nvGrpSpPr>
+        <p:cNvPr id="1" name=""/>
+        <p:cNvGrpSpPr/>
+        <p:nvPr/>
+      </p:nvGrpSpPr>
+      <p:grpSpPr>
+        <a:xfrm>
+          <a:off x="0" y="0"/>
+          <a:ext cx="0" cy="0"/>
+          <a:chOff x="0" y="0"/>
+          <a:chExt cx="0" cy="0"/>
+        </a:xfrm>
+      </p:grpSpPr>
+      <p:sp>
+        <p:nvSpPr>
+          <p:cNvPr id="2" name="Slide Image Placeholder 1"/>
+          <p:cNvSpPr>
+            <a:spLocks noGrp="1" noRot="1" noChangeAspect="1"/>
+          </p:cNvSpPr>
+          <p:nvPr>
+            <p:ph type="sldImg"/>
+          </p:nvPr>
+        </p:nvSpPr>
+        <p:spPr/>
+      </p:sp>
+      <p:sp>
+        <p:nvSpPr>
+          <p:cNvPr id="3" name="Notes Placeholder 2"/>
+          <p:cNvSpPr>
+            <a:spLocks noGrp="1"/>
+          </p:cNvSpPr>
+          <p:nvPr>
+            <p:ph type="body" idx="1"/>
+          </p:nvPr>
+        </p:nvSpPr>
+        <p:spPr/>
+        <p:txBody>
+          <a:bodyPr/>
+          <a:lstStyle/>
+          <a:p>
+            <a:r>
+              <a:rPr lang="en-US" dirty="0"/>
+              <a:t>The omissions are conscious. The roadmap begins with the correctness gap that Post/Redirect/Get does not solve: a retried network request. The phone capture proves the existing presentation adapter already reflows at 380 pixels.</a:t>
+            </a:r>
+            <a:endParaRPr lang="en-US" dirty="0"/>
+          </a:p>
+          <a:p>
+            <a:endParaRPr lang="en-US" dirty="0"/>
+          </a:p>
+          <a:p>
+            <a:r>
+              <a:rPr lang="en-US" dirty="0"/>
+              <a:t>In a real bank, the Domain and Application layers would become a backend service behind an API that every channel (ATM, mobile, web, branch) shares, so the rules live in one place. This ATM would be one thin client. Splitting that backend into microservices becomes worthwhile once separate teams own accounts, transfers, and fraud and need to deploy independently. The inward dependencies here are what make that extraction straightforward.</a:t>
+            </a:r>
+            <a:endParaRPr lang="en-US" dirty="0"/>
+          </a:p>
+        </p:txBody>
+      </p:sp>
+      <p:sp>
+        <p:nvSpPr>
+          <p:cNvPr id="4" name="Slide Number Placeholder 3"/>
+          <p:cNvSpPr>
+            <a:spLocks noGrp="1"/>
+          </p:cNvSpPr>
+          <p:nvPr>
+            <p:ph type="sldNum" sz="quarter" idx="10"/>
+          </p:nvPr>
+        </p:nvSpPr>
+        <p:spPr/>
+        <p:txBody>
+          <a:bodyPr/>
+          <a:lstStyle/>
+          <a:p>
+            <a:fld id="{F7021451-1387-4CA6-816F-3879F97B5CBC}" type="slidenum">
+              <a:rPr lang="en-US"/>
+              <a:t>7</a:t>
             </a:fld>
             <a:endParaRPr lang="en-US"/>
           </a:p>
@@ -3298,7 +3428,7 @@
                 <a:ea typeface="Avenir Next" pitchFamily="34" charset="-122"/>
                 <a:cs typeface="Avenir Next" pitchFamily="34" charset="-120"/>
               </a:rPr>
-              <a:t>Failure leaves no partial state</a:t>
+              <a:t>Datastore choice</a:t>
             </a:r>
             <a:endParaRPr lang="en-US" sz="3200" dirty="0"/>
           </a:p>
@@ -3312,8 +3442,8 @@
         </p:nvSpPr>
         <p:spPr>
           <a:xfrm>
-            <a:off x="585216" y="1307592"/>
-            <a:ext cx="411480" cy="274320"/>
+            <a:off x="832104" y="896112"/>
+            <a:ext cx="7726680" cy="237744"/>
           </a:xfrm>
           <a:prstGeom prst="rect">
             <a:avLst/>
@@ -3329,15 +3459,15 @@
               <a:buNone/>
             </a:pPr>
             <a:r>
-              <a:rPr lang="en-US" sz="1300" b="1" dirty="0">
-                <a:solidFill>
-                  <a:srgbClr val="00F604"/>
-                </a:solidFill>
-                <a:latin typeface="Avenir Next" pitchFamily="34" charset="0"/>
-                <a:ea typeface="Avenir Next" pitchFamily="34" charset="-122"/>
-                <a:cs typeface="Avenir Next" pitchFamily="34" charset="-120"/>
-              </a:rPr>
-              <a:t>01</a:t>
+              <a:rPr lang="en-US" sz="1300" dirty="0">
+                <a:solidFill>
+                  <a:srgbClr val="A9ADB3"/>
+                </a:solidFill>
+                <a:latin typeface="Avenir Next" pitchFamily="34" charset="0"/>
+                <a:ea typeface="Avenir Next" pitchFamily="34" charset="-122"/>
+                <a:cs typeface="Avenir Next" pitchFamily="34" charset="-120"/>
+              </a:rPr>
+              <a:t>In-memory would suffice.</a:t>
             </a:r>
             <a:endParaRPr lang="en-US" sz="1300" dirty="0"/>
           </a:p>
@@ -3351,8 +3481,8 @@
         </p:nvSpPr>
         <p:spPr>
           <a:xfrm>
-            <a:off x="1115568" y="1261872"/>
-            <a:ext cx="2743200" cy="512064"/>
+            <a:off x="585216" y="1536192"/>
+            <a:ext cx="1737360" cy="228600"/>
           </a:xfrm>
           <a:prstGeom prst="rect">
             <a:avLst/>
@@ -3370,17 +3500,17 @@
               <a:buNone/>
             </a:pPr>
             <a:r>
-              <a:rPr lang="en-US" sz="2000" b="1" dirty="0">
-                <a:solidFill>
-                  <a:srgbClr val="F5F5F5"/>
-                </a:solidFill>
-                <a:latin typeface="Avenir Next" pitchFamily="34" charset="0"/>
-                <a:ea typeface="Avenir Next" pitchFamily="34" charset="-122"/>
-                <a:cs typeface="Avenir Next" pitchFamily="34" charset="-120"/>
-              </a:rPr>
-              <a:t>Validate before mutation</a:t>
-            </a:r>
-            <a:endParaRPr lang="en-US" sz="2000" dirty="0"/>
+              <a:rPr lang="en-US" sz="1100" b="1" spc="160" kern="0" dirty="0">
+                <a:solidFill>
+                  <a:srgbClr val="00F604"/>
+                </a:solidFill>
+                <a:latin typeface="Avenir Next" pitchFamily="34" charset="0"/>
+                <a:ea typeface="Avenir Next" pitchFamily="34" charset="-122"/>
+                <a:cs typeface="Avenir Next" pitchFamily="34" charset="-120"/>
+              </a:rPr>
+              <a:t>CHOSEN</a:t>
+            </a:r>
+            <a:endParaRPr lang="en-US" sz="1100" dirty="0"/>
           </a:p>
         </p:txBody>
       </p:sp>
@@ -3392,47 +3522,8 @@
         </p:nvSpPr>
         <p:spPr>
           <a:xfrm>
-            <a:off x="585216" y="2313432"/>
-            <a:ext cx="411480" cy="274320"/>
-          </a:xfrm>
-          <a:prstGeom prst="rect">
-            <a:avLst/>
-          </a:prstGeom>
-          <a:noFill/>
-          <a:ln/>
-        </p:spPr>
-        <p:txBody>
-          <a:bodyPr wrap="square" lIns="0" tIns="0" rIns="0" bIns="0" rtlCol="0" anchor="t"/>
-          <a:lstStyle/>
-          <a:p>
-            <a:pPr indent="0" marL="0">
-              <a:buNone/>
-            </a:pPr>
-            <a:r>
-              <a:rPr lang="en-US" sz="1300" b="1" dirty="0">
-                <a:solidFill>
-                  <a:srgbClr val="00F604"/>
-                </a:solidFill>
-                <a:latin typeface="Avenir Next" pitchFamily="34" charset="0"/>
-                <a:ea typeface="Avenir Next" pitchFamily="34" charset="-122"/>
-                <a:cs typeface="Avenir Next" pitchFamily="34" charset="-120"/>
-              </a:rPr>
-              <a:t>02</a:t>
-            </a:r>
-            <a:endParaRPr lang="en-US" sz="1300" dirty="0"/>
-          </a:p>
-        </p:txBody>
-      </p:sp>
-      <p:sp>
-        <p:nvSpPr>
-          <p:cNvPr id="8" name="Text 5"/>
-          <p:cNvSpPr txBox="1"/>
-          <p:nvPr/>
-        </p:nvSpPr>
-        <p:spPr>
-          <a:xfrm>
-            <a:off x="1115568" y="2267712"/>
-            <a:ext cx="2743200" cy="512064"/>
+            <a:off x="2468880" y="1481328"/>
+            <a:ext cx="3017520" cy="329184"/>
           </a:xfrm>
           <a:prstGeom prst="rect">
             <a:avLst/>
@@ -3450,7 +3541,7 @@
               <a:buNone/>
             </a:pPr>
             <a:r>
-              <a:rPr lang="en-US" sz="2000" b="1" dirty="0">
+              <a:rPr lang="en-US" sz="1900" b="1" dirty="0">
                 <a:solidFill>
                   <a:srgbClr val="F5F5F5"/>
                 </a:solidFill>
@@ -3458,61 +3549,22 @@
                 <a:ea typeface="Avenir Next" pitchFamily="34" charset="-122"/>
                 <a:cs typeface="Avenir Next" pitchFamily="34" charset="-120"/>
               </a:rPr>
-              <a:t>Commit balance and history together</a:t>
-            </a:r>
-            <a:endParaRPr lang="en-US" sz="2000" dirty="0"/>
-          </a:p>
-        </p:txBody>
-      </p:sp>
-      <p:sp>
-        <p:nvSpPr>
-          <p:cNvPr id="9" name="Text 6"/>
-          <p:cNvSpPr txBox="1"/>
-          <p:nvPr/>
-        </p:nvSpPr>
-        <p:spPr>
-          <a:xfrm>
-            <a:off x="585216" y="3319272"/>
-            <a:ext cx="411480" cy="274320"/>
-          </a:xfrm>
-          <a:prstGeom prst="rect">
-            <a:avLst/>
-          </a:prstGeom>
-          <a:noFill/>
-          <a:ln/>
-        </p:spPr>
-        <p:txBody>
-          <a:bodyPr wrap="square" lIns="0" tIns="0" rIns="0" bIns="0" rtlCol="0" anchor="t"/>
-          <a:lstStyle/>
-          <a:p>
-            <a:pPr indent="0" marL="0">
-              <a:buNone/>
-            </a:pPr>
-            <a:r>
-              <a:rPr lang="en-US" sz="1300" b="1" dirty="0">
-                <a:solidFill>
-                  <a:srgbClr val="00F604"/>
-                </a:solidFill>
-                <a:latin typeface="Avenir Next" pitchFamily="34" charset="0"/>
-                <a:ea typeface="Avenir Next" pitchFamily="34" charset="-122"/>
-                <a:cs typeface="Avenir Next" pitchFamily="34" charset="-120"/>
-              </a:rPr>
-              <a:t>03</a:t>
-            </a:r>
-            <a:endParaRPr lang="en-US" sz="1300" dirty="0"/>
-          </a:p>
-        </p:txBody>
-      </p:sp>
-      <p:sp>
-        <p:nvSpPr>
-          <p:cNvPr id="10" name="Text 7"/>
-          <p:cNvSpPr txBox="1"/>
-          <p:nvPr/>
-        </p:nvSpPr>
-        <p:spPr>
-          <a:xfrm>
-            <a:off x="1115568" y="3273552"/>
-            <a:ext cx="2743200" cy="512064"/>
+              <a:t>SQLite file</a:t>
+            </a:r>
+            <a:endParaRPr lang="en-US" sz="1900" dirty="0"/>
+          </a:p>
+        </p:txBody>
+      </p:sp>
+      <p:sp>
+        <p:nvSpPr>
+          <p:cNvPr id="8" name="Text 5"/>
+          <p:cNvSpPr txBox="1"/>
+          <p:nvPr/>
+        </p:nvSpPr>
+        <p:spPr>
+          <a:xfrm>
+            <a:off x="5577840" y="1517904"/>
+            <a:ext cx="2980944" cy="292608"/>
           </a:xfrm>
           <a:prstGeom prst="rect">
             <a:avLst/>
@@ -3530,7 +3582,7 @@
               <a:buNone/>
             </a:pPr>
             <a:r>
-              <a:rPr lang="en-US" sz="2000" b="1" dirty="0">
+              <a:rPr lang="en-US" sz="1500" dirty="0">
                 <a:solidFill>
                   <a:srgbClr val="F5F5F5"/>
                 </a:solidFill>
@@ -3538,30 +3590,28 @@
                 <a:ea typeface="Avenir Next" pitchFamily="34" charset="-122"/>
                 <a:cs typeface="Avenir Next" pitchFamily="34" charset="-120"/>
               </a:rPr>
-              <a:t>Reject stale writes</a:t>
-            </a:r>
-            <a:endParaRPr lang="en-US" sz="2000" dirty="0"/>
-          </a:p>
-        </p:txBody>
-      </p:sp>
-      <p:sp>
-        <p:nvSpPr>
-          <p:cNvPr id="11" name="Shape 8"/>
+              <a:t>Survives restarts</a:t>
+            </a:r>
+            <a:endParaRPr lang="en-US" sz="1500" dirty="0"/>
+          </a:p>
+        </p:txBody>
+      </p:sp>
+      <p:sp>
+        <p:nvSpPr>
+          <p:cNvPr id="9" name="Shape 6"/>
           <p:cNvSpPr/>
           <p:nvPr/>
         </p:nvSpPr>
         <p:spPr>
           <a:xfrm>
-            <a:off x="4233672" y="1133856"/>
-            <a:ext cx="4325112" cy="3282696"/>
-          </a:xfrm>
-          <a:prstGeom prst="rect">
-            <a:avLst/>
-          </a:prstGeom>
-          <a:solidFill>
-            <a:srgbClr val="1B1B1B"/>
-          </a:solidFill>
-          <a:ln w="10160">
+            <a:off x="585216" y="1965960"/>
+            <a:ext cx="7973568" cy="0"/>
+          </a:xfrm>
+          <a:prstGeom prst="line">
+            <a:avLst/>
+          </a:prstGeom>
+          <a:noFill/>
+          <a:ln w="9525">
             <a:solidFill>
               <a:srgbClr val="333333"/>
             </a:solidFill>
@@ -3569,40 +3619,16 @@
           </a:ln>
         </p:spPr>
       </p:sp>
-      <p:pic>
-        <p:nvPicPr>
-          <p:cNvPr id="12" name="Image 0" descr="/Users/john/theborg/repos/atm/design/screenshots/overdraft.png">    </p:cNvPr>
-          <p:cNvPicPr>
-            <a:picLocks noChangeAspect="1"/>
-          </p:cNvPicPr>
-          <p:nvPr/>
-        </p:nvPicPr>
-        <p:blipFill>
-          <a:blip r:embed="rId1"/>
-          <a:stretch>
-            <a:fillRect/>
-          </a:stretch>
-        </p:blipFill>
-        <p:spPr>
-          <a:xfrm>
-            <a:off x="4270248" y="1170432"/>
-            <a:ext cx="4251960" cy="3209544"/>
-          </a:xfrm>
-          <a:prstGeom prst="rect">
-            <a:avLst/>
-          </a:prstGeom>
-        </p:spPr>
-      </p:pic>
-      <p:sp>
-        <p:nvSpPr>
-          <p:cNvPr id="13" name="Text 9"/>
-          <p:cNvSpPr txBox="1"/>
-          <p:nvPr/>
-        </p:nvSpPr>
-        <p:spPr>
-          <a:xfrm>
-            <a:off x="4233672" y="4489704"/>
-            <a:ext cx="4325112" cy="201168"/>
+      <p:sp>
+        <p:nvSpPr>
+          <p:cNvPr id="10" name="Text 7"/>
+          <p:cNvSpPr txBox="1"/>
+          <p:nvPr/>
+        </p:nvSpPr>
+        <p:spPr>
+          <a:xfrm>
+            <a:off x="585216" y="2176272"/>
+            <a:ext cx="1737360" cy="228600"/>
           </a:xfrm>
           <a:prstGeom prst="rect">
             <a:avLst/>
@@ -3616,21 +3642,418 @@
           </a:bodyPr>
           <a:lstStyle/>
           <a:p>
-            <a:pPr algn="r" indent="0" marL="0">
-              <a:buNone/>
-            </a:pPr>
-            <a:r>
-              <a:rPr lang="en-US" sz="1150" b="1" dirty="0">
-                <a:solidFill>
-                  <a:srgbClr val="00F604"/>
-                </a:solidFill>
-                <a:latin typeface="Avenir Next" pitchFamily="34" charset="0"/>
-                <a:ea typeface="Avenir Next" pitchFamily="34" charset="-122"/>
-                <a:cs typeface="Avenir Next" pitchFamily="34" charset="-120"/>
-              </a:rPr>
-              <a:t>Rejected overdraft. Persisted state stays unchanged.</a:t>
-            </a:r>
-            <a:endParaRPr lang="en-US" sz="1150" dirty="0"/>
+            <a:pPr indent="0" marL="0">
+              <a:buNone/>
+            </a:pPr>
+            <a:r>
+              <a:rPr lang="en-US" sz="1100" b="1" spc="160" kern="0" dirty="0">
+                <a:solidFill>
+                  <a:srgbClr val="F67F00"/>
+                </a:solidFill>
+                <a:latin typeface="Avenir Next" pitchFamily="34" charset="0"/>
+                <a:ea typeface="Avenir Next" pitchFamily="34" charset="-122"/>
+                <a:cs typeface="Avenir Next" pitchFamily="34" charset="-120"/>
+              </a:rPr>
+              <a:t>CONSIDERED</a:t>
+            </a:r>
+            <a:endParaRPr lang="en-US" sz="1100" dirty="0"/>
+          </a:p>
+        </p:txBody>
+      </p:sp>
+      <p:sp>
+        <p:nvSpPr>
+          <p:cNvPr id="11" name="Text 8"/>
+          <p:cNvSpPr txBox="1"/>
+          <p:nvPr/>
+        </p:nvSpPr>
+        <p:spPr>
+          <a:xfrm>
+            <a:off x="2468880" y="2121408"/>
+            <a:ext cx="3017520" cy="329184"/>
+          </a:xfrm>
+          <a:prstGeom prst="rect">
+            <a:avLst/>
+          </a:prstGeom>
+          <a:noFill/>
+          <a:ln/>
+        </p:spPr>
+        <p:txBody>
+          <a:bodyPr wrap="square" lIns="0" tIns="0" rIns="0" bIns="0" rtlCol="0" anchor="t">
+            <a:normAutofit/>
+          </a:bodyPr>
+          <a:lstStyle/>
+          <a:p>
+            <a:pPr indent="0" marL="0">
+              <a:buNone/>
+            </a:pPr>
+            <a:r>
+              <a:rPr lang="en-US" sz="1900" b="1" dirty="0">
+                <a:solidFill>
+                  <a:srgbClr val="F5F5F5"/>
+                </a:solidFill>
+                <a:latin typeface="Avenir Next" pitchFamily="34" charset="0"/>
+                <a:ea typeface="Avenir Next" pitchFamily="34" charset="-122"/>
+                <a:cs typeface="Avenir Next" pitchFamily="34" charset="-120"/>
+              </a:rPr>
+              <a:t>SQLite in-memory</a:t>
+            </a:r>
+            <a:endParaRPr lang="en-US" sz="1900" dirty="0"/>
+          </a:p>
+        </p:txBody>
+      </p:sp>
+      <p:sp>
+        <p:nvSpPr>
+          <p:cNvPr id="12" name="Text 9"/>
+          <p:cNvSpPr txBox="1"/>
+          <p:nvPr/>
+        </p:nvSpPr>
+        <p:spPr>
+          <a:xfrm>
+            <a:off x="5577840" y="2157984"/>
+            <a:ext cx="2980944" cy="292608"/>
+          </a:xfrm>
+          <a:prstGeom prst="rect">
+            <a:avLst/>
+          </a:prstGeom>
+          <a:noFill/>
+          <a:ln/>
+        </p:spPr>
+        <p:txBody>
+          <a:bodyPr wrap="square" lIns="0" tIns="0" rIns="0" bIns="0" rtlCol="0" anchor="t">
+            <a:normAutofit/>
+          </a:bodyPr>
+          <a:lstStyle/>
+          <a:p>
+            <a:pPr indent="0" marL="0">
+              <a:buNone/>
+            </a:pPr>
+            <a:r>
+              <a:rPr lang="en-US" sz="1500" dirty="0">
+                <a:solidFill>
+                  <a:srgbClr val="A9ADB3"/>
+                </a:solidFill>
+                <a:latin typeface="Avenir Next" pitchFamily="34" charset="0"/>
+                <a:ea typeface="Avenir Next" pitchFamily="34" charset="-122"/>
+                <a:cs typeface="Avenir Next" pitchFamily="34" charset="-120"/>
+              </a:rPr>
+              <a:t>Lost on restart</a:t>
+            </a:r>
+            <a:endParaRPr lang="en-US" sz="1500" dirty="0"/>
+          </a:p>
+        </p:txBody>
+      </p:sp>
+      <p:sp>
+        <p:nvSpPr>
+          <p:cNvPr id="13" name="Shape 10"/>
+          <p:cNvSpPr/>
+          <p:nvPr/>
+        </p:nvSpPr>
+        <p:spPr>
+          <a:xfrm>
+            <a:off x="585216" y="2606040"/>
+            <a:ext cx="7973568" cy="0"/>
+          </a:xfrm>
+          <a:prstGeom prst="line">
+            <a:avLst/>
+          </a:prstGeom>
+          <a:noFill/>
+          <a:ln w="9525">
+            <a:solidFill>
+              <a:srgbClr val="333333"/>
+            </a:solidFill>
+            <a:prstDash val="solid"/>
+          </a:ln>
+        </p:spPr>
+      </p:sp>
+      <p:sp>
+        <p:nvSpPr>
+          <p:cNvPr id="14" name="Text 11"/>
+          <p:cNvSpPr txBox="1"/>
+          <p:nvPr/>
+        </p:nvSpPr>
+        <p:spPr>
+          <a:xfrm>
+            <a:off x="2468880" y="2761488"/>
+            <a:ext cx="3017520" cy="329184"/>
+          </a:xfrm>
+          <a:prstGeom prst="rect">
+            <a:avLst/>
+          </a:prstGeom>
+          <a:noFill/>
+          <a:ln/>
+        </p:spPr>
+        <p:txBody>
+          <a:bodyPr wrap="square" lIns="0" tIns="0" rIns="0" bIns="0" rtlCol="0" anchor="t">
+            <a:normAutofit/>
+          </a:bodyPr>
+          <a:lstStyle/>
+          <a:p>
+            <a:pPr indent="0" marL="0">
+              <a:buNone/>
+            </a:pPr>
+            <a:r>
+              <a:rPr lang="en-US" sz="1900" b="1" dirty="0">
+                <a:solidFill>
+                  <a:srgbClr val="F5F5F5"/>
+                </a:solidFill>
+                <a:latin typeface="Avenir Next" pitchFamily="34" charset="0"/>
+                <a:ea typeface="Avenir Next" pitchFamily="34" charset="-122"/>
+                <a:cs typeface="Avenir Next" pitchFamily="34" charset="-120"/>
+              </a:rPr>
+              <a:t>Hand-written store</a:t>
+            </a:r>
+            <a:endParaRPr lang="en-US" sz="1900" dirty="0"/>
+          </a:p>
+        </p:txBody>
+      </p:sp>
+      <p:sp>
+        <p:nvSpPr>
+          <p:cNvPr id="15" name="Text 12"/>
+          <p:cNvSpPr txBox="1"/>
+          <p:nvPr/>
+        </p:nvSpPr>
+        <p:spPr>
+          <a:xfrm>
+            <a:off x="5577840" y="2798064"/>
+            <a:ext cx="2980944" cy="292608"/>
+          </a:xfrm>
+          <a:prstGeom prst="rect">
+            <a:avLst/>
+          </a:prstGeom>
+          <a:noFill/>
+          <a:ln/>
+        </p:spPr>
+        <p:txBody>
+          <a:bodyPr wrap="square" lIns="0" tIns="0" rIns="0" bIns="0" rtlCol="0" anchor="t">
+            <a:normAutofit/>
+          </a:bodyPr>
+          <a:lstStyle/>
+          <a:p>
+            <a:pPr indent="0" marL="0">
+              <a:buNone/>
+            </a:pPr>
+            <a:r>
+              <a:rPr lang="en-US" sz="1500" dirty="0">
+                <a:solidFill>
+                  <a:srgbClr val="A9ADB3"/>
+                </a:solidFill>
+                <a:latin typeface="Avenir Next" pitchFamily="34" charset="0"/>
+                <a:ea typeface="Avenir Next" pitchFamily="34" charset="-122"/>
+                <a:cs typeface="Avenir Next" pitchFamily="34" charset="-120"/>
+              </a:rPr>
+              <a:t>Owns atomicity</a:t>
+            </a:r>
+            <a:endParaRPr lang="en-US" sz="1500" dirty="0"/>
+          </a:p>
+        </p:txBody>
+      </p:sp>
+      <p:sp>
+        <p:nvSpPr>
+          <p:cNvPr id="16" name="Shape 13"/>
+          <p:cNvSpPr/>
+          <p:nvPr/>
+        </p:nvSpPr>
+        <p:spPr>
+          <a:xfrm>
+            <a:off x="585216" y="3246120"/>
+            <a:ext cx="7973568" cy="0"/>
+          </a:xfrm>
+          <a:prstGeom prst="line">
+            <a:avLst/>
+          </a:prstGeom>
+          <a:noFill/>
+          <a:ln w="9525">
+            <a:solidFill>
+              <a:srgbClr val="333333"/>
+            </a:solidFill>
+            <a:prstDash val="solid"/>
+          </a:ln>
+        </p:spPr>
+      </p:sp>
+      <p:sp>
+        <p:nvSpPr>
+          <p:cNvPr id="17" name="Text 14"/>
+          <p:cNvSpPr txBox="1"/>
+          <p:nvPr/>
+        </p:nvSpPr>
+        <p:spPr>
+          <a:xfrm>
+            <a:off x="2468880" y="3401568"/>
+            <a:ext cx="3017520" cy="329184"/>
+          </a:xfrm>
+          <a:prstGeom prst="rect">
+            <a:avLst/>
+          </a:prstGeom>
+          <a:noFill/>
+          <a:ln/>
+        </p:spPr>
+        <p:txBody>
+          <a:bodyPr wrap="square" lIns="0" tIns="0" rIns="0" bIns="0" rtlCol="0" anchor="t">
+            <a:normAutofit/>
+          </a:bodyPr>
+          <a:lstStyle/>
+          <a:p>
+            <a:pPr indent="0" marL="0">
+              <a:buNone/>
+            </a:pPr>
+            <a:r>
+              <a:rPr lang="en-US" sz="1900" b="1" dirty="0">
+                <a:solidFill>
+                  <a:srgbClr val="F5F5F5"/>
+                </a:solidFill>
+                <a:latin typeface="Avenir Next" pitchFamily="34" charset="0"/>
+                <a:ea typeface="Avenir Next" pitchFamily="34" charset="-122"/>
+                <a:cs typeface="Avenir Next" pitchFamily="34" charset="-120"/>
+              </a:rPr>
+              <a:t>EF Core InMemory</a:t>
+            </a:r>
+            <a:endParaRPr lang="en-US" sz="1900" dirty="0"/>
+          </a:p>
+        </p:txBody>
+      </p:sp>
+      <p:sp>
+        <p:nvSpPr>
+          <p:cNvPr id="18" name="Text 15"/>
+          <p:cNvSpPr txBox="1"/>
+          <p:nvPr/>
+        </p:nvSpPr>
+        <p:spPr>
+          <a:xfrm>
+            <a:off x="5577840" y="3438144"/>
+            <a:ext cx="2980944" cy="292608"/>
+          </a:xfrm>
+          <a:prstGeom prst="rect">
+            <a:avLst/>
+          </a:prstGeom>
+          <a:noFill/>
+          <a:ln/>
+        </p:spPr>
+        <p:txBody>
+          <a:bodyPr wrap="square" lIns="0" tIns="0" rIns="0" bIns="0" rtlCol="0" anchor="t">
+            <a:normAutofit/>
+          </a:bodyPr>
+          <a:lstStyle/>
+          <a:p>
+            <a:pPr indent="0" marL="0">
+              <a:buNone/>
+            </a:pPr>
+            <a:r>
+              <a:rPr lang="en-US" sz="1500" dirty="0">
+                <a:solidFill>
+                  <a:srgbClr val="A9ADB3"/>
+                </a:solidFill>
+                <a:latin typeface="Avenir Next" pitchFamily="34" charset="0"/>
+                <a:ea typeface="Avenir Next" pitchFamily="34" charset="-122"/>
+                <a:cs typeface="Avenir Next" pitchFamily="34" charset="-120"/>
+              </a:rPr>
+              <a:t>No transactions</a:t>
+            </a:r>
+            <a:endParaRPr lang="en-US" sz="1500" dirty="0"/>
+          </a:p>
+        </p:txBody>
+      </p:sp>
+      <p:sp>
+        <p:nvSpPr>
+          <p:cNvPr id="19" name="Shape 16"/>
+          <p:cNvSpPr/>
+          <p:nvPr/>
+        </p:nvSpPr>
+        <p:spPr>
+          <a:xfrm>
+            <a:off x="585216" y="3886200"/>
+            <a:ext cx="7973568" cy="0"/>
+          </a:xfrm>
+          <a:prstGeom prst="line">
+            <a:avLst/>
+          </a:prstGeom>
+          <a:noFill/>
+          <a:ln w="9525">
+            <a:solidFill>
+              <a:srgbClr val="333333"/>
+            </a:solidFill>
+            <a:prstDash val="solid"/>
+          </a:ln>
+        </p:spPr>
+      </p:sp>
+      <p:sp>
+        <p:nvSpPr>
+          <p:cNvPr id="20" name="Text 17"/>
+          <p:cNvSpPr txBox="1"/>
+          <p:nvPr/>
+        </p:nvSpPr>
+        <p:spPr>
+          <a:xfrm>
+            <a:off x="2468880" y="4041648"/>
+            <a:ext cx="3017520" cy="329184"/>
+          </a:xfrm>
+          <a:prstGeom prst="rect">
+            <a:avLst/>
+          </a:prstGeom>
+          <a:noFill/>
+          <a:ln/>
+        </p:spPr>
+        <p:txBody>
+          <a:bodyPr wrap="square" lIns="0" tIns="0" rIns="0" bIns="0" rtlCol="0" anchor="t">
+            <a:normAutofit/>
+          </a:bodyPr>
+          <a:lstStyle/>
+          <a:p>
+            <a:pPr indent="0" marL="0">
+              <a:buNone/>
+            </a:pPr>
+            <a:r>
+              <a:rPr lang="en-US" sz="1900" b="1" dirty="0">
+                <a:solidFill>
+                  <a:srgbClr val="F5F5F5"/>
+                </a:solidFill>
+                <a:latin typeface="Avenir Next" pitchFamily="34" charset="0"/>
+                <a:ea typeface="Avenir Next" pitchFamily="34" charset="-122"/>
+                <a:cs typeface="Avenir Next" pitchFamily="34" charset="-120"/>
+              </a:rPr>
+              <a:t>Redis</a:t>
+            </a:r>
+            <a:endParaRPr lang="en-US" sz="1900" dirty="0"/>
+          </a:p>
+        </p:txBody>
+      </p:sp>
+      <p:sp>
+        <p:nvSpPr>
+          <p:cNvPr id="21" name="Text 18"/>
+          <p:cNvSpPr txBox="1"/>
+          <p:nvPr/>
+        </p:nvSpPr>
+        <p:spPr>
+          <a:xfrm>
+            <a:off x="5577840" y="4078224"/>
+            <a:ext cx="2980944" cy="292608"/>
+          </a:xfrm>
+          <a:prstGeom prst="rect">
+            <a:avLst/>
+          </a:prstGeom>
+          <a:noFill/>
+          <a:ln/>
+        </p:spPr>
+        <p:txBody>
+          <a:bodyPr wrap="square" lIns="0" tIns="0" rIns="0" bIns="0" rtlCol="0" anchor="t">
+            <a:normAutofit/>
+          </a:bodyPr>
+          <a:lstStyle/>
+          <a:p>
+            <a:pPr indent="0" marL="0">
+              <a:buNone/>
+            </a:pPr>
+            <a:r>
+              <a:rPr lang="en-US" sz="1500" dirty="0">
+                <a:solidFill>
+                  <a:srgbClr val="A9ADB3"/>
+                </a:solidFill>
+                <a:latin typeface="Avenir Next" pitchFamily="34" charset="0"/>
+                <a:ea typeface="Avenir Next" pitchFamily="34" charset="-122"/>
+                <a:cs typeface="Avenir Next" pitchFamily="34" charset="-120"/>
+              </a:rPr>
+              <a:t>Extra process</a:t>
+            </a:r>
+            <a:endParaRPr lang="en-US" sz="1500" dirty="0"/>
           </a:p>
         </p:txBody>
       </p:sp>
@@ -3728,7 +4151,7 @@
                 <a:ea typeface="Avenir Next" pitchFamily="34" charset="-122"/>
                 <a:cs typeface="Avenir Next" pitchFamily="34" charset="-120"/>
               </a:rPr>
-              <a:t>143 tests by layer</a:t>
+              <a:t>Failure leaves no partial state</a:t>
             </a:r>
             <a:endParaRPr lang="en-US" sz="3200" dirty="0"/>
           </a:p>
@@ -3742,8 +4165,8 @@
         </p:nvSpPr>
         <p:spPr>
           <a:xfrm>
-            <a:off x="585216" y="1225296"/>
-            <a:ext cx="841248" cy="475488"/>
+            <a:off x="585216" y="1307592"/>
+            <a:ext cx="411480" cy="274320"/>
           </a:xfrm>
           <a:prstGeom prst="rect">
             <a:avLst/>
@@ -3759,7 +4182,7 @@
               <a:buNone/>
             </a:pPr>
             <a:r>
-              <a:rPr lang="en-US" sz="3400" b="1" dirty="0">
+              <a:rPr lang="en-US" sz="1300" b="1" dirty="0">
                 <a:solidFill>
                   <a:srgbClr val="00F604"/>
                 </a:solidFill>
@@ -3767,9 +4190,9 @@
                 <a:ea typeface="Avenir Next" pitchFamily="34" charset="-122"/>
                 <a:cs typeface="Avenir Next" pitchFamily="34" charset="-120"/>
               </a:rPr>
-              <a:t>75</a:t>
-            </a:r>
-            <a:endParaRPr lang="en-US" sz="3400" dirty="0"/>
+              <a:t>01</a:t>
+            </a:r>
+            <a:endParaRPr lang="en-US" sz="1300" dirty="0"/>
           </a:p>
         </p:txBody>
       </p:sp>
@@ -3781,8 +4204,8 @@
         </p:nvSpPr>
         <p:spPr>
           <a:xfrm>
-            <a:off x="1508760" y="1243584"/>
-            <a:ext cx="2075688" cy="256032"/>
+            <a:off x="1115568" y="1261872"/>
+            <a:ext cx="2743200" cy="512064"/>
           </a:xfrm>
           <a:prstGeom prst="rect">
             <a:avLst/>
@@ -3800,7 +4223,7 @@
               <a:buNone/>
             </a:pPr>
             <a:r>
-              <a:rPr lang="en-US" sz="1600" b="1" dirty="0">
+              <a:rPr lang="en-US" sz="2000" b="1" dirty="0">
                 <a:solidFill>
                   <a:srgbClr val="F5F5F5"/>
                 </a:solidFill>
@@ -3808,9 +4231,9 @@
                 <a:ea typeface="Avenir Next" pitchFamily="34" charset="-122"/>
                 <a:cs typeface="Avenir Next" pitchFamily="34" charset="-120"/>
               </a:rPr>
-              <a:t>Domain</a:t>
-            </a:r>
-            <a:endParaRPr lang="en-US" sz="1600" dirty="0"/>
+              <a:t>Validate before mutation</a:t>
+            </a:r>
+            <a:endParaRPr lang="en-US" sz="2000" dirty="0"/>
           </a:p>
         </p:txBody>
       </p:sp>
@@ -3822,8 +4245,47 @@
         </p:nvSpPr>
         <p:spPr>
           <a:xfrm>
-            <a:off x="1508760" y="1572768"/>
-            <a:ext cx="2075688" cy="219456"/>
+            <a:off x="585216" y="2313432"/>
+            <a:ext cx="411480" cy="274320"/>
+          </a:xfrm>
+          <a:prstGeom prst="rect">
+            <a:avLst/>
+          </a:prstGeom>
+          <a:noFill/>
+          <a:ln/>
+        </p:spPr>
+        <p:txBody>
+          <a:bodyPr wrap="square" lIns="0" tIns="0" rIns="0" bIns="0" rtlCol="0" anchor="t"/>
+          <a:lstStyle/>
+          <a:p>
+            <a:pPr indent="0" marL="0">
+              <a:buNone/>
+            </a:pPr>
+            <a:r>
+              <a:rPr lang="en-US" sz="1300" b="1" dirty="0">
+                <a:solidFill>
+                  <a:srgbClr val="00F604"/>
+                </a:solidFill>
+                <a:latin typeface="Avenir Next" pitchFamily="34" charset="0"/>
+                <a:ea typeface="Avenir Next" pitchFamily="34" charset="-122"/>
+                <a:cs typeface="Avenir Next" pitchFamily="34" charset="-120"/>
+              </a:rPr>
+              <a:t>02</a:t>
+            </a:r>
+            <a:endParaRPr lang="en-US" sz="1300" dirty="0"/>
+          </a:p>
+        </p:txBody>
+      </p:sp>
+      <p:sp>
+        <p:nvSpPr>
+          <p:cNvPr id="8" name="Text 5"/>
+          <p:cNvSpPr txBox="1"/>
+          <p:nvPr/>
+        </p:nvSpPr>
+        <p:spPr>
+          <a:xfrm>
+            <a:off x="1115568" y="2267712"/>
+            <a:ext cx="2743200" cy="512064"/>
           </a:xfrm>
           <a:prstGeom prst="rect">
             <a:avLst/>
@@ -3841,30 +4303,30 @@
               <a:buNone/>
             </a:pPr>
             <a:r>
-              <a:rPr lang="en-US" sz="1200" dirty="0">
-                <a:solidFill>
-                  <a:srgbClr val="A9ADB3"/>
-                </a:solidFill>
-                <a:latin typeface="Avenir Next" pitchFamily="34" charset="0"/>
-                <a:ea typeface="Avenir Next" pitchFamily="34" charset="-122"/>
-                <a:cs typeface="Avenir Next" pitchFamily="34" charset="-120"/>
-              </a:rPr>
-              <a:t>Invariants</a:t>
-            </a:r>
-            <a:endParaRPr lang="en-US" sz="1200" dirty="0"/>
-          </a:p>
-        </p:txBody>
-      </p:sp>
-      <p:sp>
-        <p:nvSpPr>
-          <p:cNvPr id="8" name="Text 5"/>
-          <p:cNvSpPr txBox="1"/>
-          <p:nvPr/>
-        </p:nvSpPr>
-        <p:spPr>
-          <a:xfrm>
-            <a:off x="585216" y="2203704"/>
-            <a:ext cx="841248" cy="475488"/>
+              <a:rPr lang="en-US" sz="2000" b="1" dirty="0">
+                <a:solidFill>
+                  <a:srgbClr val="F5F5F5"/>
+                </a:solidFill>
+                <a:latin typeface="Avenir Next" pitchFamily="34" charset="0"/>
+                <a:ea typeface="Avenir Next" pitchFamily="34" charset="-122"/>
+                <a:cs typeface="Avenir Next" pitchFamily="34" charset="-120"/>
+              </a:rPr>
+              <a:t>Commit balance and history together</a:t>
+            </a:r>
+            <a:endParaRPr lang="en-US" sz="2000" dirty="0"/>
+          </a:p>
+        </p:txBody>
+      </p:sp>
+      <p:sp>
+        <p:nvSpPr>
+          <p:cNvPr id="9" name="Text 6"/>
+          <p:cNvSpPr txBox="1"/>
+          <p:nvPr/>
+        </p:nvSpPr>
+        <p:spPr>
+          <a:xfrm>
+            <a:off x="585216" y="3319272"/>
+            <a:ext cx="411480" cy="274320"/>
           </a:xfrm>
           <a:prstGeom prst="rect">
             <a:avLst/>
@@ -3880,7 +4342,7 @@
               <a:buNone/>
             </a:pPr>
             <a:r>
-              <a:rPr lang="en-US" sz="3400" b="1" dirty="0">
+              <a:rPr lang="en-US" sz="1300" b="1" dirty="0">
                 <a:solidFill>
                   <a:srgbClr val="00F604"/>
                 </a:solidFill>
@@ -3888,22 +4350,22 @@
                 <a:ea typeface="Avenir Next" pitchFamily="34" charset="-122"/>
                 <a:cs typeface="Avenir Next" pitchFamily="34" charset="-120"/>
               </a:rPr>
-              <a:t>33</a:t>
-            </a:r>
-            <a:endParaRPr lang="en-US" sz="3400" dirty="0"/>
-          </a:p>
-        </p:txBody>
-      </p:sp>
-      <p:sp>
-        <p:nvSpPr>
-          <p:cNvPr id="9" name="Text 6"/>
-          <p:cNvSpPr txBox="1"/>
-          <p:nvPr/>
-        </p:nvSpPr>
-        <p:spPr>
-          <a:xfrm>
-            <a:off x="1508760" y="2221992"/>
-            <a:ext cx="2075688" cy="256032"/>
+              <a:t>03</a:t>
+            </a:r>
+            <a:endParaRPr lang="en-US" sz="1300" dirty="0"/>
+          </a:p>
+        </p:txBody>
+      </p:sp>
+      <p:sp>
+        <p:nvSpPr>
+          <p:cNvPr id="10" name="Text 7"/>
+          <p:cNvSpPr txBox="1"/>
+          <p:nvPr/>
+        </p:nvSpPr>
+        <p:spPr>
+          <a:xfrm>
+            <a:off x="1115568" y="3273552"/>
+            <a:ext cx="2743200" cy="512064"/>
           </a:xfrm>
           <a:prstGeom prst="rect">
             <a:avLst/>
@@ -3921,7 +4383,7 @@
               <a:buNone/>
             </a:pPr>
             <a:r>
-              <a:rPr lang="en-US" sz="1600" b="1" dirty="0">
+              <a:rPr lang="en-US" sz="2000" b="1" dirty="0">
                 <a:solidFill>
                   <a:srgbClr val="F5F5F5"/>
                 </a:solidFill>
@@ -3929,184 +4391,22 @@
                 <a:ea typeface="Avenir Next" pitchFamily="34" charset="-122"/>
                 <a:cs typeface="Avenir Next" pitchFamily="34" charset="-120"/>
               </a:rPr>
-              <a:t>Application</a:t>
-            </a:r>
-            <a:endParaRPr lang="en-US" sz="1600" dirty="0"/>
-          </a:p>
-        </p:txBody>
-      </p:sp>
-      <p:sp>
-        <p:nvSpPr>
-          <p:cNvPr id="10" name="Text 7"/>
-          <p:cNvSpPr txBox="1"/>
-          <p:nvPr/>
-        </p:nvSpPr>
-        <p:spPr>
-          <a:xfrm>
-            <a:off x="1508760" y="2551176"/>
-            <a:ext cx="2075688" cy="219456"/>
-          </a:xfrm>
-          <a:prstGeom prst="rect">
-            <a:avLst/>
-          </a:prstGeom>
-          <a:noFill/>
-          <a:ln/>
-        </p:spPr>
-        <p:txBody>
-          <a:bodyPr wrap="square" lIns="0" tIns="0" rIns="0" bIns="0" rtlCol="0" anchor="t">
-            <a:normAutofit/>
-          </a:bodyPr>
-          <a:lstStyle/>
-          <a:p>
-            <a:pPr indent="0" marL="0">
-              <a:buNone/>
-            </a:pPr>
-            <a:r>
-              <a:rPr lang="en-US" sz="1200" dirty="0">
-                <a:solidFill>
-                  <a:srgbClr val="A9ADB3"/>
-                </a:solidFill>
-                <a:latin typeface="Avenir Next" pitchFamily="34" charset="0"/>
-                <a:ea typeface="Avenir Next" pitchFamily="34" charset="-122"/>
-                <a:cs typeface="Avenir Next" pitchFamily="34" charset="-120"/>
-              </a:rPr>
-              <a:t>Orchestration</a:t>
-            </a:r>
-            <a:endParaRPr lang="en-US" sz="1200" dirty="0"/>
-          </a:p>
-        </p:txBody>
-      </p:sp>
-      <p:sp>
-        <p:nvSpPr>
-          <p:cNvPr id="11" name="Text 8"/>
-          <p:cNvSpPr txBox="1"/>
-          <p:nvPr/>
-        </p:nvSpPr>
-        <p:spPr>
-          <a:xfrm>
-            <a:off x="585216" y="3182112"/>
-            <a:ext cx="841248" cy="475488"/>
-          </a:xfrm>
-          <a:prstGeom prst="rect">
-            <a:avLst/>
-          </a:prstGeom>
-          <a:noFill/>
-          <a:ln/>
-        </p:spPr>
-        <p:txBody>
-          <a:bodyPr wrap="square" lIns="0" tIns="0" rIns="0" bIns="0" rtlCol="0" anchor="t"/>
-          <a:lstStyle/>
-          <a:p>
-            <a:pPr indent="0" marL="0">
-              <a:buNone/>
-            </a:pPr>
-            <a:r>
-              <a:rPr lang="en-US" sz="3400" b="1" dirty="0">
-                <a:solidFill>
-                  <a:srgbClr val="00F604"/>
-                </a:solidFill>
-                <a:latin typeface="Avenir Next" pitchFamily="34" charset="0"/>
-                <a:ea typeface="Avenir Next" pitchFamily="34" charset="-122"/>
-                <a:cs typeface="Avenir Next" pitchFamily="34" charset="-120"/>
-              </a:rPr>
-              <a:t>35</a:t>
-            </a:r>
-            <a:endParaRPr lang="en-US" sz="3400" dirty="0"/>
-          </a:p>
-        </p:txBody>
-      </p:sp>
-      <p:sp>
-        <p:nvSpPr>
-          <p:cNvPr id="12" name="Text 9"/>
-          <p:cNvSpPr txBox="1"/>
-          <p:nvPr/>
-        </p:nvSpPr>
-        <p:spPr>
-          <a:xfrm>
-            <a:off x="1508760" y="3200400"/>
-            <a:ext cx="2075688" cy="256032"/>
-          </a:xfrm>
-          <a:prstGeom prst="rect">
-            <a:avLst/>
-          </a:prstGeom>
-          <a:noFill/>
-          <a:ln/>
-        </p:spPr>
-        <p:txBody>
-          <a:bodyPr wrap="square" lIns="0" tIns="0" rIns="0" bIns="0" rtlCol="0" anchor="t">
-            <a:normAutofit/>
-          </a:bodyPr>
-          <a:lstStyle/>
-          <a:p>
-            <a:pPr indent="0" marL="0">
-              <a:buNone/>
-            </a:pPr>
-            <a:r>
-              <a:rPr lang="en-US" sz="1600" b="1" dirty="0">
-                <a:solidFill>
-                  <a:srgbClr val="F5F5F5"/>
-                </a:solidFill>
-                <a:latin typeface="Avenir Next" pitchFamily="34" charset="0"/>
-                <a:ea typeface="Avenir Next" pitchFamily="34" charset="-122"/>
-                <a:cs typeface="Avenir Next" pitchFamily="34" charset="-120"/>
-              </a:rPr>
-              <a:t>Integration + HTTP</a:t>
-            </a:r>
-            <a:endParaRPr lang="en-US" sz="1600" dirty="0"/>
-          </a:p>
-        </p:txBody>
-      </p:sp>
-      <p:sp>
-        <p:nvSpPr>
-          <p:cNvPr id="13" name="Text 10"/>
-          <p:cNvSpPr txBox="1"/>
-          <p:nvPr/>
-        </p:nvSpPr>
-        <p:spPr>
-          <a:xfrm>
-            <a:off x="1508760" y="3529584"/>
-            <a:ext cx="2075688" cy="219456"/>
-          </a:xfrm>
-          <a:prstGeom prst="rect">
-            <a:avLst/>
-          </a:prstGeom>
-          <a:noFill/>
-          <a:ln/>
-        </p:spPr>
-        <p:txBody>
-          <a:bodyPr wrap="square" lIns="0" tIns="0" rIns="0" bIns="0" rtlCol="0" anchor="t">
-            <a:normAutofit/>
-          </a:bodyPr>
-          <a:lstStyle/>
-          <a:p>
-            <a:pPr indent="0" marL="0">
-              <a:buNone/>
-            </a:pPr>
-            <a:r>
-              <a:rPr lang="en-US" sz="1200" dirty="0">
-                <a:solidFill>
-                  <a:srgbClr val="A9ADB3"/>
-                </a:solidFill>
-                <a:latin typeface="Avenir Next" pitchFamily="34" charset="0"/>
-                <a:ea typeface="Avenir Next" pitchFamily="34" charset="-122"/>
-                <a:cs typeface="Avenir Next" pitchFamily="34" charset="-120"/>
-              </a:rPr>
-              <a:t>Persistence and HTTP</a:t>
-            </a:r>
-            <a:endParaRPr lang="en-US" sz="1200" dirty="0"/>
-          </a:p>
-        </p:txBody>
-      </p:sp>
-      <p:sp>
-        <p:nvSpPr>
-          <p:cNvPr id="14" name="Shape 11"/>
+              <a:t>Reject stale writes</a:t>
+            </a:r>
+            <a:endParaRPr lang="en-US" sz="2000" dirty="0"/>
+          </a:p>
+        </p:txBody>
+      </p:sp>
+      <p:sp>
+        <p:nvSpPr>
+          <p:cNvPr id="11" name="Shape 8"/>
           <p:cNvSpPr/>
           <p:nvPr/>
         </p:nvSpPr>
         <p:spPr>
           <a:xfrm>
-            <a:off x="4800600" y="1115568"/>
-            <a:ext cx="3758184" cy="2926080"/>
+            <a:off x="4233672" y="1133856"/>
+            <a:ext cx="4325112" cy="3282696"/>
           </a:xfrm>
           <a:prstGeom prst="rect">
             <a:avLst/>
@@ -4124,7 +4424,7 @@
       </p:sp>
       <p:pic>
         <p:nvPicPr>
-          <p:cNvPr id="15" name="Image 0" descr="/Users/john/theborg/repos/atm/design/screenshots/receipt.png">    </p:cNvPr>
+          <p:cNvPr id="12" name="Image 0" descr="/Users/john/theborg/repos/atm/design/screenshots/overdraft.png">    </p:cNvPr>
           <p:cNvPicPr>
             <a:picLocks noChangeAspect="1"/>
           </p:cNvPicPr>
@@ -4138,8 +4438,8 @@
         </p:blipFill>
         <p:spPr>
           <a:xfrm>
-            <a:off x="4837176" y="1152144"/>
-            <a:ext cx="3685032" cy="2852928"/>
+            <a:off x="4270248" y="1170432"/>
+            <a:ext cx="4251960" cy="3209544"/>
           </a:xfrm>
           <a:prstGeom prst="rect">
             <a:avLst/>
@@ -4148,30 +4448,32 @@
       </p:pic>
       <p:sp>
         <p:nvSpPr>
-          <p:cNvPr id="16" name="Text 12"/>
-          <p:cNvSpPr txBox="1"/>
-          <p:nvPr/>
-        </p:nvSpPr>
-        <p:spPr>
-          <a:xfrm>
-            <a:off x="4800600" y="4187952"/>
-            <a:ext cx="3758184" cy="219456"/>
-          </a:xfrm>
-          <a:prstGeom prst="rect">
-            <a:avLst/>
-          </a:prstGeom>
-          <a:noFill/>
-          <a:ln/>
-        </p:spPr>
-        <p:txBody>
-          <a:bodyPr wrap="square" lIns="0" tIns="0" rIns="0" bIns="0" rtlCol="0" anchor="t"/>
+          <p:cNvPr id="13" name="Text 9"/>
+          <p:cNvSpPr txBox="1"/>
+          <p:nvPr/>
+        </p:nvSpPr>
+        <p:spPr>
+          <a:xfrm>
+            <a:off x="4233672" y="4489704"/>
+            <a:ext cx="4325112" cy="201168"/>
+          </a:xfrm>
+          <a:prstGeom prst="rect">
+            <a:avLst/>
+          </a:prstGeom>
+          <a:noFill/>
+          <a:ln/>
+        </p:spPr>
+        <p:txBody>
+          <a:bodyPr wrap="square" lIns="0" tIns="0" rIns="0" bIns="0" rtlCol="0" anchor="t">
+            <a:normAutofit/>
+          </a:bodyPr>
           <a:lstStyle/>
           <a:p>
             <a:pPr algn="r" indent="0" marL="0">
               <a:buNone/>
             </a:pPr>
             <a:r>
-              <a:rPr lang="en-US" sz="1200" dirty="0">
+              <a:rPr lang="en-US" sz="1150" b="1" dirty="0">
                 <a:solidFill>
                   <a:srgbClr val="00F604"/>
                 </a:solidFill>
@@ -4179,9 +4481,9 @@
                 <a:ea typeface="Avenir Next" pitchFamily="34" charset="-122"/>
                 <a:cs typeface="Avenir Next" pitchFamily="34" charset="-120"/>
               </a:rPr>
-              <a:t>Success receipt after Post/Redirect/Get.</a:t>
-            </a:r>
-            <a:endParaRPr lang="en-US" sz="1200" dirty="0"/>
+              <a:t>Rejected overdraft. Persisted state stays unchanged.</a:t>
+            </a:r>
+            <a:endParaRPr lang="en-US" sz="1150" dirty="0"/>
           </a:p>
         </p:txBody>
       </p:sp>
@@ -4196,6 +4498,557 @@
 <file path=ppt/slides/slide6.xml><?xml version="1.0" encoding="utf-8"?>
 <p:sld xmlns:a="http://schemas.openxmlformats.org/drawingml/2006/main" xmlns:r="http://schemas.openxmlformats.org/officeDocument/2006/relationships" xmlns:p="http://schemas.openxmlformats.org/presentationml/2006/main">
   <p:cSld name="Slide 6">
+    <p:bg>
+      <p:bgPr>
+        <a:solidFill>
+          <a:srgbClr val="121212"/>
+        </a:solidFill>
+      </p:bgPr>
+    </p:bg>
+    <p:spTree>
+      <p:nvGrpSpPr>
+        <p:cNvPr id="1" name=""/>
+        <p:cNvGrpSpPr/>
+        <p:nvPr/>
+      </p:nvGrpSpPr>
+      <p:grpSpPr>
+        <a:xfrm>
+          <a:off x="0" y="0"/>
+          <a:ext cx="0" cy="0"/>
+          <a:chOff x="0" y="0"/>
+          <a:chExt cx="0" cy="0"/>
+        </a:xfrm>
+      </p:grpSpPr>
+      <p:sp>
+        <p:nvSpPr>
+          <p:cNvPr id="2" name="Shape 0"/>
+          <p:cNvSpPr/>
+          <p:nvPr/>
+        </p:nvSpPr>
+        <p:spPr>
+          <a:xfrm>
+            <a:off x="585216" y="356616"/>
+            <a:ext cx="91440" cy="438912"/>
+          </a:xfrm>
+          <a:prstGeom prst="rect">
+            <a:avLst/>
+          </a:prstGeom>
+          <a:solidFill>
+            <a:srgbClr val="00F604"/>
+          </a:solidFill>
+          <a:ln w="12700">
+            <a:solidFill>
+              <a:srgbClr val="00F604">
+                <a:alpha val="0"/>
+              </a:srgbClr>
+            </a:solidFill>
+            <a:prstDash val="solid"/>
+          </a:ln>
+        </p:spPr>
+      </p:sp>
+      <p:sp>
+        <p:nvSpPr>
+          <p:cNvPr id="3" name="Text 1"/>
+          <p:cNvSpPr txBox="1"/>
+          <p:nvPr/>
+        </p:nvSpPr>
+        <p:spPr>
+          <a:xfrm>
+            <a:off x="832104" y="356616"/>
+            <a:ext cx="7726680" cy="512064"/>
+          </a:xfrm>
+          <a:prstGeom prst="rect">
+            <a:avLst/>
+          </a:prstGeom>
+          <a:noFill/>
+          <a:ln/>
+        </p:spPr>
+        <p:txBody>
+          <a:bodyPr wrap="square" lIns="0" tIns="0" rIns="0" bIns="0" rtlCol="0" anchor="t">
+            <a:normAutofit/>
+          </a:bodyPr>
+          <a:lstStyle/>
+          <a:p>
+            <a:pPr indent="0" marL="0">
+              <a:buNone/>
+            </a:pPr>
+            <a:r>
+              <a:rPr lang="en-US" sz="3200" b="1" dirty="0">
+                <a:solidFill>
+                  <a:srgbClr val="F5F5F5"/>
+                </a:solidFill>
+                <a:latin typeface="Avenir Next" pitchFamily="34" charset="0"/>
+                <a:ea typeface="Avenir Next" pitchFamily="34" charset="-122"/>
+                <a:cs typeface="Avenir Next" pitchFamily="34" charset="-120"/>
+              </a:rPr>
+              <a:t>143 tests by layer</a:t>
+            </a:r>
+            <a:endParaRPr lang="en-US" sz="3200" dirty="0"/>
+          </a:p>
+        </p:txBody>
+      </p:sp>
+      <p:sp>
+        <p:nvSpPr>
+          <p:cNvPr id="5" name="Text 2"/>
+          <p:cNvSpPr txBox="1"/>
+          <p:nvPr/>
+        </p:nvSpPr>
+        <p:spPr>
+          <a:xfrm>
+            <a:off x="585216" y="1225296"/>
+            <a:ext cx="841248" cy="475488"/>
+          </a:xfrm>
+          <a:prstGeom prst="rect">
+            <a:avLst/>
+          </a:prstGeom>
+          <a:noFill/>
+          <a:ln/>
+        </p:spPr>
+        <p:txBody>
+          <a:bodyPr wrap="square" lIns="0" tIns="0" rIns="0" bIns="0" rtlCol="0" anchor="t"/>
+          <a:lstStyle/>
+          <a:p>
+            <a:pPr indent="0" marL="0">
+              <a:buNone/>
+            </a:pPr>
+            <a:r>
+              <a:rPr lang="en-US" sz="3400" b="1" dirty="0">
+                <a:solidFill>
+                  <a:srgbClr val="00F604"/>
+                </a:solidFill>
+                <a:latin typeface="Avenir Next" pitchFamily="34" charset="0"/>
+                <a:ea typeface="Avenir Next" pitchFamily="34" charset="-122"/>
+                <a:cs typeface="Avenir Next" pitchFamily="34" charset="-120"/>
+              </a:rPr>
+              <a:t>75</a:t>
+            </a:r>
+            <a:endParaRPr lang="en-US" sz="3400" dirty="0"/>
+          </a:p>
+        </p:txBody>
+      </p:sp>
+      <p:sp>
+        <p:nvSpPr>
+          <p:cNvPr id="6" name="Text 3"/>
+          <p:cNvSpPr txBox="1"/>
+          <p:nvPr/>
+        </p:nvSpPr>
+        <p:spPr>
+          <a:xfrm>
+            <a:off x="1508760" y="1243584"/>
+            <a:ext cx="2075688" cy="256032"/>
+          </a:xfrm>
+          <a:prstGeom prst="rect">
+            <a:avLst/>
+          </a:prstGeom>
+          <a:noFill/>
+          <a:ln/>
+        </p:spPr>
+        <p:txBody>
+          <a:bodyPr wrap="square" lIns="0" tIns="0" rIns="0" bIns="0" rtlCol="0" anchor="t">
+            <a:normAutofit/>
+          </a:bodyPr>
+          <a:lstStyle/>
+          <a:p>
+            <a:pPr indent="0" marL="0">
+              <a:buNone/>
+            </a:pPr>
+            <a:r>
+              <a:rPr lang="en-US" sz="1600" b="1" dirty="0">
+                <a:solidFill>
+                  <a:srgbClr val="F5F5F5"/>
+                </a:solidFill>
+                <a:latin typeface="Avenir Next" pitchFamily="34" charset="0"/>
+                <a:ea typeface="Avenir Next" pitchFamily="34" charset="-122"/>
+                <a:cs typeface="Avenir Next" pitchFamily="34" charset="-120"/>
+              </a:rPr>
+              <a:t>Domain</a:t>
+            </a:r>
+            <a:endParaRPr lang="en-US" sz="1600" dirty="0"/>
+          </a:p>
+        </p:txBody>
+      </p:sp>
+      <p:sp>
+        <p:nvSpPr>
+          <p:cNvPr id="7" name="Text 4"/>
+          <p:cNvSpPr txBox="1"/>
+          <p:nvPr/>
+        </p:nvSpPr>
+        <p:spPr>
+          <a:xfrm>
+            <a:off x="1508760" y="1572768"/>
+            <a:ext cx="2075688" cy="219456"/>
+          </a:xfrm>
+          <a:prstGeom prst="rect">
+            <a:avLst/>
+          </a:prstGeom>
+          <a:noFill/>
+          <a:ln/>
+        </p:spPr>
+        <p:txBody>
+          <a:bodyPr wrap="square" lIns="0" tIns="0" rIns="0" bIns="0" rtlCol="0" anchor="t">
+            <a:normAutofit/>
+          </a:bodyPr>
+          <a:lstStyle/>
+          <a:p>
+            <a:pPr indent="0" marL="0">
+              <a:buNone/>
+            </a:pPr>
+            <a:r>
+              <a:rPr lang="en-US" sz="1200" dirty="0">
+                <a:solidFill>
+                  <a:srgbClr val="A9ADB3"/>
+                </a:solidFill>
+                <a:latin typeface="Avenir Next" pitchFamily="34" charset="0"/>
+                <a:ea typeface="Avenir Next" pitchFamily="34" charset="-122"/>
+                <a:cs typeface="Avenir Next" pitchFamily="34" charset="-120"/>
+              </a:rPr>
+              <a:t>Invariants</a:t>
+            </a:r>
+            <a:endParaRPr lang="en-US" sz="1200" dirty="0"/>
+          </a:p>
+        </p:txBody>
+      </p:sp>
+      <p:sp>
+        <p:nvSpPr>
+          <p:cNvPr id="8" name="Text 5"/>
+          <p:cNvSpPr txBox="1"/>
+          <p:nvPr/>
+        </p:nvSpPr>
+        <p:spPr>
+          <a:xfrm>
+            <a:off x="585216" y="2203704"/>
+            <a:ext cx="841248" cy="475488"/>
+          </a:xfrm>
+          <a:prstGeom prst="rect">
+            <a:avLst/>
+          </a:prstGeom>
+          <a:noFill/>
+          <a:ln/>
+        </p:spPr>
+        <p:txBody>
+          <a:bodyPr wrap="square" lIns="0" tIns="0" rIns="0" bIns="0" rtlCol="0" anchor="t"/>
+          <a:lstStyle/>
+          <a:p>
+            <a:pPr indent="0" marL="0">
+              <a:buNone/>
+            </a:pPr>
+            <a:r>
+              <a:rPr lang="en-US" sz="3400" b="1" dirty="0">
+                <a:solidFill>
+                  <a:srgbClr val="00F604"/>
+                </a:solidFill>
+                <a:latin typeface="Avenir Next" pitchFamily="34" charset="0"/>
+                <a:ea typeface="Avenir Next" pitchFamily="34" charset="-122"/>
+                <a:cs typeface="Avenir Next" pitchFamily="34" charset="-120"/>
+              </a:rPr>
+              <a:t>33</a:t>
+            </a:r>
+            <a:endParaRPr lang="en-US" sz="3400" dirty="0"/>
+          </a:p>
+        </p:txBody>
+      </p:sp>
+      <p:sp>
+        <p:nvSpPr>
+          <p:cNvPr id="9" name="Text 6"/>
+          <p:cNvSpPr txBox="1"/>
+          <p:nvPr/>
+        </p:nvSpPr>
+        <p:spPr>
+          <a:xfrm>
+            <a:off x="1508760" y="2221992"/>
+            <a:ext cx="2075688" cy="256032"/>
+          </a:xfrm>
+          <a:prstGeom prst="rect">
+            <a:avLst/>
+          </a:prstGeom>
+          <a:noFill/>
+          <a:ln/>
+        </p:spPr>
+        <p:txBody>
+          <a:bodyPr wrap="square" lIns="0" tIns="0" rIns="0" bIns="0" rtlCol="0" anchor="t">
+            <a:normAutofit/>
+          </a:bodyPr>
+          <a:lstStyle/>
+          <a:p>
+            <a:pPr indent="0" marL="0">
+              <a:buNone/>
+            </a:pPr>
+            <a:r>
+              <a:rPr lang="en-US" sz="1600" b="1" dirty="0">
+                <a:solidFill>
+                  <a:srgbClr val="F5F5F5"/>
+                </a:solidFill>
+                <a:latin typeface="Avenir Next" pitchFamily="34" charset="0"/>
+                <a:ea typeface="Avenir Next" pitchFamily="34" charset="-122"/>
+                <a:cs typeface="Avenir Next" pitchFamily="34" charset="-120"/>
+              </a:rPr>
+              <a:t>Application</a:t>
+            </a:r>
+            <a:endParaRPr lang="en-US" sz="1600" dirty="0"/>
+          </a:p>
+        </p:txBody>
+      </p:sp>
+      <p:sp>
+        <p:nvSpPr>
+          <p:cNvPr id="10" name="Text 7"/>
+          <p:cNvSpPr txBox="1"/>
+          <p:nvPr/>
+        </p:nvSpPr>
+        <p:spPr>
+          <a:xfrm>
+            <a:off x="1508760" y="2551176"/>
+            <a:ext cx="2075688" cy="219456"/>
+          </a:xfrm>
+          <a:prstGeom prst="rect">
+            <a:avLst/>
+          </a:prstGeom>
+          <a:noFill/>
+          <a:ln/>
+        </p:spPr>
+        <p:txBody>
+          <a:bodyPr wrap="square" lIns="0" tIns="0" rIns="0" bIns="0" rtlCol="0" anchor="t">
+            <a:normAutofit/>
+          </a:bodyPr>
+          <a:lstStyle/>
+          <a:p>
+            <a:pPr indent="0" marL="0">
+              <a:buNone/>
+            </a:pPr>
+            <a:r>
+              <a:rPr lang="en-US" sz="1200" dirty="0">
+                <a:solidFill>
+                  <a:srgbClr val="A9ADB3"/>
+                </a:solidFill>
+                <a:latin typeface="Avenir Next" pitchFamily="34" charset="0"/>
+                <a:ea typeface="Avenir Next" pitchFamily="34" charset="-122"/>
+                <a:cs typeface="Avenir Next" pitchFamily="34" charset="-120"/>
+              </a:rPr>
+              <a:t>Orchestration</a:t>
+            </a:r>
+            <a:endParaRPr lang="en-US" sz="1200" dirty="0"/>
+          </a:p>
+        </p:txBody>
+      </p:sp>
+      <p:sp>
+        <p:nvSpPr>
+          <p:cNvPr id="11" name="Text 8"/>
+          <p:cNvSpPr txBox="1"/>
+          <p:nvPr/>
+        </p:nvSpPr>
+        <p:spPr>
+          <a:xfrm>
+            <a:off x="585216" y="3182112"/>
+            <a:ext cx="841248" cy="475488"/>
+          </a:xfrm>
+          <a:prstGeom prst="rect">
+            <a:avLst/>
+          </a:prstGeom>
+          <a:noFill/>
+          <a:ln/>
+        </p:spPr>
+        <p:txBody>
+          <a:bodyPr wrap="square" lIns="0" tIns="0" rIns="0" bIns="0" rtlCol="0" anchor="t"/>
+          <a:lstStyle/>
+          <a:p>
+            <a:pPr indent="0" marL="0">
+              <a:buNone/>
+            </a:pPr>
+            <a:r>
+              <a:rPr lang="en-US" sz="3400" b="1" dirty="0">
+                <a:solidFill>
+                  <a:srgbClr val="00F604"/>
+                </a:solidFill>
+                <a:latin typeface="Avenir Next" pitchFamily="34" charset="0"/>
+                <a:ea typeface="Avenir Next" pitchFamily="34" charset="-122"/>
+                <a:cs typeface="Avenir Next" pitchFamily="34" charset="-120"/>
+              </a:rPr>
+              <a:t>35</a:t>
+            </a:r>
+            <a:endParaRPr lang="en-US" sz="3400" dirty="0"/>
+          </a:p>
+        </p:txBody>
+      </p:sp>
+      <p:sp>
+        <p:nvSpPr>
+          <p:cNvPr id="12" name="Text 9"/>
+          <p:cNvSpPr txBox="1"/>
+          <p:nvPr/>
+        </p:nvSpPr>
+        <p:spPr>
+          <a:xfrm>
+            <a:off x="1508760" y="3200400"/>
+            <a:ext cx="2075688" cy="256032"/>
+          </a:xfrm>
+          <a:prstGeom prst="rect">
+            <a:avLst/>
+          </a:prstGeom>
+          <a:noFill/>
+          <a:ln/>
+        </p:spPr>
+        <p:txBody>
+          <a:bodyPr wrap="square" lIns="0" tIns="0" rIns="0" bIns="0" rtlCol="0" anchor="t">
+            <a:normAutofit/>
+          </a:bodyPr>
+          <a:lstStyle/>
+          <a:p>
+            <a:pPr indent="0" marL="0">
+              <a:buNone/>
+            </a:pPr>
+            <a:r>
+              <a:rPr lang="en-US" sz="1600" b="1" dirty="0">
+                <a:solidFill>
+                  <a:srgbClr val="F5F5F5"/>
+                </a:solidFill>
+                <a:latin typeface="Avenir Next" pitchFamily="34" charset="0"/>
+                <a:ea typeface="Avenir Next" pitchFamily="34" charset="-122"/>
+                <a:cs typeface="Avenir Next" pitchFamily="34" charset="-120"/>
+              </a:rPr>
+              <a:t>Integration + HTTP</a:t>
+            </a:r>
+            <a:endParaRPr lang="en-US" sz="1600" dirty="0"/>
+          </a:p>
+        </p:txBody>
+      </p:sp>
+      <p:sp>
+        <p:nvSpPr>
+          <p:cNvPr id="13" name="Text 10"/>
+          <p:cNvSpPr txBox="1"/>
+          <p:nvPr/>
+        </p:nvSpPr>
+        <p:spPr>
+          <a:xfrm>
+            <a:off x="1508760" y="3529584"/>
+            <a:ext cx="2075688" cy="219456"/>
+          </a:xfrm>
+          <a:prstGeom prst="rect">
+            <a:avLst/>
+          </a:prstGeom>
+          <a:noFill/>
+          <a:ln/>
+        </p:spPr>
+        <p:txBody>
+          <a:bodyPr wrap="square" lIns="0" tIns="0" rIns="0" bIns="0" rtlCol="0" anchor="t">
+            <a:normAutofit/>
+          </a:bodyPr>
+          <a:lstStyle/>
+          <a:p>
+            <a:pPr indent="0" marL="0">
+              <a:buNone/>
+            </a:pPr>
+            <a:r>
+              <a:rPr lang="en-US" sz="1200" dirty="0">
+                <a:solidFill>
+                  <a:srgbClr val="A9ADB3"/>
+                </a:solidFill>
+                <a:latin typeface="Avenir Next" pitchFamily="34" charset="0"/>
+                <a:ea typeface="Avenir Next" pitchFamily="34" charset="-122"/>
+                <a:cs typeface="Avenir Next" pitchFamily="34" charset="-120"/>
+              </a:rPr>
+              <a:t>Persistence and HTTP</a:t>
+            </a:r>
+            <a:endParaRPr lang="en-US" sz="1200" dirty="0"/>
+          </a:p>
+        </p:txBody>
+      </p:sp>
+      <p:sp>
+        <p:nvSpPr>
+          <p:cNvPr id="14" name="Shape 11"/>
+          <p:cNvSpPr/>
+          <p:nvPr/>
+        </p:nvSpPr>
+        <p:spPr>
+          <a:xfrm>
+            <a:off x="4800600" y="1115568"/>
+            <a:ext cx="3758184" cy="2926080"/>
+          </a:xfrm>
+          <a:prstGeom prst="rect">
+            <a:avLst/>
+          </a:prstGeom>
+          <a:solidFill>
+            <a:srgbClr val="1B1B1B"/>
+          </a:solidFill>
+          <a:ln w="10160">
+            <a:solidFill>
+              <a:srgbClr val="333333"/>
+            </a:solidFill>
+            <a:prstDash val="solid"/>
+          </a:ln>
+        </p:spPr>
+      </p:sp>
+      <p:pic>
+        <p:nvPicPr>
+          <p:cNvPr id="15" name="Image 0" descr="/Users/john/theborg/repos/atm/design/screenshots/receipt.png">    </p:cNvPr>
+          <p:cNvPicPr>
+            <a:picLocks noChangeAspect="1"/>
+          </p:cNvPicPr>
+          <p:nvPr/>
+        </p:nvPicPr>
+        <p:blipFill>
+          <a:blip r:embed="rId1"/>
+          <a:stretch>
+            <a:fillRect/>
+          </a:stretch>
+        </p:blipFill>
+        <p:spPr>
+          <a:xfrm>
+            <a:off x="4837176" y="1152144"/>
+            <a:ext cx="3685032" cy="2852928"/>
+          </a:xfrm>
+          <a:prstGeom prst="rect">
+            <a:avLst/>
+          </a:prstGeom>
+        </p:spPr>
+      </p:pic>
+      <p:sp>
+        <p:nvSpPr>
+          <p:cNvPr id="16" name="Text 12"/>
+          <p:cNvSpPr txBox="1"/>
+          <p:nvPr/>
+        </p:nvSpPr>
+        <p:spPr>
+          <a:xfrm>
+            <a:off x="4800600" y="4187952"/>
+            <a:ext cx="3758184" cy="219456"/>
+          </a:xfrm>
+          <a:prstGeom prst="rect">
+            <a:avLst/>
+          </a:prstGeom>
+          <a:noFill/>
+          <a:ln/>
+        </p:spPr>
+        <p:txBody>
+          <a:bodyPr wrap="square" lIns="0" tIns="0" rIns="0" bIns="0" rtlCol="0" anchor="t"/>
+          <a:lstStyle/>
+          <a:p>
+            <a:pPr algn="r" indent="0" marL="0">
+              <a:buNone/>
+            </a:pPr>
+            <a:r>
+              <a:rPr lang="en-US" sz="1200" dirty="0">
+                <a:solidFill>
+                  <a:srgbClr val="00F604"/>
+                </a:solidFill>
+                <a:latin typeface="Avenir Next" pitchFamily="34" charset="0"/>
+                <a:ea typeface="Avenir Next" pitchFamily="34" charset="-122"/>
+                <a:cs typeface="Avenir Next" pitchFamily="34" charset="-120"/>
+              </a:rPr>
+              <a:t>Success receipt after Post/Redirect/Get.</a:t>
+            </a:r>
+            <a:endParaRPr lang="en-US" sz="1200" dirty="0"/>
+          </a:p>
+        </p:txBody>
+      </p:sp>
+    </p:spTree>
+  </p:cSld>
+  <p:clrMapOvr>
+    <a:masterClrMapping/>
+  </p:clrMapOvr>
+</p:sld>
+</file>
+
+<file path=ppt/slides/slide7.xml><?xml version="1.0" encoding="utf-8"?>
+<p:sld xmlns:a="http://schemas.openxmlformats.org/drawingml/2006/main" xmlns:r="http://schemas.openxmlformats.org/officeDocument/2006/relationships" xmlns:p="http://schemas.openxmlformats.org/presentationml/2006/main">
+  <p:cSld name="Slide 7">
     <p:bg>
       <p:bgPr>
         <a:solidFill>

</xml_diff>

<commit_message>
Add "How I AI'ed" slide 2; visual QA passed in PowerPoint
The new slide shows how the work was split across agents: GPT-5.6 in Codex
for the architecture interview and scaffold, Fable 5.1 in Claude Code for
the six test-gated phases, and Opus 5.5 and GPT-6 for docs, deck, and fixes.
Speaker notes explain choosing Fable 5.1 for speed over token cost. The
design README lists eight slides. All slides were exported to PDF with
PowerPoint and inspected; no repair prompt.

Co-Authored-By: Claude Opus 5.5 <noreply@anthropic.com>
</commit_message>
<xml_diff>
--- a/design/atm-deck.pptx
+++ b/design/atm-deck.pptx
@@ -12,9 +12,10 @@
     <p:sldId id="260" r:id="rId6"/>
     <p:sldId id="261" r:id="rId7"/>
     <p:sldId id="262" r:id="rId8"/>
+    <p:sldId id="263" r:id="rId9"/>
   </p:sldIdLst>
   <p:notesMasterIdLst>
-    <p:notesMasterId r:id="rId9"/>
+    <p:notesMasterId r:id="rId10"/>
   </p:notesMasterIdLst>
   <p:sldSz cx="9144000" cy="5143500"/>
   <p:notesSz cx="7772400" cy="10058400"/>
@@ -596,41 +597,37 @@
           <a:p>
             <a:r>
               <a:rPr lang="en-US" dirty="0"/>
-              <a:t>No client-side framework or npm packages ship with the app.</a:t>
+              <a:t>I split the work by strength: a ChatGPT agent (GPT-5.6 in Codex) for the architecture interview and scaffold, Claude Code for the implementation, and both for later docs and deck work.</a:t>
             </a:r>
             <a:endParaRPr lang="en-US" dirty="0"/>
           </a:p>
           <a:p>
+            <a:endParaRPr lang="en-US" dirty="0"/>
+          </a:p>
+          <a:p>
             <a:r>
               <a:rPr lang="en-US" dirty="0"/>
-              <a:t>Pages are server-rendered Razor Pages with a small amount of vanilla JavaScript and one “hand-written” stylesheet.</a:t>
-            </a:r>
-            <a:endParaRPr lang="en-US" dirty="0"/>
-          </a:p>
-          <a:p>
-            <a:endParaRPr lang="en-US" dirty="0"/>
-          </a:p>
-          <a:p>
-            <a:r>
-              <a:rPr lang="en-US" dirty="0"/>
-              <a:t>The solution is a modular monolith of four projects (Domain, Application, Infrastructure, Web) with dependencies pointing inward, recorded in </a:t>
+              <a:t>Frame. The agent read my notes and interviewed me on four open questions: a time-boxed scope, whether data should survive restarts, the seed accounts and balances, and GitHub repo visibility. It proposed the stack and I approved it. Before any feature code, the scaffold committed SPEC.md, PLAN.md, six </a:t>
             </a:r>
             <a:r>
               <a:rPr lang="en-US" dirty="0">
                 <a:hlinkClick r:id="rId3"/>
               </a:rPr>
-              <a:t>ADR-0002</a:t>
+              <a:t>ADRs</a:t>
             </a:r>
             <a:r>
               <a:rPr lang="en-US" dirty="0"/>
-              <a:t>.</a:t>
+              <a:t>, and AGENTS.md. AGENTS.md is the rulebook every agent reads: decimal money, no negative balances, atomic history, and changes it must ask me about first, such as adding a dependency.</a:t>
             </a:r>
             <a:endParaRPr lang="en-US" dirty="0"/>
           </a:p>
           <a:p>
+            <a:endParaRPr lang="en-US" dirty="0"/>
+          </a:p>
+          <a:p>
             <a:r>
               <a:rPr lang="en-US" dirty="0"/>
-              <a:t>EF Core and SQLite live only in the Infrastructure project.</a:t>
+              <a:t>Build. Claude Code with Fable 5.1 implemented the six phases in PLAN.md in order: domain, application, persistence, web, HTTP tests with an accessibility pass, then screenshots and the deck. Each phase had to leave the build and every test green before it was committed and the next one started. Domain tests were written before the domain code.</a:t>
             </a:r>
             <a:endParaRPr lang="en-US" dirty="0"/>
           </a:p>
@@ -640,7 +637,17 @@
           <a:p>
             <a:r>
               <a:rPr lang="en-US" dirty="0"/>
-              <a:t>Tests use xUnit, WebApplicationFactory for in-process HTTP, and coverlet for coverage.</a:t>
+              <a:t>Why Fable 5.1. It was probably more model than the job needed. I was short on time and wanted the strongest end-to-end implementation model available; Opus 5.5 had not shipped yet. I paid more in tokens to save wall-clock time. The phase gates don't depend on the model, so running a cheaper one against the same tests is the obvious experiment. Quick questions went to a lighter model (Sonnet 5).</a:t>
+            </a:r>
+            <a:endParaRPr lang="en-US" dirty="0"/>
+          </a:p>
+          <a:p>
+            <a:endParaRPr lang="en-US" dirty="0"/>
+          </a:p>
+          <a:p>
+            <a:r>
+              <a:rPr lang="en-US" dirty="0"/>
+              <a:t>Refine. Later work used Opus 5.5 and GPT-6 in Codex: Windows setup steps in the README, a Dependabot fix in the deck tooling, the deck's visual redesign, and the wording on these slides. I directed each change and sent back output that didn't hold up; the first deck skipped the design consultation and was redone.</a:t>
             </a:r>
             <a:endParaRPr lang="en-US" dirty="0"/>
           </a:p>
@@ -728,97 +735,51 @@
           <a:p>
             <a:r>
               <a:rPr lang="en-US" dirty="0"/>
-              <a:t>The </a:t>
+              <a:t>No client-side framework or npm packages ship with the app.</a:t>
+            </a:r>
+            <a:endParaRPr lang="en-US" dirty="0"/>
+          </a:p>
+          <a:p>
+            <a:r>
+              <a:rPr lang="en-US" dirty="0"/>
+              <a:t>Pages are server-rendered Razor Pages with a small amount of vanilla JavaScript and one “hand-written” stylesheet.</a:t>
+            </a:r>
+            <a:endParaRPr lang="en-US" dirty="0"/>
+          </a:p>
+          <a:p>
+            <a:endParaRPr lang="en-US" dirty="0"/>
+          </a:p>
+          <a:p>
+            <a:r>
+              <a:rPr lang="en-US" dirty="0"/>
+              <a:t>The solution is a modular monolith of four projects (Domain, Application, Infrastructure, Web) with dependencies pointing inward, recorded in </a:t>
             </a:r>
             <a:r>
               <a:rPr lang="en-US" dirty="0">
                 <a:hlinkClick r:id="rId3"/>
               </a:rPr>
-              <a:t>ADRs</a:t>
+              <a:t>ADR-0002</a:t>
             </a:r>
             <a:r>
               <a:rPr lang="en-US" dirty="0"/>
-              <a:t> explain why each choice fits the exercise.</a:t>
+              <a:t>.</a:t>
             </a:r>
             <a:endParaRPr lang="en-US" dirty="0"/>
           </a:p>
           <a:p>
+            <a:r>
+              <a:rPr lang="en-US" dirty="0"/>
+              <a:t>EF Core and SQLite live only in the Infrastructure project.</a:t>
+            </a:r>
             <a:endParaRPr lang="en-US" dirty="0"/>
           </a:p>
           <a:p>
+            <a:endParaRPr lang="en-US" dirty="0"/>
+          </a:p>
+          <a:p>
             <a:r>
               <a:rPr lang="en-US" dirty="0"/>
-              <a:t>Razor Pages (</a:t>
-            </a:r>
-            <a:r>
-              <a:rPr lang="en-US" dirty="0">
-                <a:hlinkClick r:id="rId4"/>
-              </a:rPr>
-              <a:t>ADR-0001</a:t>
-            </a:r>
-            <a:r>
-              <a:rPr lang="en-US" dirty="0"/>
-              <a:t>). Cost: a full page reload per action. The server renders HTML with minimal JavaScript, so the whole app is written in C# and ships as a single unit. A separate JavaScript front end (e.g., a React single-page app) would add its own npm build and a JSON API for the browser to call, because the browser would fetch data instead of receiving finished pages.</a:t>
-            </a:r>
-            <a:endParaRPr lang="en-US" dirty="0"/>
-          </a:p>
-          <a:p>
-            <a:endParaRPr lang="en-US" dirty="0"/>
-          </a:p>
-          <a:p>
-            <a:r>
-              <a:rPr lang="en-US" dirty="0"/>
-              <a:t>Modular monolith (</a:t>
-            </a:r>
-            <a:r>
-              <a:rPr lang="en-US" dirty="0">
-                <a:hlinkClick r:id="rId5"/>
-              </a:rPr>
-              <a:t>ADR-0002</a:t>
-            </a:r>
-            <a:r>
-              <a:rPr lang="en-US" dirty="0"/>
-              <a:t>). Cost: one feature spans four projects, so adding a transaction type touches Domain, Application, Infrastructure, and Web. The payoff is that business rules can be tested without the web host or the database. Microservices would add operational complexity with no payoff at this scope.</a:t>
-            </a:r>
-            <a:endParaRPr lang="en-US" dirty="0"/>
-          </a:p>
-          <a:p>
-            <a:endParaRPr lang="en-US" dirty="0"/>
-          </a:p>
-          <a:p>
-            <a:r>
-              <a:rPr lang="en-US" dirty="0"/>
-              <a:t>SQLite + EF Core (</a:t>
-            </a:r>
-            <a:r>
-              <a:rPr lang="en-US" dirty="0">
-                <a:hlinkClick r:id="rId6"/>
-              </a:rPr>
-              <a:t>ADR-0003</a:t>
-            </a:r>
-            <a:r>
-              <a:rPr lang="en-US" dirty="0"/>
-              <a:t>). Cost: single-writer ceiling. A server database is the upgrade path if concurrent load ever matters. The next slide covers the datastore choice.</a:t>
-            </a:r>
-            <a:endParaRPr lang="en-US" dirty="0"/>
-          </a:p>
-          <a:p>
-            <a:endParaRPr lang="en-US" dirty="0"/>
-          </a:p>
-          <a:p>
-            <a:r>
-              <a:rPr lang="en-US" dirty="0"/>
-              <a:t>2-decimal USD (</a:t>
-            </a:r>
-            <a:r>
-              <a:rPr lang="en-US" dirty="0">
-                <a:hlinkClick r:id="rId7"/>
-              </a:rPr>
-              <a:t>ADR-0005</a:t>
-            </a:r>
-            <a:r>
-              <a:rPr lang="en-US" dirty="0"/>
-              <a:t>). Cost: single-currency support. Amounts are decimal with at most two fractional digits, which rules out floating-point error. The two-digit rule fits USD only, and there is no currency field, so supporting another currency (e.g., JPY with 0 places or KWD with 3) would change the Money type.</a:t>
+              <a:t>Tests use xUnit, WebApplicationFactory for in-process HTTP, and coverlet for coverage.</a:t>
             </a:r>
             <a:endParaRPr lang="en-US" dirty="0"/>
           </a:p>
@@ -906,83 +867,97 @@
           <a:p>
             <a:r>
               <a:rPr lang="en-US" dirty="0"/>
-              <a:t>An in-memory store would have been enough. I chose a persistent one so balances and history survive restarts (</a:t>
+              <a:t>The </a:t>
             </a:r>
             <a:r>
               <a:rPr lang="en-US" dirty="0">
                 <a:hlinkClick r:id="rId3"/>
               </a:rPr>
+              <a:t>ADRs</a:t>
+            </a:r>
+            <a:r>
+              <a:rPr lang="en-US" dirty="0"/>
+              <a:t> explain why each choice fits the exercise.</a:t>
+            </a:r>
+            <a:endParaRPr lang="en-US" dirty="0"/>
+          </a:p>
+          <a:p>
+            <a:endParaRPr lang="en-US" dirty="0"/>
+          </a:p>
+          <a:p>
+            <a:r>
+              <a:rPr lang="en-US" dirty="0"/>
+              <a:t>Razor Pages (</a:t>
+            </a:r>
+            <a:r>
+              <a:rPr lang="en-US" dirty="0">
+                <a:hlinkClick r:id="rId4"/>
+              </a:rPr>
+              <a:t>ADR-0001</a:t>
+            </a:r>
+            <a:r>
+              <a:rPr lang="en-US" dirty="0"/>
+              <a:t>). Cost: a full page reload per action. The server renders HTML with minimal JavaScript, so the whole app is written in C# and ships as a single unit. A separate JavaScript front end (e.g., a React single-page app) would add its own npm build and a JSON API for the browser to call, because the browser would fetch data instead of receiving finished pages.</a:t>
+            </a:r>
+            <a:endParaRPr lang="en-US" dirty="0"/>
+          </a:p>
+          <a:p>
+            <a:endParaRPr lang="en-US" dirty="0"/>
+          </a:p>
+          <a:p>
+            <a:r>
+              <a:rPr lang="en-US" dirty="0"/>
+              <a:t>Modular monolith (</a:t>
+            </a:r>
+            <a:r>
+              <a:rPr lang="en-US" dirty="0">
+                <a:hlinkClick r:id="rId5"/>
+              </a:rPr>
+              <a:t>ADR-0002</a:t>
+            </a:r>
+            <a:r>
+              <a:rPr lang="en-US" dirty="0"/>
+              <a:t>). Cost: one feature spans four projects, so adding a transaction type touches Domain, Application, Infrastructure, and Web. The payoff is that business rules can be tested without the web host or the database. Microservices would add operational complexity with no payoff at this scope.</a:t>
+            </a:r>
+            <a:endParaRPr lang="en-US" dirty="0"/>
+          </a:p>
+          <a:p>
+            <a:endParaRPr lang="en-US" dirty="0"/>
+          </a:p>
+          <a:p>
+            <a:r>
+              <a:rPr lang="en-US" dirty="0"/>
+              <a:t>SQLite + EF Core (</a:t>
+            </a:r>
+            <a:r>
+              <a:rPr lang="en-US" dirty="0">
+                <a:hlinkClick r:id="rId6"/>
+              </a:rPr>
               <a:t>ADR-0003</a:t>
             </a:r>
             <a:r>
               <a:rPr lang="en-US" dirty="0"/>
-              <a:t>).</a:t>
+              <a:t>). Cost: single-writer ceiling. A server database is the upgrade path if concurrent load ever matters. The next slide covers the datastore choice.</a:t>
             </a:r>
             <a:endParaRPr lang="en-US" dirty="0"/>
           </a:p>
           <a:p>
+            <a:endParaRPr lang="en-US" dirty="0"/>
+          </a:p>
+          <a:p>
             <a:r>
               <a:rPr lang="en-US" dirty="0"/>
-              <a:t>• SQLite – single-file DB with near-zero setup.</a:t>
-            </a:r>
-            <a:endParaRPr lang="en-US" dirty="0"/>
-          </a:p>
-          <a:p>
+              <a:t>2-decimal USD (</a:t>
+            </a:r>
+            <a:r>
+              <a:rPr lang="en-US" dirty="0">
+                <a:hlinkClick r:id="rId7"/>
+              </a:rPr>
+              <a:t>ADR-0005</a:t>
+            </a:r>
             <a:r>
               <a:rPr lang="en-US" dirty="0"/>
-              <a:t>• EF Core – the ORM (the .NET counterpart to Hibernate).</a:t>
-            </a:r>
-            <a:endParaRPr lang="en-US" dirty="0"/>
-          </a:p>
-          <a:p>
-            <a:r>
-              <a:rPr lang="en-US" dirty="0"/>
-              <a:t>   – Transactions: saves a transfer's debit, credit, and history rows in a single DB transaction, so they either commit or roll back as a unit.</a:t>
-            </a:r>
-            <a:endParaRPr lang="en-US" dirty="0"/>
-          </a:p>
-          <a:p>
-            <a:r>
-              <a:rPr lang="en-US" dirty="0"/>
-              <a:t>   – Optimistic concurrency: rejects a write based on an outdated balance, e.g., two tabs withdrawing against the same $1,000 and overdrawing it. Doesn't lock account rows; assumes conflicts are rare.</a:t>
-            </a:r>
-            <a:endParaRPr lang="en-US" dirty="0"/>
-          </a:p>
-          <a:p>
-            <a:endParaRPr lang="en-US" dirty="0"/>
-          </a:p>
-          <a:p>
-            <a:r>
-              <a:rPr lang="en-US" dirty="0"/>
-              <a:t>Every option sits behind the same Application ports, so switching is an Infrastructure-only change.</a:t>
-            </a:r>
-            <a:endParaRPr lang="en-US" dirty="0"/>
-          </a:p>
-          <a:p>
-            <a:r>
-              <a:rPr lang="en-US" dirty="0"/>
-              <a:t>• SQLite in-memory – an in-memory connection string with one connection held open. Keeps EF Core, migrations, transactions, and constraints, but data is lost on restart. The best in-memory choice, e.g., for a demo mode.</a:t>
-            </a:r>
-            <a:endParaRPr lang="en-US" dirty="0"/>
-          </a:p>
-          <a:p>
-            <a:r>
-              <a:rPr lang="en-US" dirty="0"/>
-              <a:t>• Hand-written store – dictionaries behind a single lock. No dependencies, but the code itself must commit balance and history together instead of relying on a database transaction.</a:t>
-            </a:r>
-            <a:endParaRPr lang="en-US" dirty="0"/>
-          </a:p>
-          <a:p>
-            <a:r>
-              <a:rPr lang="en-US" dirty="0"/>
-              <a:t>• EF Core InMemory provider – discouraged by Microsoft. It isn't relational, ignores transactions, and enforces no constraints, so it can't prove the invariants.</a:t>
-            </a:r>
-            <a:endParaRPr lang="en-US" dirty="0"/>
-          </a:p>
-          <a:p>
-            <a:r>
-              <a:rPr lang="en-US" dirty="0"/>
-              <a:t>• Redis – a separate server process to install and run, and atomic transfers need MULTI/EXEC or Lua scripts. More operational machinery than this exercise needs, and still volatile unless its persistence is configured.</a:t>
+              <a:t>). Cost: single-currency support. Amounts are decimal with at most two fractional digits, which rules out floating-point error. The two-digit rule fits USD only, and there is no currency field, so supporting another currency (e.g., JPY with 0 places or KWD with 3) would change the Money type.</a:t>
             </a:r>
             <a:endParaRPr lang="en-US" dirty="0"/>
           </a:p>
@@ -1070,7 +1045,83 @@
           <a:p>
             <a:r>
               <a:rPr lang="en-US" dirty="0"/>
-              <a:t>The screenshot is a real rejected overdraft. The typed value stays visible, the error names the available balance, and persisted state is unchanged. Account versions turn stale writes into a safe retry instead of lost data.</a:t>
+              <a:t>An in-memory store would have been enough. I chose a persistent one so balances and history survive restarts (</a:t>
+            </a:r>
+            <a:r>
+              <a:rPr lang="en-US" dirty="0">
+                <a:hlinkClick r:id="rId3"/>
+              </a:rPr>
+              <a:t>ADR-0003</a:t>
+            </a:r>
+            <a:r>
+              <a:rPr lang="en-US" dirty="0"/>
+              <a:t>).</a:t>
+            </a:r>
+            <a:endParaRPr lang="en-US" dirty="0"/>
+          </a:p>
+          <a:p>
+            <a:r>
+              <a:rPr lang="en-US" dirty="0"/>
+              <a:t>• SQLite – single-file DB with near-zero setup.</a:t>
+            </a:r>
+            <a:endParaRPr lang="en-US" dirty="0"/>
+          </a:p>
+          <a:p>
+            <a:r>
+              <a:rPr lang="en-US" dirty="0"/>
+              <a:t>• EF Core – the ORM (the .NET counterpart to Hibernate).</a:t>
+            </a:r>
+            <a:endParaRPr lang="en-US" dirty="0"/>
+          </a:p>
+          <a:p>
+            <a:r>
+              <a:rPr lang="en-US" dirty="0"/>
+              <a:t>   – Transactions: saves a transfer's debit, credit, and history rows in a single DB transaction, so they either commit or roll back as a unit.</a:t>
+            </a:r>
+            <a:endParaRPr lang="en-US" dirty="0"/>
+          </a:p>
+          <a:p>
+            <a:r>
+              <a:rPr lang="en-US" dirty="0"/>
+              <a:t>   – Optimistic concurrency: rejects a write based on an outdated balance, e.g., two tabs withdrawing against the same $1,000 and overdrawing it. Doesn't lock account rows; assumes conflicts are rare.</a:t>
+            </a:r>
+            <a:endParaRPr lang="en-US" dirty="0"/>
+          </a:p>
+          <a:p>
+            <a:endParaRPr lang="en-US" dirty="0"/>
+          </a:p>
+          <a:p>
+            <a:r>
+              <a:rPr lang="en-US" dirty="0"/>
+              <a:t>Every option sits behind the same Application ports, so switching is an Infrastructure-only change.</a:t>
+            </a:r>
+            <a:endParaRPr lang="en-US" dirty="0"/>
+          </a:p>
+          <a:p>
+            <a:r>
+              <a:rPr lang="en-US" dirty="0"/>
+              <a:t>• SQLite in-memory – an in-memory connection string with one connection held open. Keeps EF Core, migrations, transactions, and constraints, but data is lost on restart. The best in-memory choice, e.g., for a demo mode.</a:t>
+            </a:r>
+            <a:endParaRPr lang="en-US" dirty="0"/>
+          </a:p>
+          <a:p>
+            <a:r>
+              <a:rPr lang="en-US" dirty="0"/>
+              <a:t>• Hand-written store – dictionaries behind a single lock. No dependencies, but the code itself must commit balance and history together instead of relying on a database transaction.</a:t>
+            </a:r>
+            <a:endParaRPr lang="en-US" dirty="0"/>
+          </a:p>
+          <a:p>
+            <a:r>
+              <a:rPr lang="en-US" dirty="0"/>
+              <a:t>• EF Core InMemory provider – discouraged by Microsoft. It isn't relational, ignores transactions, and enforces no constraints, so it can't prove the invariants.</a:t>
+            </a:r>
+            <a:endParaRPr lang="en-US" dirty="0"/>
+          </a:p>
+          <a:p>
+            <a:r>
+              <a:rPr lang="en-US" dirty="0"/>
+              <a:t>• Redis – a separate server process to install and run, and atomic transfers need MULTI/EXEC or Lua scripts. More operational machinery than this exercise needs, and still volatile unless its persistence is configured.</a:t>
             </a:r>
             <a:endParaRPr lang="en-US" dirty="0"/>
           </a:p>
@@ -1158,7 +1209,7 @@
           <a:p>
             <a:r>
               <a:rPr lang="en-US" dirty="0"/>
-              <a:t>Domain tests are pure. Application tests use hand-written fakes. Integration and HTTP tests exercise the real host with an isolated SQLite file per test, including concurrency conflicts, atomic rollback, Post/Redirect/Get, security, and accessibility structure. Commands: dotnet restore Atm.sln; dotnet build Atm.sln --no-restore; dotnet test Atm.sln --no-build.</a:t>
+              <a:t>The screenshot is a real rejected overdraft. The typed value stays visible, the error names the available balance, and persisted state is unchanged. Account versions turn stale writes into a safe retry instead of lost data.</a:t>
             </a:r>
             <a:endParaRPr lang="en-US" dirty="0"/>
           </a:p>
@@ -1246,17 +1297,7 @@
           <a:p>
             <a:r>
               <a:rPr lang="en-US" dirty="0"/>
-              <a:t>The omissions are conscious. The roadmap begins with the correctness gap that Post/Redirect/Get does not solve: a retried network request. The phone capture proves the existing presentation adapter already reflows at 380 pixels.</a:t>
-            </a:r>
-            <a:endParaRPr lang="en-US" dirty="0"/>
-          </a:p>
-          <a:p>
-            <a:endParaRPr lang="en-US" dirty="0"/>
-          </a:p>
-          <a:p>
-            <a:r>
-              <a:rPr lang="en-US" dirty="0"/>
-              <a:t>In a real bank, the Domain and Application layers would become a backend service behind an API that every channel (ATM, mobile, web, branch) shares, so the rules live in one place. This ATM would be one thin client. Splitting that backend into microservices becomes worthwhile once separate teams own accounts, transfers, and fraud and need to deploy independently. The inward dependencies here are what make that extraction straightforward.</a:t>
+              <a:t>Domain tests are pure. Application tests use hand-written fakes. Integration and HTTP tests exercise the real host with an isolated SQLite file per test, including concurrency conflicts, atomic rollback, Post/Redirect/Get, security, and accessibility structure. Commands: dotnet restore Atm.sln; dotnet build Atm.sln --no-restore; dotnet test Atm.sln --no-build.</a:t>
             </a:r>
             <a:endParaRPr lang="en-US" dirty="0"/>
           </a:p>
@@ -1280,6 +1321,104 @@
             <a:fld id="{F7021451-1387-4CA6-816F-3879F97B5CBC}" type="slidenum">
               <a:rPr lang="en-US"/>
               <a:t>7</a:t>
+            </a:fld>
+            <a:endParaRPr lang="en-US"/>
+          </a:p>
+        </p:txBody>
+      </p:sp>
+    </p:spTree>
+    <p:extLst>
+      <p:ext uri="{BB962C8B-B14F-4D97-AF65-F5344CB8AC3E}">
+        <p14:creationId xmlns:p14="http://schemas.microsoft.com/office/powerpoint/2010/main" val="1024086991"/>
+      </p:ext>
+    </p:extLst>
+  </p:cSld>
+  <p:clrMapOvr>
+    <a:masterClrMapping/>
+  </p:clrMapOvr>
+</p:notes>
+</file>
+
+<file path=ppt/notesSlides/notesSlide8.xml><?xml version="1.0" encoding="utf-8"?>
+<p:notes xmlns:a="http://schemas.openxmlformats.org/drawingml/2006/main" xmlns:r="http://schemas.openxmlformats.org/officeDocument/2006/relationships" xmlns:p="http://schemas.openxmlformats.org/presentationml/2006/main">
+  <p:cSld>
+    <p:spTree>
+      <p:nvGrpSpPr>
+        <p:cNvPr id="1" name=""/>
+        <p:cNvGrpSpPr/>
+        <p:nvPr/>
+      </p:nvGrpSpPr>
+      <p:grpSpPr>
+        <a:xfrm>
+          <a:off x="0" y="0"/>
+          <a:ext cx="0" cy="0"/>
+          <a:chOff x="0" y="0"/>
+          <a:chExt cx="0" cy="0"/>
+        </a:xfrm>
+      </p:grpSpPr>
+      <p:sp>
+        <p:nvSpPr>
+          <p:cNvPr id="2" name="Slide Image Placeholder 1"/>
+          <p:cNvSpPr>
+            <a:spLocks noGrp="1" noRot="1" noChangeAspect="1"/>
+          </p:cNvSpPr>
+          <p:nvPr>
+            <p:ph type="sldImg"/>
+          </p:nvPr>
+        </p:nvSpPr>
+        <p:spPr/>
+      </p:sp>
+      <p:sp>
+        <p:nvSpPr>
+          <p:cNvPr id="3" name="Notes Placeholder 2"/>
+          <p:cNvSpPr>
+            <a:spLocks noGrp="1"/>
+          </p:cNvSpPr>
+          <p:nvPr>
+            <p:ph type="body" idx="1"/>
+          </p:nvPr>
+        </p:nvSpPr>
+        <p:spPr/>
+        <p:txBody>
+          <a:bodyPr/>
+          <a:lstStyle/>
+          <a:p>
+            <a:r>
+              <a:rPr lang="en-US" dirty="0"/>
+              <a:t>The omissions are conscious. The roadmap begins with the correctness gap that Post/Redirect/Get does not solve: a retried network request. The phone capture proves the existing presentation adapter already reflows at 380 pixels.</a:t>
+            </a:r>
+            <a:endParaRPr lang="en-US" dirty="0"/>
+          </a:p>
+          <a:p>
+            <a:endParaRPr lang="en-US" dirty="0"/>
+          </a:p>
+          <a:p>
+            <a:r>
+              <a:rPr lang="en-US" dirty="0"/>
+              <a:t>In a real bank, the Domain and Application layers would become a backend service behind an API that every channel (ATM, mobile, web, branch) shares, so the rules live in one place. This ATM would be one thin client. Splitting that backend into microservices becomes worthwhile once separate teams own accounts, transfers, and fraud and need to deploy independently. The inward dependencies here are what make that extraction straightforward.</a:t>
+            </a:r>
+            <a:endParaRPr lang="en-US" dirty="0"/>
+          </a:p>
+        </p:txBody>
+      </p:sp>
+      <p:sp>
+        <p:nvSpPr>
+          <p:cNvPr id="4" name="Slide Number Placeholder 3"/>
+          <p:cNvSpPr>
+            <a:spLocks noGrp="1"/>
+          </p:cNvSpPr>
+          <p:nvPr>
+            <p:ph type="sldNum" sz="quarter" idx="10"/>
+          </p:nvPr>
+        </p:nvSpPr>
+        <p:spPr/>
+        <p:txBody>
+          <a:bodyPr/>
+          <a:lstStyle/>
+          <a:p>
+            <a:fld id="{F7021451-1387-4CA6-816F-3879F97B5CBC}" type="slidenum">
+              <a:rPr lang="en-US"/>
+              <a:t>8</a:t>
             </a:fld>
             <a:endParaRPr lang="en-US"/>
           </a:p>
@@ -1988,7 +2127,7 @@
                 <a:ea typeface="Avenir Next" pitchFamily="34" charset="-122"/>
                 <a:cs typeface="Avenir Next" pitchFamily="34" charset="-120"/>
               </a:rPr>
-              <a:t>Technology stack</a:t>
+              <a:t>How I AI'ed</a:t>
             </a:r>
             <a:endParaRPr lang="en-US" sz="3200" dirty="0"/>
           </a:p>
@@ -2029,7 +2168,7 @@
                 <a:ea typeface="Avenir Next" pitchFamily="34" charset="-122"/>
                 <a:cs typeface="Avenir Next" pitchFamily="34" charset="-120"/>
               </a:rPr>
-              <a:t>FRONTEND</a:t>
+              <a:t>FRAME</a:t>
             </a:r>
             <a:endParaRPr lang="en-US" sz="1100" dirty="0"/>
           </a:p>
@@ -2070,7 +2209,7 @@
                 <a:ea typeface="Avenir Next" pitchFamily="34" charset="-122"/>
                 <a:cs typeface="Avenir Next" pitchFamily="34" charset="-120"/>
               </a:rPr>
-              <a:t>Razor Pages, vanilla JavaScript, CSS</a:t>
+              <a:t>GPT-5.6 in Codex</a:t>
             </a:r>
             <a:endParaRPr lang="en-US" sz="2000" dirty="0"/>
           </a:p>
@@ -2111,7 +2250,7 @@
                 <a:ea typeface="Avenir Next" pitchFamily="34" charset="-122"/>
                 <a:cs typeface="Avenir Next" pitchFamily="34" charset="-120"/>
               </a:rPr>
-              <a:t>No client framework or packages</a:t>
+              <a:t>I approved spec, plan, ADRs</a:t>
             </a:r>
             <a:endParaRPr lang="en-US" sz="1250" dirty="0"/>
           </a:p>
@@ -2125,7 +2264,7 @@
         </p:nvSpPr>
         <p:spPr>
           <a:xfrm>
-            <a:off x="585216" y="1993392"/>
+            <a:off x="585216" y="2066544"/>
             <a:ext cx="7973568" cy="0"/>
           </a:xfrm>
           <a:prstGeom prst="line">
@@ -2148,7 +2287,7 @@
         </p:nvSpPr>
         <p:spPr>
           <a:xfrm>
-            <a:off x="585216" y="2231136"/>
+            <a:off x="585216" y="2322576"/>
             <a:ext cx="1737360" cy="228600"/>
           </a:xfrm>
           <a:prstGeom prst="rect">
@@ -2175,7 +2314,7 @@
                 <a:ea typeface="Avenir Next" pitchFamily="34" charset="-122"/>
                 <a:cs typeface="Avenir Next" pitchFamily="34" charset="-120"/>
               </a:rPr>
-              <a:t>BACKEND</a:t>
+              <a:t>BUILD</a:t>
             </a:r>
             <a:endParaRPr lang="en-US" sz="1100" dirty="0"/>
           </a:p>
@@ -2189,7 +2328,7 @@
         </p:nvSpPr>
         <p:spPr>
           <a:xfrm>
-            <a:off x="2468880" y="2176272"/>
+            <a:off x="2468880" y="2267712"/>
             <a:ext cx="6089904" cy="329184"/>
           </a:xfrm>
           <a:prstGeom prst="rect">
@@ -2216,7 +2355,7 @@
                 <a:ea typeface="Avenir Next" pitchFamily="34" charset="-122"/>
                 <a:cs typeface="Avenir Next" pitchFamily="34" charset="-120"/>
               </a:rPr>
-              <a:t>C# 14 on .NET 10</a:t>
+              <a:t>Fable 5.1 in Claude Code</a:t>
             </a:r>
             <a:endParaRPr lang="en-US" sz="2000" dirty="0"/>
           </a:p>
@@ -2230,7 +2369,7 @@
         </p:nvSpPr>
         <p:spPr>
           <a:xfrm>
-            <a:off x="2468880" y="2523744"/>
+            <a:off x="2468880" y="2615184"/>
             <a:ext cx="6089904" cy="219456"/>
           </a:xfrm>
           <a:prstGeom prst="rect">
@@ -2257,7 +2396,7 @@
                 <a:ea typeface="Avenir Next" pitchFamily="34" charset="-122"/>
                 <a:cs typeface="Avenir Next" pitchFamily="34" charset="-120"/>
               </a:rPr>
-              <a:t>ASP.NET Core</a:t>
+              <a:t>Six phases, tests green per commit</a:t>
             </a:r>
             <a:endParaRPr lang="en-US" sz="1250" dirty="0"/>
           </a:p>
@@ -2265,13 +2404,54 @@
       </p:sp>
       <p:sp>
         <p:nvSpPr>
-          <p:cNvPr id="12" name="Shape 9"/>
+          <p:cNvPr id="12" name="Text 9"/>
+          <p:cNvSpPr txBox="1"/>
+          <p:nvPr/>
+        </p:nvSpPr>
+        <p:spPr>
+          <a:xfrm>
+            <a:off x="2468880" y="2889504"/>
+            <a:ext cx="6089904" cy="219456"/>
+          </a:xfrm>
+          <a:prstGeom prst="rect">
+            <a:avLst/>
+          </a:prstGeom>
+          <a:noFill/>
+          <a:ln/>
+        </p:spPr>
+        <p:txBody>
+          <a:bodyPr wrap="square" lIns="0" tIns="0" rIns="0" bIns="0" rtlCol="0" anchor="t">
+            <a:normAutofit/>
+          </a:bodyPr>
+          <a:lstStyle/>
+          <a:p>
+            <a:pPr indent="0" marL="0">
+              <a:buNone/>
+            </a:pPr>
+            <a:r>
+              <a:rPr lang="en-US" sz="1250" b="1" dirty="0">
+                <a:solidFill>
+                  <a:srgbClr val="F67F00"/>
+                </a:solidFill>
+                <a:latin typeface="Avenir Next" pitchFamily="34" charset="0"/>
+                <a:ea typeface="Avenir Next" pitchFamily="34" charset="-122"/>
+                <a:cs typeface="Avenir Next" pitchFamily="34" charset="-120"/>
+              </a:rPr>
+              <a:t>Chose speed over token cost</a:t>
+            </a:r>
+            <a:endParaRPr lang="en-US" sz="1250" dirty="0"/>
+          </a:p>
+        </p:txBody>
+      </p:sp>
+      <p:sp>
+        <p:nvSpPr>
+          <p:cNvPr id="13" name="Shape 10"/>
           <p:cNvSpPr/>
           <p:nvPr/>
         </p:nvSpPr>
         <p:spPr>
           <a:xfrm>
-            <a:off x="585216" y="2907792"/>
+            <a:off x="585216" y="3255264"/>
             <a:ext cx="7973568" cy="0"/>
           </a:xfrm>
           <a:prstGeom prst="line">
@@ -2288,13 +2468,13 @@
       </p:sp>
       <p:sp>
         <p:nvSpPr>
-          <p:cNvPr id="13" name="Text 10"/>
-          <p:cNvSpPr txBox="1"/>
-          <p:nvPr/>
-        </p:nvSpPr>
-        <p:spPr>
-          <a:xfrm>
-            <a:off x="585216" y="3145536"/>
+          <p:cNvPr id="14" name="Text 11"/>
+          <p:cNvSpPr txBox="1"/>
+          <p:nvPr/>
+        </p:nvSpPr>
+        <p:spPr>
+          <a:xfrm>
+            <a:off x="585216" y="3511296"/>
             <a:ext cx="1737360" cy="228600"/>
           </a:xfrm>
           <a:prstGeom prst="rect">
@@ -2321,7 +2501,7 @@
                 <a:ea typeface="Avenir Next" pitchFamily="34" charset="-122"/>
                 <a:cs typeface="Avenir Next" pitchFamily="34" charset="-120"/>
               </a:rPr>
-              <a:t>DATABASE</a:t>
+              <a:t>REFINE</a:t>
             </a:r>
             <a:endParaRPr lang="en-US" sz="1100" dirty="0"/>
           </a:p>
@@ -2329,13 +2509,13 @@
       </p:sp>
       <p:sp>
         <p:nvSpPr>
-          <p:cNvPr id="14" name="Text 11"/>
-          <p:cNvSpPr txBox="1"/>
-          <p:nvPr/>
-        </p:nvSpPr>
-        <p:spPr>
-          <a:xfrm>
-            <a:off x="2468880" y="3090672"/>
+          <p:cNvPr id="15" name="Text 12"/>
+          <p:cNvSpPr txBox="1"/>
+          <p:nvPr/>
+        </p:nvSpPr>
+        <p:spPr>
+          <a:xfrm>
+            <a:off x="2468880" y="3456432"/>
             <a:ext cx="6089904" cy="329184"/>
           </a:xfrm>
           <a:prstGeom prst="rect">
@@ -2362,7 +2542,7 @@
                 <a:ea typeface="Avenir Next" pitchFamily="34" charset="-122"/>
                 <a:cs typeface="Avenir Next" pitchFamily="34" charset="-120"/>
               </a:rPr>
-              <a:t>SQLite via EF Core 10</a:t>
+              <a:t>Opus 5.5, GPT-6</a:t>
             </a:r>
             <a:endParaRPr lang="en-US" sz="2000" dirty="0"/>
           </a:p>
@@ -2370,13 +2550,13 @@
       </p:sp>
       <p:sp>
         <p:nvSpPr>
-          <p:cNvPr id="15" name="Text 12"/>
-          <p:cNvSpPr txBox="1"/>
-          <p:nvPr/>
-        </p:nvSpPr>
-        <p:spPr>
-          <a:xfrm>
-            <a:off x="2468880" y="3438144"/>
+          <p:cNvPr id="16" name="Text 13"/>
+          <p:cNvSpPr txBox="1"/>
+          <p:nvPr/>
+        </p:nvSpPr>
+        <p:spPr>
+          <a:xfrm>
+            <a:off x="2468880" y="3803904"/>
             <a:ext cx="6089904" cy="219456"/>
           </a:xfrm>
           <a:prstGeom prst="rect">
@@ -2403,114 +2583,9 @@
                 <a:ea typeface="Avenir Next" pitchFamily="34" charset="-122"/>
                 <a:cs typeface="Avenir Next" pitchFamily="34" charset="-120"/>
               </a:rPr>
-              <a:t>Code-first migrations</a:t>
+              <a:t>Docs, deck, fixes</a:t>
             </a:r>
             <a:endParaRPr lang="en-US" sz="1250" dirty="0"/>
-          </a:p>
-        </p:txBody>
-      </p:sp>
-      <p:sp>
-        <p:nvSpPr>
-          <p:cNvPr id="16" name="Shape 13"/>
-          <p:cNvSpPr/>
-          <p:nvPr/>
-        </p:nvSpPr>
-        <p:spPr>
-          <a:xfrm>
-            <a:off x="585216" y="3822192"/>
-            <a:ext cx="7973568" cy="0"/>
-          </a:xfrm>
-          <a:prstGeom prst="line">
-            <a:avLst/>
-          </a:prstGeom>
-          <a:noFill/>
-          <a:ln w="9525">
-            <a:solidFill>
-              <a:srgbClr val="333333"/>
-            </a:solidFill>
-            <a:prstDash val="solid"/>
-          </a:ln>
-        </p:spPr>
-      </p:sp>
-      <p:sp>
-        <p:nvSpPr>
-          <p:cNvPr id="17" name="Text 14"/>
-          <p:cNvSpPr txBox="1"/>
-          <p:nvPr/>
-        </p:nvSpPr>
-        <p:spPr>
-          <a:xfrm>
-            <a:off x="585216" y="4059936"/>
-            <a:ext cx="1737360" cy="228600"/>
-          </a:xfrm>
-          <a:prstGeom prst="rect">
-            <a:avLst/>
-          </a:prstGeom>
-          <a:noFill/>
-          <a:ln/>
-        </p:spPr>
-        <p:txBody>
-          <a:bodyPr wrap="square" lIns="0" tIns="0" rIns="0" bIns="0" rtlCol="0" anchor="t">
-            <a:normAutofit/>
-          </a:bodyPr>
-          <a:lstStyle/>
-          <a:p>
-            <a:pPr indent="0" marL="0">
-              <a:buNone/>
-            </a:pPr>
-            <a:r>
-              <a:rPr lang="en-US" sz="1100" b="1" spc="160" kern="0" dirty="0">
-                <a:solidFill>
-                  <a:srgbClr val="00F604"/>
-                </a:solidFill>
-                <a:latin typeface="Avenir Next" pitchFamily="34" charset="0"/>
-                <a:ea typeface="Avenir Next" pitchFamily="34" charset="-122"/>
-                <a:cs typeface="Avenir Next" pitchFamily="34" charset="-120"/>
-              </a:rPr>
-              <a:t>TESTING</a:t>
-            </a:r>
-            <a:endParaRPr lang="en-US" sz="1100" dirty="0"/>
-          </a:p>
-        </p:txBody>
-      </p:sp>
-      <p:sp>
-        <p:nvSpPr>
-          <p:cNvPr id="18" name="Text 15"/>
-          <p:cNvSpPr txBox="1"/>
-          <p:nvPr/>
-        </p:nvSpPr>
-        <p:spPr>
-          <a:xfrm>
-            <a:off x="2468880" y="4005072"/>
-            <a:ext cx="6089904" cy="329184"/>
-          </a:xfrm>
-          <a:prstGeom prst="rect">
-            <a:avLst/>
-          </a:prstGeom>
-          <a:noFill/>
-          <a:ln/>
-        </p:spPr>
-        <p:txBody>
-          <a:bodyPr wrap="square" lIns="0" tIns="0" rIns="0" bIns="0" rtlCol="0" anchor="t">
-            <a:normAutofit/>
-          </a:bodyPr>
-          <a:lstStyle/>
-          <a:p>
-            <a:pPr indent="0" marL="0">
-              <a:buNone/>
-            </a:pPr>
-            <a:r>
-              <a:rPr lang="en-US" sz="2000" b="1" dirty="0">
-                <a:solidFill>
-                  <a:srgbClr val="F5F5F5"/>
-                </a:solidFill>
-                <a:latin typeface="Avenir Next" pitchFamily="34" charset="0"/>
-                <a:ea typeface="Avenir Next" pitchFamily="34" charset="-122"/>
-                <a:cs typeface="Avenir Next" pitchFamily="34" charset="-120"/>
-              </a:rPr>
-              <a:t>xUnit, WebApplicationFactory, coverlet</a:t>
-            </a:r>
-            <a:endParaRPr lang="en-US" sz="2000" dirty="0"/>
           </a:p>
         </p:txBody>
       </p:sp>
@@ -2608,6 +2683,626 @@
                 <a:ea typeface="Avenir Next" pitchFamily="34" charset="-122"/>
                 <a:cs typeface="Avenir Next" pitchFamily="34" charset="-120"/>
               </a:rPr>
+              <a:t>Technology stack</a:t>
+            </a:r>
+            <a:endParaRPr lang="en-US" sz="3200" dirty="0"/>
+          </a:p>
+        </p:txBody>
+      </p:sp>
+      <p:sp>
+        <p:nvSpPr>
+          <p:cNvPr id="5" name="Text 2"/>
+          <p:cNvSpPr txBox="1"/>
+          <p:nvPr/>
+        </p:nvSpPr>
+        <p:spPr>
+          <a:xfrm>
+            <a:off x="585216" y="1316736"/>
+            <a:ext cx="1737360" cy="228600"/>
+          </a:xfrm>
+          <a:prstGeom prst="rect">
+            <a:avLst/>
+          </a:prstGeom>
+          <a:noFill/>
+          <a:ln/>
+        </p:spPr>
+        <p:txBody>
+          <a:bodyPr wrap="square" lIns="0" tIns="0" rIns="0" bIns="0" rtlCol="0" anchor="t">
+            <a:normAutofit/>
+          </a:bodyPr>
+          <a:lstStyle/>
+          <a:p>
+            <a:pPr indent="0" marL="0">
+              <a:buNone/>
+            </a:pPr>
+            <a:r>
+              <a:rPr lang="en-US" sz="1100" b="1" spc="160" kern="0" dirty="0">
+                <a:solidFill>
+                  <a:srgbClr val="00F604"/>
+                </a:solidFill>
+                <a:latin typeface="Avenir Next" pitchFamily="34" charset="0"/>
+                <a:ea typeface="Avenir Next" pitchFamily="34" charset="-122"/>
+                <a:cs typeface="Avenir Next" pitchFamily="34" charset="-120"/>
+              </a:rPr>
+              <a:t>FRONTEND</a:t>
+            </a:r>
+            <a:endParaRPr lang="en-US" sz="1100" dirty="0"/>
+          </a:p>
+        </p:txBody>
+      </p:sp>
+      <p:sp>
+        <p:nvSpPr>
+          <p:cNvPr id="6" name="Text 3"/>
+          <p:cNvSpPr txBox="1"/>
+          <p:nvPr/>
+        </p:nvSpPr>
+        <p:spPr>
+          <a:xfrm>
+            <a:off x="2468880" y="1261872"/>
+            <a:ext cx="6089904" cy="329184"/>
+          </a:xfrm>
+          <a:prstGeom prst="rect">
+            <a:avLst/>
+          </a:prstGeom>
+          <a:noFill/>
+          <a:ln/>
+        </p:spPr>
+        <p:txBody>
+          <a:bodyPr wrap="square" lIns="0" tIns="0" rIns="0" bIns="0" rtlCol="0" anchor="t">
+            <a:normAutofit/>
+          </a:bodyPr>
+          <a:lstStyle/>
+          <a:p>
+            <a:pPr indent="0" marL="0">
+              <a:buNone/>
+            </a:pPr>
+            <a:r>
+              <a:rPr lang="en-US" sz="2000" b="1" dirty="0">
+                <a:solidFill>
+                  <a:srgbClr val="F5F5F5"/>
+                </a:solidFill>
+                <a:latin typeface="Avenir Next" pitchFamily="34" charset="0"/>
+                <a:ea typeface="Avenir Next" pitchFamily="34" charset="-122"/>
+                <a:cs typeface="Avenir Next" pitchFamily="34" charset="-120"/>
+              </a:rPr>
+              <a:t>Razor Pages, vanilla JavaScript, CSS</a:t>
+            </a:r>
+            <a:endParaRPr lang="en-US" sz="2000" dirty="0"/>
+          </a:p>
+        </p:txBody>
+      </p:sp>
+      <p:sp>
+        <p:nvSpPr>
+          <p:cNvPr id="7" name="Text 4"/>
+          <p:cNvSpPr txBox="1"/>
+          <p:nvPr/>
+        </p:nvSpPr>
+        <p:spPr>
+          <a:xfrm>
+            <a:off x="2468880" y="1609344"/>
+            <a:ext cx="6089904" cy="219456"/>
+          </a:xfrm>
+          <a:prstGeom prst="rect">
+            <a:avLst/>
+          </a:prstGeom>
+          <a:noFill/>
+          <a:ln/>
+        </p:spPr>
+        <p:txBody>
+          <a:bodyPr wrap="square" lIns="0" tIns="0" rIns="0" bIns="0" rtlCol="0" anchor="t">
+            <a:normAutofit/>
+          </a:bodyPr>
+          <a:lstStyle/>
+          <a:p>
+            <a:pPr indent="0" marL="0">
+              <a:buNone/>
+            </a:pPr>
+            <a:r>
+              <a:rPr lang="en-US" sz="1250" dirty="0">
+                <a:solidFill>
+                  <a:srgbClr val="A9ADB3"/>
+                </a:solidFill>
+                <a:latin typeface="Avenir Next" pitchFamily="34" charset="0"/>
+                <a:ea typeface="Avenir Next" pitchFamily="34" charset="-122"/>
+                <a:cs typeface="Avenir Next" pitchFamily="34" charset="-120"/>
+              </a:rPr>
+              <a:t>No client framework or packages</a:t>
+            </a:r>
+            <a:endParaRPr lang="en-US" sz="1250" dirty="0"/>
+          </a:p>
+        </p:txBody>
+      </p:sp>
+      <p:sp>
+        <p:nvSpPr>
+          <p:cNvPr id="8" name="Shape 5"/>
+          <p:cNvSpPr/>
+          <p:nvPr/>
+        </p:nvSpPr>
+        <p:spPr>
+          <a:xfrm>
+            <a:off x="585216" y="1993392"/>
+            <a:ext cx="7973568" cy="0"/>
+          </a:xfrm>
+          <a:prstGeom prst="line">
+            <a:avLst/>
+          </a:prstGeom>
+          <a:noFill/>
+          <a:ln w="9525">
+            <a:solidFill>
+              <a:srgbClr val="333333"/>
+            </a:solidFill>
+            <a:prstDash val="solid"/>
+          </a:ln>
+        </p:spPr>
+      </p:sp>
+      <p:sp>
+        <p:nvSpPr>
+          <p:cNvPr id="9" name="Text 6"/>
+          <p:cNvSpPr txBox="1"/>
+          <p:nvPr/>
+        </p:nvSpPr>
+        <p:spPr>
+          <a:xfrm>
+            <a:off x="585216" y="2231136"/>
+            <a:ext cx="1737360" cy="228600"/>
+          </a:xfrm>
+          <a:prstGeom prst="rect">
+            <a:avLst/>
+          </a:prstGeom>
+          <a:noFill/>
+          <a:ln/>
+        </p:spPr>
+        <p:txBody>
+          <a:bodyPr wrap="square" lIns="0" tIns="0" rIns="0" bIns="0" rtlCol="0" anchor="t">
+            <a:normAutofit/>
+          </a:bodyPr>
+          <a:lstStyle/>
+          <a:p>
+            <a:pPr indent="0" marL="0">
+              <a:buNone/>
+            </a:pPr>
+            <a:r>
+              <a:rPr lang="en-US" sz="1100" b="1" spc="160" kern="0" dirty="0">
+                <a:solidFill>
+                  <a:srgbClr val="00F604"/>
+                </a:solidFill>
+                <a:latin typeface="Avenir Next" pitchFamily="34" charset="0"/>
+                <a:ea typeface="Avenir Next" pitchFamily="34" charset="-122"/>
+                <a:cs typeface="Avenir Next" pitchFamily="34" charset="-120"/>
+              </a:rPr>
+              <a:t>BACKEND</a:t>
+            </a:r>
+            <a:endParaRPr lang="en-US" sz="1100" dirty="0"/>
+          </a:p>
+        </p:txBody>
+      </p:sp>
+      <p:sp>
+        <p:nvSpPr>
+          <p:cNvPr id="10" name="Text 7"/>
+          <p:cNvSpPr txBox="1"/>
+          <p:nvPr/>
+        </p:nvSpPr>
+        <p:spPr>
+          <a:xfrm>
+            <a:off x="2468880" y="2176272"/>
+            <a:ext cx="6089904" cy="329184"/>
+          </a:xfrm>
+          <a:prstGeom prst="rect">
+            <a:avLst/>
+          </a:prstGeom>
+          <a:noFill/>
+          <a:ln/>
+        </p:spPr>
+        <p:txBody>
+          <a:bodyPr wrap="square" lIns="0" tIns="0" rIns="0" bIns="0" rtlCol="0" anchor="t">
+            <a:normAutofit/>
+          </a:bodyPr>
+          <a:lstStyle/>
+          <a:p>
+            <a:pPr indent="0" marL="0">
+              <a:buNone/>
+            </a:pPr>
+            <a:r>
+              <a:rPr lang="en-US" sz="2000" b="1" dirty="0">
+                <a:solidFill>
+                  <a:srgbClr val="F5F5F5"/>
+                </a:solidFill>
+                <a:latin typeface="Avenir Next" pitchFamily="34" charset="0"/>
+                <a:ea typeface="Avenir Next" pitchFamily="34" charset="-122"/>
+                <a:cs typeface="Avenir Next" pitchFamily="34" charset="-120"/>
+              </a:rPr>
+              <a:t>C# 14 on .NET 10</a:t>
+            </a:r>
+            <a:endParaRPr lang="en-US" sz="2000" dirty="0"/>
+          </a:p>
+        </p:txBody>
+      </p:sp>
+      <p:sp>
+        <p:nvSpPr>
+          <p:cNvPr id="11" name="Text 8"/>
+          <p:cNvSpPr txBox="1"/>
+          <p:nvPr/>
+        </p:nvSpPr>
+        <p:spPr>
+          <a:xfrm>
+            <a:off x="2468880" y="2523744"/>
+            <a:ext cx="6089904" cy="219456"/>
+          </a:xfrm>
+          <a:prstGeom prst="rect">
+            <a:avLst/>
+          </a:prstGeom>
+          <a:noFill/>
+          <a:ln/>
+        </p:spPr>
+        <p:txBody>
+          <a:bodyPr wrap="square" lIns="0" tIns="0" rIns="0" bIns="0" rtlCol="0" anchor="t">
+            <a:normAutofit/>
+          </a:bodyPr>
+          <a:lstStyle/>
+          <a:p>
+            <a:pPr indent="0" marL="0">
+              <a:buNone/>
+            </a:pPr>
+            <a:r>
+              <a:rPr lang="en-US" sz="1250" dirty="0">
+                <a:solidFill>
+                  <a:srgbClr val="A9ADB3"/>
+                </a:solidFill>
+                <a:latin typeface="Avenir Next" pitchFamily="34" charset="0"/>
+                <a:ea typeface="Avenir Next" pitchFamily="34" charset="-122"/>
+                <a:cs typeface="Avenir Next" pitchFamily="34" charset="-120"/>
+              </a:rPr>
+              <a:t>ASP.NET Core</a:t>
+            </a:r>
+            <a:endParaRPr lang="en-US" sz="1250" dirty="0"/>
+          </a:p>
+        </p:txBody>
+      </p:sp>
+      <p:sp>
+        <p:nvSpPr>
+          <p:cNvPr id="12" name="Shape 9"/>
+          <p:cNvSpPr/>
+          <p:nvPr/>
+        </p:nvSpPr>
+        <p:spPr>
+          <a:xfrm>
+            <a:off x="585216" y="2907792"/>
+            <a:ext cx="7973568" cy="0"/>
+          </a:xfrm>
+          <a:prstGeom prst="line">
+            <a:avLst/>
+          </a:prstGeom>
+          <a:noFill/>
+          <a:ln w="9525">
+            <a:solidFill>
+              <a:srgbClr val="333333"/>
+            </a:solidFill>
+            <a:prstDash val="solid"/>
+          </a:ln>
+        </p:spPr>
+      </p:sp>
+      <p:sp>
+        <p:nvSpPr>
+          <p:cNvPr id="13" name="Text 10"/>
+          <p:cNvSpPr txBox="1"/>
+          <p:nvPr/>
+        </p:nvSpPr>
+        <p:spPr>
+          <a:xfrm>
+            <a:off x="585216" y="3145536"/>
+            <a:ext cx="1737360" cy="228600"/>
+          </a:xfrm>
+          <a:prstGeom prst="rect">
+            <a:avLst/>
+          </a:prstGeom>
+          <a:noFill/>
+          <a:ln/>
+        </p:spPr>
+        <p:txBody>
+          <a:bodyPr wrap="square" lIns="0" tIns="0" rIns="0" bIns="0" rtlCol="0" anchor="t">
+            <a:normAutofit/>
+          </a:bodyPr>
+          <a:lstStyle/>
+          <a:p>
+            <a:pPr indent="0" marL="0">
+              <a:buNone/>
+            </a:pPr>
+            <a:r>
+              <a:rPr lang="en-US" sz="1100" b="1" spc="160" kern="0" dirty="0">
+                <a:solidFill>
+                  <a:srgbClr val="00F604"/>
+                </a:solidFill>
+                <a:latin typeface="Avenir Next" pitchFamily="34" charset="0"/>
+                <a:ea typeface="Avenir Next" pitchFamily="34" charset="-122"/>
+                <a:cs typeface="Avenir Next" pitchFamily="34" charset="-120"/>
+              </a:rPr>
+              <a:t>DATABASE</a:t>
+            </a:r>
+            <a:endParaRPr lang="en-US" sz="1100" dirty="0"/>
+          </a:p>
+        </p:txBody>
+      </p:sp>
+      <p:sp>
+        <p:nvSpPr>
+          <p:cNvPr id="14" name="Text 11"/>
+          <p:cNvSpPr txBox="1"/>
+          <p:nvPr/>
+        </p:nvSpPr>
+        <p:spPr>
+          <a:xfrm>
+            <a:off x="2468880" y="3090672"/>
+            <a:ext cx="6089904" cy="329184"/>
+          </a:xfrm>
+          <a:prstGeom prst="rect">
+            <a:avLst/>
+          </a:prstGeom>
+          <a:noFill/>
+          <a:ln/>
+        </p:spPr>
+        <p:txBody>
+          <a:bodyPr wrap="square" lIns="0" tIns="0" rIns="0" bIns="0" rtlCol="0" anchor="t">
+            <a:normAutofit/>
+          </a:bodyPr>
+          <a:lstStyle/>
+          <a:p>
+            <a:pPr indent="0" marL="0">
+              <a:buNone/>
+            </a:pPr>
+            <a:r>
+              <a:rPr lang="en-US" sz="2000" b="1" dirty="0">
+                <a:solidFill>
+                  <a:srgbClr val="F5F5F5"/>
+                </a:solidFill>
+                <a:latin typeface="Avenir Next" pitchFamily="34" charset="0"/>
+                <a:ea typeface="Avenir Next" pitchFamily="34" charset="-122"/>
+                <a:cs typeface="Avenir Next" pitchFamily="34" charset="-120"/>
+              </a:rPr>
+              <a:t>SQLite via EF Core 10</a:t>
+            </a:r>
+            <a:endParaRPr lang="en-US" sz="2000" dirty="0"/>
+          </a:p>
+        </p:txBody>
+      </p:sp>
+      <p:sp>
+        <p:nvSpPr>
+          <p:cNvPr id="15" name="Text 12"/>
+          <p:cNvSpPr txBox="1"/>
+          <p:nvPr/>
+        </p:nvSpPr>
+        <p:spPr>
+          <a:xfrm>
+            <a:off x="2468880" y="3438144"/>
+            <a:ext cx="6089904" cy="219456"/>
+          </a:xfrm>
+          <a:prstGeom prst="rect">
+            <a:avLst/>
+          </a:prstGeom>
+          <a:noFill/>
+          <a:ln/>
+        </p:spPr>
+        <p:txBody>
+          <a:bodyPr wrap="square" lIns="0" tIns="0" rIns="0" bIns="0" rtlCol="0" anchor="t">
+            <a:normAutofit/>
+          </a:bodyPr>
+          <a:lstStyle/>
+          <a:p>
+            <a:pPr indent="0" marL="0">
+              <a:buNone/>
+            </a:pPr>
+            <a:r>
+              <a:rPr lang="en-US" sz="1250" dirty="0">
+                <a:solidFill>
+                  <a:srgbClr val="A9ADB3"/>
+                </a:solidFill>
+                <a:latin typeface="Avenir Next" pitchFamily="34" charset="0"/>
+                <a:ea typeface="Avenir Next" pitchFamily="34" charset="-122"/>
+                <a:cs typeface="Avenir Next" pitchFamily="34" charset="-120"/>
+              </a:rPr>
+              <a:t>Code-first migrations</a:t>
+            </a:r>
+            <a:endParaRPr lang="en-US" sz="1250" dirty="0"/>
+          </a:p>
+        </p:txBody>
+      </p:sp>
+      <p:sp>
+        <p:nvSpPr>
+          <p:cNvPr id="16" name="Shape 13"/>
+          <p:cNvSpPr/>
+          <p:nvPr/>
+        </p:nvSpPr>
+        <p:spPr>
+          <a:xfrm>
+            <a:off x="585216" y="3822192"/>
+            <a:ext cx="7973568" cy="0"/>
+          </a:xfrm>
+          <a:prstGeom prst="line">
+            <a:avLst/>
+          </a:prstGeom>
+          <a:noFill/>
+          <a:ln w="9525">
+            <a:solidFill>
+              <a:srgbClr val="333333"/>
+            </a:solidFill>
+            <a:prstDash val="solid"/>
+          </a:ln>
+        </p:spPr>
+      </p:sp>
+      <p:sp>
+        <p:nvSpPr>
+          <p:cNvPr id="17" name="Text 14"/>
+          <p:cNvSpPr txBox="1"/>
+          <p:nvPr/>
+        </p:nvSpPr>
+        <p:spPr>
+          <a:xfrm>
+            <a:off x="585216" y="4059936"/>
+            <a:ext cx="1737360" cy="228600"/>
+          </a:xfrm>
+          <a:prstGeom prst="rect">
+            <a:avLst/>
+          </a:prstGeom>
+          <a:noFill/>
+          <a:ln/>
+        </p:spPr>
+        <p:txBody>
+          <a:bodyPr wrap="square" lIns="0" tIns="0" rIns="0" bIns="0" rtlCol="0" anchor="t">
+            <a:normAutofit/>
+          </a:bodyPr>
+          <a:lstStyle/>
+          <a:p>
+            <a:pPr indent="0" marL="0">
+              <a:buNone/>
+            </a:pPr>
+            <a:r>
+              <a:rPr lang="en-US" sz="1100" b="1" spc="160" kern="0" dirty="0">
+                <a:solidFill>
+                  <a:srgbClr val="00F604"/>
+                </a:solidFill>
+                <a:latin typeface="Avenir Next" pitchFamily="34" charset="0"/>
+                <a:ea typeface="Avenir Next" pitchFamily="34" charset="-122"/>
+                <a:cs typeface="Avenir Next" pitchFamily="34" charset="-120"/>
+              </a:rPr>
+              <a:t>TESTING</a:t>
+            </a:r>
+            <a:endParaRPr lang="en-US" sz="1100" dirty="0"/>
+          </a:p>
+        </p:txBody>
+      </p:sp>
+      <p:sp>
+        <p:nvSpPr>
+          <p:cNvPr id="18" name="Text 15"/>
+          <p:cNvSpPr txBox="1"/>
+          <p:nvPr/>
+        </p:nvSpPr>
+        <p:spPr>
+          <a:xfrm>
+            <a:off x="2468880" y="4005072"/>
+            <a:ext cx="6089904" cy="329184"/>
+          </a:xfrm>
+          <a:prstGeom prst="rect">
+            <a:avLst/>
+          </a:prstGeom>
+          <a:noFill/>
+          <a:ln/>
+        </p:spPr>
+        <p:txBody>
+          <a:bodyPr wrap="square" lIns="0" tIns="0" rIns="0" bIns="0" rtlCol="0" anchor="t">
+            <a:normAutofit/>
+          </a:bodyPr>
+          <a:lstStyle/>
+          <a:p>
+            <a:pPr indent="0" marL="0">
+              <a:buNone/>
+            </a:pPr>
+            <a:r>
+              <a:rPr lang="en-US" sz="2000" b="1" dirty="0">
+                <a:solidFill>
+                  <a:srgbClr val="F5F5F5"/>
+                </a:solidFill>
+                <a:latin typeface="Avenir Next" pitchFamily="34" charset="0"/>
+                <a:ea typeface="Avenir Next" pitchFamily="34" charset="-122"/>
+                <a:cs typeface="Avenir Next" pitchFamily="34" charset="-120"/>
+              </a:rPr>
+              <a:t>xUnit, WebApplicationFactory, coverlet</a:t>
+            </a:r>
+            <a:endParaRPr lang="en-US" sz="2000" dirty="0"/>
+          </a:p>
+        </p:txBody>
+      </p:sp>
+    </p:spTree>
+  </p:cSld>
+  <p:clrMapOvr>
+    <a:masterClrMapping/>
+  </p:clrMapOvr>
+</p:sld>
+</file>
+
+<file path=ppt/slides/slide4.xml><?xml version="1.0" encoding="utf-8"?>
+<p:sld xmlns:a="http://schemas.openxmlformats.org/drawingml/2006/main" xmlns:r="http://schemas.openxmlformats.org/officeDocument/2006/relationships" xmlns:p="http://schemas.openxmlformats.org/presentationml/2006/main">
+  <p:cSld name="Slide 4">
+    <p:bg>
+      <p:bgPr>
+        <a:solidFill>
+          <a:srgbClr val="121212"/>
+        </a:solidFill>
+      </p:bgPr>
+    </p:bg>
+    <p:spTree>
+      <p:nvGrpSpPr>
+        <p:cNvPr id="1" name=""/>
+        <p:cNvGrpSpPr/>
+        <p:nvPr/>
+      </p:nvGrpSpPr>
+      <p:grpSpPr>
+        <a:xfrm>
+          <a:off x="0" y="0"/>
+          <a:ext cx="0" cy="0"/>
+          <a:chOff x="0" y="0"/>
+          <a:chExt cx="0" cy="0"/>
+        </a:xfrm>
+      </p:grpSpPr>
+      <p:sp>
+        <p:nvSpPr>
+          <p:cNvPr id="2" name="Shape 0"/>
+          <p:cNvSpPr/>
+          <p:nvPr/>
+        </p:nvSpPr>
+        <p:spPr>
+          <a:xfrm>
+            <a:off x="585216" y="356616"/>
+            <a:ext cx="91440" cy="438912"/>
+          </a:xfrm>
+          <a:prstGeom prst="rect">
+            <a:avLst/>
+          </a:prstGeom>
+          <a:solidFill>
+            <a:srgbClr val="00F604"/>
+          </a:solidFill>
+          <a:ln w="12700">
+            <a:solidFill>
+              <a:srgbClr val="00F604">
+                <a:alpha val="0"/>
+              </a:srgbClr>
+            </a:solidFill>
+            <a:prstDash val="solid"/>
+          </a:ln>
+        </p:spPr>
+      </p:sp>
+      <p:sp>
+        <p:nvSpPr>
+          <p:cNvPr id="3" name="Text 1"/>
+          <p:cNvSpPr txBox="1"/>
+          <p:nvPr/>
+        </p:nvSpPr>
+        <p:spPr>
+          <a:xfrm>
+            <a:off x="832104" y="356616"/>
+            <a:ext cx="7726680" cy="512064"/>
+          </a:xfrm>
+          <a:prstGeom prst="rect">
+            <a:avLst/>
+          </a:prstGeom>
+          <a:noFill/>
+          <a:ln/>
+        </p:spPr>
+        <p:txBody>
+          <a:bodyPr wrap="square" lIns="0" tIns="0" rIns="0" bIns="0" rtlCol="0" anchor="t">
+            <a:normAutofit/>
+          </a:bodyPr>
+          <a:lstStyle/>
+          <a:p>
+            <a:pPr indent="0" marL="0">
+              <a:buNone/>
+            </a:pPr>
+            <a:r>
+              <a:rPr lang="en-US" sz="3200" b="1" dirty="0">
+                <a:solidFill>
+                  <a:srgbClr val="F5F5F5"/>
+                </a:solidFill>
+                <a:latin typeface="Avenir Next" pitchFamily="34" charset="0"/>
+                <a:ea typeface="Avenir Next" pitchFamily="34" charset="-122"/>
+                <a:cs typeface="Avenir Next" pitchFamily="34" charset="-120"/>
+              </a:rPr>
               <a:t>Decisions and costs</a:t>
             </a:r>
             <a:endParaRPr lang="en-US" sz="3200" dirty="0"/>
@@ -2616,7 +3311,7 @@
       </p:sp>
       <p:graphicFrame>
         <p:nvGraphicFramePr>
-          <p:cNvPr id="4" name="Table 0"/>
+          <p:cNvPr id="5" name="Table 0"/>
           <p:cNvGraphicFramePr>
             <a:graphicFrameLocks noGrp="1"/>
           </p:cNvGraphicFramePr>
@@ -3342,729 +4037,6 @@
 </p:sld>
 </file>
 
-<file path=ppt/slides/slide4.xml><?xml version="1.0" encoding="utf-8"?>
-<p:sld xmlns:a="http://schemas.openxmlformats.org/drawingml/2006/main" xmlns:r="http://schemas.openxmlformats.org/officeDocument/2006/relationships" xmlns:p="http://schemas.openxmlformats.org/presentationml/2006/main">
-  <p:cSld name="Slide 4">
-    <p:bg>
-      <p:bgPr>
-        <a:solidFill>
-          <a:srgbClr val="121212"/>
-        </a:solidFill>
-      </p:bgPr>
-    </p:bg>
-    <p:spTree>
-      <p:nvGrpSpPr>
-        <p:cNvPr id="1" name=""/>
-        <p:cNvGrpSpPr/>
-        <p:nvPr/>
-      </p:nvGrpSpPr>
-      <p:grpSpPr>
-        <a:xfrm>
-          <a:off x="0" y="0"/>
-          <a:ext cx="0" cy="0"/>
-          <a:chOff x="0" y="0"/>
-          <a:chExt cx="0" cy="0"/>
-        </a:xfrm>
-      </p:grpSpPr>
-      <p:sp>
-        <p:nvSpPr>
-          <p:cNvPr id="2" name="Shape 0"/>
-          <p:cNvSpPr/>
-          <p:nvPr/>
-        </p:nvSpPr>
-        <p:spPr>
-          <a:xfrm>
-            <a:off x="585216" y="356616"/>
-            <a:ext cx="91440" cy="438912"/>
-          </a:xfrm>
-          <a:prstGeom prst="rect">
-            <a:avLst/>
-          </a:prstGeom>
-          <a:solidFill>
-            <a:srgbClr val="00F604"/>
-          </a:solidFill>
-          <a:ln w="12700">
-            <a:solidFill>
-              <a:srgbClr val="00F604">
-                <a:alpha val="0"/>
-              </a:srgbClr>
-            </a:solidFill>
-            <a:prstDash val="solid"/>
-          </a:ln>
-        </p:spPr>
-      </p:sp>
-      <p:sp>
-        <p:nvSpPr>
-          <p:cNvPr id="3" name="Text 1"/>
-          <p:cNvSpPr txBox="1"/>
-          <p:nvPr/>
-        </p:nvSpPr>
-        <p:spPr>
-          <a:xfrm>
-            <a:off x="832104" y="356616"/>
-            <a:ext cx="7726680" cy="512064"/>
-          </a:xfrm>
-          <a:prstGeom prst="rect">
-            <a:avLst/>
-          </a:prstGeom>
-          <a:noFill/>
-          <a:ln/>
-        </p:spPr>
-        <p:txBody>
-          <a:bodyPr wrap="square" lIns="0" tIns="0" rIns="0" bIns="0" rtlCol="0" anchor="t">
-            <a:normAutofit/>
-          </a:bodyPr>
-          <a:lstStyle/>
-          <a:p>
-            <a:pPr indent="0" marL="0">
-              <a:buNone/>
-            </a:pPr>
-            <a:r>
-              <a:rPr lang="en-US" sz="3200" b="1" dirty="0">
-                <a:solidFill>
-                  <a:srgbClr val="F5F5F5"/>
-                </a:solidFill>
-                <a:latin typeface="Avenir Next" pitchFamily="34" charset="0"/>
-                <a:ea typeface="Avenir Next" pitchFamily="34" charset="-122"/>
-                <a:cs typeface="Avenir Next" pitchFamily="34" charset="-120"/>
-              </a:rPr>
-              <a:t>Datastore choice</a:t>
-            </a:r>
-            <a:endParaRPr lang="en-US" sz="3200" dirty="0"/>
-          </a:p>
-        </p:txBody>
-      </p:sp>
-      <p:sp>
-        <p:nvSpPr>
-          <p:cNvPr id="5" name="Text 2"/>
-          <p:cNvSpPr txBox="1"/>
-          <p:nvPr/>
-        </p:nvSpPr>
-        <p:spPr>
-          <a:xfrm>
-            <a:off x="832104" y="896112"/>
-            <a:ext cx="7726680" cy="237744"/>
-          </a:xfrm>
-          <a:prstGeom prst="rect">
-            <a:avLst/>
-          </a:prstGeom>
-          <a:noFill/>
-          <a:ln/>
-        </p:spPr>
-        <p:txBody>
-          <a:bodyPr wrap="square" lIns="0" tIns="0" rIns="0" bIns="0" rtlCol="0" anchor="t"/>
-          <a:lstStyle/>
-          <a:p>
-            <a:pPr indent="0" marL="0">
-              <a:buNone/>
-            </a:pPr>
-            <a:r>
-              <a:rPr lang="en-US" sz="1300" dirty="0">
-                <a:solidFill>
-                  <a:srgbClr val="A9ADB3"/>
-                </a:solidFill>
-                <a:latin typeface="Avenir Next" pitchFamily="34" charset="0"/>
-                <a:ea typeface="Avenir Next" pitchFamily="34" charset="-122"/>
-                <a:cs typeface="Avenir Next" pitchFamily="34" charset="-120"/>
-              </a:rPr>
-              <a:t>In-memory would suffice.</a:t>
-            </a:r>
-            <a:endParaRPr lang="en-US" sz="1300" dirty="0"/>
-          </a:p>
-        </p:txBody>
-      </p:sp>
-      <p:sp>
-        <p:nvSpPr>
-          <p:cNvPr id="6" name="Text 3"/>
-          <p:cNvSpPr txBox="1"/>
-          <p:nvPr/>
-        </p:nvSpPr>
-        <p:spPr>
-          <a:xfrm>
-            <a:off x="585216" y="1536192"/>
-            <a:ext cx="1737360" cy="228600"/>
-          </a:xfrm>
-          <a:prstGeom prst="rect">
-            <a:avLst/>
-          </a:prstGeom>
-          <a:noFill/>
-          <a:ln/>
-        </p:spPr>
-        <p:txBody>
-          <a:bodyPr wrap="square" lIns="0" tIns="0" rIns="0" bIns="0" rtlCol="0" anchor="t">
-            <a:normAutofit/>
-          </a:bodyPr>
-          <a:lstStyle/>
-          <a:p>
-            <a:pPr indent="0" marL="0">
-              <a:buNone/>
-            </a:pPr>
-            <a:r>
-              <a:rPr lang="en-US" sz="1100" b="1" spc="160" kern="0" dirty="0">
-                <a:solidFill>
-                  <a:srgbClr val="00F604"/>
-                </a:solidFill>
-                <a:latin typeface="Avenir Next" pitchFamily="34" charset="0"/>
-                <a:ea typeface="Avenir Next" pitchFamily="34" charset="-122"/>
-                <a:cs typeface="Avenir Next" pitchFamily="34" charset="-120"/>
-              </a:rPr>
-              <a:t>CHOSEN</a:t>
-            </a:r>
-            <a:endParaRPr lang="en-US" sz="1100" dirty="0"/>
-          </a:p>
-        </p:txBody>
-      </p:sp>
-      <p:sp>
-        <p:nvSpPr>
-          <p:cNvPr id="7" name="Text 4"/>
-          <p:cNvSpPr txBox="1"/>
-          <p:nvPr/>
-        </p:nvSpPr>
-        <p:spPr>
-          <a:xfrm>
-            <a:off x="2468880" y="1481328"/>
-            <a:ext cx="3017520" cy="329184"/>
-          </a:xfrm>
-          <a:prstGeom prst="rect">
-            <a:avLst/>
-          </a:prstGeom>
-          <a:noFill/>
-          <a:ln/>
-        </p:spPr>
-        <p:txBody>
-          <a:bodyPr wrap="square" lIns="0" tIns="0" rIns="0" bIns="0" rtlCol="0" anchor="t">
-            <a:normAutofit/>
-          </a:bodyPr>
-          <a:lstStyle/>
-          <a:p>
-            <a:pPr indent="0" marL="0">
-              <a:buNone/>
-            </a:pPr>
-            <a:r>
-              <a:rPr lang="en-US" sz="1900" b="1" dirty="0">
-                <a:solidFill>
-                  <a:srgbClr val="F5F5F5"/>
-                </a:solidFill>
-                <a:latin typeface="Avenir Next" pitchFamily="34" charset="0"/>
-                <a:ea typeface="Avenir Next" pitchFamily="34" charset="-122"/>
-                <a:cs typeface="Avenir Next" pitchFamily="34" charset="-120"/>
-              </a:rPr>
-              <a:t>SQLite file</a:t>
-            </a:r>
-            <a:endParaRPr lang="en-US" sz="1900" dirty="0"/>
-          </a:p>
-        </p:txBody>
-      </p:sp>
-      <p:sp>
-        <p:nvSpPr>
-          <p:cNvPr id="8" name="Text 5"/>
-          <p:cNvSpPr txBox="1"/>
-          <p:nvPr/>
-        </p:nvSpPr>
-        <p:spPr>
-          <a:xfrm>
-            <a:off x="5577840" y="1517904"/>
-            <a:ext cx="2980944" cy="292608"/>
-          </a:xfrm>
-          <a:prstGeom prst="rect">
-            <a:avLst/>
-          </a:prstGeom>
-          <a:noFill/>
-          <a:ln/>
-        </p:spPr>
-        <p:txBody>
-          <a:bodyPr wrap="square" lIns="0" tIns="0" rIns="0" bIns="0" rtlCol="0" anchor="t">
-            <a:normAutofit/>
-          </a:bodyPr>
-          <a:lstStyle/>
-          <a:p>
-            <a:pPr indent="0" marL="0">
-              <a:buNone/>
-            </a:pPr>
-            <a:r>
-              <a:rPr lang="en-US" sz="1500" dirty="0">
-                <a:solidFill>
-                  <a:srgbClr val="F5F5F5"/>
-                </a:solidFill>
-                <a:latin typeface="Avenir Next" pitchFamily="34" charset="0"/>
-                <a:ea typeface="Avenir Next" pitchFamily="34" charset="-122"/>
-                <a:cs typeface="Avenir Next" pitchFamily="34" charset="-120"/>
-              </a:rPr>
-              <a:t>Survives restarts</a:t>
-            </a:r>
-            <a:endParaRPr lang="en-US" sz="1500" dirty="0"/>
-          </a:p>
-        </p:txBody>
-      </p:sp>
-      <p:sp>
-        <p:nvSpPr>
-          <p:cNvPr id="9" name="Shape 6"/>
-          <p:cNvSpPr/>
-          <p:nvPr/>
-        </p:nvSpPr>
-        <p:spPr>
-          <a:xfrm>
-            <a:off x="585216" y="1965960"/>
-            <a:ext cx="7973568" cy="0"/>
-          </a:xfrm>
-          <a:prstGeom prst="line">
-            <a:avLst/>
-          </a:prstGeom>
-          <a:noFill/>
-          <a:ln w="9525">
-            <a:solidFill>
-              <a:srgbClr val="333333"/>
-            </a:solidFill>
-            <a:prstDash val="solid"/>
-          </a:ln>
-        </p:spPr>
-      </p:sp>
-      <p:sp>
-        <p:nvSpPr>
-          <p:cNvPr id="10" name="Text 7"/>
-          <p:cNvSpPr txBox="1"/>
-          <p:nvPr/>
-        </p:nvSpPr>
-        <p:spPr>
-          <a:xfrm>
-            <a:off x="585216" y="2176272"/>
-            <a:ext cx="1737360" cy="228600"/>
-          </a:xfrm>
-          <a:prstGeom prst="rect">
-            <a:avLst/>
-          </a:prstGeom>
-          <a:noFill/>
-          <a:ln/>
-        </p:spPr>
-        <p:txBody>
-          <a:bodyPr wrap="square" lIns="0" tIns="0" rIns="0" bIns="0" rtlCol="0" anchor="t">
-            <a:normAutofit/>
-          </a:bodyPr>
-          <a:lstStyle/>
-          <a:p>
-            <a:pPr indent="0" marL="0">
-              <a:buNone/>
-            </a:pPr>
-            <a:r>
-              <a:rPr lang="en-US" sz="1100" b="1" spc="160" kern="0" dirty="0">
-                <a:solidFill>
-                  <a:srgbClr val="F67F00"/>
-                </a:solidFill>
-                <a:latin typeface="Avenir Next" pitchFamily="34" charset="0"/>
-                <a:ea typeface="Avenir Next" pitchFamily="34" charset="-122"/>
-                <a:cs typeface="Avenir Next" pitchFamily="34" charset="-120"/>
-              </a:rPr>
-              <a:t>CONSIDERED</a:t>
-            </a:r>
-            <a:endParaRPr lang="en-US" sz="1100" dirty="0"/>
-          </a:p>
-        </p:txBody>
-      </p:sp>
-      <p:sp>
-        <p:nvSpPr>
-          <p:cNvPr id="11" name="Text 8"/>
-          <p:cNvSpPr txBox="1"/>
-          <p:nvPr/>
-        </p:nvSpPr>
-        <p:spPr>
-          <a:xfrm>
-            <a:off x="2468880" y="2121408"/>
-            <a:ext cx="3017520" cy="329184"/>
-          </a:xfrm>
-          <a:prstGeom prst="rect">
-            <a:avLst/>
-          </a:prstGeom>
-          <a:noFill/>
-          <a:ln/>
-        </p:spPr>
-        <p:txBody>
-          <a:bodyPr wrap="square" lIns="0" tIns="0" rIns="0" bIns="0" rtlCol="0" anchor="t">
-            <a:normAutofit/>
-          </a:bodyPr>
-          <a:lstStyle/>
-          <a:p>
-            <a:pPr indent="0" marL="0">
-              <a:buNone/>
-            </a:pPr>
-            <a:r>
-              <a:rPr lang="en-US" sz="1900" b="1" dirty="0">
-                <a:solidFill>
-                  <a:srgbClr val="F5F5F5"/>
-                </a:solidFill>
-                <a:latin typeface="Avenir Next" pitchFamily="34" charset="0"/>
-                <a:ea typeface="Avenir Next" pitchFamily="34" charset="-122"/>
-                <a:cs typeface="Avenir Next" pitchFamily="34" charset="-120"/>
-              </a:rPr>
-              <a:t>SQLite in-memory</a:t>
-            </a:r>
-            <a:endParaRPr lang="en-US" sz="1900" dirty="0"/>
-          </a:p>
-        </p:txBody>
-      </p:sp>
-      <p:sp>
-        <p:nvSpPr>
-          <p:cNvPr id="12" name="Text 9"/>
-          <p:cNvSpPr txBox="1"/>
-          <p:nvPr/>
-        </p:nvSpPr>
-        <p:spPr>
-          <a:xfrm>
-            <a:off x="5577840" y="2157984"/>
-            <a:ext cx="2980944" cy="292608"/>
-          </a:xfrm>
-          <a:prstGeom prst="rect">
-            <a:avLst/>
-          </a:prstGeom>
-          <a:noFill/>
-          <a:ln/>
-        </p:spPr>
-        <p:txBody>
-          <a:bodyPr wrap="square" lIns="0" tIns="0" rIns="0" bIns="0" rtlCol="0" anchor="t">
-            <a:normAutofit/>
-          </a:bodyPr>
-          <a:lstStyle/>
-          <a:p>
-            <a:pPr indent="0" marL="0">
-              <a:buNone/>
-            </a:pPr>
-            <a:r>
-              <a:rPr lang="en-US" sz="1500" dirty="0">
-                <a:solidFill>
-                  <a:srgbClr val="A9ADB3"/>
-                </a:solidFill>
-                <a:latin typeface="Avenir Next" pitchFamily="34" charset="0"/>
-                <a:ea typeface="Avenir Next" pitchFamily="34" charset="-122"/>
-                <a:cs typeface="Avenir Next" pitchFamily="34" charset="-120"/>
-              </a:rPr>
-              <a:t>Lost on restart</a:t>
-            </a:r>
-            <a:endParaRPr lang="en-US" sz="1500" dirty="0"/>
-          </a:p>
-        </p:txBody>
-      </p:sp>
-      <p:sp>
-        <p:nvSpPr>
-          <p:cNvPr id="13" name="Shape 10"/>
-          <p:cNvSpPr/>
-          <p:nvPr/>
-        </p:nvSpPr>
-        <p:spPr>
-          <a:xfrm>
-            <a:off x="585216" y="2606040"/>
-            <a:ext cx="7973568" cy="0"/>
-          </a:xfrm>
-          <a:prstGeom prst="line">
-            <a:avLst/>
-          </a:prstGeom>
-          <a:noFill/>
-          <a:ln w="9525">
-            <a:solidFill>
-              <a:srgbClr val="333333"/>
-            </a:solidFill>
-            <a:prstDash val="solid"/>
-          </a:ln>
-        </p:spPr>
-      </p:sp>
-      <p:sp>
-        <p:nvSpPr>
-          <p:cNvPr id="14" name="Text 11"/>
-          <p:cNvSpPr txBox="1"/>
-          <p:nvPr/>
-        </p:nvSpPr>
-        <p:spPr>
-          <a:xfrm>
-            <a:off x="2468880" y="2761488"/>
-            <a:ext cx="3017520" cy="329184"/>
-          </a:xfrm>
-          <a:prstGeom prst="rect">
-            <a:avLst/>
-          </a:prstGeom>
-          <a:noFill/>
-          <a:ln/>
-        </p:spPr>
-        <p:txBody>
-          <a:bodyPr wrap="square" lIns="0" tIns="0" rIns="0" bIns="0" rtlCol="0" anchor="t">
-            <a:normAutofit/>
-          </a:bodyPr>
-          <a:lstStyle/>
-          <a:p>
-            <a:pPr indent="0" marL="0">
-              <a:buNone/>
-            </a:pPr>
-            <a:r>
-              <a:rPr lang="en-US" sz="1900" b="1" dirty="0">
-                <a:solidFill>
-                  <a:srgbClr val="F5F5F5"/>
-                </a:solidFill>
-                <a:latin typeface="Avenir Next" pitchFamily="34" charset="0"/>
-                <a:ea typeface="Avenir Next" pitchFamily="34" charset="-122"/>
-                <a:cs typeface="Avenir Next" pitchFamily="34" charset="-120"/>
-              </a:rPr>
-              <a:t>Hand-written store</a:t>
-            </a:r>
-            <a:endParaRPr lang="en-US" sz="1900" dirty="0"/>
-          </a:p>
-        </p:txBody>
-      </p:sp>
-      <p:sp>
-        <p:nvSpPr>
-          <p:cNvPr id="15" name="Text 12"/>
-          <p:cNvSpPr txBox="1"/>
-          <p:nvPr/>
-        </p:nvSpPr>
-        <p:spPr>
-          <a:xfrm>
-            <a:off x="5577840" y="2798064"/>
-            <a:ext cx="2980944" cy="292608"/>
-          </a:xfrm>
-          <a:prstGeom prst="rect">
-            <a:avLst/>
-          </a:prstGeom>
-          <a:noFill/>
-          <a:ln/>
-        </p:spPr>
-        <p:txBody>
-          <a:bodyPr wrap="square" lIns="0" tIns="0" rIns="0" bIns="0" rtlCol="0" anchor="t">
-            <a:normAutofit/>
-          </a:bodyPr>
-          <a:lstStyle/>
-          <a:p>
-            <a:pPr indent="0" marL="0">
-              <a:buNone/>
-            </a:pPr>
-            <a:r>
-              <a:rPr lang="en-US" sz="1500" dirty="0">
-                <a:solidFill>
-                  <a:srgbClr val="A9ADB3"/>
-                </a:solidFill>
-                <a:latin typeface="Avenir Next" pitchFamily="34" charset="0"/>
-                <a:ea typeface="Avenir Next" pitchFamily="34" charset="-122"/>
-                <a:cs typeface="Avenir Next" pitchFamily="34" charset="-120"/>
-              </a:rPr>
-              <a:t>Owns atomicity</a:t>
-            </a:r>
-            <a:endParaRPr lang="en-US" sz="1500" dirty="0"/>
-          </a:p>
-        </p:txBody>
-      </p:sp>
-      <p:sp>
-        <p:nvSpPr>
-          <p:cNvPr id="16" name="Shape 13"/>
-          <p:cNvSpPr/>
-          <p:nvPr/>
-        </p:nvSpPr>
-        <p:spPr>
-          <a:xfrm>
-            <a:off x="585216" y="3246120"/>
-            <a:ext cx="7973568" cy="0"/>
-          </a:xfrm>
-          <a:prstGeom prst="line">
-            <a:avLst/>
-          </a:prstGeom>
-          <a:noFill/>
-          <a:ln w="9525">
-            <a:solidFill>
-              <a:srgbClr val="333333"/>
-            </a:solidFill>
-            <a:prstDash val="solid"/>
-          </a:ln>
-        </p:spPr>
-      </p:sp>
-      <p:sp>
-        <p:nvSpPr>
-          <p:cNvPr id="17" name="Text 14"/>
-          <p:cNvSpPr txBox="1"/>
-          <p:nvPr/>
-        </p:nvSpPr>
-        <p:spPr>
-          <a:xfrm>
-            <a:off x="2468880" y="3401568"/>
-            <a:ext cx="3017520" cy="329184"/>
-          </a:xfrm>
-          <a:prstGeom prst="rect">
-            <a:avLst/>
-          </a:prstGeom>
-          <a:noFill/>
-          <a:ln/>
-        </p:spPr>
-        <p:txBody>
-          <a:bodyPr wrap="square" lIns="0" tIns="0" rIns="0" bIns="0" rtlCol="0" anchor="t">
-            <a:normAutofit/>
-          </a:bodyPr>
-          <a:lstStyle/>
-          <a:p>
-            <a:pPr indent="0" marL="0">
-              <a:buNone/>
-            </a:pPr>
-            <a:r>
-              <a:rPr lang="en-US" sz="1900" b="1" dirty="0">
-                <a:solidFill>
-                  <a:srgbClr val="F5F5F5"/>
-                </a:solidFill>
-                <a:latin typeface="Avenir Next" pitchFamily="34" charset="0"/>
-                <a:ea typeface="Avenir Next" pitchFamily="34" charset="-122"/>
-                <a:cs typeface="Avenir Next" pitchFamily="34" charset="-120"/>
-              </a:rPr>
-              <a:t>EF Core InMemory</a:t>
-            </a:r>
-            <a:endParaRPr lang="en-US" sz="1900" dirty="0"/>
-          </a:p>
-        </p:txBody>
-      </p:sp>
-      <p:sp>
-        <p:nvSpPr>
-          <p:cNvPr id="18" name="Text 15"/>
-          <p:cNvSpPr txBox="1"/>
-          <p:nvPr/>
-        </p:nvSpPr>
-        <p:spPr>
-          <a:xfrm>
-            <a:off x="5577840" y="3438144"/>
-            <a:ext cx="2980944" cy="292608"/>
-          </a:xfrm>
-          <a:prstGeom prst="rect">
-            <a:avLst/>
-          </a:prstGeom>
-          <a:noFill/>
-          <a:ln/>
-        </p:spPr>
-        <p:txBody>
-          <a:bodyPr wrap="square" lIns="0" tIns="0" rIns="0" bIns="0" rtlCol="0" anchor="t">
-            <a:normAutofit/>
-          </a:bodyPr>
-          <a:lstStyle/>
-          <a:p>
-            <a:pPr indent="0" marL="0">
-              <a:buNone/>
-            </a:pPr>
-            <a:r>
-              <a:rPr lang="en-US" sz="1500" dirty="0">
-                <a:solidFill>
-                  <a:srgbClr val="A9ADB3"/>
-                </a:solidFill>
-                <a:latin typeface="Avenir Next" pitchFamily="34" charset="0"/>
-                <a:ea typeface="Avenir Next" pitchFamily="34" charset="-122"/>
-                <a:cs typeface="Avenir Next" pitchFamily="34" charset="-120"/>
-              </a:rPr>
-              <a:t>No transactions</a:t>
-            </a:r>
-            <a:endParaRPr lang="en-US" sz="1500" dirty="0"/>
-          </a:p>
-        </p:txBody>
-      </p:sp>
-      <p:sp>
-        <p:nvSpPr>
-          <p:cNvPr id="19" name="Shape 16"/>
-          <p:cNvSpPr/>
-          <p:nvPr/>
-        </p:nvSpPr>
-        <p:spPr>
-          <a:xfrm>
-            <a:off x="585216" y="3886200"/>
-            <a:ext cx="7973568" cy="0"/>
-          </a:xfrm>
-          <a:prstGeom prst="line">
-            <a:avLst/>
-          </a:prstGeom>
-          <a:noFill/>
-          <a:ln w="9525">
-            <a:solidFill>
-              <a:srgbClr val="333333"/>
-            </a:solidFill>
-            <a:prstDash val="solid"/>
-          </a:ln>
-        </p:spPr>
-      </p:sp>
-      <p:sp>
-        <p:nvSpPr>
-          <p:cNvPr id="20" name="Text 17"/>
-          <p:cNvSpPr txBox="1"/>
-          <p:nvPr/>
-        </p:nvSpPr>
-        <p:spPr>
-          <a:xfrm>
-            <a:off x="2468880" y="4041648"/>
-            <a:ext cx="3017520" cy="329184"/>
-          </a:xfrm>
-          <a:prstGeom prst="rect">
-            <a:avLst/>
-          </a:prstGeom>
-          <a:noFill/>
-          <a:ln/>
-        </p:spPr>
-        <p:txBody>
-          <a:bodyPr wrap="square" lIns="0" tIns="0" rIns="0" bIns="0" rtlCol="0" anchor="t">
-            <a:normAutofit/>
-          </a:bodyPr>
-          <a:lstStyle/>
-          <a:p>
-            <a:pPr indent="0" marL="0">
-              <a:buNone/>
-            </a:pPr>
-            <a:r>
-              <a:rPr lang="en-US" sz="1900" b="1" dirty="0">
-                <a:solidFill>
-                  <a:srgbClr val="F5F5F5"/>
-                </a:solidFill>
-                <a:latin typeface="Avenir Next" pitchFamily="34" charset="0"/>
-                <a:ea typeface="Avenir Next" pitchFamily="34" charset="-122"/>
-                <a:cs typeface="Avenir Next" pitchFamily="34" charset="-120"/>
-              </a:rPr>
-              <a:t>Redis</a:t>
-            </a:r>
-            <a:endParaRPr lang="en-US" sz="1900" dirty="0"/>
-          </a:p>
-        </p:txBody>
-      </p:sp>
-      <p:sp>
-        <p:nvSpPr>
-          <p:cNvPr id="21" name="Text 18"/>
-          <p:cNvSpPr txBox="1"/>
-          <p:nvPr/>
-        </p:nvSpPr>
-        <p:spPr>
-          <a:xfrm>
-            <a:off x="5577840" y="4078224"/>
-            <a:ext cx="2980944" cy="292608"/>
-          </a:xfrm>
-          <a:prstGeom prst="rect">
-            <a:avLst/>
-          </a:prstGeom>
-          <a:noFill/>
-          <a:ln/>
-        </p:spPr>
-        <p:txBody>
-          <a:bodyPr wrap="square" lIns="0" tIns="0" rIns="0" bIns="0" rtlCol="0" anchor="t">
-            <a:normAutofit/>
-          </a:bodyPr>
-          <a:lstStyle/>
-          <a:p>
-            <a:pPr indent="0" marL="0">
-              <a:buNone/>
-            </a:pPr>
-            <a:r>
-              <a:rPr lang="en-US" sz="1500" dirty="0">
-                <a:solidFill>
-                  <a:srgbClr val="A9ADB3"/>
-                </a:solidFill>
-                <a:latin typeface="Avenir Next" pitchFamily="34" charset="0"/>
-                <a:ea typeface="Avenir Next" pitchFamily="34" charset="-122"/>
-                <a:cs typeface="Avenir Next" pitchFamily="34" charset="-120"/>
-              </a:rPr>
-              <a:t>Extra process</a:t>
-            </a:r>
-            <a:endParaRPr lang="en-US" sz="1500" dirty="0"/>
-          </a:p>
-        </p:txBody>
-      </p:sp>
-    </p:spTree>
-  </p:cSld>
-  <p:clrMapOvr>
-    <a:masterClrMapping/>
-  </p:clrMapOvr>
-</p:sld>
-</file>
-
 <file path=ppt/slides/slide5.xml><?xml version="1.0" encoding="utf-8"?>
 <p:sld xmlns:a="http://schemas.openxmlformats.org/drawingml/2006/main" xmlns:r="http://schemas.openxmlformats.org/officeDocument/2006/relationships" xmlns:p="http://schemas.openxmlformats.org/presentationml/2006/main">
   <p:cSld name="Slide 5">
@@ -4151,7 +4123,7 @@
                 <a:ea typeface="Avenir Next" pitchFamily="34" charset="-122"/>
                 <a:cs typeface="Avenir Next" pitchFamily="34" charset="-120"/>
               </a:rPr>
-              <a:t>Failure leaves no partial state</a:t>
+              <a:t>Datastore choice</a:t>
             </a:r>
             <a:endParaRPr lang="en-US" sz="3200" dirty="0"/>
           </a:p>
@@ -4165,8 +4137,8 @@
         </p:nvSpPr>
         <p:spPr>
           <a:xfrm>
-            <a:off x="585216" y="1307592"/>
-            <a:ext cx="411480" cy="274320"/>
+            <a:off x="832104" y="896112"/>
+            <a:ext cx="7726680" cy="237744"/>
           </a:xfrm>
           <a:prstGeom prst="rect">
             <a:avLst/>
@@ -4182,15 +4154,15 @@
               <a:buNone/>
             </a:pPr>
             <a:r>
-              <a:rPr lang="en-US" sz="1300" b="1" dirty="0">
-                <a:solidFill>
-                  <a:srgbClr val="00F604"/>
-                </a:solidFill>
-                <a:latin typeface="Avenir Next" pitchFamily="34" charset="0"/>
-                <a:ea typeface="Avenir Next" pitchFamily="34" charset="-122"/>
-                <a:cs typeface="Avenir Next" pitchFamily="34" charset="-120"/>
-              </a:rPr>
-              <a:t>01</a:t>
+              <a:rPr lang="en-US" sz="1300" dirty="0">
+                <a:solidFill>
+                  <a:srgbClr val="A9ADB3"/>
+                </a:solidFill>
+                <a:latin typeface="Avenir Next" pitchFamily="34" charset="0"/>
+                <a:ea typeface="Avenir Next" pitchFamily="34" charset="-122"/>
+                <a:cs typeface="Avenir Next" pitchFamily="34" charset="-120"/>
+              </a:rPr>
+              <a:t>In-memory would suffice.</a:t>
             </a:r>
             <a:endParaRPr lang="en-US" sz="1300" dirty="0"/>
           </a:p>
@@ -4204,8 +4176,8 @@
         </p:nvSpPr>
         <p:spPr>
           <a:xfrm>
-            <a:off x="1115568" y="1261872"/>
-            <a:ext cx="2743200" cy="512064"/>
+            <a:off x="585216" y="1536192"/>
+            <a:ext cx="1737360" cy="228600"/>
           </a:xfrm>
           <a:prstGeom prst="rect">
             <a:avLst/>
@@ -4223,17 +4195,17 @@
               <a:buNone/>
             </a:pPr>
             <a:r>
-              <a:rPr lang="en-US" sz="2000" b="1" dirty="0">
-                <a:solidFill>
-                  <a:srgbClr val="F5F5F5"/>
-                </a:solidFill>
-                <a:latin typeface="Avenir Next" pitchFamily="34" charset="0"/>
-                <a:ea typeface="Avenir Next" pitchFamily="34" charset="-122"/>
-                <a:cs typeface="Avenir Next" pitchFamily="34" charset="-120"/>
-              </a:rPr>
-              <a:t>Validate before mutation</a:t>
-            </a:r>
-            <a:endParaRPr lang="en-US" sz="2000" dirty="0"/>
+              <a:rPr lang="en-US" sz="1100" b="1" spc="160" kern="0" dirty="0">
+                <a:solidFill>
+                  <a:srgbClr val="00F604"/>
+                </a:solidFill>
+                <a:latin typeface="Avenir Next" pitchFamily="34" charset="0"/>
+                <a:ea typeface="Avenir Next" pitchFamily="34" charset="-122"/>
+                <a:cs typeface="Avenir Next" pitchFamily="34" charset="-120"/>
+              </a:rPr>
+              <a:t>CHOSEN</a:t>
+            </a:r>
+            <a:endParaRPr lang="en-US" sz="1100" dirty="0"/>
           </a:p>
         </p:txBody>
       </p:sp>
@@ -4245,47 +4217,8 @@
         </p:nvSpPr>
         <p:spPr>
           <a:xfrm>
-            <a:off x="585216" y="2313432"/>
-            <a:ext cx="411480" cy="274320"/>
-          </a:xfrm>
-          <a:prstGeom prst="rect">
-            <a:avLst/>
-          </a:prstGeom>
-          <a:noFill/>
-          <a:ln/>
-        </p:spPr>
-        <p:txBody>
-          <a:bodyPr wrap="square" lIns="0" tIns="0" rIns="0" bIns="0" rtlCol="0" anchor="t"/>
-          <a:lstStyle/>
-          <a:p>
-            <a:pPr indent="0" marL="0">
-              <a:buNone/>
-            </a:pPr>
-            <a:r>
-              <a:rPr lang="en-US" sz="1300" b="1" dirty="0">
-                <a:solidFill>
-                  <a:srgbClr val="00F604"/>
-                </a:solidFill>
-                <a:latin typeface="Avenir Next" pitchFamily="34" charset="0"/>
-                <a:ea typeface="Avenir Next" pitchFamily="34" charset="-122"/>
-                <a:cs typeface="Avenir Next" pitchFamily="34" charset="-120"/>
-              </a:rPr>
-              <a:t>02</a:t>
-            </a:r>
-            <a:endParaRPr lang="en-US" sz="1300" dirty="0"/>
-          </a:p>
-        </p:txBody>
-      </p:sp>
-      <p:sp>
-        <p:nvSpPr>
-          <p:cNvPr id="8" name="Text 5"/>
-          <p:cNvSpPr txBox="1"/>
-          <p:nvPr/>
-        </p:nvSpPr>
-        <p:spPr>
-          <a:xfrm>
-            <a:off x="1115568" y="2267712"/>
-            <a:ext cx="2743200" cy="512064"/>
+            <a:off x="2468880" y="1481328"/>
+            <a:ext cx="3017520" cy="329184"/>
           </a:xfrm>
           <a:prstGeom prst="rect">
             <a:avLst/>
@@ -4303,7 +4236,7 @@
               <a:buNone/>
             </a:pPr>
             <a:r>
-              <a:rPr lang="en-US" sz="2000" b="1" dirty="0">
+              <a:rPr lang="en-US" sz="1900" b="1" dirty="0">
                 <a:solidFill>
                   <a:srgbClr val="F5F5F5"/>
                 </a:solidFill>
@@ -4311,61 +4244,22 @@
                 <a:ea typeface="Avenir Next" pitchFamily="34" charset="-122"/>
                 <a:cs typeface="Avenir Next" pitchFamily="34" charset="-120"/>
               </a:rPr>
-              <a:t>Commit balance and history together</a:t>
-            </a:r>
-            <a:endParaRPr lang="en-US" sz="2000" dirty="0"/>
-          </a:p>
-        </p:txBody>
-      </p:sp>
-      <p:sp>
-        <p:nvSpPr>
-          <p:cNvPr id="9" name="Text 6"/>
-          <p:cNvSpPr txBox="1"/>
-          <p:nvPr/>
-        </p:nvSpPr>
-        <p:spPr>
-          <a:xfrm>
-            <a:off x="585216" y="3319272"/>
-            <a:ext cx="411480" cy="274320"/>
-          </a:xfrm>
-          <a:prstGeom prst="rect">
-            <a:avLst/>
-          </a:prstGeom>
-          <a:noFill/>
-          <a:ln/>
-        </p:spPr>
-        <p:txBody>
-          <a:bodyPr wrap="square" lIns="0" tIns="0" rIns="0" bIns="0" rtlCol="0" anchor="t"/>
-          <a:lstStyle/>
-          <a:p>
-            <a:pPr indent="0" marL="0">
-              <a:buNone/>
-            </a:pPr>
-            <a:r>
-              <a:rPr lang="en-US" sz="1300" b="1" dirty="0">
-                <a:solidFill>
-                  <a:srgbClr val="00F604"/>
-                </a:solidFill>
-                <a:latin typeface="Avenir Next" pitchFamily="34" charset="0"/>
-                <a:ea typeface="Avenir Next" pitchFamily="34" charset="-122"/>
-                <a:cs typeface="Avenir Next" pitchFamily="34" charset="-120"/>
-              </a:rPr>
-              <a:t>03</a:t>
-            </a:r>
-            <a:endParaRPr lang="en-US" sz="1300" dirty="0"/>
-          </a:p>
-        </p:txBody>
-      </p:sp>
-      <p:sp>
-        <p:nvSpPr>
-          <p:cNvPr id="10" name="Text 7"/>
-          <p:cNvSpPr txBox="1"/>
-          <p:nvPr/>
-        </p:nvSpPr>
-        <p:spPr>
-          <a:xfrm>
-            <a:off x="1115568" y="3273552"/>
-            <a:ext cx="2743200" cy="512064"/>
+              <a:t>SQLite file</a:t>
+            </a:r>
+            <a:endParaRPr lang="en-US" sz="1900" dirty="0"/>
+          </a:p>
+        </p:txBody>
+      </p:sp>
+      <p:sp>
+        <p:nvSpPr>
+          <p:cNvPr id="8" name="Text 5"/>
+          <p:cNvSpPr txBox="1"/>
+          <p:nvPr/>
+        </p:nvSpPr>
+        <p:spPr>
+          <a:xfrm>
+            <a:off x="5577840" y="1517904"/>
+            <a:ext cx="2980944" cy="292608"/>
           </a:xfrm>
           <a:prstGeom prst="rect">
             <a:avLst/>
@@ -4383,7 +4277,7 @@
               <a:buNone/>
             </a:pPr>
             <a:r>
-              <a:rPr lang="en-US" sz="2000" b="1" dirty="0">
+              <a:rPr lang="en-US" sz="1500" dirty="0">
                 <a:solidFill>
                   <a:srgbClr val="F5F5F5"/>
                 </a:solidFill>
@@ -4391,30 +4285,28 @@
                 <a:ea typeface="Avenir Next" pitchFamily="34" charset="-122"/>
                 <a:cs typeface="Avenir Next" pitchFamily="34" charset="-120"/>
               </a:rPr>
-              <a:t>Reject stale writes</a:t>
-            </a:r>
-            <a:endParaRPr lang="en-US" sz="2000" dirty="0"/>
-          </a:p>
-        </p:txBody>
-      </p:sp>
-      <p:sp>
-        <p:nvSpPr>
-          <p:cNvPr id="11" name="Shape 8"/>
+              <a:t>Survives restarts</a:t>
+            </a:r>
+            <a:endParaRPr lang="en-US" sz="1500" dirty="0"/>
+          </a:p>
+        </p:txBody>
+      </p:sp>
+      <p:sp>
+        <p:nvSpPr>
+          <p:cNvPr id="9" name="Shape 6"/>
           <p:cNvSpPr/>
           <p:nvPr/>
         </p:nvSpPr>
         <p:spPr>
           <a:xfrm>
-            <a:off x="4233672" y="1133856"/>
-            <a:ext cx="4325112" cy="3282696"/>
-          </a:xfrm>
-          <a:prstGeom prst="rect">
-            <a:avLst/>
-          </a:prstGeom>
-          <a:solidFill>
-            <a:srgbClr val="1B1B1B"/>
-          </a:solidFill>
-          <a:ln w="10160">
+            <a:off x="585216" y="1965960"/>
+            <a:ext cx="7973568" cy="0"/>
+          </a:xfrm>
+          <a:prstGeom prst="line">
+            <a:avLst/>
+          </a:prstGeom>
+          <a:noFill/>
+          <a:ln w="9525">
             <a:solidFill>
               <a:srgbClr val="333333"/>
             </a:solidFill>
@@ -4422,40 +4314,16 @@
           </a:ln>
         </p:spPr>
       </p:sp>
-      <p:pic>
-        <p:nvPicPr>
-          <p:cNvPr id="12" name="Image 0" descr="/Users/john/theborg/repos/atm/design/screenshots/overdraft.png">    </p:cNvPr>
-          <p:cNvPicPr>
-            <a:picLocks noChangeAspect="1"/>
-          </p:cNvPicPr>
-          <p:nvPr/>
-        </p:nvPicPr>
-        <p:blipFill>
-          <a:blip r:embed="rId1"/>
-          <a:stretch>
-            <a:fillRect/>
-          </a:stretch>
-        </p:blipFill>
-        <p:spPr>
-          <a:xfrm>
-            <a:off x="4270248" y="1170432"/>
-            <a:ext cx="4251960" cy="3209544"/>
-          </a:xfrm>
-          <a:prstGeom prst="rect">
-            <a:avLst/>
-          </a:prstGeom>
-        </p:spPr>
-      </p:pic>
-      <p:sp>
-        <p:nvSpPr>
-          <p:cNvPr id="13" name="Text 9"/>
-          <p:cNvSpPr txBox="1"/>
-          <p:nvPr/>
-        </p:nvSpPr>
-        <p:spPr>
-          <a:xfrm>
-            <a:off x="4233672" y="4489704"/>
-            <a:ext cx="4325112" cy="201168"/>
+      <p:sp>
+        <p:nvSpPr>
+          <p:cNvPr id="10" name="Text 7"/>
+          <p:cNvSpPr txBox="1"/>
+          <p:nvPr/>
+        </p:nvSpPr>
+        <p:spPr>
+          <a:xfrm>
+            <a:off x="585216" y="2176272"/>
+            <a:ext cx="1737360" cy="228600"/>
           </a:xfrm>
           <a:prstGeom prst="rect">
             <a:avLst/>
@@ -4469,21 +4337,418 @@
           </a:bodyPr>
           <a:lstStyle/>
           <a:p>
-            <a:pPr algn="r" indent="0" marL="0">
-              <a:buNone/>
-            </a:pPr>
-            <a:r>
-              <a:rPr lang="en-US" sz="1150" b="1" dirty="0">
-                <a:solidFill>
-                  <a:srgbClr val="00F604"/>
-                </a:solidFill>
-                <a:latin typeface="Avenir Next" pitchFamily="34" charset="0"/>
-                <a:ea typeface="Avenir Next" pitchFamily="34" charset="-122"/>
-                <a:cs typeface="Avenir Next" pitchFamily="34" charset="-120"/>
-              </a:rPr>
-              <a:t>Rejected overdraft. Persisted state stays unchanged.</a:t>
-            </a:r>
-            <a:endParaRPr lang="en-US" sz="1150" dirty="0"/>
+            <a:pPr indent="0" marL="0">
+              <a:buNone/>
+            </a:pPr>
+            <a:r>
+              <a:rPr lang="en-US" sz="1100" b="1" spc="160" kern="0" dirty="0">
+                <a:solidFill>
+                  <a:srgbClr val="F67F00"/>
+                </a:solidFill>
+                <a:latin typeface="Avenir Next" pitchFamily="34" charset="0"/>
+                <a:ea typeface="Avenir Next" pitchFamily="34" charset="-122"/>
+                <a:cs typeface="Avenir Next" pitchFamily="34" charset="-120"/>
+              </a:rPr>
+              <a:t>CONSIDERED</a:t>
+            </a:r>
+            <a:endParaRPr lang="en-US" sz="1100" dirty="0"/>
+          </a:p>
+        </p:txBody>
+      </p:sp>
+      <p:sp>
+        <p:nvSpPr>
+          <p:cNvPr id="11" name="Text 8"/>
+          <p:cNvSpPr txBox="1"/>
+          <p:nvPr/>
+        </p:nvSpPr>
+        <p:spPr>
+          <a:xfrm>
+            <a:off x="2468880" y="2121408"/>
+            <a:ext cx="3017520" cy="329184"/>
+          </a:xfrm>
+          <a:prstGeom prst="rect">
+            <a:avLst/>
+          </a:prstGeom>
+          <a:noFill/>
+          <a:ln/>
+        </p:spPr>
+        <p:txBody>
+          <a:bodyPr wrap="square" lIns="0" tIns="0" rIns="0" bIns="0" rtlCol="0" anchor="t">
+            <a:normAutofit/>
+          </a:bodyPr>
+          <a:lstStyle/>
+          <a:p>
+            <a:pPr indent="0" marL="0">
+              <a:buNone/>
+            </a:pPr>
+            <a:r>
+              <a:rPr lang="en-US" sz="1900" b="1" dirty="0">
+                <a:solidFill>
+                  <a:srgbClr val="F5F5F5"/>
+                </a:solidFill>
+                <a:latin typeface="Avenir Next" pitchFamily="34" charset="0"/>
+                <a:ea typeface="Avenir Next" pitchFamily="34" charset="-122"/>
+                <a:cs typeface="Avenir Next" pitchFamily="34" charset="-120"/>
+              </a:rPr>
+              <a:t>SQLite in-memory</a:t>
+            </a:r>
+            <a:endParaRPr lang="en-US" sz="1900" dirty="0"/>
+          </a:p>
+        </p:txBody>
+      </p:sp>
+      <p:sp>
+        <p:nvSpPr>
+          <p:cNvPr id="12" name="Text 9"/>
+          <p:cNvSpPr txBox="1"/>
+          <p:nvPr/>
+        </p:nvSpPr>
+        <p:spPr>
+          <a:xfrm>
+            <a:off x="5577840" y="2157984"/>
+            <a:ext cx="2980944" cy="292608"/>
+          </a:xfrm>
+          <a:prstGeom prst="rect">
+            <a:avLst/>
+          </a:prstGeom>
+          <a:noFill/>
+          <a:ln/>
+        </p:spPr>
+        <p:txBody>
+          <a:bodyPr wrap="square" lIns="0" tIns="0" rIns="0" bIns="0" rtlCol="0" anchor="t">
+            <a:normAutofit/>
+          </a:bodyPr>
+          <a:lstStyle/>
+          <a:p>
+            <a:pPr indent="0" marL="0">
+              <a:buNone/>
+            </a:pPr>
+            <a:r>
+              <a:rPr lang="en-US" sz="1500" dirty="0">
+                <a:solidFill>
+                  <a:srgbClr val="A9ADB3"/>
+                </a:solidFill>
+                <a:latin typeface="Avenir Next" pitchFamily="34" charset="0"/>
+                <a:ea typeface="Avenir Next" pitchFamily="34" charset="-122"/>
+                <a:cs typeface="Avenir Next" pitchFamily="34" charset="-120"/>
+              </a:rPr>
+              <a:t>Lost on restart</a:t>
+            </a:r>
+            <a:endParaRPr lang="en-US" sz="1500" dirty="0"/>
+          </a:p>
+        </p:txBody>
+      </p:sp>
+      <p:sp>
+        <p:nvSpPr>
+          <p:cNvPr id="13" name="Shape 10"/>
+          <p:cNvSpPr/>
+          <p:nvPr/>
+        </p:nvSpPr>
+        <p:spPr>
+          <a:xfrm>
+            <a:off x="585216" y="2606040"/>
+            <a:ext cx="7973568" cy="0"/>
+          </a:xfrm>
+          <a:prstGeom prst="line">
+            <a:avLst/>
+          </a:prstGeom>
+          <a:noFill/>
+          <a:ln w="9525">
+            <a:solidFill>
+              <a:srgbClr val="333333"/>
+            </a:solidFill>
+            <a:prstDash val="solid"/>
+          </a:ln>
+        </p:spPr>
+      </p:sp>
+      <p:sp>
+        <p:nvSpPr>
+          <p:cNvPr id="14" name="Text 11"/>
+          <p:cNvSpPr txBox="1"/>
+          <p:nvPr/>
+        </p:nvSpPr>
+        <p:spPr>
+          <a:xfrm>
+            <a:off x="2468880" y="2761488"/>
+            <a:ext cx="3017520" cy="329184"/>
+          </a:xfrm>
+          <a:prstGeom prst="rect">
+            <a:avLst/>
+          </a:prstGeom>
+          <a:noFill/>
+          <a:ln/>
+        </p:spPr>
+        <p:txBody>
+          <a:bodyPr wrap="square" lIns="0" tIns="0" rIns="0" bIns="0" rtlCol="0" anchor="t">
+            <a:normAutofit/>
+          </a:bodyPr>
+          <a:lstStyle/>
+          <a:p>
+            <a:pPr indent="0" marL="0">
+              <a:buNone/>
+            </a:pPr>
+            <a:r>
+              <a:rPr lang="en-US" sz="1900" b="1" dirty="0">
+                <a:solidFill>
+                  <a:srgbClr val="F5F5F5"/>
+                </a:solidFill>
+                <a:latin typeface="Avenir Next" pitchFamily="34" charset="0"/>
+                <a:ea typeface="Avenir Next" pitchFamily="34" charset="-122"/>
+                <a:cs typeface="Avenir Next" pitchFamily="34" charset="-120"/>
+              </a:rPr>
+              <a:t>Hand-written store</a:t>
+            </a:r>
+            <a:endParaRPr lang="en-US" sz="1900" dirty="0"/>
+          </a:p>
+        </p:txBody>
+      </p:sp>
+      <p:sp>
+        <p:nvSpPr>
+          <p:cNvPr id="15" name="Text 12"/>
+          <p:cNvSpPr txBox="1"/>
+          <p:nvPr/>
+        </p:nvSpPr>
+        <p:spPr>
+          <a:xfrm>
+            <a:off x="5577840" y="2798064"/>
+            <a:ext cx="2980944" cy="292608"/>
+          </a:xfrm>
+          <a:prstGeom prst="rect">
+            <a:avLst/>
+          </a:prstGeom>
+          <a:noFill/>
+          <a:ln/>
+        </p:spPr>
+        <p:txBody>
+          <a:bodyPr wrap="square" lIns="0" tIns="0" rIns="0" bIns="0" rtlCol="0" anchor="t">
+            <a:normAutofit/>
+          </a:bodyPr>
+          <a:lstStyle/>
+          <a:p>
+            <a:pPr indent="0" marL="0">
+              <a:buNone/>
+            </a:pPr>
+            <a:r>
+              <a:rPr lang="en-US" sz="1500" dirty="0">
+                <a:solidFill>
+                  <a:srgbClr val="A9ADB3"/>
+                </a:solidFill>
+                <a:latin typeface="Avenir Next" pitchFamily="34" charset="0"/>
+                <a:ea typeface="Avenir Next" pitchFamily="34" charset="-122"/>
+                <a:cs typeface="Avenir Next" pitchFamily="34" charset="-120"/>
+              </a:rPr>
+              <a:t>Owns atomicity</a:t>
+            </a:r>
+            <a:endParaRPr lang="en-US" sz="1500" dirty="0"/>
+          </a:p>
+        </p:txBody>
+      </p:sp>
+      <p:sp>
+        <p:nvSpPr>
+          <p:cNvPr id="16" name="Shape 13"/>
+          <p:cNvSpPr/>
+          <p:nvPr/>
+        </p:nvSpPr>
+        <p:spPr>
+          <a:xfrm>
+            <a:off x="585216" y="3246120"/>
+            <a:ext cx="7973568" cy="0"/>
+          </a:xfrm>
+          <a:prstGeom prst="line">
+            <a:avLst/>
+          </a:prstGeom>
+          <a:noFill/>
+          <a:ln w="9525">
+            <a:solidFill>
+              <a:srgbClr val="333333"/>
+            </a:solidFill>
+            <a:prstDash val="solid"/>
+          </a:ln>
+        </p:spPr>
+      </p:sp>
+      <p:sp>
+        <p:nvSpPr>
+          <p:cNvPr id="17" name="Text 14"/>
+          <p:cNvSpPr txBox="1"/>
+          <p:nvPr/>
+        </p:nvSpPr>
+        <p:spPr>
+          <a:xfrm>
+            <a:off x="2468880" y="3401568"/>
+            <a:ext cx="3017520" cy="329184"/>
+          </a:xfrm>
+          <a:prstGeom prst="rect">
+            <a:avLst/>
+          </a:prstGeom>
+          <a:noFill/>
+          <a:ln/>
+        </p:spPr>
+        <p:txBody>
+          <a:bodyPr wrap="square" lIns="0" tIns="0" rIns="0" bIns="0" rtlCol="0" anchor="t">
+            <a:normAutofit/>
+          </a:bodyPr>
+          <a:lstStyle/>
+          <a:p>
+            <a:pPr indent="0" marL="0">
+              <a:buNone/>
+            </a:pPr>
+            <a:r>
+              <a:rPr lang="en-US" sz="1900" b="1" dirty="0">
+                <a:solidFill>
+                  <a:srgbClr val="F5F5F5"/>
+                </a:solidFill>
+                <a:latin typeface="Avenir Next" pitchFamily="34" charset="0"/>
+                <a:ea typeface="Avenir Next" pitchFamily="34" charset="-122"/>
+                <a:cs typeface="Avenir Next" pitchFamily="34" charset="-120"/>
+              </a:rPr>
+              <a:t>EF Core InMemory</a:t>
+            </a:r>
+            <a:endParaRPr lang="en-US" sz="1900" dirty="0"/>
+          </a:p>
+        </p:txBody>
+      </p:sp>
+      <p:sp>
+        <p:nvSpPr>
+          <p:cNvPr id="18" name="Text 15"/>
+          <p:cNvSpPr txBox="1"/>
+          <p:nvPr/>
+        </p:nvSpPr>
+        <p:spPr>
+          <a:xfrm>
+            <a:off x="5577840" y="3438144"/>
+            <a:ext cx="2980944" cy="292608"/>
+          </a:xfrm>
+          <a:prstGeom prst="rect">
+            <a:avLst/>
+          </a:prstGeom>
+          <a:noFill/>
+          <a:ln/>
+        </p:spPr>
+        <p:txBody>
+          <a:bodyPr wrap="square" lIns="0" tIns="0" rIns="0" bIns="0" rtlCol="0" anchor="t">
+            <a:normAutofit/>
+          </a:bodyPr>
+          <a:lstStyle/>
+          <a:p>
+            <a:pPr indent="0" marL="0">
+              <a:buNone/>
+            </a:pPr>
+            <a:r>
+              <a:rPr lang="en-US" sz="1500" dirty="0">
+                <a:solidFill>
+                  <a:srgbClr val="A9ADB3"/>
+                </a:solidFill>
+                <a:latin typeface="Avenir Next" pitchFamily="34" charset="0"/>
+                <a:ea typeface="Avenir Next" pitchFamily="34" charset="-122"/>
+                <a:cs typeface="Avenir Next" pitchFamily="34" charset="-120"/>
+              </a:rPr>
+              <a:t>No transactions</a:t>
+            </a:r>
+            <a:endParaRPr lang="en-US" sz="1500" dirty="0"/>
+          </a:p>
+        </p:txBody>
+      </p:sp>
+      <p:sp>
+        <p:nvSpPr>
+          <p:cNvPr id="19" name="Shape 16"/>
+          <p:cNvSpPr/>
+          <p:nvPr/>
+        </p:nvSpPr>
+        <p:spPr>
+          <a:xfrm>
+            <a:off x="585216" y="3886200"/>
+            <a:ext cx="7973568" cy="0"/>
+          </a:xfrm>
+          <a:prstGeom prst="line">
+            <a:avLst/>
+          </a:prstGeom>
+          <a:noFill/>
+          <a:ln w="9525">
+            <a:solidFill>
+              <a:srgbClr val="333333"/>
+            </a:solidFill>
+            <a:prstDash val="solid"/>
+          </a:ln>
+        </p:spPr>
+      </p:sp>
+      <p:sp>
+        <p:nvSpPr>
+          <p:cNvPr id="20" name="Text 17"/>
+          <p:cNvSpPr txBox="1"/>
+          <p:nvPr/>
+        </p:nvSpPr>
+        <p:spPr>
+          <a:xfrm>
+            <a:off x="2468880" y="4041648"/>
+            <a:ext cx="3017520" cy="329184"/>
+          </a:xfrm>
+          <a:prstGeom prst="rect">
+            <a:avLst/>
+          </a:prstGeom>
+          <a:noFill/>
+          <a:ln/>
+        </p:spPr>
+        <p:txBody>
+          <a:bodyPr wrap="square" lIns="0" tIns="0" rIns="0" bIns="0" rtlCol="0" anchor="t">
+            <a:normAutofit/>
+          </a:bodyPr>
+          <a:lstStyle/>
+          <a:p>
+            <a:pPr indent="0" marL="0">
+              <a:buNone/>
+            </a:pPr>
+            <a:r>
+              <a:rPr lang="en-US" sz="1900" b="1" dirty="0">
+                <a:solidFill>
+                  <a:srgbClr val="F5F5F5"/>
+                </a:solidFill>
+                <a:latin typeface="Avenir Next" pitchFamily="34" charset="0"/>
+                <a:ea typeface="Avenir Next" pitchFamily="34" charset="-122"/>
+                <a:cs typeface="Avenir Next" pitchFamily="34" charset="-120"/>
+              </a:rPr>
+              <a:t>Redis</a:t>
+            </a:r>
+            <a:endParaRPr lang="en-US" sz="1900" dirty="0"/>
+          </a:p>
+        </p:txBody>
+      </p:sp>
+      <p:sp>
+        <p:nvSpPr>
+          <p:cNvPr id="21" name="Text 18"/>
+          <p:cNvSpPr txBox="1"/>
+          <p:nvPr/>
+        </p:nvSpPr>
+        <p:spPr>
+          <a:xfrm>
+            <a:off x="5577840" y="4078224"/>
+            <a:ext cx="2980944" cy="292608"/>
+          </a:xfrm>
+          <a:prstGeom prst="rect">
+            <a:avLst/>
+          </a:prstGeom>
+          <a:noFill/>
+          <a:ln/>
+        </p:spPr>
+        <p:txBody>
+          <a:bodyPr wrap="square" lIns="0" tIns="0" rIns="0" bIns="0" rtlCol="0" anchor="t">
+            <a:normAutofit/>
+          </a:bodyPr>
+          <a:lstStyle/>
+          <a:p>
+            <a:pPr indent="0" marL="0">
+              <a:buNone/>
+            </a:pPr>
+            <a:r>
+              <a:rPr lang="en-US" sz="1500" dirty="0">
+                <a:solidFill>
+                  <a:srgbClr val="A9ADB3"/>
+                </a:solidFill>
+                <a:latin typeface="Avenir Next" pitchFamily="34" charset="0"/>
+                <a:ea typeface="Avenir Next" pitchFamily="34" charset="-122"/>
+                <a:cs typeface="Avenir Next" pitchFamily="34" charset="-120"/>
+              </a:rPr>
+              <a:t>Extra process</a:t>
+            </a:r>
+            <a:endParaRPr lang="en-US" sz="1500" dirty="0"/>
           </a:p>
         </p:txBody>
       </p:sp>
@@ -4581,7 +4846,7 @@
                 <a:ea typeface="Avenir Next" pitchFamily="34" charset="-122"/>
                 <a:cs typeface="Avenir Next" pitchFamily="34" charset="-120"/>
               </a:rPr>
-              <a:t>143 tests by layer</a:t>
+              <a:t>Failure leaves no partial state</a:t>
             </a:r>
             <a:endParaRPr lang="en-US" sz="3200" dirty="0"/>
           </a:p>
@@ -4595,8 +4860,8 @@
         </p:nvSpPr>
         <p:spPr>
           <a:xfrm>
-            <a:off x="585216" y="1225296"/>
-            <a:ext cx="841248" cy="475488"/>
+            <a:off x="585216" y="1307592"/>
+            <a:ext cx="411480" cy="274320"/>
           </a:xfrm>
           <a:prstGeom prst="rect">
             <a:avLst/>
@@ -4612,7 +4877,7 @@
               <a:buNone/>
             </a:pPr>
             <a:r>
-              <a:rPr lang="en-US" sz="3400" b="1" dirty="0">
+              <a:rPr lang="en-US" sz="1300" b="1" dirty="0">
                 <a:solidFill>
                   <a:srgbClr val="00F604"/>
                 </a:solidFill>
@@ -4620,9 +4885,9 @@
                 <a:ea typeface="Avenir Next" pitchFamily="34" charset="-122"/>
                 <a:cs typeface="Avenir Next" pitchFamily="34" charset="-120"/>
               </a:rPr>
-              <a:t>75</a:t>
-            </a:r>
-            <a:endParaRPr lang="en-US" sz="3400" dirty="0"/>
+              <a:t>01</a:t>
+            </a:r>
+            <a:endParaRPr lang="en-US" sz="1300" dirty="0"/>
           </a:p>
         </p:txBody>
       </p:sp>
@@ -4634,8 +4899,8 @@
         </p:nvSpPr>
         <p:spPr>
           <a:xfrm>
-            <a:off x="1508760" y="1243584"/>
-            <a:ext cx="2075688" cy="256032"/>
+            <a:off x="1115568" y="1261872"/>
+            <a:ext cx="2743200" cy="512064"/>
           </a:xfrm>
           <a:prstGeom prst="rect">
             <a:avLst/>
@@ -4653,7 +4918,7 @@
               <a:buNone/>
             </a:pPr>
             <a:r>
-              <a:rPr lang="en-US" sz="1600" b="1" dirty="0">
+              <a:rPr lang="en-US" sz="2000" b="1" dirty="0">
                 <a:solidFill>
                   <a:srgbClr val="F5F5F5"/>
                 </a:solidFill>
@@ -4661,9 +4926,9 @@
                 <a:ea typeface="Avenir Next" pitchFamily="34" charset="-122"/>
                 <a:cs typeface="Avenir Next" pitchFamily="34" charset="-120"/>
               </a:rPr>
-              <a:t>Domain</a:t>
-            </a:r>
-            <a:endParaRPr lang="en-US" sz="1600" dirty="0"/>
+              <a:t>Validate before mutation</a:t>
+            </a:r>
+            <a:endParaRPr lang="en-US" sz="2000" dirty="0"/>
           </a:p>
         </p:txBody>
       </p:sp>
@@ -4675,8 +4940,47 @@
         </p:nvSpPr>
         <p:spPr>
           <a:xfrm>
-            <a:off x="1508760" y="1572768"/>
-            <a:ext cx="2075688" cy="219456"/>
+            <a:off x="585216" y="2313432"/>
+            <a:ext cx="411480" cy="274320"/>
+          </a:xfrm>
+          <a:prstGeom prst="rect">
+            <a:avLst/>
+          </a:prstGeom>
+          <a:noFill/>
+          <a:ln/>
+        </p:spPr>
+        <p:txBody>
+          <a:bodyPr wrap="square" lIns="0" tIns="0" rIns="0" bIns="0" rtlCol="0" anchor="t"/>
+          <a:lstStyle/>
+          <a:p>
+            <a:pPr indent="0" marL="0">
+              <a:buNone/>
+            </a:pPr>
+            <a:r>
+              <a:rPr lang="en-US" sz="1300" b="1" dirty="0">
+                <a:solidFill>
+                  <a:srgbClr val="00F604"/>
+                </a:solidFill>
+                <a:latin typeface="Avenir Next" pitchFamily="34" charset="0"/>
+                <a:ea typeface="Avenir Next" pitchFamily="34" charset="-122"/>
+                <a:cs typeface="Avenir Next" pitchFamily="34" charset="-120"/>
+              </a:rPr>
+              <a:t>02</a:t>
+            </a:r>
+            <a:endParaRPr lang="en-US" sz="1300" dirty="0"/>
+          </a:p>
+        </p:txBody>
+      </p:sp>
+      <p:sp>
+        <p:nvSpPr>
+          <p:cNvPr id="8" name="Text 5"/>
+          <p:cNvSpPr txBox="1"/>
+          <p:nvPr/>
+        </p:nvSpPr>
+        <p:spPr>
+          <a:xfrm>
+            <a:off x="1115568" y="2267712"/>
+            <a:ext cx="2743200" cy="512064"/>
           </a:xfrm>
           <a:prstGeom prst="rect">
             <a:avLst/>
@@ -4694,30 +4998,30 @@
               <a:buNone/>
             </a:pPr>
             <a:r>
-              <a:rPr lang="en-US" sz="1200" dirty="0">
-                <a:solidFill>
-                  <a:srgbClr val="A9ADB3"/>
-                </a:solidFill>
-                <a:latin typeface="Avenir Next" pitchFamily="34" charset="0"/>
-                <a:ea typeface="Avenir Next" pitchFamily="34" charset="-122"/>
-                <a:cs typeface="Avenir Next" pitchFamily="34" charset="-120"/>
-              </a:rPr>
-              <a:t>Invariants</a:t>
-            </a:r>
-            <a:endParaRPr lang="en-US" sz="1200" dirty="0"/>
-          </a:p>
-        </p:txBody>
-      </p:sp>
-      <p:sp>
-        <p:nvSpPr>
-          <p:cNvPr id="8" name="Text 5"/>
-          <p:cNvSpPr txBox="1"/>
-          <p:nvPr/>
-        </p:nvSpPr>
-        <p:spPr>
-          <a:xfrm>
-            <a:off x="585216" y="2203704"/>
-            <a:ext cx="841248" cy="475488"/>
+              <a:rPr lang="en-US" sz="2000" b="1" dirty="0">
+                <a:solidFill>
+                  <a:srgbClr val="F5F5F5"/>
+                </a:solidFill>
+                <a:latin typeface="Avenir Next" pitchFamily="34" charset="0"/>
+                <a:ea typeface="Avenir Next" pitchFamily="34" charset="-122"/>
+                <a:cs typeface="Avenir Next" pitchFamily="34" charset="-120"/>
+              </a:rPr>
+              <a:t>Commit balance and history together</a:t>
+            </a:r>
+            <a:endParaRPr lang="en-US" sz="2000" dirty="0"/>
+          </a:p>
+        </p:txBody>
+      </p:sp>
+      <p:sp>
+        <p:nvSpPr>
+          <p:cNvPr id="9" name="Text 6"/>
+          <p:cNvSpPr txBox="1"/>
+          <p:nvPr/>
+        </p:nvSpPr>
+        <p:spPr>
+          <a:xfrm>
+            <a:off x="585216" y="3319272"/>
+            <a:ext cx="411480" cy="274320"/>
           </a:xfrm>
           <a:prstGeom prst="rect">
             <a:avLst/>
@@ -4733,7 +5037,7 @@
               <a:buNone/>
             </a:pPr>
             <a:r>
-              <a:rPr lang="en-US" sz="3400" b="1" dirty="0">
+              <a:rPr lang="en-US" sz="1300" b="1" dirty="0">
                 <a:solidFill>
                   <a:srgbClr val="00F604"/>
                 </a:solidFill>
@@ -4741,22 +5045,22 @@
                 <a:ea typeface="Avenir Next" pitchFamily="34" charset="-122"/>
                 <a:cs typeface="Avenir Next" pitchFamily="34" charset="-120"/>
               </a:rPr>
-              <a:t>33</a:t>
-            </a:r>
-            <a:endParaRPr lang="en-US" sz="3400" dirty="0"/>
-          </a:p>
-        </p:txBody>
-      </p:sp>
-      <p:sp>
-        <p:nvSpPr>
-          <p:cNvPr id="9" name="Text 6"/>
-          <p:cNvSpPr txBox="1"/>
-          <p:nvPr/>
-        </p:nvSpPr>
-        <p:spPr>
-          <a:xfrm>
-            <a:off x="1508760" y="2221992"/>
-            <a:ext cx="2075688" cy="256032"/>
+              <a:t>03</a:t>
+            </a:r>
+            <a:endParaRPr lang="en-US" sz="1300" dirty="0"/>
+          </a:p>
+        </p:txBody>
+      </p:sp>
+      <p:sp>
+        <p:nvSpPr>
+          <p:cNvPr id="10" name="Text 7"/>
+          <p:cNvSpPr txBox="1"/>
+          <p:nvPr/>
+        </p:nvSpPr>
+        <p:spPr>
+          <a:xfrm>
+            <a:off x="1115568" y="3273552"/>
+            <a:ext cx="2743200" cy="512064"/>
           </a:xfrm>
           <a:prstGeom prst="rect">
             <a:avLst/>
@@ -4774,7 +5078,7 @@
               <a:buNone/>
             </a:pPr>
             <a:r>
-              <a:rPr lang="en-US" sz="1600" b="1" dirty="0">
+              <a:rPr lang="en-US" sz="2000" b="1" dirty="0">
                 <a:solidFill>
                   <a:srgbClr val="F5F5F5"/>
                 </a:solidFill>
@@ -4782,184 +5086,22 @@
                 <a:ea typeface="Avenir Next" pitchFamily="34" charset="-122"/>
                 <a:cs typeface="Avenir Next" pitchFamily="34" charset="-120"/>
               </a:rPr>
-              <a:t>Application</a:t>
-            </a:r>
-            <a:endParaRPr lang="en-US" sz="1600" dirty="0"/>
-          </a:p>
-        </p:txBody>
-      </p:sp>
-      <p:sp>
-        <p:nvSpPr>
-          <p:cNvPr id="10" name="Text 7"/>
-          <p:cNvSpPr txBox="1"/>
-          <p:nvPr/>
-        </p:nvSpPr>
-        <p:spPr>
-          <a:xfrm>
-            <a:off x="1508760" y="2551176"/>
-            <a:ext cx="2075688" cy="219456"/>
-          </a:xfrm>
-          <a:prstGeom prst="rect">
-            <a:avLst/>
-          </a:prstGeom>
-          <a:noFill/>
-          <a:ln/>
-        </p:spPr>
-        <p:txBody>
-          <a:bodyPr wrap="square" lIns="0" tIns="0" rIns="0" bIns="0" rtlCol="0" anchor="t">
-            <a:normAutofit/>
-          </a:bodyPr>
-          <a:lstStyle/>
-          <a:p>
-            <a:pPr indent="0" marL="0">
-              <a:buNone/>
-            </a:pPr>
-            <a:r>
-              <a:rPr lang="en-US" sz="1200" dirty="0">
-                <a:solidFill>
-                  <a:srgbClr val="A9ADB3"/>
-                </a:solidFill>
-                <a:latin typeface="Avenir Next" pitchFamily="34" charset="0"/>
-                <a:ea typeface="Avenir Next" pitchFamily="34" charset="-122"/>
-                <a:cs typeface="Avenir Next" pitchFamily="34" charset="-120"/>
-              </a:rPr>
-              <a:t>Orchestration</a:t>
-            </a:r>
-            <a:endParaRPr lang="en-US" sz="1200" dirty="0"/>
-          </a:p>
-        </p:txBody>
-      </p:sp>
-      <p:sp>
-        <p:nvSpPr>
-          <p:cNvPr id="11" name="Text 8"/>
-          <p:cNvSpPr txBox="1"/>
-          <p:nvPr/>
-        </p:nvSpPr>
-        <p:spPr>
-          <a:xfrm>
-            <a:off x="585216" y="3182112"/>
-            <a:ext cx="841248" cy="475488"/>
-          </a:xfrm>
-          <a:prstGeom prst="rect">
-            <a:avLst/>
-          </a:prstGeom>
-          <a:noFill/>
-          <a:ln/>
-        </p:spPr>
-        <p:txBody>
-          <a:bodyPr wrap="square" lIns="0" tIns="0" rIns="0" bIns="0" rtlCol="0" anchor="t"/>
-          <a:lstStyle/>
-          <a:p>
-            <a:pPr indent="0" marL="0">
-              <a:buNone/>
-            </a:pPr>
-            <a:r>
-              <a:rPr lang="en-US" sz="3400" b="1" dirty="0">
-                <a:solidFill>
-                  <a:srgbClr val="00F604"/>
-                </a:solidFill>
-                <a:latin typeface="Avenir Next" pitchFamily="34" charset="0"/>
-                <a:ea typeface="Avenir Next" pitchFamily="34" charset="-122"/>
-                <a:cs typeface="Avenir Next" pitchFamily="34" charset="-120"/>
-              </a:rPr>
-              <a:t>35</a:t>
-            </a:r>
-            <a:endParaRPr lang="en-US" sz="3400" dirty="0"/>
-          </a:p>
-        </p:txBody>
-      </p:sp>
-      <p:sp>
-        <p:nvSpPr>
-          <p:cNvPr id="12" name="Text 9"/>
-          <p:cNvSpPr txBox="1"/>
-          <p:nvPr/>
-        </p:nvSpPr>
-        <p:spPr>
-          <a:xfrm>
-            <a:off x="1508760" y="3200400"/>
-            <a:ext cx="2075688" cy="256032"/>
-          </a:xfrm>
-          <a:prstGeom prst="rect">
-            <a:avLst/>
-          </a:prstGeom>
-          <a:noFill/>
-          <a:ln/>
-        </p:spPr>
-        <p:txBody>
-          <a:bodyPr wrap="square" lIns="0" tIns="0" rIns="0" bIns="0" rtlCol="0" anchor="t">
-            <a:normAutofit/>
-          </a:bodyPr>
-          <a:lstStyle/>
-          <a:p>
-            <a:pPr indent="0" marL="0">
-              <a:buNone/>
-            </a:pPr>
-            <a:r>
-              <a:rPr lang="en-US" sz="1600" b="1" dirty="0">
-                <a:solidFill>
-                  <a:srgbClr val="F5F5F5"/>
-                </a:solidFill>
-                <a:latin typeface="Avenir Next" pitchFamily="34" charset="0"/>
-                <a:ea typeface="Avenir Next" pitchFamily="34" charset="-122"/>
-                <a:cs typeface="Avenir Next" pitchFamily="34" charset="-120"/>
-              </a:rPr>
-              <a:t>Integration + HTTP</a:t>
-            </a:r>
-            <a:endParaRPr lang="en-US" sz="1600" dirty="0"/>
-          </a:p>
-        </p:txBody>
-      </p:sp>
-      <p:sp>
-        <p:nvSpPr>
-          <p:cNvPr id="13" name="Text 10"/>
-          <p:cNvSpPr txBox="1"/>
-          <p:nvPr/>
-        </p:nvSpPr>
-        <p:spPr>
-          <a:xfrm>
-            <a:off x="1508760" y="3529584"/>
-            <a:ext cx="2075688" cy="219456"/>
-          </a:xfrm>
-          <a:prstGeom prst="rect">
-            <a:avLst/>
-          </a:prstGeom>
-          <a:noFill/>
-          <a:ln/>
-        </p:spPr>
-        <p:txBody>
-          <a:bodyPr wrap="square" lIns="0" tIns="0" rIns="0" bIns="0" rtlCol="0" anchor="t">
-            <a:normAutofit/>
-          </a:bodyPr>
-          <a:lstStyle/>
-          <a:p>
-            <a:pPr indent="0" marL="0">
-              <a:buNone/>
-            </a:pPr>
-            <a:r>
-              <a:rPr lang="en-US" sz="1200" dirty="0">
-                <a:solidFill>
-                  <a:srgbClr val="A9ADB3"/>
-                </a:solidFill>
-                <a:latin typeface="Avenir Next" pitchFamily="34" charset="0"/>
-                <a:ea typeface="Avenir Next" pitchFamily="34" charset="-122"/>
-                <a:cs typeface="Avenir Next" pitchFamily="34" charset="-120"/>
-              </a:rPr>
-              <a:t>Persistence and HTTP</a:t>
-            </a:r>
-            <a:endParaRPr lang="en-US" sz="1200" dirty="0"/>
-          </a:p>
-        </p:txBody>
-      </p:sp>
-      <p:sp>
-        <p:nvSpPr>
-          <p:cNvPr id="14" name="Shape 11"/>
+              <a:t>Reject stale writes</a:t>
+            </a:r>
+            <a:endParaRPr lang="en-US" sz="2000" dirty="0"/>
+          </a:p>
+        </p:txBody>
+      </p:sp>
+      <p:sp>
+        <p:nvSpPr>
+          <p:cNvPr id="11" name="Shape 8"/>
           <p:cNvSpPr/>
           <p:nvPr/>
         </p:nvSpPr>
         <p:spPr>
           <a:xfrm>
-            <a:off x="4800600" y="1115568"/>
-            <a:ext cx="3758184" cy="2926080"/>
+            <a:off x="4233672" y="1133856"/>
+            <a:ext cx="4325112" cy="3282696"/>
           </a:xfrm>
           <a:prstGeom prst="rect">
             <a:avLst/>
@@ -4977,7 +5119,7 @@
       </p:sp>
       <p:pic>
         <p:nvPicPr>
-          <p:cNvPr id="15" name="Image 0" descr="/Users/john/theborg/repos/atm/design/screenshots/receipt.png">    </p:cNvPr>
+          <p:cNvPr id="12" name="Image 0" descr="/Users/john/theborg/repos/atm/design/screenshots/overdraft.png">    </p:cNvPr>
           <p:cNvPicPr>
             <a:picLocks noChangeAspect="1"/>
           </p:cNvPicPr>
@@ -4991,8 +5133,8 @@
         </p:blipFill>
         <p:spPr>
           <a:xfrm>
-            <a:off x="4837176" y="1152144"/>
-            <a:ext cx="3685032" cy="2852928"/>
+            <a:off x="4270248" y="1170432"/>
+            <a:ext cx="4251960" cy="3209544"/>
           </a:xfrm>
           <a:prstGeom prst="rect">
             <a:avLst/>
@@ -5001,30 +5143,32 @@
       </p:pic>
       <p:sp>
         <p:nvSpPr>
-          <p:cNvPr id="16" name="Text 12"/>
-          <p:cNvSpPr txBox="1"/>
-          <p:nvPr/>
-        </p:nvSpPr>
-        <p:spPr>
-          <a:xfrm>
-            <a:off x="4800600" y="4187952"/>
-            <a:ext cx="3758184" cy="219456"/>
-          </a:xfrm>
-          <a:prstGeom prst="rect">
-            <a:avLst/>
-          </a:prstGeom>
-          <a:noFill/>
-          <a:ln/>
-        </p:spPr>
-        <p:txBody>
-          <a:bodyPr wrap="square" lIns="0" tIns="0" rIns="0" bIns="0" rtlCol="0" anchor="t"/>
+          <p:cNvPr id="13" name="Text 9"/>
+          <p:cNvSpPr txBox="1"/>
+          <p:nvPr/>
+        </p:nvSpPr>
+        <p:spPr>
+          <a:xfrm>
+            <a:off x="4233672" y="4489704"/>
+            <a:ext cx="4325112" cy="201168"/>
+          </a:xfrm>
+          <a:prstGeom prst="rect">
+            <a:avLst/>
+          </a:prstGeom>
+          <a:noFill/>
+          <a:ln/>
+        </p:spPr>
+        <p:txBody>
+          <a:bodyPr wrap="square" lIns="0" tIns="0" rIns="0" bIns="0" rtlCol="0" anchor="t">
+            <a:normAutofit/>
+          </a:bodyPr>
           <a:lstStyle/>
           <a:p>
             <a:pPr algn="r" indent="0" marL="0">
               <a:buNone/>
             </a:pPr>
             <a:r>
-              <a:rPr lang="en-US" sz="1200" dirty="0">
+              <a:rPr lang="en-US" sz="1150" b="1" dirty="0">
                 <a:solidFill>
                   <a:srgbClr val="00F604"/>
                 </a:solidFill>
@@ -5032,9 +5176,9 @@
                 <a:ea typeface="Avenir Next" pitchFamily="34" charset="-122"/>
                 <a:cs typeface="Avenir Next" pitchFamily="34" charset="-120"/>
               </a:rPr>
-              <a:t>Success receipt after Post/Redirect/Get.</a:t>
-            </a:r>
-            <a:endParaRPr lang="en-US" sz="1200" dirty="0"/>
+              <a:t>Rejected overdraft. Persisted state stays unchanged.</a:t>
+            </a:r>
+            <a:endParaRPr lang="en-US" sz="1150" dirty="0"/>
           </a:p>
         </p:txBody>
       </p:sp>
@@ -5049,6 +5193,557 @@
 <file path=ppt/slides/slide7.xml><?xml version="1.0" encoding="utf-8"?>
 <p:sld xmlns:a="http://schemas.openxmlformats.org/drawingml/2006/main" xmlns:r="http://schemas.openxmlformats.org/officeDocument/2006/relationships" xmlns:p="http://schemas.openxmlformats.org/presentationml/2006/main">
   <p:cSld name="Slide 7">
+    <p:bg>
+      <p:bgPr>
+        <a:solidFill>
+          <a:srgbClr val="121212"/>
+        </a:solidFill>
+      </p:bgPr>
+    </p:bg>
+    <p:spTree>
+      <p:nvGrpSpPr>
+        <p:cNvPr id="1" name=""/>
+        <p:cNvGrpSpPr/>
+        <p:nvPr/>
+      </p:nvGrpSpPr>
+      <p:grpSpPr>
+        <a:xfrm>
+          <a:off x="0" y="0"/>
+          <a:ext cx="0" cy="0"/>
+          <a:chOff x="0" y="0"/>
+          <a:chExt cx="0" cy="0"/>
+        </a:xfrm>
+      </p:grpSpPr>
+      <p:sp>
+        <p:nvSpPr>
+          <p:cNvPr id="2" name="Shape 0"/>
+          <p:cNvSpPr/>
+          <p:nvPr/>
+        </p:nvSpPr>
+        <p:spPr>
+          <a:xfrm>
+            <a:off x="585216" y="356616"/>
+            <a:ext cx="91440" cy="438912"/>
+          </a:xfrm>
+          <a:prstGeom prst="rect">
+            <a:avLst/>
+          </a:prstGeom>
+          <a:solidFill>
+            <a:srgbClr val="00F604"/>
+          </a:solidFill>
+          <a:ln w="12700">
+            <a:solidFill>
+              <a:srgbClr val="00F604">
+                <a:alpha val="0"/>
+              </a:srgbClr>
+            </a:solidFill>
+            <a:prstDash val="solid"/>
+          </a:ln>
+        </p:spPr>
+      </p:sp>
+      <p:sp>
+        <p:nvSpPr>
+          <p:cNvPr id="3" name="Text 1"/>
+          <p:cNvSpPr txBox="1"/>
+          <p:nvPr/>
+        </p:nvSpPr>
+        <p:spPr>
+          <a:xfrm>
+            <a:off x="832104" y="356616"/>
+            <a:ext cx="7726680" cy="512064"/>
+          </a:xfrm>
+          <a:prstGeom prst="rect">
+            <a:avLst/>
+          </a:prstGeom>
+          <a:noFill/>
+          <a:ln/>
+        </p:spPr>
+        <p:txBody>
+          <a:bodyPr wrap="square" lIns="0" tIns="0" rIns="0" bIns="0" rtlCol="0" anchor="t">
+            <a:normAutofit/>
+          </a:bodyPr>
+          <a:lstStyle/>
+          <a:p>
+            <a:pPr indent="0" marL="0">
+              <a:buNone/>
+            </a:pPr>
+            <a:r>
+              <a:rPr lang="en-US" sz="3200" b="1" dirty="0">
+                <a:solidFill>
+                  <a:srgbClr val="F5F5F5"/>
+                </a:solidFill>
+                <a:latin typeface="Avenir Next" pitchFamily="34" charset="0"/>
+                <a:ea typeface="Avenir Next" pitchFamily="34" charset="-122"/>
+                <a:cs typeface="Avenir Next" pitchFamily="34" charset="-120"/>
+              </a:rPr>
+              <a:t>143 tests by layer</a:t>
+            </a:r>
+            <a:endParaRPr lang="en-US" sz="3200" dirty="0"/>
+          </a:p>
+        </p:txBody>
+      </p:sp>
+      <p:sp>
+        <p:nvSpPr>
+          <p:cNvPr id="5" name="Text 2"/>
+          <p:cNvSpPr txBox="1"/>
+          <p:nvPr/>
+        </p:nvSpPr>
+        <p:spPr>
+          <a:xfrm>
+            <a:off x="585216" y="1225296"/>
+            <a:ext cx="841248" cy="475488"/>
+          </a:xfrm>
+          <a:prstGeom prst="rect">
+            <a:avLst/>
+          </a:prstGeom>
+          <a:noFill/>
+          <a:ln/>
+        </p:spPr>
+        <p:txBody>
+          <a:bodyPr wrap="square" lIns="0" tIns="0" rIns="0" bIns="0" rtlCol="0" anchor="t"/>
+          <a:lstStyle/>
+          <a:p>
+            <a:pPr indent="0" marL="0">
+              <a:buNone/>
+            </a:pPr>
+            <a:r>
+              <a:rPr lang="en-US" sz="3400" b="1" dirty="0">
+                <a:solidFill>
+                  <a:srgbClr val="00F604"/>
+                </a:solidFill>
+                <a:latin typeface="Avenir Next" pitchFamily="34" charset="0"/>
+                <a:ea typeface="Avenir Next" pitchFamily="34" charset="-122"/>
+                <a:cs typeface="Avenir Next" pitchFamily="34" charset="-120"/>
+              </a:rPr>
+              <a:t>75</a:t>
+            </a:r>
+            <a:endParaRPr lang="en-US" sz="3400" dirty="0"/>
+          </a:p>
+        </p:txBody>
+      </p:sp>
+      <p:sp>
+        <p:nvSpPr>
+          <p:cNvPr id="6" name="Text 3"/>
+          <p:cNvSpPr txBox="1"/>
+          <p:nvPr/>
+        </p:nvSpPr>
+        <p:spPr>
+          <a:xfrm>
+            <a:off x="1508760" y="1243584"/>
+            <a:ext cx="2075688" cy="256032"/>
+          </a:xfrm>
+          <a:prstGeom prst="rect">
+            <a:avLst/>
+          </a:prstGeom>
+          <a:noFill/>
+          <a:ln/>
+        </p:spPr>
+        <p:txBody>
+          <a:bodyPr wrap="square" lIns="0" tIns="0" rIns="0" bIns="0" rtlCol="0" anchor="t">
+            <a:normAutofit/>
+          </a:bodyPr>
+          <a:lstStyle/>
+          <a:p>
+            <a:pPr indent="0" marL="0">
+              <a:buNone/>
+            </a:pPr>
+            <a:r>
+              <a:rPr lang="en-US" sz="1600" b="1" dirty="0">
+                <a:solidFill>
+                  <a:srgbClr val="F5F5F5"/>
+                </a:solidFill>
+                <a:latin typeface="Avenir Next" pitchFamily="34" charset="0"/>
+                <a:ea typeface="Avenir Next" pitchFamily="34" charset="-122"/>
+                <a:cs typeface="Avenir Next" pitchFamily="34" charset="-120"/>
+              </a:rPr>
+              <a:t>Domain</a:t>
+            </a:r>
+            <a:endParaRPr lang="en-US" sz="1600" dirty="0"/>
+          </a:p>
+        </p:txBody>
+      </p:sp>
+      <p:sp>
+        <p:nvSpPr>
+          <p:cNvPr id="7" name="Text 4"/>
+          <p:cNvSpPr txBox="1"/>
+          <p:nvPr/>
+        </p:nvSpPr>
+        <p:spPr>
+          <a:xfrm>
+            <a:off x="1508760" y="1572768"/>
+            <a:ext cx="2075688" cy="219456"/>
+          </a:xfrm>
+          <a:prstGeom prst="rect">
+            <a:avLst/>
+          </a:prstGeom>
+          <a:noFill/>
+          <a:ln/>
+        </p:spPr>
+        <p:txBody>
+          <a:bodyPr wrap="square" lIns="0" tIns="0" rIns="0" bIns="0" rtlCol="0" anchor="t">
+            <a:normAutofit/>
+          </a:bodyPr>
+          <a:lstStyle/>
+          <a:p>
+            <a:pPr indent="0" marL="0">
+              <a:buNone/>
+            </a:pPr>
+            <a:r>
+              <a:rPr lang="en-US" sz="1200" dirty="0">
+                <a:solidFill>
+                  <a:srgbClr val="A9ADB3"/>
+                </a:solidFill>
+                <a:latin typeface="Avenir Next" pitchFamily="34" charset="0"/>
+                <a:ea typeface="Avenir Next" pitchFamily="34" charset="-122"/>
+                <a:cs typeface="Avenir Next" pitchFamily="34" charset="-120"/>
+              </a:rPr>
+              <a:t>Invariants</a:t>
+            </a:r>
+            <a:endParaRPr lang="en-US" sz="1200" dirty="0"/>
+          </a:p>
+        </p:txBody>
+      </p:sp>
+      <p:sp>
+        <p:nvSpPr>
+          <p:cNvPr id="8" name="Text 5"/>
+          <p:cNvSpPr txBox="1"/>
+          <p:nvPr/>
+        </p:nvSpPr>
+        <p:spPr>
+          <a:xfrm>
+            <a:off x="585216" y="2203704"/>
+            <a:ext cx="841248" cy="475488"/>
+          </a:xfrm>
+          <a:prstGeom prst="rect">
+            <a:avLst/>
+          </a:prstGeom>
+          <a:noFill/>
+          <a:ln/>
+        </p:spPr>
+        <p:txBody>
+          <a:bodyPr wrap="square" lIns="0" tIns="0" rIns="0" bIns="0" rtlCol="0" anchor="t"/>
+          <a:lstStyle/>
+          <a:p>
+            <a:pPr indent="0" marL="0">
+              <a:buNone/>
+            </a:pPr>
+            <a:r>
+              <a:rPr lang="en-US" sz="3400" b="1" dirty="0">
+                <a:solidFill>
+                  <a:srgbClr val="00F604"/>
+                </a:solidFill>
+                <a:latin typeface="Avenir Next" pitchFamily="34" charset="0"/>
+                <a:ea typeface="Avenir Next" pitchFamily="34" charset="-122"/>
+                <a:cs typeface="Avenir Next" pitchFamily="34" charset="-120"/>
+              </a:rPr>
+              <a:t>33</a:t>
+            </a:r>
+            <a:endParaRPr lang="en-US" sz="3400" dirty="0"/>
+          </a:p>
+        </p:txBody>
+      </p:sp>
+      <p:sp>
+        <p:nvSpPr>
+          <p:cNvPr id="9" name="Text 6"/>
+          <p:cNvSpPr txBox="1"/>
+          <p:nvPr/>
+        </p:nvSpPr>
+        <p:spPr>
+          <a:xfrm>
+            <a:off x="1508760" y="2221992"/>
+            <a:ext cx="2075688" cy="256032"/>
+          </a:xfrm>
+          <a:prstGeom prst="rect">
+            <a:avLst/>
+          </a:prstGeom>
+          <a:noFill/>
+          <a:ln/>
+        </p:spPr>
+        <p:txBody>
+          <a:bodyPr wrap="square" lIns="0" tIns="0" rIns="0" bIns="0" rtlCol="0" anchor="t">
+            <a:normAutofit/>
+          </a:bodyPr>
+          <a:lstStyle/>
+          <a:p>
+            <a:pPr indent="0" marL="0">
+              <a:buNone/>
+            </a:pPr>
+            <a:r>
+              <a:rPr lang="en-US" sz="1600" b="1" dirty="0">
+                <a:solidFill>
+                  <a:srgbClr val="F5F5F5"/>
+                </a:solidFill>
+                <a:latin typeface="Avenir Next" pitchFamily="34" charset="0"/>
+                <a:ea typeface="Avenir Next" pitchFamily="34" charset="-122"/>
+                <a:cs typeface="Avenir Next" pitchFamily="34" charset="-120"/>
+              </a:rPr>
+              <a:t>Application</a:t>
+            </a:r>
+            <a:endParaRPr lang="en-US" sz="1600" dirty="0"/>
+          </a:p>
+        </p:txBody>
+      </p:sp>
+      <p:sp>
+        <p:nvSpPr>
+          <p:cNvPr id="10" name="Text 7"/>
+          <p:cNvSpPr txBox="1"/>
+          <p:nvPr/>
+        </p:nvSpPr>
+        <p:spPr>
+          <a:xfrm>
+            <a:off x="1508760" y="2551176"/>
+            <a:ext cx="2075688" cy="219456"/>
+          </a:xfrm>
+          <a:prstGeom prst="rect">
+            <a:avLst/>
+          </a:prstGeom>
+          <a:noFill/>
+          <a:ln/>
+        </p:spPr>
+        <p:txBody>
+          <a:bodyPr wrap="square" lIns="0" tIns="0" rIns="0" bIns="0" rtlCol="0" anchor="t">
+            <a:normAutofit/>
+          </a:bodyPr>
+          <a:lstStyle/>
+          <a:p>
+            <a:pPr indent="0" marL="0">
+              <a:buNone/>
+            </a:pPr>
+            <a:r>
+              <a:rPr lang="en-US" sz="1200" dirty="0">
+                <a:solidFill>
+                  <a:srgbClr val="A9ADB3"/>
+                </a:solidFill>
+                <a:latin typeface="Avenir Next" pitchFamily="34" charset="0"/>
+                <a:ea typeface="Avenir Next" pitchFamily="34" charset="-122"/>
+                <a:cs typeface="Avenir Next" pitchFamily="34" charset="-120"/>
+              </a:rPr>
+              <a:t>Orchestration</a:t>
+            </a:r>
+            <a:endParaRPr lang="en-US" sz="1200" dirty="0"/>
+          </a:p>
+        </p:txBody>
+      </p:sp>
+      <p:sp>
+        <p:nvSpPr>
+          <p:cNvPr id="11" name="Text 8"/>
+          <p:cNvSpPr txBox="1"/>
+          <p:nvPr/>
+        </p:nvSpPr>
+        <p:spPr>
+          <a:xfrm>
+            <a:off x="585216" y="3182112"/>
+            <a:ext cx="841248" cy="475488"/>
+          </a:xfrm>
+          <a:prstGeom prst="rect">
+            <a:avLst/>
+          </a:prstGeom>
+          <a:noFill/>
+          <a:ln/>
+        </p:spPr>
+        <p:txBody>
+          <a:bodyPr wrap="square" lIns="0" tIns="0" rIns="0" bIns="0" rtlCol="0" anchor="t"/>
+          <a:lstStyle/>
+          <a:p>
+            <a:pPr indent="0" marL="0">
+              <a:buNone/>
+            </a:pPr>
+            <a:r>
+              <a:rPr lang="en-US" sz="3400" b="1" dirty="0">
+                <a:solidFill>
+                  <a:srgbClr val="00F604"/>
+                </a:solidFill>
+                <a:latin typeface="Avenir Next" pitchFamily="34" charset="0"/>
+                <a:ea typeface="Avenir Next" pitchFamily="34" charset="-122"/>
+                <a:cs typeface="Avenir Next" pitchFamily="34" charset="-120"/>
+              </a:rPr>
+              <a:t>35</a:t>
+            </a:r>
+            <a:endParaRPr lang="en-US" sz="3400" dirty="0"/>
+          </a:p>
+        </p:txBody>
+      </p:sp>
+      <p:sp>
+        <p:nvSpPr>
+          <p:cNvPr id="12" name="Text 9"/>
+          <p:cNvSpPr txBox="1"/>
+          <p:nvPr/>
+        </p:nvSpPr>
+        <p:spPr>
+          <a:xfrm>
+            <a:off x="1508760" y="3200400"/>
+            <a:ext cx="2075688" cy="256032"/>
+          </a:xfrm>
+          <a:prstGeom prst="rect">
+            <a:avLst/>
+          </a:prstGeom>
+          <a:noFill/>
+          <a:ln/>
+        </p:spPr>
+        <p:txBody>
+          <a:bodyPr wrap="square" lIns="0" tIns="0" rIns="0" bIns="0" rtlCol="0" anchor="t">
+            <a:normAutofit/>
+          </a:bodyPr>
+          <a:lstStyle/>
+          <a:p>
+            <a:pPr indent="0" marL="0">
+              <a:buNone/>
+            </a:pPr>
+            <a:r>
+              <a:rPr lang="en-US" sz="1600" b="1" dirty="0">
+                <a:solidFill>
+                  <a:srgbClr val="F5F5F5"/>
+                </a:solidFill>
+                <a:latin typeface="Avenir Next" pitchFamily="34" charset="0"/>
+                <a:ea typeface="Avenir Next" pitchFamily="34" charset="-122"/>
+                <a:cs typeface="Avenir Next" pitchFamily="34" charset="-120"/>
+              </a:rPr>
+              <a:t>Integration + HTTP</a:t>
+            </a:r>
+            <a:endParaRPr lang="en-US" sz="1600" dirty="0"/>
+          </a:p>
+        </p:txBody>
+      </p:sp>
+      <p:sp>
+        <p:nvSpPr>
+          <p:cNvPr id="13" name="Text 10"/>
+          <p:cNvSpPr txBox="1"/>
+          <p:nvPr/>
+        </p:nvSpPr>
+        <p:spPr>
+          <a:xfrm>
+            <a:off x="1508760" y="3529584"/>
+            <a:ext cx="2075688" cy="219456"/>
+          </a:xfrm>
+          <a:prstGeom prst="rect">
+            <a:avLst/>
+          </a:prstGeom>
+          <a:noFill/>
+          <a:ln/>
+        </p:spPr>
+        <p:txBody>
+          <a:bodyPr wrap="square" lIns="0" tIns="0" rIns="0" bIns="0" rtlCol="0" anchor="t">
+            <a:normAutofit/>
+          </a:bodyPr>
+          <a:lstStyle/>
+          <a:p>
+            <a:pPr indent="0" marL="0">
+              <a:buNone/>
+            </a:pPr>
+            <a:r>
+              <a:rPr lang="en-US" sz="1200" dirty="0">
+                <a:solidFill>
+                  <a:srgbClr val="A9ADB3"/>
+                </a:solidFill>
+                <a:latin typeface="Avenir Next" pitchFamily="34" charset="0"/>
+                <a:ea typeface="Avenir Next" pitchFamily="34" charset="-122"/>
+                <a:cs typeface="Avenir Next" pitchFamily="34" charset="-120"/>
+              </a:rPr>
+              <a:t>Persistence and HTTP</a:t>
+            </a:r>
+            <a:endParaRPr lang="en-US" sz="1200" dirty="0"/>
+          </a:p>
+        </p:txBody>
+      </p:sp>
+      <p:sp>
+        <p:nvSpPr>
+          <p:cNvPr id="14" name="Shape 11"/>
+          <p:cNvSpPr/>
+          <p:nvPr/>
+        </p:nvSpPr>
+        <p:spPr>
+          <a:xfrm>
+            <a:off x="4800600" y="1115568"/>
+            <a:ext cx="3758184" cy="2926080"/>
+          </a:xfrm>
+          <a:prstGeom prst="rect">
+            <a:avLst/>
+          </a:prstGeom>
+          <a:solidFill>
+            <a:srgbClr val="1B1B1B"/>
+          </a:solidFill>
+          <a:ln w="10160">
+            <a:solidFill>
+              <a:srgbClr val="333333"/>
+            </a:solidFill>
+            <a:prstDash val="solid"/>
+          </a:ln>
+        </p:spPr>
+      </p:sp>
+      <p:pic>
+        <p:nvPicPr>
+          <p:cNvPr id="15" name="Image 0" descr="/Users/john/theborg/repos/atm/design/screenshots/receipt.png">    </p:cNvPr>
+          <p:cNvPicPr>
+            <a:picLocks noChangeAspect="1"/>
+          </p:cNvPicPr>
+          <p:nvPr/>
+        </p:nvPicPr>
+        <p:blipFill>
+          <a:blip r:embed="rId1"/>
+          <a:stretch>
+            <a:fillRect/>
+          </a:stretch>
+        </p:blipFill>
+        <p:spPr>
+          <a:xfrm>
+            <a:off x="4837176" y="1152144"/>
+            <a:ext cx="3685032" cy="2852928"/>
+          </a:xfrm>
+          <a:prstGeom prst="rect">
+            <a:avLst/>
+          </a:prstGeom>
+        </p:spPr>
+      </p:pic>
+      <p:sp>
+        <p:nvSpPr>
+          <p:cNvPr id="16" name="Text 12"/>
+          <p:cNvSpPr txBox="1"/>
+          <p:nvPr/>
+        </p:nvSpPr>
+        <p:spPr>
+          <a:xfrm>
+            <a:off x="4800600" y="4187952"/>
+            <a:ext cx="3758184" cy="219456"/>
+          </a:xfrm>
+          <a:prstGeom prst="rect">
+            <a:avLst/>
+          </a:prstGeom>
+          <a:noFill/>
+          <a:ln/>
+        </p:spPr>
+        <p:txBody>
+          <a:bodyPr wrap="square" lIns="0" tIns="0" rIns="0" bIns="0" rtlCol="0" anchor="t"/>
+          <a:lstStyle/>
+          <a:p>
+            <a:pPr algn="r" indent="0" marL="0">
+              <a:buNone/>
+            </a:pPr>
+            <a:r>
+              <a:rPr lang="en-US" sz="1200" dirty="0">
+                <a:solidFill>
+                  <a:srgbClr val="00F604"/>
+                </a:solidFill>
+                <a:latin typeface="Avenir Next" pitchFamily="34" charset="0"/>
+                <a:ea typeface="Avenir Next" pitchFamily="34" charset="-122"/>
+                <a:cs typeface="Avenir Next" pitchFamily="34" charset="-120"/>
+              </a:rPr>
+              <a:t>Success receipt after Post/Redirect/Get.</a:t>
+            </a:r>
+            <a:endParaRPr lang="en-US" sz="1200" dirty="0"/>
+          </a:p>
+        </p:txBody>
+      </p:sp>
+    </p:spTree>
+  </p:cSld>
+  <p:clrMapOvr>
+    <a:masterClrMapping/>
+  </p:clrMapOvr>
+</p:sld>
+</file>
+
+<file path=ppt/slides/slide8.xml><?xml version="1.0" encoding="utf-8"?>
+<p:sld xmlns:a="http://schemas.openxmlformats.org/drawingml/2006/main" xmlns:r="http://schemas.openxmlformats.org/officeDocument/2006/relationships" xmlns:p="http://schemas.openxmlformats.org/presentationml/2006/main">
+  <p:cSld name="Slide 8">
     <p:bg>
       <p:bgPr>
         <a:solidFill>

</xml_diff>

<commit_message>
Name GPT models Sol and reframe the Fable tradeoff on slide 2
The slide now names GPT-5.6 Sol and GPT-6 Sol, and the Build row's
tradeoff reads "Rework cost more than tokens". Speaker notes acknowledge
the usual plan-strong, execute-cheap split and how the same phase gates
would support it with more time. Tool names move to the notes to keep the
36-word budget. Checked in PowerPoint.

Co-Authored-By: Claude Opus 5.5 <noreply@anthropic.com>
</commit_message>
<xml_diff>
--- a/design/atm-deck.pptx
+++ b/design/atm-deck.pptx
@@ -597,7 +597,7 @@
           <a:p>
             <a:r>
               <a:rPr lang="en-US" dirty="0"/>
-              <a:t>I split the work by strength: a ChatGPT agent (GPT-5.6 in Codex) for the architecture interview and scaffold, Claude Code for the implementation, and both for later docs and deck work.</a:t>
+              <a:t>I split the work by strength: a ChatGPT agent (GPT-5.6 Sol in Codex) for the architecture interview and scaffold, Claude Code for the implementation, and both for later docs and deck work.</a:t>
             </a:r>
             <a:endParaRPr lang="en-US" dirty="0"/>
           </a:p>
@@ -637,7 +637,7 @@
           <a:p>
             <a:r>
               <a:rPr lang="en-US" dirty="0"/>
-              <a:t>Why Fable 5.1. It was probably more model than the job needed. I was short on time and wanted the strongest end-to-end implementation model available; Opus 5.5 had not shipped yet. I paid more in tokens to save wall-clock time. The phase gates don't depend on the model, so running a cheaper one against the same tests is the obvious experiment. Quick questions went to a lighter model (Sonnet 5).</a:t>
+              <a:t>Why Fable 5.1. It was probably more model than the job needed. I was short on time and wanted the strongest end-to-end implementation model available; Opus 5.5 had not shipped yet. In a time box, a failed or mediocre phase costs wall-clock time to find and redo, and this build had subtle traps: decimal money, atomic transfers, concurrency tokens, and migrations. Rework would have cost more than tokens. Quick questions went to a lighter model (Sonnet 5).</a:t>
             </a:r>
             <a:endParaRPr lang="en-US" dirty="0"/>
           </a:p>
@@ -647,7 +647,17 @@
           <a:p>
             <a:r>
               <a:rPr lang="en-US" dirty="0"/>
-              <a:t>Refine. Later work used Opus 5.5 and GPT-6 in Codex: Windows setup steps in the README, a Dependabot fix in the deck tooling, the deck's visual redesign, and the wording on these slides. I directed each change and sent back output that didn't hold up; the first deck skipped the design consultation and was redone.</a:t>
+              <a:t>The usual split is the reverse: the strongest model plans and cheaper models execute. Here the plan also came from a frontier model (GPT-5.6 Sol). With more time, I'd have Fable 5.1 plan each phase and a cheaper model such as Sonnet 5 implement it. The phase gates don't depend on the model, so the same tests would catch its regressions.</a:t>
+            </a:r>
+            <a:endParaRPr lang="en-US" dirty="0"/>
+          </a:p>
+          <a:p>
+            <a:endParaRPr lang="en-US" dirty="0"/>
+          </a:p>
+          <a:p>
+            <a:r>
+              <a:rPr lang="en-US" dirty="0"/>
+              <a:t>Refine. Later work used Opus 5.5 and GPT-6 Sol in Codex: Windows setup steps in the README, a Dependabot fix in the deck tooling, the deck's visual redesign, and the wording on these slides. I directed each change and sent back output that didn't hold up; the first deck skipped the design consultation and was redone.</a:t>
             </a:r>
             <a:endParaRPr lang="en-US" dirty="0"/>
           </a:p>
@@ -2209,7 +2219,7 @@
                 <a:ea typeface="Avenir Next" pitchFamily="34" charset="-122"/>
                 <a:cs typeface="Avenir Next" pitchFamily="34" charset="-120"/>
               </a:rPr>
-              <a:t>GPT-5.6 in Codex</a:t>
+              <a:t>GPT-5.6 Sol</a:t>
             </a:r>
             <a:endParaRPr lang="en-US" sz="2000" dirty="0"/>
           </a:p>
@@ -2355,7 +2365,7 @@
                 <a:ea typeface="Avenir Next" pitchFamily="34" charset="-122"/>
                 <a:cs typeface="Avenir Next" pitchFamily="34" charset="-120"/>
               </a:rPr>
-              <a:t>Fable 5.1 in Claude Code</a:t>
+              <a:t>Fable 5.1</a:t>
             </a:r>
             <a:endParaRPr lang="en-US" sz="2000" dirty="0"/>
           </a:p>
@@ -2437,7 +2447,7 @@
                 <a:ea typeface="Avenir Next" pitchFamily="34" charset="-122"/>
                 <a:cs typeface="Avenir Next" pitchFamily="34" charset="-120"/>
               </a:rPr>
-              <a:t>Chose speed over token cost</a:t>
+              <a:t>Rework cost more than tokens</a:t>
             </a:r>
             <a:endParaRPr lang="en-US" sz="1250" dirty="0"/>
           </a:p>
@@ -2542,7 +2552,7 @@
                 <a:ea typeface="Avenir Next" pitchFamily="34" charset="-122"/>
                 <a:cs typeface="Avenir Next" pitchFamily="34" charset="-120"/>
               </a:rPr>
-              <a:t>Opus 5.5, GPT-6</a:t>
+              <a:t>Opus 5.5, GPT-6 Sol</a:t>
             </a:r>
             <a:endParaRPr lang="en-US" sz="2000" dirty="0"/>
           </a:p>

</xml_diff>

<commit_message>
Drop the partial-state slide and plain-word the tests slide
The deck is now seven slides. On "143 tests by layer", "Invariants"
becomes "Business rules", the receipt caption says what Post/Redirect/Get
buys ("Deposit confirmed. Refreshing won't repeat it."), the speaker
notes are four bullets that explain what "pure" domain tests are, and
the build commands are gone.

Edited the pptx directly to keep the author's manual changes, and
mirrored the edits in build.js and the design README. Exported to PDF
with PowerPoint and inspected all seven slides; no repair prompt.

Co-Authored-By: Claude Opus 5.5 <noreply@anthropic.com>
</commit_message>
<xml_diff>
--- a/design/atm-deck.pptx
+++ b/design/atm-deck.pptx
@@ -13,7 +13,6 @@
     <p:sldId id="258" r:id="rId8"/>
     <p:sldId id="259" r:id="rId9"/>
     <p:sldId id="260" r:id="rId10"/>
-    <p:sldId id="261" r:id="rId11"/>
     <p:sldId id="262" r:id="rId12"/>
     <p:sldId id="263" r:id="rId13"/>
   </p:sldIdLst>
@@ -3041,12 +3040,12 @@
 </p:notes>
 </file>
 
-<file path=ppt/notesSlides/notesSlide6.xml><?xml version="1.0" encoding="utf-8"?>
+<file path=ppt/notesSlides/notesSlide7.xml><?xml version="1.0" encoding="utf-8"?>
 <p:notes xmlns:a="http://schemas.openxmlformats.org/drawingml/2006/main" xmlns:r="http://schemas.openxmlformats.org/officeDocument/2006/relationships" xmlns:mc="http://schemas.openxmlformats.org/markup-compatibility/2006" xmlns:mv="urn:schemas-microsoft-com:mac:vml" xmlns:p="http://schemas.openxmlformats.org/presentationml/2006/main" xmlns:c="http://schemas.openxmlformats.org/drawingml/2006/chart" xmlns:dgm="http://schemas.openxmlformats.org/drawingml/2006/diagram" xmlns:o="urn:schemas-microsoft-com:office:office" xmlns:v="urn:schemas-microsoft-com:vml" xmlns:pvml="urn:schemas-microsoft-com:office:powerpoint" xmlns:com="http://schemas.openxmlformats.org/drawingml/2006/compatibility" xmlns:p14="http://schemas.microsoft.com/office/powerpoint/2010/main" xmlns:p15="http://schemas.microsoft.com/office/powerpoint/2012/main" xmlns:ahyp="http://schemas.microsoft.com/office/drawing/2018/hyperlinkcolor" showMasterPhAnim="0" showMasterSp="0">
   <p:cSld>
     <p:spTree>
       <p:nvGrpSpPr>
-        <p:cNvPr id="95" name="Shape 95"/>
+        <p:cNvPr id="111" name="Shape 111"/>
         <p:cNvGrpSpPr/>
         <p:nvPr/>
       </p:nvGrpSpPr>
@@ -3060,7 +3059,7 @@
       </p:grpSpPr>
       <p:sp>
         <p:nvSpPr>
-          <p:cNvPr id="96" name="Google Shape;96;p6:notes"/>
+          <p:cNvPr id="112" name="Google Shape;112;p7:notes"/>
           <p:cNvSpPr/>
           <p:nvPr>
             <p:ph idx="2" type="sldImg"/>
@@ -3105,7 +3104,7 @@
       </p:sp>
       <p:sp>
         <p:nvSpPr>
-          <p:cNvPr id="97" name="Google Shape;97;p6:notes"/>
+          <p:cNvPr id="113" name="Google Shape;113;p7:notes"/>
           <p:cNvSpPr txBox="1"/>
           <p:nvPr>
             <p:ph idx="1" type="body"/>
@@ -3130,178 +3129,64 @@
           </a:bodyPr>
           <a:lstStyle/>
           <a:p>
-            <a:pPr indent="0" lvl="0" marL="0" rtl="0" algn="l">
-              <a:spcBef>
-                <a:spcPts val="0"/>
-              </a:spcBef>
-              <a:spcAft>
-                <a:spcPts val="0"/>
-              </a:spcAft>
-              <a:buNone/>
+            <a:pPr indent="-228600" lvl="0" marL="228600" rtl="0" algn="l">
+              <a:spcBef>
+                <a:spcPts val="0"/>
+              </a:spcBef>
+              <a:spcAft>
+                <a:spcPts val="600"/>
+              </a:spcAft>
+              <a:buChar char="•"/>
             </a:pPr>
             <a:r>
               <a:rPr lang="en-US"/>
-              <a:t>The screenshot is a real rejected overdraft. The typed value stays visible, the error names the available balance, and persisted state is unchanged. Account versions turn stale writes into a safe retry instead of lost data.</a:t>
-            </a:r>
-            <a:endParaRPr/>
-          </a:p>
-        </p:txBody>
-      </p:sp>
-      <p:sp>
-        <p:nvSpPr>
-          <p:cNvPr id="98" name="Google Shape;98;p6:notes"/>
-          <p:cNvSpPr txBox="1"/>
-          <p:nvPr>
-            <p:ph idx="12" type="sldNum"/>
-          </p:nvPr>
-        </p:nvSpPr>
-        <p:spPr>
-          <a:xfrm>
-            <a:off x="3886200" y="9371013"/>
-            <a:ext cx="3429000" cy="458787"/>
-          </a:xfrm>
-          <a:prstGeom prst="rect">
-            <a:avLst/>
-          </a:prstGeom>
-          <a:noFill/>
-          <a:ln>
-            <a:noFill/>
-          </a:ln>
-        </p:spPr>
-        <p:txBody>
-          <a:bodyPr anchorCtr="0" anchor="b" bIns="45700" lIns="91425" spcFirstLastPara="1" rIns="91425" wrap="square" tIns="45700">
-            <a:noAutofit/>
-          </a:bodyPr>
-          <a:lstStyle/>
-          <a:p>
-            <a:pPr indent="0" lvl="0" marL="0" rtl="0" algn="r">
-              <a:spcBef>
-                <a:spcPts val="0"/>
-              </a:spcBef>
-              <a:spcAft>
-                <a:spcPts val="0"/>
-              </a:spcAft>
-              <a:buNone/>
-            </a:pPr>
-            <a:fld id="{00000000-1234-1234-1234-123412341234}" type="slidenum">
+              <a:t>Domain (75): pure tests. No database, no I/O, no fakes. They call the business rules directly (money, accounts, transfers), so they are fast and deterministic.</a:t>
+            </a:r>
+          </a:p>
+          <a:p>
+            <a:pPr indent="-228600" lvl="0" marL="228600" rtl="0" algn="l">
+              <a:spcBef>
+                <a:spcPts val="0"/>
+              </a:spcBef>
+              <a:spcAft>
+                <a:spcPts val="600"/>
+              </a:spcAft>
+              <a:buChar char="•"/>
+            </a:pPr>
+            <a:r>
               <a:rPr lang="en-US"/>
-              <a:t>‹#›</a:t>
-            </a:fld>
-            <a:endParaRPr/>
-          </a:p>
-        </p:txBody>
-      </p:sp>
-    </p:spTree>
-  </p:cSld>
-  <p:clrMapOvr>
-    <a:masterClrMapping/>
-  </p:clrMapOvr>
-</p:notes>
-</file>
-
-<file path=ppt/notesSlides/notesSlide7.xml><?xml version="1.0" encoding="utf-8"?>
-<p:notes xmlns:a="http://schemas.openxmlformats.org/drawingml/2006/main" xmlns:r="http://schemas.openxmlformats.org/officeDocument/2006/relationships" xmlns:mc="http://schemas.openxmlformats.org/markup-compatibility/2006" xmlns:mv="urn:schemas-microsoft-com:mac:vml" xmlns:p="http://schemas.openxmlformats.org/presentationml/2006/main" xmlns:c="http://schemas.openxmlformats.org/drawingml/2006/chart" xmlns:dgm="http://schemas.openxmlformats.org/drawingml/2006/diagram" xmlns:o="urn:schemas-microsoft-com:office:office" xmlns:v="urn:schemas-microsoft-com:vml" xmlns:pvml="urn:schemas-microsoft-com:office:powerpoint" xmlns:com="http://schemas.openxmlformats.org/drawingml/2006/compatibility" xmlns:p14="http://schemas.microsoft.com/office/powerpoint/2010/main" xmlns:p15="http://schemas.microsoft.com/office/powerpoint/2012/main" xmlns:ahyp="http://schemas.microsoft.com/office/drawing/2018/hyperlinkcolor" showMasterPhAnim="0" showMasterSp="0">
-  <p:cSld>
-    <p:spTree>
-      <p:nvGrpSpPr>
-        <p:cNvPr id="111" name="Shape 111"/>
-        <p:cNvGrpSpPr/>
-        <p:nvPr/>
-      </p:nvGrpSpPr>
-      <p:grpSpPr>
-        <a:xfrm>
-          <a:off x="0" y="0"/>
-          <a:ext cx="0" cy="0"/>
-          <a:chOff x="0" y="0"/>
-          <a:chExt cx="0" cy="0"/>
-        </a:xfrm>
-      </p:grpSpPr>
-      <p:sp>
-        <p:nvSpPr>
-          <p:cNvPr id="112" name="Google Shape;112;p7:notes"/>
-          <p:cNvSpPr/>
-          <p:nvPr>
-            <p:ph idx="2" type="sldImg"/>
-          </p:nvPr>
-        </p:nvSpPr>
-        <p:spPr>
-          <a:xfrm>
-            <a:off x="457200" y="685800"/>
-            <a:ext cx="6858000" cy="3857625"/>
-          </a:xfrm>
-          <a:custGeom>
-            <a:rect b="b" l="l" r="r" t="t"/>
-            <a:pathLst>
-              <a:path extrusionOk="0" h="120000" w="120000">
-                <a:moveTo>
-                  <a:pt x="0" y="0"/>
-                </a:moveTo>
-                <a:lnTo>
-                  <a:pt x="120000" y="0"/>
-                </a:lnTo>
-                <a:lnTo>
-                  <a:pt x="120000" y="120000"/>
-                </a:lnTo>
-                <a:lnTo>
-                  <a:pt x="0" y="120000"/>
-                </a:lnTo>
-                <a:close/>
-              </a:path>
-            </a:pathLst>
-          </a:custGeom>
-          <a:noFill/>
-          <a:ln cap="flat" cmpd="sng" w="12700">
-            <a:solidFill>
-              <a:srgbClr val="000000"/>
-            </a:solidFill>
-            <a:prstDash val="solid"/>
-            <a:round/>
-            <a:headEnd len="sm" w="sm" type="none"/>
-            <a:tailEnd len="sm" w="sm" type="none"/>
-          </a:ln>
-        </p:spPr>
-      </p:sp>
-      <p:sp>
-        <p:nvSpPr>
-          <p:cNvPr id="113" name="Google Shape;113;p7:notes"/>
-          <p:cNvSpPr txBox="1"/>
-          <p:nvPr>
-            <p:ph idx="1" type="body"/>
-          </p:nvPr>
-        </p:nvSpPr>
-        <p:spPr>
-          <a:xfrm>
-            <a:off x="457200" y="4800600"/>
-            <a:ext cx="6858000" cy="4480560"/>
-          </a:xfrm>
-          <a:prstGeom prst="rect">
-            <a:avLst/>
-          </a:prstGeom>
-          <a:noFill/>
-          <a:ln>
-            <a:noFill/>
-          </a:ln>
-        </p:spPr>
-        <p:txBody>
-          <a:bodyPr anchorCtr="0" anchor="t" bIns="45700" lIns="91425" spcFirstLastPara="1" rIns="91425" wrap="square" tIns="45700">
-            <a:noAutofit/>
-          </a:bodyPr>
-          <a:lstStyle/>
-          <a:p>
-            <a:pPr indent="0" lvl="0" marL="0" rtl="0" algn="l">
-              <a:spcBef>
-                <a:spcPts val="0"/>
-              </a:spcBef>
-              <a:spcAft>
-                <a:spcPts val="0"/>
-              </a:spcAft>
-              <a:buNone/>
+              <a:t>Application (33): use cases run against hand-written fakes for the store and the clock.</a:t>
+            </a:r>
+          </a:p>
+          <a:p>
+            <a:pPr indent="-228600" lvl="0" marL="228600" rtl="0" algn="l">
+              <a:spcBef>
+                <a:spcPts val="0"/>
+              </a:spcBef>
+              <a:spcAft>
+                <a:spcPts val="600"/>
+              </a:spcAft>
+              <a:buChar char="•"/>
             </a:pPr>
             <a:r>
               <a:rPr lang="en-US"/>
-              <a:t>Domain tests are pure. Application tests use hand-written fakes. Integration and HTTP tests exercise the real host with an isolated SQLite file per test, including concurrency conflicts, atomic rollback, Post/Redirect/Get, security, and accessibility structure. Commands: dotnet restore Atm.sln; dotnet build Atm.sln --no-restore; dotnet test Atm.sln --no-build.</a:t>
-            </a:r>
-            <a:endParaRPr/>
+              <a:t>Integration + HTTP (35): the real host, with an isolated SQLite file per test.</a:t>
+            </a:r>
+          </a:p>
+          <a:p>
+            <a:pPr indent="-228600" lvl="0" marL="228600" rtl="0" algn="l">
+              <a:spcBef>
+                <a:spcPts val="0"/>
+              </a:spcBef>
+              <a:spcAft>
+                <a:spcPts val="600"/>
+              </a:spcAft>
+              <a:buChar char="•"/>
+            </a:pPr>
+            <a:r>
+              <a:rPr lang="en-US"/>
+              <a:t>Those cover concurrency conflicts, atomic rollback, Post/Redirect/Get, security, and accessibility structure.</a:t>
+            </a:r>
           </a:p>
         </p:txBody>
       </p:sp>
@@ -8559,669 +8444,6 @@
 </p:sld>
 </file>
 
-<file path=ppt/slides/slide6.xml><?xml version="1.0" encoding="utf-8"?>
-<p:sld xmlns:a="http://schemas.openxmlformats.org/drawingml/2006/main" xmlns:r="http://schemas.openxmlformats.org/officeDocument/2006/relationships" xmlns:mc="http://schemas.openxmlformats.org/markup-compatibility/2006" xmlns:mv="urn:schemas-microsoft-com:mac:vml" xmlns:p="http://schemas.openxmlformats.org/presentationml/2006/main" xmlns:c="http://schemas.openxmlformats.org/drawingml/2006/chart" xmlns:dgm="http://schemas.openxmlformats.org/drawingml/2006/diagram" xmlns:o="urn:schemas-microsoft-com:office:office" xmlns:v="urn:schemas-microsoft-com:vml" xmlns:pvml="urn:schemas-microsoft-com:office:powerpoint" xmlns:com="http://schemas.openxmlformats.org/drawingml/2006/compatibility" xmlns:p14="http://schemas.microsoft.com/office/powerpoint/2010/main" xmlns:p15="http://schemas.microsoft.com/office/powerpoint/2012/main" xmlns:ahyp="http://schemas.microsoft.com/office/drawing/2018/hyperlinkcolor">
-  <p:cSld>
-    <p:bg>
-      <p:bgPr>
-        <a:solidFill>
-          <a:srgbClr val="121212"/>
-        </a:solidFill>
-      </p:bgPr>
-    </p:bg>
-    <p:spTree>
-      <p:nvGrpSpPr>
-        <p:cNvPr id="99" name="Shape 99"/>
-        <p:cNvGrpSpPr/>
-        <p:nvPr/>
-      </p:nvGrpSpPr>
-      <p:grpSpPr>
-        <a:xfrm>
-          <a:off x="0" y="0"/>
-          <a:ext cx="0" cy="0"/>
-          <a:chOff x="0" y="0"/>
-          <a:chExt cx="0" cy="0"/>
-        </a:xfrm>
-      </p:grpSpPr>
-      <p:sp>
-        <p:nvSpPr>
-          <p:cNvPr id="100" name="Google Shape;100;p6"/>
-          <p:cNvSpPr/>
-          <p:nvPr/>
-        </p:nvSpPr>
-        <p:spPr>
-          <a:xfrm>
-            <a:off x="585216" y="356616"/>
-            <a:ext cx="91440" cy="438912"/>
-          </a:xfrm>
-          <a:prstGeom prst="rect">
-            <a:avLst/>
-          </a:prstGeom>
-          <a:solidFill>
-            <a:srgbClr val="00F604"/>
-          </a:solidFill>
-          <a:ln cap="flat" cmpd="sng" w="12700">
-            <a:solidFill>
-              <a:srgbClr val="00F604">
-                <a:alpha val="0"/>
-              </a:srgbClr>
-            </a:solidFill>
-            <a:prstDash val="solid"/>
-            <a:round/>
-            <a:headEnd len="sm" w="sm" type="none"/>
-            <a:tailEnd len="sm" w="sm" type="none"/>
-          </a:ln>
-        </p:spPr>
-        <p:txBody>
-          <a:bodyPr anchorCtr="0" anchor="ctr" bIns="91425" lIns="91425" spcFirstLastPara="1" rIns="91425" wrap="square" tIns="91425">
-            <a:noAutofit/>
-          </a:bodyPr>
-          <a:lstStyle/>
-          <a:p>
-            <a:pPr indent="0" lvl="0" marL="0" rtl="0" algn="l">
-              <a:spcBef>
-                <a:spcPts val="0"/>
-              </a:spcBef>
-              <a:spcAft>
-                <a:spcPts val="0"/>
-              </a:spcAft>
-              <a:buNone/>
-            </a:pPr>
-            <a:r>
-              <a:t/>
-            </a:r>
-            <a:endParaRPr/>
-          </a:p>
-        </p:txBody>
-      </p:sp>
-      <p:sp>
-        <p:nvSpPr>
-          <p:cNvPr id="101" name="Google Shape;101;p6"/>
-          <p:cNvSpPr txBox="1"/>
-          <p:nvPr/>
-        </p:nvSpPr>
-        <p:spPr>
-          <a:xfrm>
-            <a:off x="832104" y="356616"/>
-            <a:ext cx="7726680" cy="512064"/>
-          </a:xfrm>
-          <a:prstGeom prst="rect">
-            <a:avLst/>
-          </a:prstGeom>
-          <a:noFill/>
-          <a:ln>
-            <a:noFill/>
-          </a:ln>
-        </p:spPr>
-        <p:txBody>
-          <a:bodyPr anchorCtr="0" anchor="t" bIns="0" lIns="0" spcFirstLastPara="1" rIns="0" wrap="square" tIns="0">
-            <a:normAutofit/>
-          </a:bodyPr>
-          <a:lstStyle/>
-          <a:p>
-            <a:pPr indent="0" lvl="0" marL="0" marR="0" rtl="0" algn="l">
-              <a:spcBef>
-                <a:spcPts val="0"/>
-              </a:spcBef>
-              <a:spcAft>
-                <a:spcPts val="0"/>
-              </a:spcAft>
-              <a:buClr>
-                <a:srgbClr val="F5F5F5"/>
-              </a:buClr>
-              <a:buSzPts val="3200"/>
-              <a:buFont typeface="Avenir"/>
-              <a:buNone/>
-            </a:pPr>
-            <a:r>
-              <a:rPr b="1" i="0" lang="en-US" sz="3200" u="none" cap="none" strike="noStrike">
-                <a:solidFill>
-                  <a:srgbClr val="F5F5F5"/>
-                </a:solidFill>
-                <a:latin typeface="Avenir"/>
-                <a:ea typeface="Avenir"/>
-                <a:cs typeface="Avenir"/>
-                <a:sym typeface="Avenir"/>
-              </a:rPr>
-              <a:t>Failure leaves no partial state</a:t>
-            </a:r>
-            <a:endParaRPr b="0" i="0" sz="3200" u="none" cap="none" strike="noStrike">
-              <a:solidFill>
-                <a:schemeClr val="dk1"/>
-              </a:solidFill>
-              <a:latin typeface="Avenir"/>
-              <a:ea typeface="Avenir"/>
-              <a:cs typeface="Avenir"/>
-              <a:sym typeface="Avenir"/>
-            </a:endParaRPr>
-          </a:p>
-        </p:txBody>
-      </p:sp>
-      <p:sp>
-        <p:nvSpPr>
-          <p:cNvPr id="102" name="Google Shape;102;p6"/>
-          <p:cNvSpPr txBox="1"/>
-          <p:nvPr/>
-        </p:nvSpPr>
-        <p:spPr>
-          <a:xfrm>
-            <a:off x="585216" y="1307592"/>
-            <a:ext cx="411480" cy="274320"/>
-          </a:xfrm>
-          <a:prstGeom prst="rect">
-            <a:avLst/>
-          </a:prstGeom>
-          <a:noFill/>
-          <a:ln>
-            <a:noFill/>
-          </a:ln>
-        </p:spPr>
-        <p:txBody>
-          <a:bodyPr anchorCtr="0" anchor="t" bIns="0" lIns="0" spcFirstLastPara="1" rIns="0" wrap="square" tIns="0">
-            <a:noAutofit/>
-          </a:bodyPr>
-          <a:lstStyle/>
-          <a:p>
-            <a:pPr indent="0" lvl="0" marL="0" marR="0" rtl="0" algn="l">
-              <a:spcBef>
-                <a:spcPts val="0"/>
-              </a:spcBef>
-              <a:spcAft>
-                <a:spcPts val="0"/>
-              </a:spcAft>
-              <a:buClr>
-                <a:srgbClr val="00F604"/>
-              </a:buClr>
-              <a:buSzPts val="1300"/>
-              <a:buFont typeface="Avenir"/>
-              <a:buNone/>
-            </a:pPr>
-            <a:r>
-              <a:rPr b="1" i="0" lang="en-US" sz="1300" u="none" cap="none" strike="noStrike">
-                <a:solidFill>
-                  <a:srgbClr val="00F604"/>
-                </a:solidFill>
-                <a:latin typeface="Avenir"/>
-                <a:ea typeface="Avenir"/>
-                <a:cs typeface="Avenir"/>
-                <a:sym typeface="Avenir"/>
-              </a:rPr>
-              <a:t>01</a:t>
-            </a:r>
-            <a:endParaRPr b="0" i="0" sz="1300" u="none" cap="none" strike="noStrike">
-              <a:solidFill>
-                <a:schemeClr val="dk1"/>
-              </a:solidFill>
-              <a:latin typeface="Avenir"/>
-              <a:ea typeface="Avenir"/>
-              <a:cs typeface="Avenir"/>
-              <a:sym typeface="Avenir"/>
-            </a:endParaRPr>
-          </a:p>
-        </p:txBody>
-      </p:sp>
-      <p:sp>
-        <p:nvSpPr>
-          <p:cNvPr id="103" name="Google Shape;103;p6"/>
-          <p:cNvSpPr txBox="1"/>
-          <p:nvPr/>
-        </p:nvSpPr>
-        <p:spPr>
-          <a:xfrm>
-            <a:off x="1115568" y="1261872"/>
-            <a:ext cx="2743200" cy="512064"/>
-          </a:xfrm>
-          <a:prstGeom prst="rect">
-            <a:avLst/>
-          </a:prstGeom>
-          <a:noFill/>
-          <a:ln>
-            <a:noFill/>
-          </a:ln>
-        </p:spPr>
-        <p:txBody>
-          <a:bodyPr anchorCtr="0" anchor="t" bIns="0" lIns="0" spcFirstLastPara="1" rIns="0" wrap="square" tIns="0">
-            <a:normAutofit/>
-          </a:bodyPr>
-          <a:lstStyle/>
-          <a:p>
-            <a:pPr indent="0" lvl="0" marL="0" marR="0" rtl="0" algn="l">
-              <a:spcBef>
-                <a:spcPts val="0"/>
-              </a:spcBef>
-              <a:spcAft>
-                <a:spcPts val="0"/>
-              </a:spcAft>
-              <a:buClr>
-                <a:srgbClr val="F5F5F5"/>
-              </a:buClr>
-              <a:buSzPts val="2000"/>
-              <a:buFont typeface="Avenir"/>
-              <a:buNone/>
-            </a:pPr>
-            <a:r>
-              <a:rPr b="1" i="0" lang="en-US" sz="2000" u="none" cap="none" strike="noStrike">
-                <a:solidFill>
-                  <a:srgbClr val="F5F5F5"/>
-                </a:solidFill>
-                <a:latin typeface="Avenir"/>
-                <a:ea typeface="Avenir"/>
-                <a:cs typeface="Avenir"/>
-                <a:sym typeface="Avenir"/>
-              </a:rPr>
-              <a:t>Validate before mutation</a:t>
-            </a:r>
-            <a:endParaRPr b="0" i="0" sz="2000" u="none" cap="none" strike="noStrike">
-              <a:solidFill>
-                <a:schemeClr val="dk1"/>
-              </a:solidFill>
-              <a:latin typeface="Avenir"/>
-              <a:ea typeface="Avenir"/>
-              <a:cs typeface="Avenir"/>
-              <a:sym typeface="Avenir"/>
-            </a:endParaRPr>
-          </a:p>
-        </p:txBody>
-      </p:sp>
-      <p:sp>
-        <p:nvSpPr>
-          <p:cNvPr id="104" name="Google Shape;104;p6"/>
-          <p:cNvSpPr txBox="1"/>
-          <p:nvPr/>
-        </p:nvSpPr>
-        <p:spPr>
-          <a:xfrm>
-            <a:off x="585216" y="2313432"/>
-            <a:ext cx="411480" cy="274320"/>
-          </a:xfrm>
-          <a:prstGeom prst="rect">
-            <a:avLst/>
-          </a:prstGeom>
-          <a:noFill/>
-          <a:ln>
-            <a:noFill/>
-          </a:ln>
-        </p:spPr>
-        <p:txBody>
-          <a:bodyPr anchorCtr="0" anchor="t" bIns="0" lIns="0" spcFirstLastPara="1" rIns="0" wrap="square" tIns="0">
-            <a:noAutofit/>
-          </a:bodyPr>
-          <a:lstStyle/>
-          <a:p>
-            <a:pPr indent="0" lvl="0" marL="0" marR="0" rtl="0" algn="l">
-              <a:spcBef>
-                <a:spcPts val="0"/>
-              </a:spcBef>
-              <a:spcAft>
-                <a:spcPts val="0"/>
-              </a:spcAft>
-              <a:buClr>
-                <a:srgbClr val="00F604"/>
-              </a:buClr>
-              <a:buSzPts val="1300"/>
-              <a:buFont typeface="Avenir"/>
-              <a:buNone/>
-            </a:pPr>
-            <a:r>
-              <a:rPr b="1" i="0" lang="en-US" sz="1300" u="none" cap="none" strike="noStrike">
-                <a:solidFill>
-                  <a:srgbClr val="00F604"/>
-                </a:solidFill>
-                <a:latin typeface="Avenir"/>
-                <a:ea typeface="Avenir"/>
-                <a:cs typeface="Avenir"/>
-                <a:sym typeface="Avenir"/>
-              </a:rPr>
-              <a:t>02</a:t>
-            </a:r>
-            <a:endParaRPr b="0" i="0" sz="1300" u="none" cap="none" strike="noStrike">
-              <a:solidFill>
-                <a:schemeClr val="dk1"/>
-              </a:solidFill>
-              <a:latin typeface="Avenir"/>
-              <a:ea typeface="Avenir"/>
-              <a:cs typeface="Avenir"/>
-              <a:sym typeface="Avenir"/>
-            </a:endParaRPr>
-          </a:p>
-        </p:txBody>
-      </p:sp>
-      <p:sp>
-        <p:nvSpPr>
-          <p:cNvPr id="105" name="Google Shape;105;p6"/>
-          <p:cNvSpPr txBox="1"/>
-          <p:nvPr/>
-        </p:nvSpPr>
-        <p:spPr>
-          <a:xfrm>
-            <a:off x="1115568" y="2267712"/>
-            <a:ext cx="2743200" cy="512064"/>
-          </a:xfrm>
-          <a:prstGeom prst="rect">
-            <a:avLst/>
-          </a:prstGeom>
-          <a:noFill/>
-          <a:ln>
-            <a:noFill/>
-          </a:ln>
-        </p:spPr>
-        <p:txBody>
-          <a:bodyPr anchorCtr="0" anchor="t" bIns="0" lIns="0" spcFirstLastPara="1" rIns="0" wrap="square" tIns="0">
-            <a:normAutofit/>
-          </a:bodyPr>
-          <a:lstStyle/>
-          <a:p>
-            <a:pPr indent="0" lvl="0" marL="0" marR="0" rtl="0" algn="l">
-              <a:spcBef>
-                <a:spcPts val="0"/>
-              </a:spcBef>
-              <a:spcAft>
-                <a:spcPts val="0"/>
-              </a:spcAft>
-              <a:buClr>
-                <a:srgbClr val="F5F5F5"/>
-              </a:buClr>
-              <a:buSzPts val="2000"/>
-              <a:buFont typeface="Avenir"/>
-              <a:buNone/>
-            </a:pPr>
-            <a:r>
-              <a:rPr b="1" i="0" lang="en-US" sz="2000" u="none" cap="none" strike="noStrike">
-                <a:solidFill>
-                  <a:srgbClr val="F5F5F5"/>
-                </a:solidFill>
-                <a:latin typeface="Avenir"/>
-                <a:ea typeface="Avenir"/>
-                <a:cs typeface="Avenir"/>
-                <a:sym typeface="Avenir"/>
-              </a:rPr>
-              <a:t>Commit balance and history together</a:t>
-            </a:r>
-            <a:endParaRPr b="0" i="0" sz="2000" u="none" cap="none" strike="noStrike">
-              <a:solidFill>
-                <a:schemeClr val="dk1"/>
-              </a:solidFill>
-              <a:latin typeface="Avenir"/>
-              <a:ea typeface="Avenir"/>
-              <a:cs typeface="Avenir"/>
-              <a:sym typeface="Avenir"/>
-            </a:endParaRPr>
-          </a:p>
-        </p:txBody>
-      </p:sp>
-      <p:sp>
-        <p:nvSpPr>
-          <p:cNvPr id="106" name="Google Shape;106;p6"/>
-          <p:cNvSpPr txBox="1"/>
-          <p:nvPr/>
-        </p:nvSpPr>
-        <p:spPr>
-          <a:xfrm>
-            <a:off x="585216" y="3319272"/>
-            <a:ext cx="411480" cy="274320"/>
-          </a:xfrm>
-          <a:prstGeom prst="rect">
-            <a:avLst/>
-          </a:prstGeom>
-          <a:noFill/>
-          <a:ln>
-            <a:noFill/>
-          </a:ln>
-        </p:spPr>
-        <p:txBody>
-          <a:bodyPr anchorCtr="0" anchor="t" bIns="0" lIns="0" spcFirstLastPara="1" rIns="0" wrap="square" tIns="0">
-            <a:noAutofit/>
-          </a:bodyPr>
-          <a:lstStyle/>
-          <a:p>
-            <a:pPr indent="0" lvl="0" marL="0" marR="0" rtl="0" algn="l">
-              <a:spcBef>
-                <a:spcPts val="0"/>
-              </a:spcBef>
-              <a:spcAft>
-                <a:spcPts val="0"/>
-              </a:spcAft>
-              <a:buClr>
-                <a:srgbClr val="00F604"/>
-              </a:buClr>
-              <a:buSzPts val="1300"/>
-              <a:buFont typeface="Avenir"/>
-              <a:buNone/>
-            </a:pPr>
-            <a:r>
-              <a:rPr b="1" i="0" lang="en-US" sz="1300" u="none" cap="none" strike="noStrike">
-                <a:solidFill>
-                  <a:srgbClr val="00F604"/>
-                </a:solidFill>
-                <a:latin typeface="Avenir"/>
-                <a:ea typeface="Avenir"/>
-                <a:cs typeface="Avenir"/>
-                <a:sym typeface="Avenir"/>
-              </a:rPr>
-              <a:t>03</a:t>
-            </a:r>
-            <a:endParaRPr b="0" i="0" sz="1300" u="none" cap="none" strike="noStrike">
-              <a:solidFill>
-                <a:schemeClr val="dk1"/>
-              </a:solidFill>
-              <a:latin typeface="Avenir"/>
-              <a:ea typeface="Avenir"/>
-              <a:cs typeface="Avenir"/>
-              <a:sym typeface="Avenir"/>
-            </a:endParaRPr>
-          </a:p>
-        </p:txBody>
-      </p:sp>
-      <p:sp>
-        <p:nvSpPr>
-          <p:cNvPr id="107" name="Google Shape;107;p6"/>
-          <p:cNvSpPr txBox="1"/>
-          <p:nvPr/>
-        </p:nvSpPr>
-        <p:spPr>
-          <a:xfrm>
-            <a:off x="1115568" y="3273552"/>
-            <a:ext cx="2743200" cy="512064"/>
-          </a:xfrm>
-          <a:prstGeom prst="rect">
-            <a:avLst/>
-          </a:prstGeom>
-          <a:noFill/>
-          <a:ln>
-            <a:noFill/>
-          </a:ln>
-        </p:spPr>
-        <p:txBody>
-          <a:bodyPr anchorCtr="0" anchor="t" bIns="0" lIns="0" spcFirstLastPara="1" rIns="0" wrap="square" tIns="0">
-            <a:normAutofit/>
-          </a:bodyPr>
-          <a:lstStyle/>
-          <a:p>
-            <a:pPr indent="0" lvl="0" marL="0" marR="0" rtl="0" algn="l">
-              <a:spcBef>
-                <a:spcPts val="0"/>
-              </a:spcBef>
-              <a:spcAft>
-                <a:spcPts val="0"/>
-              </a:spcAft>
-              <a:buClr>
-                <a:srgbClr val="F5F5F5"/>
-              </a:buClr>
-              <a:buSzPts val="2000"/>
-              <a:buFont typeface="Avenir"/>
-              <a:buNone/>
-            </a:pPr>
-            <a:r>
-              <a:rPr b="1" i="0" lang="en-US" sz="2000" u="none" cap="none" strike="noStrike">
-                <a:solidFill>
-                  <a:srgbClr val="F5F5F5"/>
-                </a:solidFill>
-                <a:latin typeface="Avenir"/>
-                <a:ea typeface="Avenir"/>
-                <a:cs typeface="Avenir"/>
-                <a:sym typeface="Avenir"/>
-              </a:rPr>
-              <a:t>Reject stale writes</a:t>
-            </a:r>
-            <a:endParaRPr b="0" i="0" sz="2000" u="none" cap="none" strike="noStrike">
-              <a:solidFill>
-                <a:schemeClr val="dk1"/>
-              </a:solidFill>
-              <a:latin typeface="Avenir"/>
-              <a:ea typeface="Avenir"/>
-              <a:cs typeface="Avenir"/>
-              <a:sym typeface="Avenir"/>
-            </a:endParaRPr>
-          </a:p>
-        </p:txBody>
-      </p:sp>
-      <p:sp>
-        <p:nvSpPr>
-          <p:cNvPr id="108" name="Google Shape;108;p6"/>
-          <p:cNvSpPr/>
-          <p:nvPr/>
-        </p:nvSpPr>
-        <p:spPr>
-          <a:xfrm>
-            <a:off x="4233672" y="1133856"/>
-            <a:ext cx="4325112" cy="3282696"/>
-          </a:xfrm>
-          <a:prstGeom prst="rect">
-            <a:avLst/>
-          </a:prstGeom>
-          <a:solidFill>
-            <a:srgbClr val="1B1B1B"/>
-          </a:solidFill>
-          <a:ln cap="flat" cmpd="sng" w="10150">
-            <a:solidFill>
-              <a:srgbClr val="333333"/>
-            </a:solidFill>
-            <a:prstDash val="solid"/>
-            <a:round/>
-            <a:headEnd len="sm" w="sm" type="none"/>
-            <a:tailEnd len="sm" w="sm" type="none"/>
-          </a:ln>
-        </p:spPr>
-        <p:txBody>
-          <a:bodyPr anchorCtr="0" anchor="ctr" bIns="91425" lIns="91425" spcFirstLastPara="1" rIns="91425" wrap="square" tIns="91425">
-            <a:noAutofit/>
-          </a:bodyPr>
-          <a:lstStyle/>
-          <a:p>
-            <a:pPr indent="0" lvl="0" marL="0" rtl="0" algn="l">
-              <a:spcBef>
-                <a:spcPts val="0"/>
-              </a:spcBef>
-              <a:spcAft>
-                <a:spcPts val="0"/>
-              </a:spcAft>
-              <a:buNone/>
-            </a:pPr>
-            <a:r>
-              <a:t/>
-            </a:r>
-            <a:endParaRPr/>
-          </a:p>
-        </p:txBody>
-      </p:sp>
-      <p:pic>
-        <p:nvPicPr>
-          <p:cNvPr descr="/Users/john/theborg/repos/atm/design/screenshots/overdraft.png" id="109" name="Google Shape;109;p6"/>
-          <p:cNvPicPr preferRelativeResize="0"/>
-          <p:nvPr/>
-        </p:nvPicPr>
-        <p:blipFill rotWithShape="1">
-          <a:blip r:embed="rId3">
-            <a:alphaModFix/>
-          </a:blip>
-          <a:srcRect b="0" l="0" r="0" t="0"/>
-          <a:stretch/>
-        </p:blipFill>
-        <p:spPr>
-          <a:xfrm>
-            <a:off x="4270248" y="1170432"/>
-            <a:ext cx="4251960" cy="3209544"/>
-          </a:xfrm>
-          <a:prstGeom prst="rect">
-            <a:avLst/>
-          </a:prstGeom>
-          <a:noFill/>
-          <a:ln>
-            <a:noFill/>
-          </a:ln>
-        </p:spPr>
-      </p:pic>
-      <p:sp>
-        <p:nvSpPr>
-          <p:cNvPr id="110" name="Google Shape;110;p6"/>
-          <p:cNvSpPr txBox="1"/>
-          <p:nvPr/>
-        </p:nvSpPr>
-        <p:spPr>
-          <a:xfrm>
-            <a:off x="4233672" y="4489704"/>
-            <a:ext cx="4325112" cy="201168"/>
-          </a:xfrm>
-          <a:prstGeom prst="rect">
-            <a:avLst/>
-          </a:prstGeom>
-          <a:noFill/>
-          <a:ln>
-            <a:noFill/>
-          </a:ln>
-        </p:spPr>
-        <p:txBody>
-          <a:bodyPr anchorCtr="0" anchor="t" bIns="0" lIns="0" spcFirstLastPara="1" rIns="0" wrap="square" tIns="0">
-            <a:normAutofit/>
-          </a:bodyPr>
-          <a:lstStyle/>
-          <a:p>
-            <a:pPr indent="0" lvl="0" marL="0" marR="0" rtl="0" algn="r">
-              <a:spcBef>
-                <a:spcPts val="0"/>
-              </a:spcBef>
-              <a:spcAft>
-                <a:spcPts val="0"/>
-              </a:spcAft>
-              <a:buClr>
-                <a:srgbClr val="00F604"/>
-              </a:buClr>
-              <a:buSzPts val="1150"/>
-              <a:buFont typeface="Avenir"/>
-              <a:buNone/>
-            </a:pPr>
-            <a:r>
-              <a:rPr b="1" i="0" lang="en-US" sz="1150" u="none" cap="none" strike="noStrike">
-                <a:solidFill>
-                  <a:srgbClr val="00F604"/>
-                </a:solidFill>
-                <a:latin typeface="Avenir"/>
-                <a:ea typeface="Avenir"/>
-                <a:cs typeface="Avenir"/>
-                <a:sym typeface="Avenir"/>
-              </a:rPr>
-              <a:t>Rejected overdraft. Persisted state stays unchanged.</a:t>
-            </a:r>
-            <a:endParaRPr b="0" i="0" sz="1150" u="none" cap="none" strike="noStrike">
-              <a:solidFill>
-                <a:schemeClr val="dk1"/>
-              </a:solidFill>
-              <a:latin typeface="Avenir"/>
-              <a:ea typeface="Avenir"/>
-              <a:cs typeface="Avenir"/>
-              <a:sym typeface="Avenir"/>
-            </a:endParaRPr>
-          </a:p>
-        </p:txBody>
-      </p:sp>
-    </p:spTree>
-  </p:cSld>
-  <p:clrMapOvr>
-    <a:masterClrMapping/>
-  </p:clrMapOvr>
-</p:sld>
-</file>
-
 <file path=ppt/slides/slide7.xml><?xml version="1.0" encoding="utf-8"?>
 <p:sld xmlns:a="http://schemas.openxmlformats.org/drawingml/2006/main" xmlns:r="http://schemas.openxmlformats.org/officeDocument/2006/relationships" xmlns:mc="http://schemas.openxmlformats.org/markup-compatibility/2006" xmlns:mv="urn:schemas-microsoft-com:mac:vml" xmlns:p="http://schemas.openxmlformats.org/presentationml/2006/main" xmlns:c="http://schemas.openxmlformats.org/drawingml/2006/chart" xmlns:dgm="http://schemas.openxmlformats.org/drawingml/2006/diagram" xmlns:o="urn:schemas-microsoft-com:office:office" xmlns:v="urn:schemas-microsoft-com:vml" xmlns:pvml="urn:schemas-microsoft-com:office:powerpoint" xmlns:com="http://schemas.openxmlformats.org/drawingml/2006/compatibility" xmlns:p14="http://schemas.microsoft.com/office/powerpoint/2010/main" xmlns:p15="http://schemas.microsoft.com/office/powerpoint/2012/main" xmlns:ahyp="http://schemas.microsoft.com/office/drawing/2018/hyperlinkcolor">
   <p:cSld>
@@ -9535,7 +8757,7 @@
                 <a:cs typeface="Avenir"/>
                 <a:sym typeface="Avenir"/>
               </a:rPr>
-              <a:t>Invariants</a:t>
+              <a:t>Business rules</a:t>
             </a:r>
             <a:endParaRPr b="0" i="0" sz="1200" u="none" cap="none" strike="noStrike">
               <a:solidFill>
@@ -10052,7 +9274,7 @@
                 <a:cs typeface="Avenir"/>
                 <a:sym typeface="Avenir"/>
               </a:rPr>
-              <a:t>Success receipt after Post/Redirect/Get.</a:t>
+              <a:t>Deposit confirmed. Refreshing won’t repeat it.</a:t>
             </a:r>
             <a:endParaRPr b="0" i="0" sz="1200" u="none" cap="none" strike="noStrike">
               <a:solidFill>

</xml_diff>

<commit_message>
Retitle slide 7 "Roadmap" with Now / Next / Later stages
Most tradeoffs already appear on "Decisions and costs", so the slide is
now just the roadmap. Stages follow the standard Now / Next / Later
format, and "Double-submit protection" becomes "Idempotency keys":
Post/Redirect/Get already covers refreshes and double-clicks, and EF
Core's concurrency token cannot catch a retried request. Speaker notes
are rewritten as one bullet per omitted and roadmap item.

Co-Authored-By: Claude Opus 5.5 <noreply@anthropic.com>
</commit_message>
<xml_diff>
--- a/design/atm-deck.pptx
+++ b/design/atm-deck.pptx
@@ -1463,17 +1463,147 @@
           <a:p>
             <a:r>
               <a:rPr lang="en-US" dirty="0"/>
-              <a:t>The omissions are conscious. The roadmap begins with the correctness gap that Post/Redirect/Get does not solve: a retried network request. The phone capture proves the existing presentation adapter already reflows at 380 pixels.</a:t>
-            </a:r>
-            <a:endParaRPr lang="en-US" dirty="0"/>
-          </a:p>
-          <a:p>
-            <a:endParaRPr lang="en-US" dirty="0"/>
-          </a:p>
-          <a:p>
-            <a:r>
-              <a:rPr lang="en-US" dirty="0"/>
-              <a:t>In a real bank, the Domain and Application layers would become a backend service behind an API that every channel (ATM, mobile, web, branch) shares, so the rules live in one place. This ATM would be one thin client. Splitting that backend into microservices becomes worthwhile once separate teams own accounts, transfers, and fraud and need to deploy independently. The inward dependencies here are what make that extraction straightforward.</a:t>
+              <a:t>Omitted on purpose; </a:t>
+            </a:r>
+            <a:r>
+              <a:rPr lang="en-US" dirty="0">
+                <a:hlinkClick r:id="rId3"/>
+              </a:rPr>
+              <a:t>SPEC.md</a:t>
+            </a:r>
+            <a:r>
+              <a:rPr lang="en-US" dirty="0"/>
+              <a:t> lists all three as out of scope.</a:t>
+            </a:r>
+            <a:endParaRPr lang="en-US" dirty="0"/>
+          </a:p>
+          <a:p>
+            <a:endParaRPr lang="en-US" dirty="0"/>
+          </a:p>
+          <a:p>
+            <a:r>
+              <a:rPr lang="en-US" dirty="0"/>
+              <a:t>• Identity: no login, card, PIN, or session. There is one local user, so there is nothing to authenticate.</a:t>
+            </a:r>
+            <a:endParaRPr lang="en-US" dirty="0"/>
+          </a:p>
+          <a:p>
+            <a:endParaRPr lang="en-US" dirty="0"/>
+          </a:p>
+          <a:p>
+            <a:r>
+              <a:rPr lang="en-US" dirty="0"/>
+              <a:t>• Banking breadth: no fees, interest, overdraft lines, scheduled payments, other currencies, or external bank rails. Two seeded accounts and three operations keep the review on correctness.</a:t>
+            </a:r>
+            <a:endParaRPr lang="en-US" dirty="0"/>
+          </a:p>
+          <a:p>
+            <a:endParaRPr lang="en-US" dirty="0"/>
+          </a:p>
+          <a:p>
+            <a:r>
+              <a:rPr lang="en-US" dirty="0"/>
+              <a:t>• Distributed operations: one process and one SQLite file, with no services, queues, or cloud infrastructure. In a real bank, the Domain and Application layers would become a backend service behind an API that every channel (ATM, mobile, web, branch) shares, so the rules live in one place, and this ATM would be one thin client. Microservices become worthwhile once separate teams own accounts, transfers, and fraud and need to deploy independently. The inward dependencies here make that extraction straightforward.</a:t>
+            </a:r>
+            <a:endParaRPr lang="en-US" dirty="0"/>
+          </a:p>
+          <a:p>
+            <a:endParaRPr lang="en-US" dirty="0"/>
+          </a:p>
+          <a:p>
+            <a:r>
+              <a:rPr lang="en-US" dirty="0"/>
+              <a:t>Roadmap</a:t>
+            </a:r>
+            <a:endParaRPr lang="en-US" dirty="0"/>
+          </a:p>
+          <a:p>
+            <a:endParaRPr lang="en-US" dirty="0"/>
+          </a:p>
+          <a:p>
+            <a:r>
+              <a:rPr lang="en-US" dirty="0"/>
+              <a:t>• Now, idempotency keys: Post/Redirect/Get, a disabled submit button, and confirmation dialogs already stop refreshes and double-clicks. The remaining gap is a retried network request: the server commits, the response is lost, and the retry runs the operation again. EF Core's concurrency token does not catch it, because the retry is a valid second write against the new balance. Idempotency keys close it.</a:t>
+            </a:r>
+            <a:endParaRPr lang="en-US" dirty="0"/>
+          </a:p>
+          <a:p>
+            <a:endParaRPr lang="en-US" dirty="0"/>
+          </a:p>
+          <a:p>
+            <a:r>
+              <a:rPr lang="en-US" dirty="0"/>
+              <a:t>• Now, auditing: every balance change already writes a history record in the same transaction. A real audit trail also records who acted and from where, which needs identity first.</a:t>
+            </a:r>
+            <a:endParaRPr lang="en-US" dirty="0"/>
+          </a:p>
+          <a:p>
+            <a:endParaRPr lang="en-US" dirty="0"/>
+          </a:p>
+          <a:p>
+            <a:r>
+              <a:rPr lang="en-US" dirty="0"/>
+              <a:t>• Now, authentication: login and per-user authorization, the prerequisite for multiple users and attributable audit records.</a:t>
+            </a:r>
+            <a:endParaRPr lang="en-US" dirty="0"/>
+          </a:p>
+          <a:p>
+            <a:endParaRPr lang="en-US" dirty="0"/>
+          </a:p>
+          <a:p>
+            <a:r>
+              <a:rPr lang="en-US" dirty="0"/>
+              <a:t>• Next, accessibility: a manual WCAG 2.2 AA pass is done. Screen-reader testing (VoiceOver, NVDA) and automated axe or Lighthouse checks in CI are not.</a:t>
+            </a:r>
+            <a:endParaRPr lang="en-US" dirty="0"/>
+          </a:p>
+          <a:p>
+            <a:endParaRPr lang="en-US" dirty="0"/>
+          </a:p>
+          <a:p>
+            <a:r>
+              <a:rPr lang="en-US" dirty="0"/>
+              <a:t>• Next, observability: structured logs, metrics, and traces, still without logging sensitive form values.</a:t>
+            </a:r>
+            <a:endParaRPr lang="en-US" dirty="0"/>
+          </a:p>
+          <a:p>
+            <a:endParaRPr lang="en-US" dirty="0"/>
+          </a:p>
+          <a:p>
+            <a:r>
+              <a:rPr lang="en-US" dirty="0"/>
+              <a:t>• Next, load tests: measure SQLite's single-writer ceiling and how often concurrency conflicts reach users under contention.</a:t>
+            </a:r>
+            <a:endParaRPr lang="en-US" dirty="0"/>
+          </a:p>
+          <a:p>
+            <a:endParaRPr lang="en-US" dirty="0"/>
+          </a:p>
+          <a:p>
+            <a:r>
+              <a:rPr lang="en-US" dirty="0"/>
+              <a:t>• Later, deployment: a container, a CI/CD pipeline, and hosting. Production deployment is out of scope today.</a:t>
+            </a:r>
+            <a:endParaRPr lang="en-US" dirty="0"/>
+          </a:p>
+          <a:p>
+            <a:endParaRPr lang="en-US" dirty="0"/>
+          </a:p>
+          <a:p>
+            <a:r>
+              <a:rPr lang="en-US" dirty="0"/>
+              <a:t>• Later, browser coverage: the HTTP tests drive the app the way a browser would but do not run one. Cross-browser end-to-end tests (e.g., Playwright) would.</a:t>
+            </a:r>
+            <a:endParaRPr lang="en-US" dirty="0"/>
+          </a:p>
+          <a:p>
+            <a:endParaRPr lang="en-US" dirty="0"/>
+          </a:p>
+          <a:p>
+            <a:r>
+              <a:rPr lang="en-US" dirty="0"/>
+              <a:t>The phone capture shows the same page reflowing at 380 pixels, with no separate mobile build.</a:t>
             </a:r>
             <a:endParaRPr lang="en-US" dirty="0"/>
           </a:p>
@@ -5475,7 +5605,7 @@
                 <a:ea typeface="Avenir Next" pitchFamily="34" charset="-122"/>
                 <a:cs typeface="Avenir Next" pitchFamily="34" charset="-120"/>
               </a:rPr>
-              <a:t>Tradeoffs and roadmap</a:t>
+              <a:t>Roadmap</a:t>
             </a:r>
             <a:endParaRPr lang="en-US" sz="3200" dirty="0"/>
           </a:p>
@@ -5703,7 +5833,7 @@
                 <a:ea typeface="Avenir Next" pitchFamily="34" charset="-122"/>
                 <a:cs typeface="Avenir Next" pitchFamily="34" charset="-120"/>
               </a:rPr>
-              <a:t>NEXT</a:t>
+              <a:t>NOW</a:t>
             </a:r>
             <a:endParaRPr lang="en-US" sz="1100" dirty="0"/>
           </a:p>
@@ -5744,7 +5874,7 @@
                 <a:ea typeface="Avenir Next" pitchFamily="34" charset="-122"/>
                 <a:cs typeface="Avenir Next" pitchFamily="34" charset="-120"/>
               </a:rPr>
-              <a:t>Double-submit protection, auditing, authentication</a:t>
+              <a:t>Idempotency keys, auditing, authentication</a:t>
             </a:r>
             <a:endParaRPr lang="en-US" sz="1600" dirty="0"/>
           </a:p>
@@ -5785,7 +5915,7 @@
                 <a:ea typeface="Avenir Next" pitchFamily="34" charset="-122"/>
                 <a:cs typeface="Avenir Next" pitchFamily="34" charset="-120"/>
               </a:rPr>
-              <a:t>THEN</a:t>
+              <a:t>NEXT</a:t>
             </a:r>
             <a:endParaRPr lang="en-US" sz="1100" dirty="0"/>
           </a:p>

</xml_diff>

<commit_message>
Outline slide 7 notes and drop the phone capture
The phone capture did not support anything the roadmap slide says, so it
is gone and the roadmap column takes its width. Browser coverage is cut
for brevity: server-rendered pages carry little cross-browser risk.

Speaker notes gain outline syntax: "- " lines become real bulleted
paragraphs, two leading spaces per nesting level, and "# " lines become
bold headers. Slide 7's notes use it for a terse outline; other slides
are unchanged.

Co-Authored-By: Claude Opus 5.5 <noreply@anthropic.com>
</commit_message>
<xml_diff>
--- a/design/atm-deck.pptx
+++ b/design/atm-deck.pptx
@@ -1462,148 +1462,226 @@
           <a:lstStyle/>
           <a:p>
             <a:r>
-              <a:rPr lang="en-US" dirty="0"/>
-              <a:t>Omitted on purpose; </a:t>
-            </a:r>
-            <a:r>
-              <a:rPr lang="en-US" dirty="0">
+              <a:rPr lang="en-US" b="1" dirty="0"/>
+              <a:t>Omitted (out of scope in </a:t>
+            </a:r>
+            <a:r>
+              <a:rPr lang="en-US" b="1" dirty="0">
                 <a:hlinkClick r:id="rId3"/>
               </a:rPr>
               <a:t>SPEC.md</a:t>
             </a:r>
             <a:r>
-              <a:rPr lang="en-US" dirty="0"/>
-              <a:t> lists all three as out of scope.</a:t>
-            </a:r>
-            <a:endParaRPr lang="en-US" dirty="0"/>
-          </a:p>
-          <a:p>
-            <a:endParaRPr lang="en-US" dirty="0"/>
-          </a:p>
-          <a:p>
-            <a:r>
-              <a:rPr lang="en-US" dirty="0"/>
-              <a:t>• Identity: no login, card, PIN, or session. There is one local user, so there is nothing to authenticate.</a:t>
-            </a:r>
-            <a:endParaRPr lang="en-US" dirty="0"/>
-          </a:p>
-          <a:p>
-            <a:endParaRPr lang="en-US" dirty="0"/>
-          </a:p>
-          <a:p>
-            <a:r>
-              <a:rPr lang="en-US" dirty="0"/>
-              <a:t>• Banking breadth: no fees, interest, overdraft lines, scheduled payments, other currencies, or external bank rails. Two seeded accounts and three operations keep the review on correctness.</a:t>
-            </a:r>
-            <a:endParaRPr lang="en-US" dirty="0"/>
-          </a:p>
-          <a:p>
-            <a:endParaRPr lang="en-US" dirty="0"/>
-          </a:p>
-          <a:p>
-            <a:r>
-              <a:rPr lang="en-US" dirty="0"/>
-              <a:t>• Distributed operations: one process and one SQLite file, with no services, queues, or cloud infrastructure. In a real bank, the Domain and Application layers would become a backend service behind an API that every channel (ATM, mobile, web, branch) shares, so the rules live in one place, and this ATM would be one thin client. Microservices become worthwhile once separate teams own accounts, transfers, and fraud and need to deploy independently. The inward dependencies here make that extraction straightforward.</a:t>
-            </a:r>
-            <a:endParaRPr lang="en-US" dirty="0"/>
-          </a:p>
-          <a:p>
-            <a:endParaRPr lang="en-US" dirty="0"/>
-          </a:p>
-          <a:p>
-            <a:r>
-              <a:rPr lang="en-US" dirty="0"/>
+              <a:rPr lang="en-US" b="1" dirty="0"/>
+              <a:t>)</a:t>
+            </a:r>
+            <a:endParaRPr lang="en-US" dirty="0"/>
+          </a:p>
+          <a:p>
+            <a:pPr marL="228600" lvl="0" indent="-228600">
+              <a:buFont typeface="Arial"/>
+              <a:buChar char="•"/>
+            </a:pPr>
+            <a:r>
+              <a:rPr lang="en-US" dirty="0"/>
+              <a:t>Identity</a:t>
+            </a:r>
+            <a:endParaRPr lang="en-US" dirty="0"/>
+          </a:p>
+          <a:p>
+            <a:pPr marL="457200" lvl="1" indent="-228600">
+              <a:buFont typeface="Arial"/>
+              <a:buChar char="–"/>
+            </a:pPr>
+            <a:r>
+              <a:rPr lang="en-US" dirty="0"/>
+              <a:t>No login, card, PIN, or session; one local user</a:t>
+            </a:r>
+            <a:endParaRPr lang="en-US" dirty="0"/>
+          </a:p>
+          <a:p>
+            <a:pPr marL="228600" lvl="0" indent="-228600">
+              <a:buFont typeface="Arial"/>
+              <a:buChar char="•"/>
+            </a:pPr>
+            <a:r>
+              <a:rPr lang="en-US" dirty="0"/>
+              <a:t>Banking breadth</a:t>
+            </a:r>
+            <a:endParaRPr lang="en-US" dirty="0"/>
+          </a:p>
+          <a:p>
+            <a:pPr marL="457200" lvl="1" indent="-228600">
+              <a:buFont typeface="Arial"/>
+              <a:buChar char="–"/>
+            </a:pPr>
+            <a:r>
+              <a:rPr lang="en-US" dirty="0"/>
+              <a:t>No fees, interest, overdraft lines, scheduled payments, other currencies, or bank rails</a:t>
+            </a:r>
+            <a:endParaRPr lang="en-US" dirty="0"/>
+          </a:p>
+          <a:p>
+            <a:pPr marL="228600" lvl="0" indent="-228600">
+              <a:buFont typeface="Arial"/>
+              <a:buChar char="•"/>
+            </a:pPr>
+            <a:r>
+              <a:rPr lang="en-US" dirty="0"/>
+              <a:t>Distributed operations</a:t>
+            </a:r>
+            <a:endParaRPr lang="en-US" dirty="0"/>
+          </a:p>
+          <a:p>
+            <a:pPr marL="457200" lvl="1" indent="-228600">
+              <a:buFont typeface="Arial"/>
+              <a:buChar char="–"/>
+            </a:pPr>
+            <a:r>
+              <a:rPr lang="en-US" dirty="0"/>
+              <a:t>One process, one SQLite file</a:t>
+            </a:r>
+            <a:endParaRPr lang="en-US" dirty="0"/>
+          </a:p>
+          <a:p>
+            <a:pPr marL="457200" lvl="1" indent="-228600">
+              <a:buFont typeface="Arial"/>
+              <a:buChar char="–"/>
+            </a:pPr>
+            <a:r>
+              <a:rPr lang="en-US" dirty="0"/>
+              <a:t>In a real bank, Domain and Application would become a backend service shared by every client (ATMs, mobile app, online banking, branch tellers)</a:t>
+            </a:r>
+            <a:endParaRPr lang="en-US" dirty="0"/>
+          </a:p>
+          <a:p>
+            <a:pPr marL="457200" lvl="1" indent="-228600">
+              <a:buFont typeface="Arial"/>
+              <a:buChar char="–"/>
+            </a:pPr>
+            <a:r>
+              <a:rPr lang="en-US" dirty="0"/>
+              <a:t>Microservices only once separate teams need to deploy independently</a:t>
+            </a:r>
+            <a:endParaRPr lang="en-US" dirty="0"/>
+          </a:p>
+          <a:p>
+            <a:endParaRPr lang="en-US" dirty="0"/>
+          </a:p>
+          <a:p>
+            <a:r>
+              <a:rPr lang="en-US" b="1" dirty="0"/>
               <a:t>Roadmap</a:t>
             </a:r>
             <a:endParaRPr lang="en-US" dirty="0"/>
           </a:p>
           <a:p>
-            <a:endParaRPr lang="en-US" dirty="0"/>
-          </a:p>
-          <a:p>
-            <a:r>
-              <a:rPr lang="en-US" dirty="0"/>
-              <a:t>• Now, idempotency keys: Post/Redirect/Get, a disabled submit button, and confirmation dialogs already stop refreshes and double-clicks. The remaining gap is a retried network request: the server commits, the response is lost, and the retry runs the operation again. EF Core's concurrency token does not catch it, because the retry is a valid second write against the new balance. Idempotency keys close it.</a:t>
-            </a:r>
-            <a:endParaRPr lang="en-US" dirty="0"/>
-          </a:p>
-          <a:p>
-            <a:endParaRPr lang="en-US" dirty="0"/>
-          </a:p>
-          <a:p>
-            <a:r>
-              <a:rPr lang="en-US" dirty="0"/>
-              <a:t>• Now, auditing: every balance change already writes a history record in the same transaction. A real audit trail also records who acted and from where, which needs identity first.</a:t>
-            </a:r>
-            <a:endParaRPr lang="en-US" dirty="0"/>
-          </a:p>
-          <a:p>
-            <a:endParaRPr lang="en-US" dirty="0"/>
-          </a:p>
-          <a:p>
-            <a:r>
-              <a:rPr lang="en-US" dirty="0"/>
-              <a:t>• Now, authentication: login and per-user authorization, the prerequisite for multiple users and attributable audit records.</a:t>
-            </a:r>
-            <a:endParaRPr lang="en-US" dirty="0"/>
-          </a:p>
-          <a:p>
-            <a:endParaRPr lang="en-US" dirty="0"/>
-          </a:p>
-          <a:p>
-            <a:r>
-              <a:rPr lang="en-US" dirty="0"/>
-              <a:t>• Next, accessibility: a manual WCAG 2.2 AA pass is done. Screen-reader testing (VoiceOver, NVDA) and automated axe or Lighthouse checks in CI are not.</a:t>
-            </a:r>
-            <a:endParaRPr lang="en-US" dirty="0"/>
-          </a:p>
-          <a:p>
-            <a:endParaRPr lang="en-US" dirty="0"/>
-          </a:p>
-          <a:p>
-            <a:r>
-              <a:rPr lang="en-US" dirty="0"/>
-              <a:t>• Next, observability: structured logs, metrics, and traces, still without logging sensitive form values.</a:t>
-            </a:r>
-            <a:endParaRPr lang="en-US" dirty="0"/>
-          </a:p>
-          <a:p>
-            <a:endParaRPr lang="en-US" dirty="0"/>
-          </a:p>
-          <a:p>
-            <a:r>
-              <a:rPr lang="en-US" dirty="0"/>
-              <a:t>• Next, load tests: measure SQLite's single-writer ceiling and how often concurrency conflicts reach users under contention.</a:t>
-            </a:r>
-            <a:endParaRPr lang="en-US" dirty="0"/>
-          </a:p>
-          <a:p>
-            <a:endParaRPr lang="en-US" dirty="0"/>
-          </a:p>
-          <a:p>
-            <a:r>
-              <a:rPr lang="en-US" dirty="0"/>
-              <a:t>• Later, deployment: a container, a CI/CD pipeline, and hosting. Production deployment is out of scope today.</a:t>
-            </a:r>
-            <a:endParaRPr lang="en-US" dirty="0"/>
-          </a:p>
-          <a:p>
-            <a:endParaRPr lang="en-US" dirty="0"/>
-          </a:p>
-          <a:p>
-            <a:r>
-              <a:rPr lang="en-US" dirty="0"/>
-              <a:t>• Later, browser coverage: the HTTP tests drive the app the way a browser would but do not run one. Cross-browser end-to-end tests (e.g., Playwright) would.</a:t>
-            </a:r>
-            <a:endParaRPr lang="en-US" dirty="0"/>
-          </a:p>
-          <a:p>
-            <a:endParaRPr lang="en-US" dirty="0"/>
-          </a:p>
-          <a:p>
-            <a:r>
-              <a:rPr lang="en-US" dirty="0"/>
-              <a:t>The phone capture shows the same page reflowing at 380 pixels, with no separate mobile build.</a:t>
+            <a:pPr marL="228600" lvl="0" indent="-228600">
+              <a:buFont typeface="Arial"/>
+              <a:buChar char="•"/>
+            </a:pPr>
+            <a:r>
+              <a:rPr lang="en-US" dirty="0"/>
+              <a:t>Now</a:t>
+            </a:r>
+            <a:endParaRPr lang="en-US" dirty="0"/>
+          </a:p>
+          <a:p>
+            <a:pPr marL="457200" lvl="1" indent="-228600">
+              <a:buFont typeface="Arial"/>
+              <a:buChar char="–"/>
+            </a:pPr>
+            <a:r>
+              <a:rPr lang="en-US" dirty="0"/>
+              <a:t>Idempotency keys: a retry after a lost response repeats the operation; Post/Redirect/Get and EF Core's concurrency token cannot catch it</a:t>
+            </a:r>
+            <a:endParaRPr lang="en-US" dirty="0"/>
+          </a:p>
+          <a:p>
+            <a:pPr marL="457200" lvl="1" indent="-228600">
+              <a:buFont typeface="Arial"/>
+              <a:buChar char="–"/>
+            </a:pPr>
+            <a:r>
+              <a:rPr lang="en-US" dirty="0"/>
+              <a:t>Auditing: history exists; add who acted and from where</a:t>
+            </a:r>
+            <a:endParaRPr lang="en-US" dirty="0"/>
+          </a:p>
+          <a:p>
+            <a:pPr marL="457200" lvl="1" indent="-228600">
+              <a:buFont typeface="Arial"/>
+              <a:buChar char="–"/>
+            </a:pPr>
+            <a:r>
+              <a:rPr lang="en-US" dirty="0"/>
+              <a:t>Authentication: prerequisite for multiple users and attributable audits</a:t>
+            </a:r>
+            <a:endParaRPr lang="en-US" dirty="0"/>
+          </a:p>
+          <a:p>
+            <a:pPr marL="228600" lvl="0" indent="-228600">
+              <a:buFont typeface="Arial"/>
+              <a:buChar char="•"/>
+            </a:pPr>
+            <a:r>
+              <a:rPr lang="en-US" dirty="0"/>
+              <a:t>Next</a:t>
+            </a:r>
+            <a:endParaRPr lang="en-US" dirty="0"/>
+          </a:p>
+          <a:p>
+            <a:pPr marL="457200" lvl="1" indent="-228600">
+              <a:buFont typeface="Arial"/>
+              <a:buChar char="–"/>
+            </a:pPr>
+            <a:r>
+              <a:rPr lang="en-US" dirty="0"/>
+              <a:t>Accessibility: screen-reader testing, axe or Lighthouse in CI</a:t>
+            </a:r>
+            <a:endParaRPr lang="en-US" dirty="0"/>
+          </a:p>
+          <a:p>
+            <a:pPr marL="457200" lvl="1" indent="-228600">
+              <a:buFont typeface="Arial"/>
+              <a:buChar char="–"/>
+            </a:pPr>
+            <a:r>
+              <a:rPr lang="en-US" dirty="0"/>
+              <a:t>Observability: structured logs, metrics, traces</a:t>
+            </a:r>
+            <a:endParaRPr lang="en-US" dirty="0"/>
+          </a:p>
+          <a:p>
+            <a:pPr marL="457200" lvl="1" indent="-228600">
+              <a:buFont typeface="Arial"/>
+              <a:buChar char="–"/>
+            </a:pPr>
+            <a:r>
+              <a:rPr lang="en-US" dirty="0"/>
+              <a:t>Load tests: find SQLite's single-writer ceiling</a:t>
+            </a:r>
+            <a:endParaRPr lang="en-US" dirty="0"/>
+          </a:p>
+          <a:p>
+            <a:pPr marL="228600" lvl="0" indent="-228600">
+              <a:buFont typeface="Arial"/>
+              <a:buChar char="•"/>
+            </a:pPr>
+            <a:r>
+              <a:rPr lang="en-US" dirty="0"/>
+              <a:t>Later</a:t>
+            </a:r>
+            <a:endParaRPr lang="en-US" dirty="0"/>
+          </a:p>
+          <a:p>
+            <a:pPr marL="457200" lvl="1" indent="-228600">
+              <a:buFont typeface="Arial"/>
+              <a:buChar char="–"/>
+            </a:pPr>
+            <a:r>
+              <a:rPr lang="en-US" dirty="0"/>
+              <a:t>Deployment: container, CI/CD, hosting</a:t>
             </a:r>
             <a:endParaRPr lang="en-US" dirty="0"/>
           </a:p>
@@ -5848,7 +5926,7 @@
         <p:spPr>
           <a:xfrm>
             <a:off x="3383280" y="1536192"/>
-            <a:ext cx="2743200" cy="475488"/>
+            <a:ext cx="5175504" cy="475488"/>
           </a:xfrm>
           <a:prstGeom prst="rect">
             <a:avLst/>
@@ -5930,7 +6008,7 @@
         <p:spPr>
           <a:xfrm>
             <a:off x="3383280" y="2514600"/>
-            <a:ext cx="2743200" cy="475488"/>
+            <a:ext cx="5175504" cy="475488"/>
           </a:xfrm>
           <a:prstGeom prst="rect">
             <a:avLst/>
@@ -6012,7 +6090,7 @@
         <p:spPr>
           <a:xfrm>
             <a:off x="3383280" y="3493008"/>
-            <a:ext cx="2743200" cy="475488"/>
+            <a:ext cx="5175504" cy="475488"/>
           </a:xfrm>
           <a:prstGeom prst="rect">
             <a:avLst/>
@@ -6038,99 +6116,9 @@
                 <a:ea typeface="Avenir Next" pitchFamily="34" charset="-122"/>
                 <a:cs typeface="Avenir Next" pitchFamily="34" charset="-120"/>
               </a:rPr>
-              <a:t>Deployment, browser coverage</a:t>
+              <a:t>Deployment</a:t>
             </a:r>
             <a:endParaRPr lang="en-US" sz="1600" dirty="0"/>
-          </a:p>
-        </p:txBody>
-      </p:sp>
-      <p:sp>
-        <p:nvSpPr>
-          <p:cNvPr id="16" name="Shape 13"/>
-          <p:cNvSpPr/>
-          <p:nvPr/>
-        </p:nvSpPr>
-        <p:spPr>
-          <a:xfrm>
-            <a:off x="6986016" y="1078992"/>
-            <a:ext cx="1005840" cy="3310128"/>
-          </a:xfrm>
-          <a:prstGeom prst="rect">
-            <a:avLst/>
-          </a:prstGeom>
-          <a:solidFill>
-            <a:srgbClr val="1B1B1B"/>
-          </a:solidFill>
-          <a:ln w="10160">
-            <a:solidFill>
-              <a:srgbClr val="333333"/>
-            </a:solidFill>
-            <a:prstDash val="solid"/>
-          </a:ln>
-        </p:spPr>
-      </p:sp>
-      <p:pic>
-        <p:nvPicPr>
-          <p:cNvPr id="17" name="Image 0" descr="/Users/john/theborg/repos/atm/design/screenshots/phone.png">    </p:cNvPr>
-          <p:cNvPicPr>
-            <a:picLocks noChangeAspect="1"/>
-          </p:cNvPicPr>
-          <p:nvPr/>
-        </p:nvPicPr>
-        <p:blipFill>
-          <a:blip r:embed="rId1"/>
-          <a:stretch>
-            <a:fillRect/>
-          </a:stretch>
-        </p:blipFill>
-        <p:spPr>
-          <a:xfrm>
-            <a:off x="7022592" y="1115568"/>
-            <a:ext cx="932688" cy="3236976"/>
-          </a:xfrm>
-          <a:prstGeom prst="rect">
-            <a:avLst/>
-          </a:prstGeom>
-        </p:spPr>
-      </p:pic>
-      <p:sp>
-        <p:nvSpPr>
-          <p:cNvPr id="18" name="Text 14"/>
-          <p:cNvSpPr txBox="1"/>
-          <p:nvPr/>
-        </p:nvSpPr>
-        <p:spPr>
-          <a:xfrm>
-            <a:off x="6309360" y="4489704"/>
-            <a:ext cx="2359152" cy="164592"/>
-          </a:xfrm>
-          <a:prstGeom prst="rect">
-            <a:avLst/>
-          </a:prstGeom>
-          <a:noFill/>
-          <a:ln/>
-        </p:spPr>
-        <p:txBody>
-          <a:bodyPr wrap="square" lIns="0" tIns="0" rIns="0" bIns="0" rtlCol="0" anchor="t">
-            <a:normAutofit/>
-          </a:bodyPr>
-          <a:lstStyle/>
-          <a:p>
-            <a:pPr algn="ctr" indent="0" marL="0">
-              <a:buNone/>
-            </a:pPr>
-            <a:r>
-              <a:rPr lang="en-US" sz="1050" dirty="0">
-                <a:solidFill>
-                  <a:srgbClr val="00F604"/>
-                </a:solidFill>
-                <a:latin typeface="Avenir Next" pitchFamily="34" charset="0"/>
-                <a:ea typeface="Avenir Next" pitchFamily="34" charset="-122"/>
-                <a:cs typeface="Avenir Next" pitchFamily="34" charset="-120"/>
-              </a:rPr>
-              <a:t>Responsive at 380 px.</a:t>
-            </a:r>
-            <a:endParaRPr lang="en-US" sz="1050" dirty="0"/>
           </a:p>
         </p:txBody>
       </p:sp>

</xml_diff>

<commit_message>
Swap Roadmap auditing for cross-model review and note the Tab gap
Co-Authored-By: Claude Opus 5.5 <noreply@anthropic.com>
</commit_message>
<xml_diff>
--- a/design/atm-deck.pptx
+++ b/design/atm-deck.pptx
@@ -1604,7 +1604,7 @@
             </a:pPr>
             <a:r>
               <a:rPr lang="en-US" dirty="0"/>
-              <a:t>Auditing: history exists; add who acted and from where</a:t>
+              <a:t>Cross-model code review: Fable 5.1 wrote the implementation, so have a different model (GPT-6 Sol) review it; a second model does not share the author's blind spots</a:t>
             </a:r>
             <a:endParaRPr lang="en-US" dirty="0"/>
           </a:p>
@@ -1638,6 +1638,17 @@
             <a:r>
               <a:rPr lang="en-US" dirty="0"/>
               <a:t>Accessibility: screen-reader testing, axe or Lighthouse in CI</a:t>
+            </a:r>
+            <a:endParaRPr lang="en-US" dirty="0"/>
+          </a:p>
+          <a:p>
+            <a:pPr marL="685800" lvl="2" indent="-228600">
+              <a:buFont typeface="Arial"/>
+              <a:buChar char="–"/>
+            </a:pPr>
+            <a:r>
+              <a:rPr lang="en-US" dirty="0"/>
+              <a:t>Known gap: with JavaScript on, Tab cannot reach the Withdraw and Transfer tabs (in BACKLOG.md)</a:t>
             </a:r>
             <a:endParaRPr lang="en-US" dirty="0"/>
           </a:p>
@@ -5952,7 +5963,7 @@
                 <a:ea typeface="Avenir Next" pitchFamily="34" charset="-122"/>
                 <a:cs typeface="Avenir Next" pitchFamily="34" charset="-120"/>
               </a:rPr>
-              <a:t>Idempotency keys, auditing, authentication</a:t>
+              <a:t>Idempotency keys, cross-model review, authentication</a:t>
             </a:r>
             <a:endParaRPr lang="en-US" sz="1600" dirty="0"/>
           </a:p>

</xml_diff>

<commit_message>
Drop the tests-by-layer slide and trim two Roadmap notes
Co-Authored-By: Claude Sonnet 5 <noreply@anthropic.com>
</commit_message>
<xml_diff>
--- a/design/atm-deck.pptx
+++ b/design/atm-deck.pptx
@@ -11,10 +11,9 @@
     <p:sldId id="259" r:id="rId5"/>
     <p:sldId id="260" r:id="rId6"/>
     <p:sldId id="261" r:id="rId7"/>
-    <p:sldId id="262" r:id="rId8"/>
   </p:sldIdLst>
   <p:notesMasterIdLst>
-    <p:notesMasterId r:id="rId9"/>
+    <p:notesMasterId r:id="rId8"/>
   </p:notesMasterIdLst>
   <p:sldSz cx="9144000" cy="5143500"/>
   <p:notesSz cx="7772400" cy="10058400"/>
@@ -1344,38 +1343,215 @@
           <a:lstStyle/>
           <a:p>
             <a:r>
-              <a:rPr lang="en-US" dirty="0"/>
-              <a:t>• Domain (75): pure tests. No database, no I/O, no fakes. They call the business rules directly (money, accounts, transfers), so they are fast and deterministic.</a:t>
-            </a:r>
-            <a:endParaRPr lang="en-US" dirty="0"/>
-          </a:p>
-          <a:p>
-            <a:endParaRPr lang="en-US" dirty="0"/>
-          </a:p>
-          <a:p>
-            <a:r>
-              <a:rPr lang="en-US" dirty="0"/>
-              <a:t>• Application (33): use cases run against hand-written fakes for the store and the clock.</a:t>
-            </a:r>
-            <a:endParaRPr lang="en-US" dirty="0"/>
-          </a:p>
-          <a:p>
-            <a:endParaRPr lang="en-US" dirty="0"/>
-          </a:p>
-          <a:p>
-            <a:r>
-              <a:rPr lang="en-US" dirty="0"/>
-              <a:t>• Integration + HTTP (35): the real host, with an isolated SQLite file per test.</a:t>
-            </a:r>
-            <a:endParaRPr lang="en-US" dirty="0"/>
-          </a:p>
-          <a:p>
-            <a:endParaRPr lang="en-US" dirty="0"/>
-          </a:p>
-          <a:p>
-            <a:r>
-              <a:rPr lang="en-US" dirty="0"/>
-              <a:t>• Those cover concurrency conflicts, atomic rollback, Post/Redirect/Get, security, and accessibility structure.</a:t>
+              <a:rPr lang="en-US" b="1" dirty="0"/>
+              <a:t>Omitted (out of scope in </a:t>
+            </a:r>
+            <a:r>
+              <a:rPr lang="en-US" b="1" dirty="0">
+                <a:hlinkClick r:id="rId3"/>
+              </a:rPr>
+              <a:t>SPEC.md</a:t>
+            </a:r>
+            <a:r>
+              <a:rPr lang="en-US" b="1" dirty="0"/>
+              <a:t>)</a:t>
+            </a:r>
+            <a:endParaRPr lang="en-US" dirty="0"/>
+          </a:p>
+          <a:p>
+            <a:pPr marL="228600" lvl="0" indent="-228600">
+              <a:buFont typeface="Arial"/>
+              <a:buChar char="•"/>
+            </a:pPr>
+            <a:r>
+              <a:rPr lang="en-US" dirty="0"/>
+              <a:t>Identity</a:t>
+            </a:r>
+            <a:endParaRPr lang="en-US" dirty="0"/>
+          </a:p>
+          <a:p>
+            <a:pPr marL="457200" lvl="1" indent="-228600">
+              <a:buFont typeface="Arial"/>
+              <a:buChar char="–"/>
+            </a:pPr>
+            <a:r>
+              <a:rPr lang="en-US" dirty="0"/>
+              <a:t>No login, card, PIN, or session; one local user</a:t>
+            </a:r>
+            <a:endParaRPr lang="en-US" dirty="0"/>
+          </a:p>
+          <a:p>
+            <a:pPr marL="228600" lvl="0" indent="-228600">
+              <a:buFont typeface="Arial"/>
+              <a:buChar char="•"/>
+            </a:pPr>
+            <a:r>
+              <a:rPr lang="en-US" dirty="0"/>
+              <a:t>Banking breadth</a:t>
+            </a:r>
+            <a:endParaRPr lang="en-US" dirty="0"/>
+          </a:p>
+          <a:p>
+            <a:pPr marL="457200" lvl="1" indent="-228600">
+              <a:buFont typeface="Arial"/>
+              <a:buChar char="–"/>
+            </a:pPr>
+            <a:r>
+              <a:rPr lang="en-US" dirty="0"/>
+              <a:t>No fees, interest, overdraft lines, scheduled payments, other currencies, or bank rails</a:t>
+            </a:r>
+            <a:endParaRPr lang="en-US" dirty="0"/>
+          </a:p>
+          <a:p>
+            <a:pPr marL="228600" lvl="0" indent="-228600">
+              <a:buFont typeface="Arial"/>
+              <a:buChar char="•"/>
+            </a:pPr>
+            <a:r>
+              <a:rPr lang="en-US" dirty="0"/>
+              <a:t>Distributed operations</a:t>
+            </a:r>
+            <a:endParaRPr lang="en-US" dirty="0"/>
+          </a:p>
+          <a:p>
+            <a:pPr marL="457200" lvl="1" indent="-228600">
+              <a:buFont typeface="Arial"/>
+              <a:buChar char="–"/>
+            </a:pPr>
+            <a:r>
+              <a:rPr lang="en-US" dirty="0"/>
+              <a:t>One process, one SQLite file</a:t>
+            </a:r>
+            <a:endParaRPr lang="en-US" dirty="0"/>
+          </a:p>
+          <a:p>
+            <a:pPr marL="457200" lvl="1" indent="-228600">
+              <a:buFont typeface="Arial"/>
+              <a:buChar char="–"/>
+            </a:pPr>
+            <a:r>
+              <a:rPr lang="en-US" dirty="0"/>
+              <a:t>In a real bank, Domain and Application would become a backend service shared by every client (ATMs, mobile app, online banking, branch tellers)</a:t>
+            </a:r>
+            <a:endParaRPr lang="en-US" dirty="0"/>
+          </a:p>
+          <a:p>
+            <a:endParaRPr lang="en-US" dirty="0"/>
+          </a:p>
+          <a:p>
+            <a:r>
+              <a:rPr lang="en-US" b="1" dirty="0"/>
+              <a:t>Roadmap</a:t>
+            </a:r>
+            <a:endParaRPr lang="en-US" dirty="0"/>
+          </a:p>
+          <a:p>
+            <a:pPr marL="228600" lvl="0" indent="-228600">
+              <a:buFont typeface="Arial"/>
+              <a:buChar char="•"/>
+            </a:pPr>
+            <a:r>
+              <a:rPr lang="en-US" dirty="0"/>
+              <a:t>Now</a:t>
+            </a:r>
+            <a:endParaRPr lang="en-US" dirty="0"/>
+          </a:p>
+          <a:p>
+            <a:pPr marL="457200" lvl="1" indent="-228600">
+              <a:buFont typeface="Arial"/>
+              <a:buChar char="–"/>
+            </a:pPr>
+            <a:r>
+              <a:rPr lang="en-US" dirty="0"/>
+              <a:t>Idempotency keys: a retry after a lost response repeats the operation; Post/Redirect/Get and EF Core's concurrency token cannot catch it</a:t>
+            </a:r>
+            <a:endParaRPr lang="en-US" dirty="0"/>
+          </a:p>
+          <a:p>
+            <a:pPr marL="457200" lvl="1" indent="-228600">
+              <a:buFont typeface="Arial"/>
+              <a:buChar char="–"/>
+            </a:pPr>
+            <a:r>
+              <a:rPr lang="en-US" dirty="0"/>
+              <a:t>Cross-model code review: Fable 5.1 wrote the implementation, so have a different model (GPT-6 Sol) review it; a second model does not share the author's blind spots</a:t>
+            </a:r>
+            <a:endParaRPr lang="en-US" dirty="0"/>
+          </a:p>
+          <a:p>
+            <a:pPr marL="457200" lvl="1" indent="-228600">
+              <a:buFont typeface="Arial"/>
+              <a:buChar char="–"/>
+            </a:pPr>
+            <a:r>
+              <a:rPr lang="en-US" dirty="0"/>
+              <a:t>Authentication: prerequisite for multiple users and attributable audits</a:t>
+            </a:r>
+            <a:endParaRPr lang="en-US" dirty="0"/>
+          </a:p>
+          <a:p>
+            <a:pPr marL="228600" lvl="0" indent="-228600">
+              <a:buFont typeface="Arial"/>
+              <a:buChar char="•"/>
+            </a:pPr>
+            <a:r>
+              <a:rPr lang="en-US" dirty="0"/>
+              <a:t>Next</a:t>
+            </a:r>
+            <a:endParaRPr lang="en-US" dirty="0"/>
+          </a:p>
+          <a:p>
+            <a:pPr marL="457200" lvl="1" indent="-228600">
+              <a:buFont typeface="Arial"/>
+              <a:buChar char="–"/>
+            </a:pPr>
+            <a:r>
+              <a:rPr lang="en-US" dirty="0"/>
+              <a:t>Accessibility: screen-reader testing, axe or Lighthouse in CI</a:t>
+            </a:r>
+            <a:endParaRPr lang="en-US" dirty="0"/>
+          </a:p>
+          <a:p>
+            <a:pPr marL="685800" lvl="2" indent="-228600">
+              <a:buFont typeface="Arial"/>
+              <a:buChar char="–"/>
+            </a:pPr>
+            <a:r>
+              <a:rPr lang="en-US" dirty="0"/>
+              <a:t>Known gap: with JavaScript on, Tab cannot reach the Withdraw and Transfer tabs (in BACKLOG.md)</a:t>
+            </a:r>
+            <a:endParaRPr lang="en-US" dirty="0"/>
+          </a:p>
+          <a:p>
+            <a:pPr marL="457200" lvl="1" indent="-228600">
+              <a:buFont typeface="Arial"/>
+              <a:buChar char="–"/>
+            </a:pPr>
+            <a:r>
+              <a:rPr lang="en-US" dirty="0"/>
+              <a:t>Observability: structured logs, metrics, traces</a:t>
+            </a:r>
+            <a:endParaRPr lang="en-US" dirty="0"/>
+          </a:p>
+          <a:p>
+            <a:pPr marL="228600" lvl="0" indent="-228600">
+              <a:buFont typeface="Arial"/>
+              <a:buChar char="•"/>
+            </a:pPr>
+            <a:r>
+              <a:rPr lang="en-US" dirty="0"/>
+              <a:t>Later</a:t>
+            </a:r>
+            <a:endParaRPr lang="en-US" dirty="0"/>
+          </a:p>
+          <a:p>
+            <a:pPr marL="457200" lvl="1" indent="-228600">
+              <a:buFont typeface="Arial"/>
+              <a:buChar char="–"/>
+            </a:pPr>
+            <a:r>
+              <a:rPr lang="en-US" dirty="0"/>
+              <a:t>Deployment: container, CI/CD, hosting</a:t>
             </a:r>
             <a:endParaRPr lang="en-US" dirty="0"/>
           </a:p>
@@ -1399,323 +1575,6 @@
             <a:fld id="{F7021451-1387-4CA6-816F-3879F97B5CBC}" type="slidenum">
               <a:rPr lang="en-US"/>
               <a:t>6</a:t>
-            </a:fld>
-            <a:endParaRPr lang="en-US"/>
-          </a:p>
-        </p:txBody>
-      </p:sp>
-    </p:spTree>
-    <p:extLst>
-      <p:ext uri="{BB962C8B-B14F-4D97-AF65-F5344CB8AC3E}">
-        <p14:creationId xmlns:p14="http://schemas.microsoft.com/office/powerpoint/2010/main" val="1024086991"/>
-      </p:ext>
-    </p:extLst>
-  </p:cSld>
-  <p:clrMapOvr>
-    <a:masterClrMapping/>
-  </p:clrMapOvr>
-</p:notes>
-</file>
-
-<file path=ppt/notesSlides/notesSlide7.xml><?xml version="1.0" encoding="utf-8"?>
-<p:notes xmlns:a="http://schemas.openxmlformats.org/drawingml/2006/main" xmlns:r="http://schemas.openxmlformats.org/officeDocument/2006/relationships" xmlns:p="http://schemas.openxmlformats.org/presentationml/2006/main">
-  <p:cSld>
-    <p:spTree>
-      <p:nvGrpSpPr>
-        <p:cNvPr id="1" name=""/>
-        <p:cNvGrpSpPr/>
-        <p:nvPr/>
-      </p:nvGrpSpPr>
-      <p:grpSpPr>
-        <a:xfrm>
-          <a:off x="0" y="0"/>
-          <a:ext cx="0" cy="0"/>
-          <a:chOff x="0" y="0"/>
-          <a:chExt cx="0" cy="0"/>
-        </a:xfrm>
-      </p:grpSpPr>
-      <p:sp>
-        <p:nvSpPr>
-          <p:cNvPr id="2" name="Slide Image Placeholder 1"/>
-          <p:cNvSpPr>
-            <a:spLocks noGrp="1" noRot="1" noChangeAspect="1"/>
-          </p:cNvSpPr>
-          <p:nvPr>
-            <p:ph type="sldImg"/>
-          </p:nvPr>
-        </p:nvSpPr>
-        <p:spPr/>
-      </p:sp>
-      <p:sp>
-        <p:nvSpPr>
-          <p:cNvPr id="3" name="Notes Placeholder 2"/>
-          <p:cNvSpPr>
-            <a:spLocks noGrp="1"/>
-          </p:cNvSpPr>
-          <p:nvPr>
-            <p:ph type="body" idx="1"/>
-          </p:nvPr>
-        </p:nvSpPr>
-        <p:spPr/>
-        <p:txBody>
-          <a:bodyPr/>
-          <a:lstStyle/>
-          <a:p>
-            <a:r>
-              <a:rPr lang="en-US" b="1" dirty="0"/>
-              <a:t>Omitted (out of scope in </a:t>
-            </a:r>
-            <a:r>
-              <a:rPr lang="en-US" b="1" dirty="0">
-                <a:hlinkClick r:id="rId3"/>
-              </a:rPr>
-              <a:t>SPEC.md</a:t>
-            </a:r>
-            <a:r>
-              <a:rPr lang="en-US" b="1" dirty="0"/>
-              <a:t>)</a:t>
-            </a:r>
-            <a:endParaRPr lang="en-US" dirty="0"/>
-          </a:p>
-          <a:p>
-            <a:pPr marL="228600" lvl="0" indent="-228600">
-              <a:buFont typeface="Arial"/>
-              <a:buChar char="•"/>
-            </a:pPr>
-            <a:r>
-              <a:rPr lang="en-US" dirty="0"/>
-              <a:t>Identity</a:t>
-            </a:r>
-            <a:endParaRPr lang="en-US" dirty="0"/>
-          </a:p>
-          <a:p>
-            <a:pPr marL="457200" lvl="1" indent="-228600">
-              <a:buFont typeface="Arial"/>
-              <a:buChar char="–"/>
-            </a:pPr>
-            <a:r>
-              <a:rPr lang="en-US" dirty="0"/>
-              <a:t>No login, card, PIN, or session; one local user</a:t>
-            </a:r>
-            <a:endParaRPr lang="en-US" dirty="0"/>
-          </a:p>
-          <a:p>
-            <a:pPr marL="228600" lvl="0" indent="-228600">
-              <a:buFont typeface="Arial"/>
-              <a:buChar char="•"/>
-            </a:pPr>
-            <a:r>
-              <a:rPr lang="en-US" dirty="0"/>
-              <a:t>Banking breadth</a:t>
-            </a:r>
-            <a:endParaRPr lang="en-US" dirty="0"/>
-          </a:p>
-          <a:p>
-            <a:pPr marL="457200" lvl="1" indent="-228600">
-              <a:buFont typeface="Arial"/>
-              <a:buChar char="–"/>
-            </a:pPr>
-            <a:r>
-              <a:rPr lang="en-US" dirty="0"/>
-              <a:t>No fees, interest, overdraft lines, scheduled payments, other currencies, or bank rails</a:t>
-            </a:r>
-            <a:endParaRPr lang="en-US" dirty="0"/>
-          </a:p>
-          <a:p>
-            <a:pPr marL="228600" lvl="0" indent="-228600">
-              <a:buFont typeface="Arial"/>
-              <a:buChar char="•"/>
-            </a:pPr>
-            <a:r>
-              <a:rPr lang="en-US" dirty="0"/>
-              <a:t>Distributed operations</a:t>
-            </a:r>
-            <a:endParaRPr lang="en-US" dirty="0"/>
-          </a:p>
-          <a:p>
-            <a:pPr marL="457200" lvl="1" indent="-228600">
-              <a:buFont typeface="Arial"/>
-              <a:buChar char="–"/>
-            </a:pPr>
-            <a:r>
-              <a:rPr lang="en-US" dirty="0"/>
-              <a:t>One process, one SQLite file</a:t>
-            </a:r>
-            <a:endParaRPr lang="en-US" dirty="0"/>
-          </a:p>
-          <a:p>
-            <a:pPr marL="457200" lvl="1" indent="-228600">
-              <a:buFont typeface="Arial"/>
-              <a:buChar char="–"/>
-            </a:pPr>
-            <a:r>
-              <a:rPr lang="en-US" dirty="0"/>
-              <a:t>In a real bank, Domain and Application would become a backend service shared by every client (ATMs, mobile app, online banking, branch tellers)</a:t>
-            </a:r>
-            <a:endParaRPr lang="en-US" dirty="0"/>
-          </a:p>
-          <a:p>
-            <a:pPr marL="457200" lvl="1" indent="-228600">
-              <a:buFont typeface="Arial"/>
-              <a:buChar char="–"/>
-            </a:pPr>
-            <a:r>
-              <a:rPr lang="en-US" dirty="0"/>
-              <a:t>Microservices only once separate teams need to deploy independently</a:t>
-            </a:r>
-            <a:endParaRPr lang="en-US" dirty="0"/>
-          </a:p>
-          <a:p>
-            <a:endParaRPr lang="en-US" dirty="0"/>
-          </a:p>
-          <a:p>
-            <a:r>
-              <a:rPr lang="en-US" b="1" dirty="0"/>
-              <a:t>Roadmap</a:t>
-            </a:r>
-            <a:endParaRPr lang="en-US" dirty="0"/>
-          </a:p>
-          <a:p>
-            <a:pPr marL="228600" lvl="0" indent="-228600">
-              <a:buFont typeface="Arial"/>
-              <a:buChar char="•"/>
-            </a:pPr>
-            <a:r>
-              <a:rPr lang="en-US" dirty="0"/>
-              <a:t>Now</a:t>
-            </a:r>
-            <a:endParaRPr lang="en-US" dirty="0"/>
-          </a:p>
-          <a:p>
-            <a:pPr marL="457200" lvl="1" indent="-228600">
-              <a:buFont typeface="Arial"/>
-              <a:buChar char="–"/>
-            </a:pPr>
-            <a:r>
-              <a:rPr lang="en-US" dirty="0"/>
-              <a:t>Idempotency keys: a retry after a lost response repeats the operation; Post/Redirect/Get and EF Core's concurrency token cannot catch it</a:t>
-            </a:r>
-            <a:endParaRPr lang="en-US" dirty="0"/>
-          </a:p>
-          <a:p>
-            <a:pPr marL="457200" lvl="1" indent="-228600">
-              <a:buFont typeface="Arial"/>
-              <a:buChar char="–"/>
-            </a:pPr>
-            <a:r>
-              <a:rPr lang="en-US" dirty="0"/>
-              <a:t>Cross-model code review: Fable 5.1 wrote the implementation, so have a different model (GPT-6 Sol) review it; a second model does not share the author's blind spots</a:t>
-            </a:r>
-            <a:endParaRPr lang="en-US" dirty="0"/>
-          </a:p>
-          <a:p>
-            <a:pPr marL="457200" lvl="1" indent="-228600">
-              <a:buFont typeface="Arial"/>
-              <a:buChar char="–"/>
-            </a:pPr>
-            <a:r>
-              <a:rPr lang="en-US" dirty="0"/>
-              <a:t>Authentication: prerequisite for multiple users and attributable audits</a:t>
-            </a:r>
-            <a:endParaRPr lang="en-US" dirty="0"/>
-          </a:p>
-          <a:p>
-            <a:pPr marL="228600" lvl="0" indent="-228600">
-              <a:buFont typeface="Arial"/>
-              <a:buChar char="•"/>
-            </a:pPr>
-            <a:r>
-              <a:rPr lang="en-US" dirty="0"/>
-              <a:t>Next</a:t>
-            </a:r>
-            <a:endParaRPr lang="en-US" dirty="0"/>
-          </a:p>
-          <a:p>
-            <a:pPr marL="457200" lvl="1" indent="-228600">
-              <a:buFont typeface="Arial"/>
-              <a:buChar char="–"/>
-            </a:pPr>
-            <a:r>
-              <a:rPr lang="en-US" dirty="0"/>
-              <a:t>Accessibility: screen-reader testing, axe or Lighthouse in CI</a:t>
-            </a:r>
-            <a:endParaRPr lang="en-US" dirty="0"/>
-          </a:p>
-          <a:p>
-            <a:pPr marL="685800" lvl="2" indent="-228600">
-              <a:buFont typeface="Arial"/>
-              <a:buChar char="–"/>
-            </a:pPr>
-            <a:r>
-              <a:rPr lang="en-US" dirty="0"/>
-              <a:t>Known gap: with JavaScript on, Tab cannot reach the Withdraw and Transfer tabs (in BACKLOG.md)</a:t>
-            </a:r>
-            <a:endParaRPr lang="en-US" dirty="0"/>
-          </a:p>
-          <a:p>
-            <a:pPr marL="457200" lvl="1" indent="-228600">
-              <a:buFont typeface="Arial"/>
-              <a:buChar char="–"/>
-            </a:pPr>
-            <a:r>
-              <a:rPr lang="en-US" dirty="0"/>
-              <a:t>Observability: structured logs, metrics, traces</a:t>
-            </a:r>
-            <a:endParaRPr lang="en-US" dirty="0"/>
-          </a:p>
-          <a:p>
-            <a:pPr marL="457200" lvl="1" indent="-228600">
-              <a:buFont typeface="Arial"/>
-              <a:buChar char="–"/>
-            </a:pPr>
-            <a:r>
-              <a:rPr lang="en-US" dirty="0"/>
-              <a:t>Load tests: find SQLite's single-writer ceiling</a:t>
-            </a:r>
-            <a:endParaRPr lang="en-US" dirty="0"/>
-          </a:p>
-          <a:p>
-            <a:pPr marL="228600" lvl="0" indent="-228600">
-              <a:buFont typeface="Arial"/>
-              <a:buChar char="•"/>
-            </a:pPr>
-            <a:r>
-              <a:rPr lang="en-US" dirty="0"/>
-              <a:t>Later</a:t>
-            </a:r>
-            <a:endParaRPr lang="en-US" dirty="0"/>
-          </a:p>
-          <a:p>
-            <a:pPr marL="457200" lvl="1" indent="-228600">
-              <a:buFont typeface="Arial"/>
-              <a:buChar char="–"/>
-            </a:pPr>
-            <a:r>
-              <a:rPr lang="en-US" dirty="0"/>
-              <a:t>Deployment: container, CI/CD, hosting</a:t>
-            </a:r>
-            <a:endParaRPr lang="en-US" dirty="0"/>
-          </a:p>
-        </p:txBody>
-      </p:sp>
-      <p:sp>
-        <p:nvSpPr>
-          <p:cNvPr id="4" name="Slide Number Placeholder 3"/>
-          <p:cNvSpPr>
-            <a:spLocks noGrp="1"/>
-          </p:cNvSpPr>
-          <p:nvPr>
-            <p:ph type="sldNum" sz="quarter" idx="10"/>
-          </p:nvPr>
-        </p:nvSpPr>
-        <p:spPr/>
-        <p:txBody>
-          <a:bodyPr/>
-          <a:lstStyle/>
-          <a:p>
-            <a:fld id="{F7021451-1387-4CA6-816F-3879F97B5CBC}" type="slidenum">
-              <a:rPr lang="en-US"/>
-              <a:t>7</a:t>
             </a:fld>
             <a:endParaRPr lang="en-US"/>
           </a:p>
@@ -5143,7 +5002,7 @@
                 <a:ea typeface="Avenir Next" pitchFamily="34" charset="-122"/>
                 <a:cs typeface="Avenir Next" pitchFamily="34" charset="-120"/>
               </a:rPr>
-              <a:t>143 tests by layer</a:t>
+              <a:t>Roadmap</a:t>
             </a:r>
             <a:endParaRPr lang="en-US" sz="3200" dirty="0"/>
           </a:p>
@@ -5157,8 +5016,8 @@
         </p:nvSpPr>
         <p:spPr>
           <a:xfrm>
-            <a:off x="585216" y="1225296"/>
-            <a:ext cx="841248" cy="475488"/>
+            <a:off x="585216" y="1188720"/>
+            <a:ext cx="2240280" cy="228600"/>
           </a:xfrm>
           <a:prstGeom prst="rect">
             <a:avLst/>
@@ -5167,14 +5026,203 @@
           <a:ln/>
         </p:spPr>
         <p:txBody>
-          <a:bodyPr wrap="square" lIns="0" tIns="0" rIns="0" bIns="0" rtlCol="0" anchor="t"/>
+          <a:bodyPr wrap="square" lIns="0" tIns="0" rIns="0" bIns="0" rtlCol="0" anchor="t">
+            <a:normAutofit/>
+          </a:bodyPr>
           <a:lstStyle/>
           <a:p>
             <a:pPr indent="0" marL="0">
               <a:buNone/>
             </a:pPr>
             <a:r>
-              <a:rPr lang="en-US" sz="3400" b="1" dirty="0">
+              <a:rPr lang="en-US" sz="1100" b="1" spc="160" kern="0" dirty="0">
+                <a:solidFill>
+                  <a:srgbClr val="F67F00"/>
+                </a:solidFill>
+                <a:latin typeface="Avenir Next" pitchFamily="34" charset="0"/>
+                <a:ea typeface="Avenir Next" pitchFamily="34" charset="-122"/>
+                <a:cs typeface="Avenir Next" pitchFamily="34" charset="-120"/>
+              </a:rPr>
+              <a:t>OMITTED</a:t>
+            </a:r>
+            <a:endParaRPr lang="en-US" sz="1100" dirty="0"/>
+          </a:p>
+        </p:txBody>
+      </p:sp>
+      <p:sp>
+        <p:nvSpPr>
+          <p:cNvPr id="6" name="Text 3"/>
+          <p:cNvSpPr txBox="1"/>
+          <p:nvPr/>
+        </p:nvSpPr>
+        <p:spPr>
+          <a:xfrm>
+            <a:off x="585216" y="1627632"/>
+            <a:ext cx="2240280" cy="320040"/>
+          </a:xfrm>
+          <a:prstGeom prst="rect">
+            <a:avLst/>
+          </a:prstGeom>
+          <a:noFill/>
+          <a:ln/>
+        </p:spPr>
+        <p:txBody>
+          <a:bodyPr wrap="square" lIns="0" tIns="0" rIns="0" bIns="0" rtlCol="0" anchor="t">
+            <a:normAutofit/>
+          </a:bodyPr>
+          <a:lstStyle/>
+          <a:p>
+            <a:pPr indent="0" marL="0">
+              <a:buNone/>
+            </a:pPr>
+            <a:r>
+              <a:rPr lang="en-US" sz="1900" b="1" dirty="0">
+                <a:solidFill>
+                  <a:srgbClr val="F5F5F5"/>
+                </a:solidFill>
+                <a:latin typeface="Avenir Next" pitchFamily="34" charset="0"/>
+                <a:ea typeface="Avenir Next" pitchFamily="34" charset="-122"/>
+                <a:cs typeface="Avenir Next" pitchFamily="34" charset="-120"/>
+              </a:rPr>
+              <a:t>Identity</a:t>
+            </a:r>
+            <a:endParaRPr lang="en-US" sz="1900" dirty="0"/>
+          </a:p>
+        </p:txBody>
+      </p:sp>
+      <p:sp>
+        <p:nvSpPr>
+          <p:cNvPr id="7" name="Text 4"/>
+          <p:cNvSpPr txBox="1"/>
+          <p:nvPr/>
+        </p:nvSpPr>
+        <p:spPr>
+          <a:xfrm>
+            <a:off x="585216" y="2286000"/>
+            <a:ext cx="2240280" cy="320040"/>
+          </a:xfrm>
+          <a:prstGeom prst="rect">
+            <a:avLst/>
+          </a:prstGeom>
+          <a:noFill/>
+          <a:ln/>
+        </p:spPr>
+        <p:txBody>
+          <a:bodyPr wrap="square" lIns="0" tIns="0" rIns="0" bIns="0" rtlCol="0" anchor="t">
+            <a:normAutofit/>
+          </a:bodyPr>
+          <a:lstStyle/>
+          <a:p>
+            <a:pPr indent="0" marL="0">
+              <a:buNone/>
+            </a:pPr>
+            <a:r>
+              <a:rPr lang="en-US" sz="1900" b="1" dirty="0">
+                <a:solidFill>
+                  <a:srgbClr val="F5F5F5"/>
+                </a:solidFill>
+                <a:latin typeface="Avenir Next" pitchFamily="34" charset="0"/>
+                <a:ea typeface="Avenir Next" pitchFamily="34" charset="-122"/>
+                <a:cs typeface="Avenir Next" pitchFamily="34" charset="-120"/>
+              </a:rPr>
+              <a:t>Banking breadth</a:t>
+            </a:r>
+            <a:endParaRPr lang="en-US" sz="1900" dirty="0"/>
+          </a:p>
+        </p:txBody>
+      </p:sp>
+      <p:sp>
+        <p:nvSpPr>
+          <p:cNvPr id="8" name="Text 5"/>
+          <p:cNvSpPr txBox="1"/>
+          <p:nvPr/>
+        </p:nvSpPr>
+        <p:spPr>
+          <a:xfrm>
+            <a:off x="585216" y="2944368"/>
+            <a:ext cx="2240280" cy="320040"/>
+          </a:xfrm>
+          <a:prstGeom prst="rect">
+            <a:avLst/>
+          </a:prstGeom>
+          <a:noFill/>
+          <a:ln/>
+        </p:spPr>
+        <p:txBody>
+          <a:bodyPr wrap="square" lIns="0" tIns="0" rIns="0" bIns="0" rtlCol="0" anchor="t">
+            <a:normAutofit/>
+          </a:bodyPr>
+          <a:lstStyle/>
+          <a:p>
+            <a:pPr indent="0" marL="0">
+              <a:buNone/>
+            </a:pPr>
+            <a:r>
+              <a:rPr lang="en-US" sz="1900" b="1" dirty="0">
+                <a:solidFill>
+                  <a:srgbClr val="F5F5F5"/>
+                </a:solidFill>
+                <a:latin typeface="Avenir Next" pitchFamily="34" charset="0"/>
+                <a:ea typeface="Avenir Next" pitchFamily="34" charset="-122"/>
+                <a:cs typeface="Avenir Next" pitchFamily="34" charset="-120"/>
+              </a:rPr>
+              <a:t>Distributed operations</a:t>
+            </a:r>
+            <a:endParaRPr lang="en-US" sz="1900" dirty="0"/>
+          </a:p>
+        </p:txBody>
+      </p:sp>
+      <p:sp>
+        <p:nvSpPr>
+          <p:cNvPr id="9" name="Shape 6"/>
+          <p:cNvSpPr/>
+          <p:nvPr/>
+        </p:nvSpPr>
+        <p:spPr>
+          <a:xfrm>
+            <a:off x="3054096" y="1179576"/>
+            <a:ext cx="0" cy="3054096"/>
+          </a:xfrm>
+          <a:prstGeom prst="line">
+            <a:avLst/>
+          </a:prstGeom>
+          <a:noFill/>
+          <a:ln w="12700">
+            <a:solidFill>
+              <a:srgbClr val="333333"/>
+            </a:solidFill>
+            <a:prstDash val="solid"/>
+          </a:ln>
+        </p:spPr>
+      </p:sp>
+      <p:sp>
+        <p:nvSpPr>
+          <p:cNvPr id="10" name="Text 7"/>
+          <p:cNvSpPr txBox="1"/>
+          <p:nvPr/>
+        </p:nvSpPr>
+        <p:spPr>
+          <a:xfrm>
+            <a:off x="3383280" y="1188720"/>
+            <a:ext cx="731520" cy="228600"/>
+          </a:xfrm>
+          <a:prstGeom prst="rect">
+            <a:avLst/>
+          </a:prstGeom>
+          <a:noFill/>
+          <a:ln/>
+        </p:spPr>
+        <p:txBody>
+          <a:bodyPr wrap="square" lIns="0" tIns="0" rIns="0" bIns="0" rtlCol="0" anchor="t">
+            <a:normAutofit/>
+          </a:bodyPr>
+          <a:lstStyle/>
+          <a:p>
+            <a:pPr indent="0" marL="0">
+              <a:buNone/>
+            </a:pPr>
+            <a:r>
+              <a:rPr lang="en-US" sz="1100" b="1" spc="160" kern="0" dirty="0">
                 <a:solidFill>
                   <a:srgbClr val="00F604"/>
                 </a:solidFill>
@@ -5182,22 +5230,22 @@
                 <a:ea typeface="Avenir Next" pitchFamily="34" charset="-122"/>
                 <a:cs typeface="Avenir Next" pitchFamily="34" charset="-120"/>
               </a:rPr>
-              <a:t>75</a:t>
-            </a:r>
-            <a:endParaRPr lang="en-US" sz="3400" dirty="0"/>
-          </a:p>
-        </p:txBody>
-      </p:sp>
-      <p:sp>
-        <p:nvSpPr>
-          <p:cNvPr id="6" name="Text 3"/>
+              <a:t>NOW</a:t>
+            </a:r>
+            <a:endParaRPr lang="en-US" sz="1100" dirty="0"/>
+          </a:p>
+        </p:txBody>
+      </p:sp>
+      <p:sp>
+        <p:nvSpPr>
+          <p:cNvPr id="11" name="Text 8"/>
           <p:cNvSpPr txBox="1"/>
           <p:nvPr/>
         </p:nvSpPr>
         <p:spPr>
           <a:xfrm>
-            <a:off x="1508760" y="1243584"/>
-            <a:ext cx="2075688" cy="256032"/>
+            <a:off x="3383280" y="1536192"/>
+            <a:ext cx="5175504" cy="475488"/>
           </a:xfrm>
           <a:prstGeom prst="rect">
             <a:avLst/>
@@ -5223,7 +5271,7 @@
                 <a:ea typeface="Avenir Next" pitchFamily="34" charset="-122"/>
                 <a:cs typeface="Avenir Next" pitchFamily="34" charset="-120"/>
               </a:rPr>
-              <a:t>Domain</a:t>
+              <a:t>Idempotency keys, cross-model review, authentication</a:t>
             </a:r>
             <a:endParaRPr lang="en-US" sz="1600" dirty="0"/>
           </a:p>
@@ -5231,14 +5279,14 @@
       </p:sp>
       <p:sp>
         <p:nvSpPr>
-          <p:cNvPr id="7" name="Text 4"/>
+          <p:cNvPr id="12" name="Text 9"/>
           <p:cNvSpPr txBox="1"/>
           <p:nvPr/>
         </p:nvSpPr>
         <p:spPr>
           <a:xfrm>
-            <a:off x="1508760" y="1572768"/>
-            <a:ext cx="2075688" cy="219456"/>
+            <a:off x="3383280" y="2167128"/>
+            <a:ext cx="731520" cy="228600"/>
           </a:xfrm>
           <a:prstGeom prst="rect">
             <a:avLst/>
@@ -5256,46 +5304,7 @@
               <a:buNone/>
             </a:pPr>
             <a:r>
-              <a:rPr lang="en-US" sz="1200" dirty="0">
-                <a:solidFill>
-                  <a:srgbClr val="A9ADB3"/>
-                </a:solidFill>
-                <a:latin typeface="Avenir Next" pitchFamily="34" charset="0"/>
-                <a:ea typeface="Avenir Next" pitchFamily="34" charset="-122"/>
-                <a:cs typeface="Avenir Next" pitchFamily="34" charset="-120"/>
-              </a:rPr>
-              <a:t>Business rules</a:t>
-            </a:r>
-            <a:endParaRPr lang="en-US" sz="1200" dirty="0"/>
-          </a:p>
-        </p:txBody>
-      </p:sp>
-      <p:sp>
-        <p:nvSpPr>
-          <p:cNvPr id="8" name="Text 5"/>
-          <p:cNvSpPr txBox="1"/>
-          <p:nvPr/>
-        </p:nvSpPr>
-        <p:spPr>
-          <a:xfrm>
-            <a:off x="585216" y="2203704"/>
-            <a:ext cx="841248" cy="475488"/>
-          </a:xfrm>
-          <a:prstGeom prst="rect">
-            <a:avLst/>
-          </a:prstGeom>
-          <a:noFill/>
-          <a:ln/>
-        </p:spPr>
-        <p:txBody>
-          <a:bodyPr wrap="square" lIns="0" tIns="0" rIns="0" bIns="0" rtlCol="0" anchor="t"/>
-          <a:lstStyle/>
-          <a:p>
-            <a:pPr indent="0" marL="0">
-              <a:buNone/>
-            </a:pPr>
-            <a:r>
-              <a:rPr lang="en-US" sz="3400" b="1" dirty="0">
+              <a:rPr lang="en-US" sz="1100" b="1" spc="160" kern="0" dirty="0">
                 <a:solidFill>
                   <a:srgbClr val="00F604"/>
                 </a:solidFill>
@@ -5303,22 +5312,22 @@
                 <a:ea typeface="Avenir Next" pitchFamily="34" charset="-122"/>
                 <a:cs typeface="Avenir Next" pitchFamily="34" charset="-120"/>
               </a:rPr>
-              <a:t>33</a:t>
-            </a:r>
-            <a:endParaRPr lang="en-US" sz="3400" dirty="0"/>
-          </a:p>
-        </p:txBody>
-      </p:sp>
-      <p:sp>
-        <p:nvSpPr>
-          <p:cNvPr id="9" name="Text 6"/>
+              <a:t>NEXT</a:t>
+            </a:r>
+            <a:endParaRPr lang="en-US" sz="1100" dirty="0"/>
+          </a:p>
+        </p:txBody>
+      </p:sp>
+      <p:sp>
+        <p:nvSpPr>
+          <p:cNvPr id="13" name="Text 10"/>
           <p:cNvSpPr txBox="1"/>
           <p:nvPr/>
         </p:nvSpPr>
         <p:spPr>
           <a:xfrm>
-            <a:off x="1508760" y="2221992"/>
-            <a:ext cx="2075688" cy="256032"/>
+            <a:off x="3383280" y="2514600"/>
+            <a:ext cx="5175504" cy="475488"/>
           </a:xfrm>
           <a:prstGeom prst="rect">
             <a:avLst/>
@@ -5344,708 +5353,7 @@
                 <a:ea typeface="Avenir Next" pitchFamily="34" charset="-122"/>
                 <a:cs typeface="Avenir Next" pitchFamily="34" charset="-120"/>
               </a:rPr>
-              <a:t>Application</a:t>
-            </a:r>
-            <a:endParaRPr lang="en-US" sz="1600" dirty="0"/>
-          </a:p>
-        </p:txBody>
-      </p:sp>
-      <p:sp>
-        <p:nvSpPr>
-          <p:cNvPr id="10" name="Text 7"/>
-          <p:cNvSpPr txBox="1"/>
-          <p:nvPr/>
-        </p:nvSpPr>
-        <p:spPr>
-          <a:xfrm>
-            <a:off x="1508760" y="2551176"/>
-            <a:ext cx="2075688" cy="219456"/>
-          </a:xfrm>
-          <a:prstGeom prst="rect">
-            <a:avLst/>
-          </a:prstGeom>
-          <a:noFill/>
-          <a:ln/>
-        </p:spPr>
-        <p:txBody>
-          <a:bodyPr wrap="square" lIns="0" tIns="0" rIns="0" bIns="0" rtlCol="0" anchor="t">
-            <a:normAutofit/>
-          </a:bodyPr>
-          <a:lstStyle/>
-          <a:p>
-            <a:pPr indent="0" marL="0">
-              <a:buNone/>
-            </a:pPr>
-            <a:r>
-              <a:rPr lang="en-US" sz="1200" dirty="0">
-                <a:solidFill>
-                  <a:srgbClr val="A9ADB3"/>
-                </a:solidFill>
-                <a:latin typeface="Avenir Next" pitchFamily="34" charset="0"/>
-                <a:ea typeface="Avenir Next" pitchFamily="34" charset="-122"/>
-                <a:cs typeface="Avenir Next" pitchFamily="34" charset="-120"/>
-              </a:rPr>
-              <a:t>Orchestration</a:t>
-            </a:r>
-            <a:endParaRPr lang="en-US" sz="1200" dirty="0"/>
-          </a:p>
-        </p:txBody>
-      </p:sp>
-      <p:sp>
-        <p:nvSpPr>
-          <p:cNvPr id="11" name="Text 8"/>
-          <p:cNvSpPr txBox="1"/>
-          <p:nvPr/>
-        </p:nvSpPr>
-        <p:spPr>
-          <a:xfrm>
-            <a:off x="585216" y="3182112"/>
-            <a:ext cx="841248" cy="475488"/>
-          </a:xfrm>
-          <a:prstGeom prst="rect">
-            <a:avLst/>
-          </a:prstGeom>
-          <a:noFill/>
-          <a:ln/>
-        </p:spPr>
-        <p:txBody>
-          <a:bodyPr wrap="square" lIns="0" tIns="0" rIns="0" bIns="0" rtlCol="0" anchor="t"/>
-          <a:lstStyle/>
-          <a:p>
-            <a:pPr indent="0" marL="0">
-              <a:buNone/>
-            </a:pPr>
-            <a:r>
-              <a:rPr lang="en-US" sz="3400" b="1" dirty="0">
-                <a:solidFill>
-                  <a:srgbClr val="00F604"/>
-                </a:solidFill>
-                <a:latin typeface="Avenir Next" pitchFamily="34" charset="0"/>
-                <a:ea typeface="Avenir Next" pitchFamily="34" charset="-122"/>
-                <a:cs typeface="Avenir Next" pitchFamily="34" charset="-120"/>
-              </a:rPr>
-              <a:t>35</a:t>
-            </a:r>
-            <a:endParaRPr lang="en-US" sz="3400" dirty="0"/>
-          </a:p>
-        </p:txBody>
-      </p:sp>
-      <p:sp>
-        <p:nvSpPr>
-          <p:cNvPr id="12" name="Text 9"/>
-          <p:cNvSpPr txBox="1"/>
-          <p:nvPr/>
-        </p:nvSpPr>
-        <p:spPr>
-          <a:xfrm>
-            <a:off x="1508760" y="3200400"/>
-            <a:ext cx="2075688" cy="256032"/>
-          </a:xfrm>
-          <a:prstGeom prst="rect">
-            <a:avLst/>
-          </a:prstGeom>
-          <a:noFill/>
-          <a:ln/>
-        </p:spPr>
-        <p:txBody>
-          <a:bodyPr wrap="square" lIns="0" tIns="0" rIns="0" bIns="0" rtlCol="0" anchor="t">
-            <a:normAutofit/>
-          </a:bodyPr>
-          <a:lstStyle/>
-          <a:p>
-            <a:pPr indent="0" marL="0">
-              <a:buNone/>
-            </a:pPr>
-            <a:r>
-              <a:rPr lang="en-US" sz="1600" b="1" dirty="0">
-                <a:solidFill>
-                  <a:srgbClr val="F5F5F5"/>
-                </a:solidFill>
-                <a:latin typeface="Avenir Next" pitchFamily="34" charset="0"/>
-                <a:ea typeface="Avenir Next" pitchFamily="34" charset="-122"/>
-                <a:cs typeface="Avenir Next" pitchFamily="34" charset="-120"/>
-              </a:rPr>
-              <a:t>Integration + HTTP</a:t>
-            </a:r>
-            <a:endParaRPr lang="en-US" sz="1600" dirty="0"/>
-          </a:p>
-        </p:txBody>
-      </p:sp>
-      <p:sp>
-        <p:nvSpPr>
-          <p:cNvPr id="13" name="Text 10"/>
-          <p:cNvSpPr txBox="1"/>
-          <p:nvPr/>
-        </p:nvSpPr>
-        <p:spPr>
-          <a:xfrm>
-            <a:off x="1508760" y="3529584"/>
-            <a:ext cx="2075688" cy="219456"/>
-          </a:xfrm>
-          <a:prstGeom prst="rect">
-            <a:avLst/>
-          </a:prstGeom>
-          <a:noFill/>
-          <a:ln/>
-        </p:spPr>
-        <p:txBody>
-          <a:bodyPr wrap="square" lIns="0" tIns="0" rIns="0" bIns="0" rtlCol="0" anchor="t">
-            <a:normAutofit/>
-          </a:bodyPr>
-          <a:lstStyle/>
-          <a:p>
-            <a:pPr indent="0" marL="0">
-              <a:buNone/>
-            </a:pPr>
-            <a:r>
-              <a:rPr lang="en-US" sz="1200" dirty="0">
-                <a:solidFill>
-                  <a:srgbClr val="A9ADB3"/>
-                </a:solidFill>
-                <a:latin typeface="Avenir Next" pitchFamily="34" charset="0"/>
-                <a:ea typeface="Avenir Next" pitchFamily="34" charset="-122"/>
-                <a:cs typeface="Avenir Next" pitchFamily="34" charset="-120"/>
-              </a:rPr>
-              <a:t>Persistence and HTTP</a:t>
-            </a:r>
-            <a:endParaRPr lang="en-US" sz="1200" dirty="0"/>
-          </a:p>
-        </p:txBody>
-      </p:sp>
-      <p:sp>
-        <p:nvSpPr>
-          <p:cNvPr id="14" name="Shape 11"/>
-          <p:cNvSpPr/>
-          <p:nvPr/>
-        </p:nvSpPr>
-        <p:spPr>
-          <a:xfrm>
-            <a:off x="4800600" y="1115568"/>
-            <a:ext cx="3758184" cy="2926080"/>
-          </a:xfrm>
-          <a:prstGeom prst="rect">
-            <a:avLst/>
-          </a:prstGeom>
-          <a:solidFill>
-            <a:srgbClr val="1B1B1B"/>
-          </a:solidFill>
-          <a:ln w="10160">
-            <a:solidFill>
-              <a:srgbClr val="333333"/>
-            </a:solidFill>
-            <a:prstDash val="solid"/>
-          </a:ln>
-        </p:spPr>
-      </p:sp>
-      <p:pic>
-        <p:nvPicPr>
-          <p:cNvPr id="15" name="Image 0" descr="/Users/john/theborg/repos/atm/design/screenshots/receipt.png">    </p:cNvPr>
-          <p:cNvPicPr>
-            <a:picLocks noChangeAspect="1"/>
-          </p:cNvPicPr>
-          <p:nvPr/>
-        </p:nvPicPr>
-        <p:blipFill>
-          <a:blip r:embed="rId1"/>
-          <a:stretch>
-            <a:fillRect/>
-          </a:stretch>
-        </p:blipFill>
-        <p:spPr>
-          <a:xfrm>
-            <a:off x="4837176" y="1152144"/>
-            <a:ext cx="3685032" cy="2852928"/>
-          </a:xfrm>
-          <a:prstGeom prst="rect">
-            <a:avLst/>
-          </a:prstGeom>
-        </p:spPr>
-      </p:pic>
-      <p:sp>
-        <p:nvSpPr>
-          <p:cNvPr id="16" name="Text 12"/>
-          <p:cNvSpPr txBox="1"/>
-          <p:nvPr/>
-        </p:nvSpPr>
-        <p:spPr>
-          <a:xfrm>
-            <a:off x="4800600" y="4187952"/>
-            <a:ext cx="3758184" cy="219456"/>
-          </a:xfrm>
-          <a:prstGeom prst="rect">
-            <a:avLst/>
-          </a:prstGeom>
-          <a:noFill/>
-          <a:ln/>
-        </p:spPr>
-        <p:txBody>
-          <a:bodyPr wrap="square" lIns="0" tIns="0" rIns="0" bIns="0" rtlCol="0" anchor="t"/>
-          <a:lstStyle/>
-          <a:p>
-            <a:pPr algn="r" indent="0" marL="0">
-              <a:buNone/>
-            </a:pPr>
-            <a:r>
-              <a:rPr lang="en-US" sz="1200" dirty="0">
-                <a:solidFill>
-                  <a:srgbClr val="00F604"/>
-                </a:solidFill>
-                <a:latin typeface="Avenir Next" pitchFamily="34" charset="0"/>
-                <a:ea typeface="Avenir Next" pitchFamily="34" charset="-122"/>
-                <a:cs typeface="Avenir Next" pitchFamily="34" charset="-120"/>
-              </a:rPr>
-              <a:t>Deposit confirmed. Refreshing won’t repeat it.</a:t>
-            </a:r>
-            <a:endParaRPr lang="en-US" sz="1200" dirty="0"/>
-          </a:p>
-        </p:txBody>
-      </p:sp>
-    </p:spTree>
-  </p:cSld>
-  <p:clrMapOvr>
-    <a:masterClrMapping/>
-  </p:clrMapOvr>
-</p:sld>
-</file>
-
-<file path=ppt/slides/slide7.xml><?xml version="1.0" encoding="utf-8"?>
-<p:sld xmlns:a="http://schemas.openxmlformats.org/drawingml/2006/main" xmlns:r="http://schemas.openxmlformats.org/officeDocument/2006/relationships" xmlns:p="http://schemas.openxmlformats.org/presentationml/2006/main">
-  <p:cSld name="Slide 7">
-    <p:bg>
-      <p:bgPr>
-        <a:solidFill>
-          <a:srgbClr val="121212"/>
-        </a:solidFill>
-      </p:bgPr>
-    </p:bg>
-    <p:spTree>
-      <p:nvGrpSpPr>
-        <p:cNvPr id="1" name=""/>
-        <p:cNvGrpSpPr/>
-        <p:nvPr/>
-      </p:nvGrpSpPr>
-      <p:grpSpPr>
-        <a:xfrm>
-          <a:off x="0" y="0"/>
-          <a:ext cx="0" cy="0"/>
-          <a:chOff x="0" y="0"/>
-          <a:chExt cx="0" cy="0"/>
-        </a:xfrm>
-      </p:grpSpPr>
-      <p:sp>
-        <p:nvSpPr>
-          <p:cNvPr id="2" name="Shape 0"/>
-          <p:cNvSpPr/>
-          <p:nvPr/>
-        </p:nvSpPr>
-        <p:spPr>
-          <a:xfrm>
-            <a:off x="585216" y="356616"/>
-            <a:ext cx="91440" cy="438912"/>
-          </a:xfrm>
-          <a:prstGeom prst="rect">
-            <a:avLst/>
-          </a:prstGeom>
-          <a:solidFill>
-            <a:srgbClr val="00F604"/>
-          </a:solidFill>
-          <a:ln w="12700">
-            <a:solidFill>
-              <a:srgbClr val="00F604">
-                <a:alpha val="0"/>
-              </a:srgbClr>
-            </a:solidFill>
-            <a:prstDash val="solid"/>
-          </a:ln>
-        </p:spPr>
-      </p:sp>
-      <p:sp>
-        <p:nvSpPr>
-          <p:cNvPr id="3" name="Text 1"/>
-          <p:cNvSpPr txBox="1"/>
-          <p:nvPr/>
-        </p:nvSpPr>
-        <p:spPr>
-          <a:xfrm>
-            <a:off x="832104" y="356616"/>
-            <a:ext cx="7726680" cy="512064"/>
-          </a:xfrm>
-          <a:prstGeom prst="rect">
-            <a:avLst/>
-          </a:prstGeom>
-          <a:noFill/>
-          <a:ln/>
-        </p:spPr>
-        <p:txBody>
-          <a:bodyPr wrap="square" lIns="0" tIns="0" rIns="0" bIns="0" rtlCol="0" anchor="t">
-            <a:normAutofit/>
-          </a:bodyPr>
-          <a:lstStyle/>
-          <a:p>
-            <a:pPr indent="0" marL="0">
-              <a:buNone/>
-            </a:pPr>
-            <a:r>
-              <a:rPr lang="en-US" sz="3200" b="1" dirty="0">
-                <a:solidFill>
-                  <a:srgbClr val="F5F5F5"/>
-                </a:solidFill>
-                <a:latin typeface="Avenir Next" pitchFamily="34" charset="0"/>
-                <a:ea typeface="Avenir Next" pitchFamily="34" charset="-122"/>
-                <a:cs typeface="Avenir Next" pitchFamily="34" charset="-120"/>
-              </a:rPr>
-              <a:t>Roadmap</a:t>
-            </a:r>
-            <a:endParaRPr lang="en-US" sz="3200" dirty="0"/>
-          </a:p>
-        </p:txBody>
-      </p:sp>
-      <p:sp>
-        <p:nvSpPr>
-          <p:cNvPr id="5" name="Text 2"/>
-          <p:cNvSpPr txBox="1"/>
-          <p:nvPr/>
-        </p:nvSpPr>
-        <p:spPr>
-          <a:xfrm>
-            <a:off x="585216" y="1188720"/>
-            <a:ext cx="2240280" cy="228600"/>
-          </a:xfrm>
-          <a:prstGeom prst="rect">
-            <a:avLst/>
-          </a:prstGeom>
-          <a:noFill/>
-          <a:ln/>
-        </p:spPr>
-        <p:txBody>
-          <a:bodyPr wrap="square" lIns="0" tIns="0" rIns="0" bIns="0" rtlCol="0" anchor="t">
-            <a:normAutofit/>
-          </a:bodyPr>
-          <a:lstStyle/>
-          <a:p>
-            <a:pPr indent="0" marL="0">
-              <a:buNone/>
-            </a:pPr>
-            <a:r>
-              <a:rPr lang="en-US" sz="1100" b="1" spc="160" kern="0" dirty="0">
-                <a:solidFill>
-                  <a:srgbClr val="F67F00"/>
-                </a:solidFill>
-                <a:latin typeface="Avenir Next" pitchFamily="34" charset="0"/>
-                <a:ea typeface="Avenir Next" pitchFamily="34" charset="-122"/>
-                <a:cs typeface="Avenir Next" pitchFamily="34" charset="-120"/>
-              </a:rPr>
-              <a:t>OMITTED</a:t>
-            </a:r>
-            <a:endParaRPr lang="en-US" sz="1100" dirty="0"/>
-          </a:p>
-        </p:txBody>
-      </p:sp>
-      <p:sp>
-        <p:nvSpPr>
-          <p:cNvPr id="6" name="Text 3"/>
-          <p:cNvSpPr txBox="1"/>
-          <p:nvPr/>
-        </p:nvSpPr>
-        <p:spPr>
-          <a:xfrm>
-            <a:off x="585216" y="1627632"/>
-            <a:ext cx="2240280" cy="320040"/>
-          </a:xfrm>
-          <a:prstGeom prst="rect">
-            <a:avLst/>
-          </a:prstGeom>
-          <a:noFill/>
-          <a:ln/>
-        </p:spPr>
-        <p:txBody>
-          <a:bodyPr wrap="square" lIns="0" tIns="0" rIns="0" bIns="0" rtlCol="0" anchor="t">
-            <a:normAutofit/>
-          </a:bodyPr>
-          <a:lstStyle/>
-          <a:p>
-            <a:pPr indent="0" marL="0">
-              <a:buNone/>
-            </a:pPr>
-            <a:r>
-              <a:rPr lang="en-US" sz="1900" b="1" dirty="0">
-                <a:solidFill>
-                  <a:srgbClr val="F5F5F5"/>
-                </a:solidFill>
-                <a:latin typeface="Avenir Next" pitchFamily="34" charset="0"/>
-                <a:ea typeface="Avenir Next" pitchFamily="34" charset="-122"/>
-                <a:cs typeface="Avenir Next" pitchFamily="34" charset="-120"/>
-              </a:rPr>
-              <a:t>Identity</a:t>
-            </a:r>
-            <a:endParaRPr lang="en-US" sz="1900" dirty="0"/>
-          </a:p>
-        </p:txBody>
-      </p:sp>
-      <p:sp>
-        <p:nvSpPr>
-          <p:cNvPr id="7" name="Text 4"/>
-          <p:cNvSpPr txBox="1"/>
-          <p:nvPr/>
-        </p:nvSpPr>
-        <p:spPr>
-          <a:xfrm>
-            <a:off x="585216" y="2286000"/>
-            <a:ext cx="2240280" cy="320040"/>
-          </a:xfrm>
-          <a:prstGeom prst="rect">
-            <a:avLst/>
-          </a:prstGeom>
-          <a:noFill/>
-          <a:ln/>
-        </p:spPr>
-        <p:txBody>
-          <a:bodyPr wrap="square" lIns="0" tIns="0" rIns="0" bIns="0" rtlCol="0" anchor="t">
-            <a:normAutofit/>
-          </a:bodyPr>
-          <a:lstStyle/>
-          <a:p>
-            <a:pPr indent="0" marL="0">
-              <a:buNone/>
-            </a:pPr>
-            <a:r>
-              <a:rPr lang="en-US" sz="1900" b="1" dirty="0">
-                <a:solidFill>
-                  <a:srgbClr val="F5F5F5"/>
-                </a:solidFill>
-                <a:latin typeface="Avenir Next" pitchFamily="34" charset="0"/>
-                <a:ea typeface="Avenir Next" pitchFamily="34" charset="-122"/>
-                <a:cs typeface="Avenir Next" pitchFamily="34" charset="-120"/>
-              </a:rPr>
-              <a:t>Banking breadth</a:t>
-            </a:r>
-            <a:endParaRPr lang="en-US" sz="1900" dirty="0"/>
-          </a:p>
-        </p:txBody>
-      </p:sp>
-      <p:sp>
-        <p:nvSpPr>
-          <p:cNvPr id="8" name="Text 5"/>
-          <p:cNvSpPr txBox="1"/>
-          <p:nvPr/>
-        </p:nvSpPr>
-        <p:spPr>
-          <a:xfrm>
-            <a:off x="585216" y="2944368"/>
-            <a:ext cx="2240280" cy="320040"/>
-          </a:xfrm>
-          <a:prstGeom prst="rect">
-            <a:avLst/>
-          </a:prstGeom>
-          <a:noFill/>
-          <a:ln/>
-        </p:spPr>
-        <p:txBody>
-          <a:bodyPr wrap="square" lIns="0" tIns="0" rIns="0" bIns="0" rtlCol="0" anchor="t">
-            <a:normAutofit/>
-          </a:bodyPr>
-          <a:lstStyle/>
-          <a:p>
-            <a:pPr indent="0" marL="0">
-              <a:buNone/>
-            </a:pPr>
-            <a:r>
-              <a:rPr lang="en-US" sz="1900" b="1" dirty="0">
-                <a:solidFill>
-                  <a:srgbClr val="F5F5F5"/>
-                </a:solidFill>
-                <a:latin typeface="Avenir Next" pitchFamily="34" charset="0"/>
-                <a:ea typeface="Avenir Next" pitchFamily="34" charset="-122"/>
-                <a:cs typeface="Avenir Next" pitchFamily="34" charset="-120"/>
-              </a:rPr>
-              <a:t>Distributed operations</a:t>
-            </a:r>
-            <a:endParaRPr lang="en-US" sz="1900" dirty="0"/>
-          </a:p>
-        </p:txBody>
-      </p:sp>
-      <p:sp>
-        <p:nvSpPr>
-          <p:cNvPr id="9" name="Shape 6"/>
-          <p:cNvSpPr/>
-          <p:nvPr/>
-        </p:nvSpPr>
-        <p:spPr>
-          <a:xfrm>
-            <a:off x="3054096" y="1179576"/>
-            <a:ext cx="0" cy="3054096"/>
-          </a:xfrm>
-          <a:prstGeom prst="line">
-            <a:avLst/>
-          </a:prstGeom>
-          <a:noFill/>
-          <a:ln w="12700">
-            <a:solidFill>
-              <a:srgbClr val="333333"/>
-            </a:solidFill>
-            <a:prstDash val="solid"/>
-          </a:ln>
-        </p:spPr>
-      </p:sp>
-      <p:sp>
-        <p:nvSpPr>
-          <p:cNvPr id="10" name="Text 7"/>
-          <p:cNvSpPr txBox="1"/>
-          <p:nvPr/>
-        </p:nvSpPr>
-        <p:spPr>
-          <a:xfrm>
-            <a:off x="3383280" y="1188720"/>
-            <a:ext cx="731520" cy="228600"/>
-          </a:xfrm>
-          <a:prstGeom prst="rect">
-            <a:avLst/>
-          </a:prstGeom>
-          <a:noFill/>
-          <a:ln/>
-        </p:spPr>
-        <p:txBody>
-          <a:bodyPr wrap="square" lIns="0" tIns="0" rIns="0" bIns="0" rtlCol="0" anchor="t">
-            <a:normAutofit/>
-          </a:bodyPr>
-          <a:lstStyle/>
-          <a:p>
-            <a:pPr indent="0" marL="0">
-              <a:buNone/>
-            </a:pPr>
-            <a:r>
-              <a:rPr lang="en-US" sz="1100" b="1" spc="160" kern="0" dirty="0">
-                <a:solidFill>
-                  <a:srgbClr val="00F604"/>
-                </a:solidFill>
-                <a:latin typeface="Avenir Next" pitchFamily="34" charset="0"/>
-                <a:ea typeface="Avenir Next" pitchFamily="34" charset="-122"/>
-                <a:cs typeface="Avenir Next" pitchFamily="34" charset="-120"/>
-              </a:rPr>
-              <a:t>NOW</a:t>
-            </a:r>
-            <a:endParaRPr lang="en-US" sz="1100" dirty="0"/>
-          </a:p>
-        </p:txBody>
-      </p:sp>
-      <p:sp>
-        <p:nvSpPr>
-          <p:cNvPr id="11" name="Text 8"/>
-          <p:cNvSpPr txBox="1"/>
-          <p:nvPr/>
-        </p:nvSpPr>
-        <p:spPr>
-          <a:xfrm>
-            <a:off x="3383280" y="1536192"/>
-            <a:ext cx="5175504" cy="475488"/>
-          </a:xfrm>
-          <a:prstGeom prst="rect">
-            <a:avLst/>
-          </a:prstGeom>
-          <a:noFill/>
-          <a:ln/>
-        </p:spPr>
-        <p:txBody>
-          <a:bodyPr wrap="square" lIns="0" tIns="0" rIns="0" bIns="0" rtlCol="0" anchor="t">
-            <a:normAutofit/>
-          </a:bodyPr>
-          <a:lstStyle/>
-          <a:p>
-            <a:pPr indent="0" marL="0">
-              <a:buNone/>
-            </a:pPr>
-            <a:r>
-              <a:rPr lang="en-US" sz="1600" b="1" dirty="0">
-                <a:solidFill>
-                  <a:srgbClr val="F5F5F5"/>
-                </a:solidFill>
-                <a:latin typeface="Avenir Next" pitchFamily="34" charset="0"/>
-                <a:ea typeface="Avenir Next" pitchFamily="34" charset="-122"/>
-                <a:cs typeface="Avenir Next" pitchFamily="34" charset="-120"/>
-              </a:rPr>
-              <a:t>Idempotency keys, cross-model review, authentication</a:t>
-            </a:r>
-            <a:endParaRPr lang="en-US" sz="1600" dirty="0"/>
-          </a:p>
-        </p:txBody>
-      </p:sp>
-      <p:sp>
-        <p:nvSpPr>
-          <p:cNvPr id="12" name="Text 9"/>
-          <p:cNvSpPr txBox="1"/>
-          <p:nvPr/>
-        </p:nvSpPr>
-        <p:spPr>
-          <a:xfrm>
-            <a:off x="3383280" y="2167128"/>
-            <a:ext cx="731520" cy="228600"/>
-          </a:xfrm>
-          <a:prstGeom prst="rect">
-            <a:avLst/>
-          </a:prstGeom>
-          <a:noFill/>
-          <a:ln/>
-        </p:spPr>
-        <p:txBody>
-          <a:bodyPr wrap="square" lIns="0" tIns="0" rIns="0" bIns="0" rtlCol="0" anchor="t">
-            <a:normAutofit/>
-          </a:bodyPr>
-          <a:lstStyle/>
-          <a:p>
-            <a:pPr indent="0" marL="0">
-              <a:buNone/>
-            </a:pPr>
-            <a:r>
-              <a:rPr lang="en-US" sz="1100" b="1" spc="160" kern="0" dirty="0">
-                <a:solidFill>
-                  <a:srgbClr val="00F604"/>
-                </a:solidFill>
-                <a:latin typeface="Avenir Next" pitchFamily="34" charset="0"/>
-                <a:ea typeface="Avenir Next" pitchFamily="34" charset="-122"/>
-                <a:cs typeface="Avenir Next" pitchFamily="34" charset="-120"/>
-              </a:rPr>
-              <a:t>NEXT</a:t>
-            </a:r>
-            <a:endParaRPr lang="en-US" sz="1100" dirty="0"/>
-          </a:p>
-        </p:txBody>
-      </p:sp>
-      <p:sp>
-        <p:nvSpPr>
-          <p:cNvPr id="13" name="Text 10"/>
-          <p:cNvSpPr txBox="1"/>
-          <p:nvPr/>
-        </p:nvSpPr>
-        <p:spPr>
-          <a:xfrm>
-            <a:off x="3383280" y="2514600"/>
-            <a:ext cx="5175504" cy="475488"/>
-          </a:xfrm>
-          <a:prstGeom prst="rect">
-            <a:avLst/>
-          </a:prstGeom>
-          <a:noFill/>
-          <a:ln/>
-        </p:spPr>
-        <p:txBody>
-          <a:bodyPr wrap="square" lIns="0" tIns="0" rIns="0" bIns="0" rtlCol="0" anchor="t">
-            <a:normAutofit/>
-          </a:bodyPr>
-          <a:lstStyle/>
-          <a:p>
-            <a:pPr indent="0" marL="0">
-              <a:buNone/>
-            </a:pPr>
-            <a:r>
-              <a:rPr lang="en-US" sz="1600" b="1" dirty="0">
-                <a:solidFill>
-                  <a:srgbClr val="F5F5F5"/>
-                </a:solidFill>
-                <a:latin typeface="Avenir Next" pitchFamily="34" charset="0"/>
-                <a:ea typeface="Avenir Next" pitchFamily="34" charset="-122"/>
-                <a:cs typeface="Avenir Next" pitchFamily="34" charset="-120"/>
-              </a:rPr>
-              <a:t>Accessibility, observability, load tests</a:t>
+              <a:t>Accessibility, observability</a:t>
             </a:r>
             <a:endParaRPr lang="en-US" sz="1600" dirty="0"/>
           </a:p>

</xml_diff>

<commit_message>
Add a "Best framework for the model" slide and port hand edits
Slide 5 ranks ASP.NET Core, Django, Spring Boot, and Node.js by how soon
LLM mistakes surface, with pro/con notes. Carries over PowerPoint edits to
slides 1-3 (dropped kicker, rewritten notes) and adds inline **bold** to
the notes renderer.

Co-Authored-By: Claude Opus 5.5 <noreply@anthropic.com>
</commit_message>
<xml_diff>
--- a/design/atm-deck.pptx
+++ b/design/atm-deck.pptx
@@ -11,9 +11,10 @@
     <p:sldId id="259" r:id="rId5"/>
     <p:sldId id="260" r:id="rId6"/>
     <p:sldId id="261" r:id="rId7"/>
+    <p:sldId id="262" r:id="rId8"/>
   </p:sldIdLst>
   <p:notesMasterIdLst>
-    <p:notesMasterId r:id="rId8"/>
+    <p:notesMasterId r:id="rId9"/>
   </p:notesMasterIdLst>
   <p:sldSz cx="9144000" cy="5143500"/>
   <p:notesSz cx="7772400" cy="10058400"/>
@@ -507,7 +508,27 @@
           <a:p>
             <a:r>
               <a:rPr lang="en-US" dirty="0"/>
-              <a:t>Open with the finished product, running against a scratch SQLite database. The intentionally narrow scope keeps the review on correctness, architectural boundaries, and evidence. The hint points at an opt-in easter egg: the Konami code (up, up, down, down, left, right, left, right, B, A) toggles a Matrix theme; Esc, the blue pill, or the code again exits it.</a:t>
+              <a:t>Runs against a scratch SQLite database.</a:t>
+            </a:r>
+            <a:endParaRPr lang="en-US" dirty="0"/>
+          </a:p>
+          <a:p>
+            <a:endParaRPr lang="en-US" dirty="0"/>
+          </a:p>
+          <a:p>
+            <a:r>
+              <a:rPr lang="en-US" dirty="0"/>
+              <a:t>The intentionally narrow scope keeps the review on correctness, architectural boundaries, and evidence.</a:t>
+            </a:r>
+            <a:endParaRPr lang="en-US" dirty="0"/>
+          </a:p>
+          <a:p>
+            <a:endParaRPr lang="en-US" dirty="0"/>
+          </a:p>
+          <a:p>
+            <a:r>
+              <a:rPr lang="en-US" dirty="0"/>
+              <a:t>The Konami code is up, up, down, down, left, right, left, right, B, A.</a:t>
             </a:r>
             <a:endParaRPr lang="en-US" dirty="0"/>
           </a:p>
@@ -595,7 +616,7 @@
           <a:p>
             <a:r>
               <a:rPr lang="en-US" dirty="0"/>
-              <a:t>No client-side framework or npm packages ship with the app.</a:t>
+              <a:t>Minimal dependencies: no client-side framework or npm packages.</a:t>
             </a:r>
             <a:endParaRPr lang="en-US" dirty="0"/>
           </a:p>
@@ -726,98 +747,150 @@
           <a:lstStyle/>
           <a:p>
             <a:r>
-              <a:rPr lang="en-US" dirty="0"/>
-              <a:t>The </a:t>
-            </a:r>
-            <a:r>
-              <a:rPr lang="en-US" dirty="0">
+              <a:rPr lang="en-US" b="1" dirty="0"/>
+              <a:t>Razor Pages (</a:t>
+            </a:r>
+            <a:r>
+              <a:rPr lang="en-US" b="1" dirty="0">
                 <a:hlinkClick r:id="rId3"/>
               </a:rPr>
-              <a:t>ADRs</a:t>
-            </a:r>
-            <a:r>
-              <a:rPr lang="en-US" dirty="0"/>
-              <a:t> explain why each choice fits the exercise.</a:t>
-            </a:r>
-            <a:endParaRPr lang="en-US" dirty="0"/>
-          </a:p>
-          <a:p>
-            <a:endParaRPr lang="en-US" dirty="0"/>
-          </a:p>
-          <a:p>
-            <a:r>
-              <a:rPr lang="en-US" dirty="0"/>
-              <a:t>Razor Pages (</a:t>
-            </a:r>
-            <a:r>
-              <a:rPr lang="en-US" dirty="0">
+              <a:t>ADR-0001</a:t>
+            </a:r>
+            <a:r>
+              <a:rPr lang="en-US" b="1" dirty="0"/>
+              <a:t>)</a:t>
+            </a:r>
+            <a:endParaRPr lang="en-US" dirty="0"/>
+          </a:p>
+          <a:p>
+            <a:r>
+              <a:rPr lang="en-US" b="1" dirty="0"/>
+              <a:t>Cost</a:t>
+            </a:r>
+            <a:r>
+              <a:rPr lang="en-US" dirty="0"/>
+              <a:t>: a full page reload per action.</a:t>
+            </a:r>
+            <a:endParaRPr lang="en-US" dirty="0"/>
+          </a:p>
+          <a:p>
+            <a:r>
+              <a:rPr lang="en-US" dirty="0"/>
+              <a:t>The server renders HTML with minimal JavaScript, so the whole app is written in C# and ships as a single unit. A separate JavaScript front end (e.g., a React single-page app) would add its own npm build and a JSON API for the browser to call, because the browser would fetch data instead of receiving finished pages.</a:t>
+            </a:r>
+            <a:endParaRPr lang="en-US" dirty="0"/>
+          </a:p>
+          <a:p>
+            <a:endParaRPr lang="en-US" dirty="0"/>
+          </a:p>
+          <a:p>
+            <a:r>
+              <a:rPr lang="en-US" b="1" dirty="0"/>
+              <a:t>Modular monolith (</a:t>
+            </a:r>
+            <a:r>
+              <a:rPr lang="en-US" b="1" dirty="0">
                 <a:hlinkClick r:id="rId4"/>
               </a:rPr>
-              <a:t>ADR-0001</a:t>
-            </a:r>
-            <a:r>
-              <a:rPr lang="en-US" dirty="0"/>
-              <a:t>). Cost: a full page reload per action. The server renders HTML with minimal JavaScript, so the whole app is written in C# and ships as a single unit. A separate JavaScript front end (e.g., a React single-page app) would add its own npm build and a JSON API for the browser to call, because the browser would fetch data instead of receiving finished pages.</a:t>
-            </a:r>
-            <a:endParaRPr lang="en-US" dirty="0"/>
-          </a:p>
-          <a:p>
-            <a:endParaRPr lang="en-US" dirty="0"/>
-          </a:p>
-          <a:p>
-            <a:r>
-              <a:rPr lang="en-US" dirty="0"/>
-              <a:t>Modular monolith (</a:t>
-            </a:r>
-            <a:r>
-              <a:rPr lang="en-US" dirty="0">
+              <a:t>ADR-0002</a:t>
+            </a:r>
+            <a:r>
+              <a:rPr lang="en-US" b="1" dirty="0"/>
+              <a:t>)</a:t>
+            </a:r>
+            <a:endParaRPr lang="en-US" dirty="0"/>
+          </a:p>
+          <a:p>
+            <a:r>
+              <a:rPr lang="en-US" b="1" dirty="0"/>
+              <a:t>Cost</a:t>
+            </a:r>
+            <a:r>
+              <a:rPr lang="en-US" dirty="0"/>
+              <a:t>: one feature spans four projects, so adding a transaction type touches Domain, Application, Infrastructure, and Web.</a:t>
+            </a:r>
+            <a:endParaRPr lang="en-US" dirty="0"/>
+          </a:p>
+          <a:p>
+            <a:r>
+              <a:rPr lang="en-US" dirty="0"/>
+              <a:t>The payoff is that business rules can be tested without the web host or the database. Microservices would add operational complexity with no payoff at this scope.</a:t>
+            </a:r>
+            <a:endParaRPr lang="en-US" dirty="0"/>
+          </a:p>
+          <a:p>
+            <a:endParaRPr lang="en-US" dirty="0"/>
+          </a:p>
+          <a:p>
+            <a:r>
+              <a:rPr lang="en-US" b="1" dirty="0"/>
+              <a:t>SQLite + EF Core (</a:t>
+            </a:r>
+            <a:r>
+              <a:rPr lang="en-US" b="1" dirty="0">
                 <a:hlinkClick r:id="rId5"/>
               </a:rPr>
-              <a:t>ADR-0002</a:t>
-            </a:r>
-            <a:r>
-              <a:rPr lang="en-US" dirty="0"/>
-              <a:t>). Cost: one feature spans four projects, so adding a transaction type touches Domain, Application, Infrastructure, and Web. The payoff is that business rules can be tested without the web host or the database. Microservices would add operational complexity with no payoff at this scope.</a:t>
-            </a:r>
-            <a:endParaRPr lang="en-US" dirty="0"/>
-          </a:p>
-          <a:p>
-            <a:endParaRPr lang="en-US" dirty="0"/>
-          </a:p>
-          <a:p>
-            <a:r>
-              <a:rPr lang="en-US" dirty="0"/>
-              <a:t>SQLite + EF Core (</a:t>
-            </a:r>
-            <a:r>
-              <a:rPr lang="en-US" dirty="0">
+              <a:t>ADR-0003</a:t>
+            </a:r>
+            <a:r>
+              <a:rPr lang="en-US" b="1" dirty="0"/>
+              <a:t>)</a:t>
+            </a:r>
+            <a:endParaRPr lang="en-US" dirty="0"/>
+          </a:p>
+          <a:p>
+            <a:r>
+              <a:rPr lang="en-US" b="1" dirty="0"/>
+              <a:t>Cost</a:t>
+            </a:r>
+            <a:r>
+              <a:rPr lang="en-US" dirty="0"/>
+              <a:t>: single-writer ceiling.</a:t>
+            </a:r>
+            <a:endParaRPr lang="en-US" dirty="0"/>
+          </a:p>
+          <a:p>
+            <a:r>
+              <a:rPr lang="en-US" dirty="0"/>
+              <a:t>A server database is the upgrade path if concurrent load ever matters. The next slide covers the datastore choice.</a:t>
+            </a:r>
+            <a:endParaRPr lang="en-US" dirty="0"/>
+          </a:p>
+          <a:p>
+            <a:endParaRPr lang="en-US" dirty="0"/>
+          </a:p>
+          <a:p>
+            <a:r>
+              <a:rPr lang="en-US" b="1" dirty="0"/>
+              <a:t>2-decimal USD (</a:t>
+            </a:r>
+            <a:r>
+              <a:rPr lang="en-US" b="1" dirty="0">
                 <a:hlinkClick r:id="rId6"/>
               </a:rPr>
-              <a:t>ADR-0003</a:t>
-            </a:r>
-            <a:r>
-              <a:rPr lang="en-US" dirty="0"/>
-              <a:t>). Cost: single-writer ceiling. A server database is the upgrade path if concurrent load ever matters. The next slide covers the datastore choice.</a:t>
-            </a:r>
-            <a:endParaRPr lang="en-US" dirty="0"/>
-          </a:p>
-          <a:p>
-            <a:endParaRPr lang="en-US" dirty="0"/>
-          </a:p>
-          <a:p>
-            <a:r>
-              <a:rPr lang="en-US" dirty="0"/>
-              <a:t>2-decimal USD (</a:t>
-            </a:r>
-            <a:r>
-              <a:rPr lang="en-US" dirty="0">
-                <a:hlinkClick r:id="rId7"/>
-              </a:rPr>
               <a:t>ADR-0005</a:t>
             </a:r>
             <a:r>
-              <a:rPr lang="en-US" dirty="0"/>
-              <a:t>). Cost: single-currency support. Amounts are decimal with at most two fractional digits, which rules out floating-point error. The two-digit rule fits USD only, and there is no currency field, so supporting another currency (e.g., JPY with 0 places or KWD with 3) would change the Money type.</a:t>
+              <a:rPr lang="en-US" b="1" dirty="0"/>
+              <a:t>)</a:t>
+            </a:r>
+            <a:endParaRPr lang="en-US" dirty="0"/>
+          </a:p>
+          <a:p>
+            <a:r>
+              <a:rPr lang="en-US" b="1" dirty="0"/>
+              <a:t>Cost</a:t>
+            </a:r>
+            <a:r>
+              <a:rPr lang="en-US" dirty="0"/>
+              <a:t>: single-currency support.</a:t>
+            </a:r>
+            <a:endParaRPr lang="en-US" dirty="0"/>
+          </a:p>
+          <a:p>
+            <a:r>
+              <a:rPr lang="en-US" dirty="0"/>
+              <a:t>Amounts are decimal with at most two fractional digits, which rules out floating-point error. The two-digit rule fits USD but not many other currencies.</a:t>
             </a:r>
             <a:endParaRPr lang="en-US" dirty="0"/>
           </a:p>
@@ -1068,195 +1141,188 @@
           <a:lstStyle/>
           <a:p>
             <a:r>
-              <a:rPr lang="en-US" dirty="0"/>
-              <a:t>Frame: GPT-5.6 Sol in Codex with my architect agent</a:t>
-            </a:r>
-            <a:endParaRPr lang="en-US" dirty="0"/>
-          </a:p>
-          <a:p>
-            <a:r>
-              <a:rPr lang="en-US" dirty="0"/>
-              <a:t>• </a:t>
-            </a:r>
-            <a:r>
-              <a:rPr lang="en-US" dirty="0">
-                <a:hlinkClick r:id="rId3"/>
-              </a:rPr>
-              <a:t>Architetto</a:t>
-            </a:r>
-            <a:r>
-              <a:rPr lang="en-US" dirty="0"/>
-              <a:t> is my open-source architect agent: it bootstraps new repositories and records every foundational decision.</a:t>
-            </a:r>
-            <a:endParaRPr lang="en-US" dirty="0"/>
-          </a:p>
-          <a:p>
-            <a:r>
-              <a:rPr lang="en-US" dirty="0"/>
-              <a:t>• Interviewed me on four open questions: time box, persistence, seed accounts, repo visibility.</a:t>
-            </a:r>
-            <a:endParaRPr lang="en-US" dirty="0"/>
-          </a:p>
-          <a:p>
-            <a:r>
-              <a:rPr lang="en-US" dirty="0"/>
-              <a:t>• The model proposed the stack; I approved it.</a:t>
-            </a:r>
-            <a:endParaRPr lang="en-US" dirty="0"/>
-          </a:p>
-          <a:p>
-            <a:r>
-              <a:rPr lang="en-US" dirty="0"/>
-              <a:t>• Scaffolded before any feature code: </a:t>
-            </a:r>
-            <a:r>
-              <a:rPr lang="en-US" dirty="0">
-                <a:hlinkClick r:id="rId4"/>
-              </a:rPr>
-              <a:t>SPEC.md</a:t>
-            </a:r>
-            <a:r>
-              <a:rPr lang="en-US" dirty="0"/>
-              <a:t>, </a:t>
-            </a:r>
-            <a:r>
-              <a:rPr lang="en-US" dirty="0">
-                <a:hlinkClick r:id="rId5"/>
-              </a:rPr>
-              <a:t>PLAN.md</a:t>
-            </a:r>
-            <a:r>
-              <a:rPr lang="en-US" dirty="0"/>
-              <a:t>, six </a:t>
-            </a:r>
-            <a:r>
-              <a:rPr lang="en-US" dirty="0">
-                <a:hlinkClick r:id="rId6"/>
-              </a:rPr>
-              <a:t>ADRs</a:t>
-            </a:r>
-            <a:r>
-              <a:rPr lang="en-US" dirty="0"/>
-              <a:t>, </a:t>
-            </a:r>
-            <a:r>
-              <a:rPr lang="en-US" dirty="0">
-                <a:hlinkClick r:id="rId7"/>
-              </a:rPr>
-              <a:t>AGENTS.md</a:t>
-            </a:r>
-            <a:r>
-              <a:rPr lang="en-US" dirty="0"/>
-              <a:t>.</a:t>
-            </a:r>
-            <a:endParaRPr lang="en-US" dirty="0"/>
-          </a:p>
-          <a:p>
-            <a:r>
-              <a:rPr lang="en-US" dirty="0"/>
-              <a:t>   – </a:t>
-            </a:r>
-            <a:r>
-              <a:rPr lang="en-US" dirty="0">
-                <a:hlinkClick r:id="rId8"/>
-              </a:rPr>
-              <a:t>AGENTS.md</a:t>
-            </a:r>
-            <a:r>
-              <a:rPr lang="en-US" dirty="0"/>
-              <a:t> lists the rules for this repo: money is decimal, balances never go negative, etc.</a:t>
-            </a:r>
-            <a:endParaRPr lang="en-US" dirty="0"/>
-          </a:p>
-          <a:p>
-            <a:endParaRPr lang="en-US" dirty="0"/>
-          </a:p>
-          <a:p>
-            <a:r>
-              <a:rPr lang="en-US" dirty="0"/>
-              <a:t>Build: Fable 5.1 in Claude Code</a:t>
-            </a:r>
-            <a:endParaRPr lang="en-US" dirty="0"/>
-          </a:p>
-          <a:p>
-            <a:r>
-              <a:rPr lang="en-US" dirty="0"/>
-              <a:t>• Why Fable 5.1: I know the best approach is to plan with the strongest model and execute with cheaper ones, but when I reached the implementation phase, I was running short on time. Therefore, I chose the strongest end-to-end model at the time (a whopping week ago, before Opus 5.5 shipped).</a:t>
-            </a:r>
-            <a:endParaRPr lang="en-US" dirty="0"/>
-          </a:p>
-          <a:p>
-            <a:r>
-              <a:rPr lang="en-US" dirty="0"/>
-              <a:t>• Six phases in order: domain, application, persistence, web, HTTP tests and accessibility, deck.</a:t>
-            </a:r>
-            <a:endParaRPr lang="en-US" dirty="0"/>
-          </a:p>
-          <a:p>
-            <a:r>
-              <a:rPr lang="en-US" dirty="0"/>
-              <a:t>• Each phase committed only with the build and every test green; domain tests written first.</a:t>
-            </a:r>
-            <a:endParaRPr lang="en-US" dirty="0"/>
-          </a:p>
-          <a:p>
-            <a:endParaRPr lang="en-US" dirty="0"/>
-          </a:p>
-          <a:p>
-            <a:r>
-              <a:rPr lang="en-US" dirty="0"/>
-              <a:t>Refine: Opus 5.5 and GPT-6 Sol in Codex</a:t>
-            </a:r>
-            <a:endParaRPr lang="en-US" dirty="0"/>
-          </a:p>
-          <a:p>
-            <a:r>
-              <a:rPr lang="en-US" dirty="0"/>
-              <a:t>• Windows setup steps in </a:t>
-            </a:r>
-            <a:r>
-              <a:rPr lang="en-US" dirty="0">
-                <a:hlinkClick r:id="rId9"/>
-              </a:rPr>
-              <a:t>README.md</a:t>
-            </a:r>
-            <a:r>
-              <a:rPr lang="en-US" dirty="0"/>
-              <a:t>, a Dependabot fix, the deck redesign, slide wording.</a:t>
-            </a:r>
-            <a:endParaRPr lang="en-US" dirty="0"/>
-          </a:p>
-          <a:p>
-            <a:r>
-              <a:rPr lang="en-US" dirty="0"/>
-              <a:t>• The design direction came from </a:t>
-            </a:r>
-            <a:r>
-              <a:rPr lang="en-US" dirty="0">
-                <a:hlinkClick r:id="rId10"/>
-              </a:rPr>
-              <a:t>jony-vibe</a:t>
-            </a:r>
-            <a:r>
-              <a:rPr lang="en-US" dirty="0"/>
-              <a:t>, my design-consultation agent; the first deck skipped that consultation and was redone.</a:t>
-            </a:r>
-            <a:endParaRPr lang="en-US" dirty="0"/>
-          </a:p>
-          <a:p>
-            <a:r>
-              <a:rPr lang="en-US" dirty="0"/>
-              <a:t>• </a:t>
-            </a:r>
-            <a:r>
-              <a:rPr lang="en-US" dirty="0">
-                <a:hlinkClick r:id="rId11"/>
-              </a:rPr>
-              <a:t>c4po</a:t>
-            </a:r>
-            <a:r>
-              <a:rPr lang="en-US" dirty="0"/>
-              <a:t>, my workspace-admin agent, moved the deck's visual checks from Keynote to PowerPoint after Keynote passed a deck that PowerPoint had to repair.</a:t>
+              <a:rPr lang="en-US" b="1" dirty="0"/>
+              <a:t>Ranked by how soon LLM mistakes surface</a:t>
+            </a:r>
+            <a:endParaRPr lang="en-US" dirty="0"/>
+          </a:p>
+          <a:p>
+            <a:pPr marL="228600" lvl="0" indent="-228600">
+              <a:buFont typeface="Arial"/>
+              <a:buChar char="•"/>
+            </a:pPr>
+            <a:r>
+              <a:rPr lang="en-US" dirty="0"/>
+              <a:t>A model writes, runs, and fixes code; the sooner an error appears, the fewer turns it wastes</a:t>
+            </a:r>
+            <a:endParaRPr lang="en-US" dirty="0"/>
+          </a:p>
+          <a:p>
+            <a:pPr marL="228600" lvl="0" indent="-228600">
+              <a:buFont typeface="Arial"/>
+              <a:buChar char="•"/>
+            </a:pPr>
+            <a:r>
+              <a:rPr lang="en-US" dirty="0"/>
+              <a:t>A fast-changing framework can confuse an LLM into mixing in a pattern from an older version; newer or niche frameworks, released after a model's training cutoff, are where it is weakest</a:t>
+            </a:r>
+            <a:endParaRPr lang="en-US" dirty="0"/>
+          </a:p>
+          <a:p>
+            <a:pPr marL="228600" lvl="0" indent="-228600">
+              <a:buFont typeface="Arial"/>
+              <a:buChar char="•"/>
+            </a:pPr>
+            <a:r>
+              <a:rPr lang="en-US" b="1" dirty="0"/>
+              <a:t>ASP.NET Core</a:t>
+            </a:r>
+            <a:r>
+              <a:rPr lang="en-US" dirty="0"/>
+              <a:t> (chosen)</a:t>
+            </a:r>
+            <a:endParaRPr lang="en-US" dirty="0"/>
+          </a:p>
+          <a:p>
+            <a:pPr marL="457200" lvl="1" indent="-228600">
+              <a:buFont typeface="Arial"/>
+              <a:buChar char="–"/>
+            </a:pPr>
+            <a:r>
+              <a:rPr lang="en-US" dirty="0"/>
+              <a:t>Pro: the compiler catches type and null errors before tests run</a:t>
+            </a:r>
+            <a:endParaRPr lang="en-US" dirty="0"/>
+          </a:p>
+          <a:p>
+            <a:pPr marL="457200" lvl="1" indent="-228600">
+              <a:buFont typeface="Arial"/>
+              <a:buChar char="–"/>
+            </a:pPr>
+            <a:r>
+              <a:rPr lang="en-US" dirty="0"/>
+              <a:t>Pro: in-process HTTP tests run in seconds</a:t>
+            </a:r>
+            <a:endParaRPr lang="en-US" dirty="0"/>
+          </a:p>
+          <a:p>
+            <a:pPr marL="457200" lvl="1" indent="-228600">
+              <a:buFont typeface="Arial"/>
+              <a:buChar char="–"/>
+            </a:pPr>
+            <a:r>
+              <a:rPr lang="en-US" dirty="0"/>
+              <a:t>Con: less public code; outdated patterns (Startup.cs) linger in examples</a:t>
+            </a:r>
+            <a:endParaRPr lang="en-US" dirty="0"/>
+          </a:p>
+          <a:p>
+            <a:pPr marL="228600" lvl="0" indent="-228600">
+              <a:buFont typeface="Arial"/>
+              <a:buChar char="•"/>
+            </a:pPr>
+            <a:r>
+              <a:rPr lang="en-US" b="1" dirty="0"/>
+              <a:t>Django</a:t>
+            </a:r>
+            <a:endParaRPr lang="en-US" dirty="0"/>
+          </a:p>
+          <a:p>
+            <a:pPr marL="457200" lvl="1" indent="-228600">
+              <a:buFont typeface="Arial"/>
+              <a:buChar char="–"/>
+            </a:pPr>
+            <a:r>
+              <a:rPr lang="en-US" dirty="0"/>
+              <a:t>Pro: most public examples; stable API</a:t>
+            </a:r>
+            <a:endParaRPr lang="en-US" dirty="0"/>
+          </a:p>
+          <a:p>
+            <a:pPr marL="457200" lvl="1" indent="-228600">
+              <a:buFont typeface="Arial"/>
+              <a:buChar char="–"/>
+            </a:pPr>
+            <a:r>
+              <a:rPr lang="en-US" dirty="0"/>
+              <a:t>Con: no static types, so errors wait for a test to hit them</a:t>
+            </a:r>
+            <a:endParaRPr lang="en-US" dirty="0"/>
+          </a:p>
+          <a:p>
+            <a:pPr marL="228600" lvl="0" indent="-228600">
+              <a:buFont typeface="Arial"/>
+              <a:buChar char="•"/>
+            </a:pPr>
+            <a:r>
+              <a:rPr lang="en-US" b="1" dirty="0"/>
+              <a:t>Spring Boot</a:t>
+            </a:r>
+            <a:endParaRPr lang="en-US" dirty="0"/>
+          </a:p>
+          <a:p>
+            <a:pPr marL="457200" lvl="1" indent="-228600">
+              <a:buFont typeface="Arial"/>
+              <a:buChar char="–"/>
+            </a:pPr>
+            <a:r>
+              <a:rPr lang="en-US" dirty="0"/>
+              <a:t>Pro: huge corpus; static types</a:t>
+            </a:r>
+            <a:endParaRPr lang="en-US" dirty="0"/>
+          </a:p>
+          <a:p>
+            <a:pPr marL="457200" lvl="1" indent="-228600">
+              <a:buFont typeface="Arial"/>
+              <a:buChar char="–"/>
+            </a:pPr>
+            <a:r>
+              <a:rPr lang="en-US" dirty="0"/>
+              <a:t>Con: wiring errors appear at startup; tests start slowly</a:t>
+            </a:r>
+            <a:endParaRPr lang="en-US" dirty="0"/>
+          </a:p>
+          <a:p>
+            <a:pPr marL="457200" lvl="1" indent="-228600">
+              <a:buFont typeface="Arial"/>
+              <a:buChar char="–"/>
+            </a:pPr>
+            <a:r>
+              <a:rPr lang="en-US" dirty="0"/>
+              <a:t>Con: the javax-to-jakarta rename splits examples</a:t>
+            </a:r>
+            <a:endParaRPr lang="en-US" dirty="0"/>
+          </a:p>
+          <a:p>
+            <a:pPr marL="228600" lvl="0" indent="-228600">
+              <a:buFont typeface="Arial"/>
+              <a:buChar char="•"/>
+            </a:pPr>
+            <a:r>
+              <a:rPr lang="en-US" b="1" dirty="0"/>
+              <a:t>Node.js</a:t>
+            </a:r>
+            <a:endParaRPr lang="en-US" dirty="0"/>
+          </a:p>
+          <a:p>
+            <a:pPr marL="457200" lvl="1" indent="-228600">
+              <a:buFont typeface="Arial"/>
+              <a:buChar char="–"/>
+            </a:pPr>
+            <a:r>
+              <a:rPr lang="en-US" dirty="0"/>
+              <a:t>Pro: huge corpus; TypeScript types</a:t>
+            </a:r>
+            <a:endParaRPr lang="en-US" dirty="0"/>
+          </a:p>
+          <a:p>
+            <a:pPr marL="457200" lvl="1" indent="-228600">
+              <a:buFont typeface="Arial"/>
+              <a:buChar char="–"/>
+            </a:pPr>
+            <a:r>
+              <a:rPr lang="en-US" dirty="0"/>
+              <a:t>Con: no default stack; fastest-changing ecosystem</a:t>
             </a:r>
             <a:endParaRPr lang="en-US" dirty="0"/>
           </a:p>
@@ -1343,215 +1409,195 @@
           <a:lstStyle/>
           <a:p>
             <a:r>
-              <a:rPr lang="en-US" b="1" dirty="0"/>
-              <a:t>Omitted (out of scope in </a:t>
-            </a:r>
-            <a:r>
-              <a:rPr lang="en-US" b="1" dirty="0">
+              <a:rPr lang="en-US" dirty="0"/>
+              <a:t>Frame: GPT-5.6 Sol in Codex with my architect agent</a:t>
+            </a:r>
+            <a:endParaRPr lang="en-US" dirty="0"/>
+          </a:p>
+          <a:p>
+            <a:r>
+              <a:rPr lang="en-US" dirty="0"/>
+              <a:t>• </a:t>
+            </a:r>
+            <a:r>
+              <a:rPr lang="en-US" dirty="0">
                 <a:hlinkClick r:id="rId3"/>
               </a:rPr>
+              <a:t>Architetto</a:t>
+            </a:r>
+            <a:r>
+              <a:rPr lang="en-US" dirty="0"/>
+              <a:t> is my open-source architect agent: it bootstraps new repositories and records every foundational decision.</a:t>
+            </a:r>
+            <a:endParaRPr lang="en-US" dirty="0"/>
+          </a:p>
+          <a:p>
+            <a:r>
+              <a:rPr lang="en-US" dirty="0"/>
+              <a:t>• Interviewed me on four open questions: time box, persistence, seed accounts, repo visibility.</a:t>
+            </a:r>
+            <a:endParaRPr lang="en-US" dirty="0"/>
+          </a:p>
+          <a:p>
+            <a:r>
+              <a:rPr lang="en-US" dirty="0"/>
+              <a:t>• The model proposed the stack; I approved it.</a:t>
+            </a:r>
+            <a:endParaRPr lang="en-US" dirty="0"/>
+          </a:p>
+          <a:p>
+            <a:r>
+              <a:rPr lang="en-US" dirty="0"/>
+              <a:t>• Scaffolded before any feature code: </a:t>
+            </a:r>
+            <a:r>
+              <a:rPr lang="en-US" dirty="0">
+                <a:hlinkClick r:id="rId4"/>
+              </a:rPr>
               <a:t>SPEC.md</a:t>
             </a:r>
             <a:r>
-              <a:rPr lang="en-US" b="1" dirty="0"/>
-              <a:t>)</a:t>
-            </a:r>
-            <a:endParaRPr lang="en-US" dirty="0"/>
-          </a:p>
-          <a:p>
-            <a:pPr marL="228600" lvl="0" indent="-228600">
-              <a:buFont typeface="Arial"/>
-              <a:buChar char="•"/>
-            </a:pPr>
-            <a:r>
-              <a:rPr lang="en-US" dirty="0"/>
-              <a:t>Identity</a:t>
-            </a:r>
-            <a:endParaRPr lang="en-US" dirty="0"/>
-          </a:p>
-          <a:p>
-            <a:pPr marL="457200" lvl="1" indent="-228600">
-              <a:buFont typeface="Arial"/>
-              <a:buChar char="–"/>
-            </a:pPr>
-            <a:r>
-              <a:rPr lang="en-US" dirty="0"/>
-              <a:t>No login, card, PIN, or session; one local user</a:t>
-            </a:r>
-            <a:endParaRPr lang="en-US" dirty="0"/>
-          </a:p>
-          <a:p>
-            <a:pPr marL="228600" lvl="0" indent="-228600">
-              <a:buFont typeface="Arial"/>
-              <a:buChar char="•"/>
-            </a:pPr>
-            <a:r>
-              <a:rPr lang="en-US" dirty="0"/>
-              <a:t>Banking breadth</a:t>
-            </a:r>
-            <a:endParaRPr lang="en-US" dirty="0"/>
-          </a:p>
-          <a:p>
-            <a:pPr marL="457200" lvl="1" indent="-228600">
-              <a:buFont typeface="Arial"/>
-              <a:buChar char="–"/>
-            </a:pPr>
-            <a:r>
-              <a:rPr lang="en-US" dirty="0"/>
-              <a:t>No fees, interest, overdraft lines, scheduled payments, other currencies, or bank rails</a:t>
-            </a:r>
-            <a:endParaRPr lang="en-US" dirty="0"/>
-          </a:p>
-          <a:p>
-            <a:pPr marL="228600" lvl="0" indent="-228600">
-              <a:buFont typeface="Arial"/>
-              <a:buChar char="•"/>
-            </a:pPr>
-            <a:r>
-              <a:rPr lang="en-US" dirty="0"/>
-              <a:t>Distributed operations</a:t>
-            </a:r>
-            <a:endParaRPr lang="en-US" dirty="0"/>
-          </a:p>
-          <a:p>
-            <a:pPr marL="457200" lvl="1" indent="-228600">
-              <a:buFont typeface="Arial"/>
-              <a:buChar char="–"/>
-            </a:pPr>
-            <a:r>
-              <a:rPr lang="en-US" dirty="0"/>
-              <a:t>One process, one SQLite file</a:t>
-            </a:r>
-            <a:endParaRPr lang="en-US" dirty="0"/>
-          </a:p>
-          <a:p>
-            <a:pPr marL="457200" lvl="1" indent="-228600">
-              <a:buFont typeface="Arial"/>
-              <a:buChar char="–"/>
-            </a:pPr>
-            <a:r>
-              <a:rPr lang="en-US" dirty="0"/>
-              <a:t>In a real bank, Domain and Application would become a backend service shared by every client (ATMs, mobile app, online banking, branch tellers)</a:t>
-            </a:r>
-            <a:endParaRPr lang="en-US" dirty="0"/>
-          </a:p>
-          <a:p>
-            <a:endParaRPr lang="en-US" dirty="0"/>
-          </a:p>
-          <a:p>
-            <a:r>
-              <a:rPr lang="en-US" b="1" dirty="0"/>
-              <a:t>Roadmap</a:t>
-            </a:r>
-            <a:endParaRPr lang="en-US" dirty="0"/>
-          </a:p>
-          <a:p>
-            <a:pPr marL="228600" lvl="0" indent="-228600">
-              <a:buFont typeface="Arial"/>
-              <a:buChar char="•"/>
-            </a:pPr>
-            <a:r>
-              <a:rPr lang="en-US" dirty="0"/>
-              <a:t>Now</a:t>
-            </a:r>
-            <a:endParaRPr lang="en-US" dirty="0"/>
-          </a:p>
-          <a:p>
-            <a:pPr marL="457200" lvl="1" indent="-228600">
-              <a:buFont typeface="Arial"/>
-              <a:buChar char="–"/>
-            </a:pPr>
-            <a:r>
-              <a:rPr lang="en-US" dirty="0"/>
-              <a:t>Idempotency keys: a retry after a lost response repeats the operation; Post/Redirect/Get and EF Core's concurrency token cannot catch it</a:t>
-            </a:r>
-            <a:endParaRPr lang="en-US" dirty="0"/>
-          </a:p>
-          <a:p>
-            <a:pPr marL="457200" lvl="1" indent="-228600">
-              <a:buFont typeface="Arial"/>
-              <a:buChar char="–"/>
-            </a:pPr>
-            <a:r>
-              <a:rPr lang="en-US" dirty="0"/>
-              <a:t>Cross-model code review: Fable 5.1 wrote the implementation, so have a different model (GPT-6 Sol) review it; a second model does not share the author's blind spots</a:t>
-            </a:r>
-            <a:endParaRPr lang="en-US" dirty="0"/>
-          </a:p>
-          <a:p>
-            <a:pPr marL="457200" lvl="1" indent="-228600">
-              <a:buFont typeface="Arial"/>
-              <a:buChar char="–"/>
-            </a:pPr>
-            <a:r>
-              <a:rPr lang="en-US" dirty="0"/>
-              <a:t>Authentication: prerequisite for multiple users and attributable audits</a:t>
-            </a:r>
-            <a:endParaRPr lang="en-US" dirty="0"/>
-          </a:p>
-          <a:p>
-            <a:pPr marL="228600" lvl="0" indent="-228600">
-              <a:buFont typeface="Arial"/>
-              <a:buChar char="•"/>
-            </a:pPr>
-            <a:r>
-              <a:rPr lang="en-US" dirty="0"/>
-              <a:t>Next</a:t>
-            </a:r>
-            <a:endParaRPr lang="en-US" dirty="0"/>
-          </a:p>
-          <a:p>
-            <a:pPr marL="457200" lvl="1" indent="-228600">
-              <a:buFont typeface="Arial"/>
-              <a:buChar char="–"/>
-            </a:pPr>
-            <a:r>
-              <a:rPr lang="en-US" dirty="0"/>
-              <a:t>Accessibility: screen-reader testing, axe or Lighthouse in CI</a:t>
-            </a:r>
-            <a:endParaRPr lang="en-US" dirty="0"/>
-          </a:p>
-          <a:p>
-            <a:pPr marL="685800" lvl="2" indent="-228600">
-              <a:buFont typeface="Arial"/>
-              <a:buChar char="–"/>
-            </a:pPr>
-            <a:r>
-              <a:rPr lang="en-US" dirty="0"/>
-              <a:t>Known gap: with JavaScript on, Tab cannot reach the Withdraw and Transfer tabs (in BACKLOG.md)</a:t>
-            </a:r>
-            <a:endParaRPr lang="en-US" dirty="0"/>
-          </a:p>
-          <a:p>
-            <a:pPr marL="457200" lvl="1" indent="-228600">
-              <a:buFont typeface="Arial"/>
-              <a:buChar char="–"/>
-            </a:pPr>
-            <a:r>
-              <a:rPr lang="en-US" dirty="0"/>
-              <a:t>Observability: structured logs, metrics, traces</a:t>
-            </a:r>
-            <a:endParaRPr lang="en-US" dirty="0"/>
-          </a:p>
-          <a:p>
-            <a:pPr marL="228600" lvl="0" indent="-228600">
-              <a:buFont typeface="Arial"/>
-              <a:buChar char="•"/>
-            </a:pPr>
-            <a:r>
-              <a:rPr lang="en-US" dirty="0"/>
-              <a:t>Later</a:t>
-            </a:r>
-            <a:endParaRPr lang="en-US" dirty="0"/>
-          </a:p>
-          <a:p>
-            <a:pPr marL="457200" lvl="1" indent="-228600">
-              <a:buFont typeface="Arial"/>
-              <a:buChar char="–"/>
-            </a:pPr>
-            <a:r>
-              <a:rPr lang="en-US" dirty="0"/>
-              <a:t>Deployment: container, CI/CD, hosting</a:t>
+              <a:rPr lang="en-US" dirty="0"/>
+              <a:t>, </a:t>
+            </a:r>
+            <a:r>
+              <a:rPr lang="en-US" dirty="0">
+                <a:hlinkClick r:id="rId5"/>
+              </a:rPr>
+              <a:t>PLAN.md</a:t>
+            </a:r>
+            <a:r>
+              <a:rPr lang="en-US" dirty="0"/>
+              <a:t>, six </a:t>
+            </a:r>
+            <a:r>
+              <a:rPr lang="en-US" dirty="0">
+                <a:hlinkClick r:id="rId6"/>
+              </a:rPr>
+              <a:t>ADRs</a:t>
+            </a:r>
+            <a:r>
+              <a:rPr lang="en-US" dirty="0"/>
+              <a:t>, </a:t>
+            </a:r>
+            <a:r>
+              <a:rPr lang="en-US" dirty="0">
+                <a:hlinkClick r:id="rId7"/>
+              </a:rPr>
+              <a:t>AGENTS.md</a:t>
+            </a:r>
+            <a:r>
+              <a:rPr lang="en-US" dirty="0"/>
+              <a:t>.</a:t>
+            </a:r>
+            <a:endParaRPr lang="en-US" dirty="0"/>
+          </a:p>
+          <a:p>
+            <a:r>
+              <a:rPr lang="en-US" dirty="0"/>
+              <a:t>   – </a:t>
+            </a:r>
+            <a:r>
+              <a:rPr lang="en-US" dirty="0">
+                <a:hlinkClick r:id="rId8"/>
+              </a:rPr>
+              <a:t>AGENTS.md</a:t>
+            </a:r>
+            <a:r>
+              <a:rPr lang="en-US" dirty="0"/>
+              <a:t> lists the rules for this repo: money is decimal, balances never go negative, etc.</a:t>
+            </a:r>
+            <a:endParaRPr lang="en-US" dirty="0"/>
+          </a:p>
+          <a:p>
+            <a:endParaRPr lang="en-US" dirty="0"/>
+          </a:p>
+          <a:p>
+            <a:r>
+              <a:rPr lang="en-US" dirty="0"/>
+              <a:t>Build: Fable 5.1 in Claude Code</a:t>
+            </a:r>
+            <a:endParaRPr lang="en-US" dirty="0"/>
+          </a:p>
+          <a:p>
+            <a:r>
+              <a:rPr lang="en-US" dirty="0"/>
+              <a:t>• Why Fable 5.1: I know the best approach is to plan with the strongest model and execute with cheaper ones, but when I reached the implementation phase, I was running short on time. Therefore, I chose the strongest end-to-end model at the time (a whopping week ago, before Opus 5.5 shipped).</a:t>
+            </a:r>
+            <a:endParaRPr lang="en-US" dirty="0"/>
+          </a:p>
+          <a:p>
+            <a:r>
+              <a:rPr lang="en-US" dirty="0"/>
+              <a:t>• Six phases in order: domain, application, persistence, web, HTTP tests and accessibility, deck.</a:t>
+            </a:r>
+            <a:endParaRPr lang="en-US" dirty="0"/>
+          </a:p>
+          <a:p>
+            <a:r>
+              <a:rPr lang="en-US" dirty="0"/>
+              <a:t>• Each phase committed only with the build and every test green; domain tests written first.</a:t>
+            </a:r>
+            <a:endParaRPr lang="en-US" dirty="0"/>
+          </a:p>
+          <a:p>
+            <a:endParaRPr lang="en-US" dirty="0"/>
+          </a:p>
+          <a:p>
+            <a:r>
+              <a:rPr lang="en-US" dirty="0"/>
+              <a:t>Refine: Opus 5.5 and GPT-6 Sol in Codex</a:t>
+            </a:r>
+            <a:endParaRPr lang="en-US" dirty="0"/>
+          </a:p>
+          <a:p>
+            <a:r>
+              <a:rPr lang="en-US" dirty="0"/>
+              <a:t>• Windows setup steps in </a:t>
+            </a:r>
+            <a:r>
+              <a:rPr lang="en-US" dirty="0">
+                <a:hlinkClick r:id="rId9"/>
+              </a:rPr>
+              <a:t>README.md</a:t>
+            </a:r>
+            <a:r>
+              <a:rPr lang="en-US" dirty="0"/>
+              <a:t>, a Dependabot fix, the deck redesign, slide wording.</a:t>
+            </a:r>
+            <a:endParaRPr lang="en-US" dirty="0"/>
+          </a:p>
+          <a:p>
+            <a:r>
+              <a:rPr lang="en-US" dirty="0"/>
+              <a:t>• The design direction came from </a:t>
+            </a:r>
+            <a:r>
+              <a:rPr lang="en-US" dirty="0">
+                <a:hlinkClick r:id="rId10"/>
+              </a:rPr>
+              <a:t>jony-vibe</a:t>
+            </a:r>
+            <a:r>
+              <a:rPr lang="en-US" dirty="0"/>
+              <a:t>, my design-consultation agent; the first deck skipped that consultation and was redone.</a:t>
+            </a:r>
+            <a:endParaRPr lang="en-US" dirty="0"/>
+          </a:p>
+          <a:p>
+            <a:r>
+              <a:rPr lang="en-US" dirty="0"/>
+              <a:t>• </a:t>
+            </a:r>
+            <a:r>
+              <a:rPr lang="en-US" dirty="0">
+                <a:hlinkClick r:id="rId11"/>
+              </a:rPr>
+              <a:t>c4po</a:t>
+            </a:r>
+            <a:r>
+              <a:rPr lang="en-US" dirty="0"/>
+              <a:t>, my workspace-admin agent, moved the deck's visual checks from Keynote to PowerPoint after Keynote passed a deck that PowerPoint had to repair.</a:t>
             </a:r>
             <a:endParaRPr lang="en-US" dirty="0"/>
           </a:p>
@@ -1575,6 +1621,301 @@
             <a:fld id="{F7021451-1387-4CA6-816F-3879F97B5CBC}" type="slidenum">
               <a:rPr lang="en-US"/>
               <a:t>6</a:t>
+            </a:fld>
+            <a:endParaRPr lang="en-US"/>
+          </a:p>
+        </p:txBody>
+      </p:sp>
+    </p:spTree>
+    <p:extLst>
+      <p:ext uri="{BB962C8B-B14F-4D97-AF65-F5344CB8AC3E}">
+        <p14:creationId xmlns:p14="http://schemas.microsoft.com/office/powerpoint/2010/main" val="1024086991"/>
+      </p:ext>
+    </p:extLst>
+  </p:cSld>
+  <p:clrMapOvr>
+    <a:masterClrMapping/>
+  </p:clrMapOvr>
+</p:notes>
+</file>
+
+<file path=ppt/notesSlides/notesSlide7.xml><?xml version="1.0" encoding="utf-8"?>
+<p:notes xmlns:a="http://schemas.openxmlformats.org/drawingml/2006/main" xmlns:r="http://schemas.openxmlformats.org/officeDocument/2006/relationships" xmlns:p="http://schemas.openxmlformats.org/presentationml/2006/main">
+  <p:cSld>
+    <p:spTree>
+      <p:nvGrpSpPr>
+        <p:cNvPr id="1" name=""/>
+        <p:cNvGrpSpPr/>
+        <p:nvPr/>
+      </p:nvGrpSpPr>
+      <p:grpSpPr>
+        <a:xfrm>
+          <a:off x="0" y="0"/>
+          <a:ext cx="0" cy="0"/>
+          <a:chOff x="0" y="0"/>
+          <a:chExt cx="0" cy="0"/>
+        </a:xfrm>
+      </p:grpSpPr>
+      <p:sp>
+        <p:nvSpPr>
+          <p:cNvPr id="2" name="Slide Image Placeholder 1"/>
+          <p:cNvSpPr>
+            <a:spLocks noGrp="1" noRot="1" noChangeAspect="1"/>
+          </p:cNvSpPr>
+          <p:nvPr>
+            <p:ph type="sldImg"/>
+          </p:nvPr>
+        </p:nvSpPr>
+        <p:spPr/>
+      </p:sp>
+      <p:sp>
+        <p:nvSpPr>
+          <p:cNvPr id="3" name="Notes Placeholder 2"/>
+          <p:cNvSpPr>
+            <a:spLocks noGrp="1"/>
+          </p:cNvSpPr>
+          <p:nvPr>
+            <p:ph type="body" idx="1"/>
+          </p:nvPr>
+        </p:nvSpPr>
+        <p:spPr/>
+        <p:txBody>
+          <a:bodyPr/>
+          <a:lstStyle/>
+          <a:p>
+            <a:r>
+              <a:rPr lang="en-US" b="1" dirty="0"/>
+              <a:t>Omitted (out of scope in </a:t>
+            </a:r>
+            <a:r>
+              <a:rPr lang="en-US" b="1" dirty="0">
+                <a:hlinkClick r:id="rId3"/>
+              </a:rPr>
+              <a:t>SPEC.md</a:t>
+            </a:r>
+            <a:r>
+              <a:rPr lang="en-US" b="1" dirty="0"/>
+              <a:t>)</a:t>
+            </a:r>
+            <a:endParaRPr lang="en-US" dirty="0"/>
+          </a:p>
+          <a:p>
+            <a:pPr marL="228600" lvl="0" indent="-228600">
+              <a:buFont typeface="Arial"/>
+              <a:buChar char="•"/>
+            </a:pPr>
+            <a:r>
+              <a:rPr lang="en-US" dirty="0"/>
+              <a:t>Identity</a:t>
+            </a:r>
+            <a:endParaRPr lang="en-US" dirty="0"/>
+          </a:p>
+          <a:p>
+            <a:pPr marL="457200" lvl="1" indent="-228600">
+              <a:buFont typeface="Arial"/>
+              <a:buChar char="–"/>
+            </a:pPr>
+            <a:r>
+              <a:rPr lang="en-US" dirty="0"/>
+              <a:t>No login, card, PIN, or session; one local user</a:t>
+            </a:r>
+            <a:endParaRPr lang="en-US" dirty="0"/>
+          </a:p>
+          <a:p>
+            <a:pPr marL="228600" lvl="0" indent="-228600">
+              <a:buFont typeface="Arial"/>
+              <a:buChar char="•"/>
+            </a:pPr>
+            <a:r>
+              <a:rPr lang="en-US" dirty="0"/>
+              <a:t>Banking breadth</a:t>
+            </a:r>
+            <a:endParaRPr lang="en-US" dirty="0"/>
+          </a:p>
+          <a:p>
+            <a:pPr marL="457200" lvl="1" indent="-228600">
+              <a:buFont typeface="Arial"/>
+              <a:buChar char="–"/>
+            </a:pPr>
+            <a:r>
+              <a:rPr lang="en-US" dirty="0"/>
+              <a:t>No fees, interest, overdraft lines, scheduled payments, other currencies, or bank rails</a:t>
+            </a:r>
+            <a:endParaRPr lang="en-US" dirty="0"/>
+          </a:p>
+          <a:p>
+            <a:pPr marL="228600" lvl="0" indent="-228600">
+              <a:buFont typeface="Arial"/>
+              <a:buChar char="•"/>
+            </a:pPr>
+            <a:r>
+              <a:rPr lang="en-US" dirty="0"/>
+              <a:t>Distributed operations</a:t>
+            </a:r>
+            <a:endParaRPr lang="en-US" dirty="0"/>
+          </a:p>
+          <a:p>
+            <a:pPr marL="457200" lvl="1" indent="-228600">
+              <a:buFont typeface="Arial"/>
+              <a:buChar char="–"/>
+            </a:pPr>
+            <a:r>
+              <a:rPr lang="en-US" dirty="0"/>
+              <a:t>One process, one SQLite file</a:t>
+            </a:r>
+            <a:endParaRPr lang="en-US" dirty="0"/>
+          </a:p>
+          <a:p>
+            <a:pPr marL="457200" lvl="1" indent="-228600">
+              <a:buFont typeface="Arial"/>
+              <a:buChar char="–"/>
+            </a:pPr>
+            <a:r>
+              <a:rPr lang="en-US" dirty="0"/>
+              <a:t>In a real bank, Domain and Application would become a backend service shared by every client (ATMs, mobile app, online banking, branch tellers)</a:t>
+            </a:r>
+            <a:endParaRPr lang="en-US" dirty="0"/>
+          </a:p>
+          <a:p>
+            <a:endParaRPr lang="en-US" dirty="0"/>
+          </a:p>
+          <a:p>
+            <a:r>
+              <a:rPr lang="en-US" b="1" dirty="0"/>
+              <a:t>Roadmap</a:t>
+            </a:r>
+            <a:endParaRPr lang="en-US" dirty="0"/>
+          </a:p>
+          <a:p>
+            <a:pPr marL="228600" lvl="0" indent="-228600">
+              <a:buFont typeface="Arial"/>
+              <a:buChar char="•"/>
+            </a:pPr>
+            <a:r>
+              <a:rPr lang="en-US" dirty="0"/>
+              <a:t>Now</a:t>
+            </a:r>
+            <a:endParaRPr lang="en-US" dirty="0"/>
+          </a:p>
+          <a:p>
+            <a:pPr marL="457200" lvl="1" indent="-228600">
+              <a:buFont typeface="Arial"/>
+              <a:buChar char="–"/>
+            </a:pPr>
+            <a:r>
+              <a:rPr lang="en-US" dirty="0"/>
+              <a:t>Idempotency keys: a retry after a lost response repeats the operation; Post/Redirect/Get and EF Core's concurrency token cannot catch it</a:t>
+            </a:r>
+            <a:endParaRPr lang="en-US" dirty="0"/>
+          </a:p>
+          <a:p>
+            <a:pPr marL="457200" lvl="1" indent="-228600">
+              <a:buFont typeface="Arial"/>
+              <a:buChar char="–"/>
+            </a:pPr>
+            <a:r>
+              <a:rPr lang="en-US" dirty="0"/>
+              <a:t>Cross-model code review: Fable 5.1 wrote the implementation, so have a different model (GPT-6 Sol) review it; a second model does not share the author's blind spots</a:t>
+            </a:r>
+            <a:endParaRPr lang="en-US" dirty="0"/>
+          </a:p>
+          <a:p>
+            <a:pPr marL="457200" lvl="1" indent="-228600">
+              <a:buFont typeface="Arial"/>
+              <a:buChar char="–"/>
+            </a:pPr>
+            <a:r>
+              <a:rPr lang="en-US" dirty="0"/>
+              <a:t>Authentication: prerequisite for multiple users and attributable audits</a:t>
+            </a:r>
+            <a:endParaRPr lang="en-US" dirty="0"/>
+          </a:p>
+          <a:p>
+            <a:pPr marL="228600" lvl="0" indent="-228600">
+              <a:buFont typeface="Arial"/>
+              <a:buChar char="•"/>
+            </a:pPr>
+            <a:r>
+              <a:rPr lang="en-US" dirty="0"/>
+              <a:t>Next</a:t>
+            </a:r>
+            <a:endParaRPr lang="en-US" dirty="0"/>
+          </a:p>
+          <a:p>
+            <a:pPr marL="457200" lvl="1" indent="-228600">
+              <a:buFont typeface="Arial"/>
+              <a:buChar char="–"/>
+            </a:pPr>
+            <a:r>
+              <a:rPr lang="en-US" dirty="0"/>
+              <a:t>Accessibility: screen-reader testing, axe or Lighthouse in CI</a:t>
+            </a:r>
+            <a:endParaRPr lang="en-US" dirty="0"/>
+          </a:p>
+          <a:p>
+            <a:pPr marL="685800" lvl="2" indent="-228600">
+              <a:buFont typeface="Arial"/>
+              <a:buChar char="–"/>
+            </a:pPr>
+            <a:r>
+              <a:rPr lang="en-US" dirty="0"/>
+              <a:t>Known gap: with JavaScript on, Tab cannot reach the Withdraw and Transfer tabs (in BACKLOG.md)</a:t>
+            </a:r>
+            <a:endParaRPr lang="en-US" dirty="0"/>
+          </a:p>
+          <a:p>
+            <a:pPr marL="457200" lvl="1" indent="-228600">
+              <a:buFont typeface="Arial"/>
+              <a:buChar char="–"/>
+            </a:pPr>
+            <a:r>
+              <a:rPr lang="en-US" dirty="0"/>
+              <a:t>Observability: structured logs, metrics, traces</a:t>
+            </a:r>
+            <a:endParaRPr lang="en-US" dirty="0"/>
+          </a:p>
+          <a:p>
+            <a:pPr marL="228600" lvl="0" indent="-228600">
+              <a:buFont typeface="Arial"/>
+              <a:buChar char="•"/>
+            </a:pPr>
+            <a:r>
+              <a:rPr lang="en-US" dirty="0"/>
+              <a:t>Later</a:t>
+            </a:r>
+            <a:endParaRPr lang="en-US" dirty="0"/>
+          </a:p>
+          <a:p>
+            <a:pPr marL="457200" lvl="1" indent="-228600">
+              <a:buFont typeface="Arial"/>
+              <a:buChar char="–"/>
+            </a:pPr>
+            <a:r>
+              <a:rPr lang="en-US" dirty="0"/>
+              <a:t>Deployment: container, CI/CD, hosting</a:t>
+            </a:r>
+            <a:endParaRPr lang="en-US" dirty="0"/>
+          </a:p>
+        </p:txBody>
+      </p:sp>
+      <p:sp>
+        <p:nvSpPr>
+          <p:cNvPr id="4" name="Slide Number Placeholder 3"/>
+          <p:cNvSpPr>
+            <a:spLocks noGrp="1"/>
+          </p:cNvSpPr>
+          <p:nvPr>
+            <p:ph type="sldNum" sz="quarter" idx="10"/>
+          </p:nvPr>
+        </p:nvSpPr>
+        <p:spPr/>
+        <p:txBody>
+          <a:bodyPr/>
+          <a:lstStyle/>
+          <a:p>
+            <a:fld id="{F7021451-1387-4CA6-816F-3879F97B5CBC}" type="slidenum">
+              <a:rPr lang="en-US"/>
+              <a:t>7</a:t>
             </a:fld>
             <a:endParaRPr lang="en-US"/>
           </a:p>
@@ -1932,47 +2273,6 @@
         </p:nvSpPr>
         <p:spPr>
           <a:xfrm>
-            <a:off x="585216" y="457200"/>
-            <a:ext cx="2560320" cy="228600"/>
-          </a:xfrm>
-          <a:prstGeom prst="rect">
-            <a:avLst/>
-          </a:prstGeom>
-          <a:noFill/>
-          <a:ln/>
-        </p:spPr>
-        <p:txBody>
-          <a:bodyPr wrap="square" lIns="0" tIns="0" rIns="0" bIns="0" rtlCol="0" anchor="t">
-            <a:normAutofit/>
-          </a:bodyPr>
-          <a:lstStyle/>
-          <a:p>
-            <a:pPr indent="0" marL="0">
-              <a:buNone/>
-            </a:pPr>
-            <a:r>
-              <a:rPr lang="en-US" sz="1100" b="1" spc="160" kern="0" dirty="0">
-                <a:solidFill>
-                  <a:srgbClr val="00F604"/>
-                </a:solidFill>
-                <a:latin typeface="Avenir Next" pitchFamily="34" charset="0"/>
-                <a:ea typeface="Avenir Next" pitchFamily="34" charset="-122"/>
-                <a:cs typeface="Avenir Next" pitchFamily="34" charset="-120"/>
-              </a:rPr>
-              <a:t>CASE STUDY</a:t>
-            </a:r>
-            <a:endParaRPr lang="en-US" sz="1100" dirty="0"/>
-          </a:p>
-        </p:txBody>
-      </p:sp>
-      <p:sp>
-        <p:nvSpPr>
-          <p:cNvPr id="3" name="Text 1"/>
-          <p:cNvSpPr txBox="1"/>
-          <p:nvPr/>
-        </p:nvSpPr>
-        <p:spPr>
-          <a:xfrm>
             <a:off x="585216" y="850392"/>
             <a:ext cx="2834640" cy="594360"/>
           </a:xfrm>
@@ -2006,7 +2306,7 @@
       </p:sp>
       <p:sp>
         <p:nvSpPr>
-          <p:cNvPr id="4" name="Text 2"/>
+          <p:cNvPr id="3" name="Text 1"/>
           <p:cNvSpPr txBox="1"/>
           <p:nvPr/>
         </p:nvSpPr>
@@ -2047,7 +2347,7 @@
       </p:sp>
       <p:sp>
         <p:nvSpPr>
-          <p:cNvPr id="5" name="Text 3"/>
+          <p:cNvPr id="4" name="Text 2"/>
           <p:cNvSpPr txBox="1"/>
           <p:nvPr/>
         </p:nvSpPr>
@@ -2103,7 +2403,7 @@
       </p:sp>
       <p:sp>
         <p:nvSpPr>
-          <p:cNvPr id="6" name="Shape 4"/>
+          <p:cNvPr id="5" name="Shape 3"/>
           <p:cNvSpPr/>
           <p:nvPr/>
         </p:nvSpPr>
@@ -2128,7 +2428,7 @@
       </p:sp>
       <p:pic>
         <p:nvPicPr>
-          <p:cNvPr id="7" name="Image 0" descr="/Users/john/theborg/repos/atm/design/screenshots/dashboard.png">    </p:cNvPr>
+          <p:cNvPr id="6" name="Image 0" descr="/Users/john/theborg/repos/atm/design/screenshots/dashboard.png">    </p:cNvPr>
           <p:cNvPicPr>
             <a:picLocks noChangeAspect="1"/>
           </p:cNvPicPr>
@@ -2152,7 +2452,7 @@
       </p:pic>
       <p:sp>
         <p:nvSpPr>
-          <p:cNvPr id="8" name="Text 5"/>
+          <p:cNvPr id="7" name="Text 4"/>
           <p:cNvSpPr txBox="1"/>
           <p:nvPr/>
         </p:nvSpPr>
@@ -4446,7 +4746,7 @@
                 <a:ea typeface="Avenir Next" pitchFamily="34" charset="-122"/>
                 <a:cs typeface="Avenir Next" pitchFamily="34" charset="-120"/>
               </a:rPr>
-              <a:t>How I AI'ed</a:t>
+              <a:t>Best framework for the model</a:t>
             </a:r>
             <a:endParaRPr lang="en-US" sz="3200" dirty="0"/>
           </a:p>
@@ -4460,7 +4760,7 @@
         </p:nvSpPr>
         <p:spPr>
           <a:xfrm>
-            <a:off x="585216" y="1316736"/>
+            <a:off x="585216" y="1353312"/>
             <a:ext cx="1737360" cy="228600"/>
           </a:xfrm>
           <a:prstGeom prst="rect">
@@ -4487,7 +4787,7 @@
                 <a:ea typeface="Avenir Next" pitchFamily="34" charset="-122"/>
                 <a:cs typeface="Avenir Next" pitchFamily="34" charset="-120"/>
               </a:rPr>
-              <a:t>FRAME</a:t>
+              <a:t>CHOSEN</a:t>
             </a:r>
             <a:endParaRPr lang="en-US" sz="1100" dirty="0"/>
           </a:p>
@@ -4501,8 +4801,8 @@
         </p:nvSpPr>
         <p:spPr>
           <a:xfrm>
-            <a:off x="2468880" y="1261872"/>
-            <a:ext cx="6089904" cy="329184"/>
+            <a:off x="2468880" y="1298448"/>
+            <a:ext cx="2286000" cy="329184"/>
           </a:xfrm>
           <a:prstGeom prst="rect">
             <a:avLst/>
@@ -4520,7 +4820,7 @@
               <a:buNone/>
             </a:pPr>
             <a:r>
-              <a:rPr lang="en-US" sz="2000" b="1" dirty="0">
+              <a:rPr lang="en-US" sz="1900" b="1" dirty="0">
                 <a:solidFill>
                   <a:srgbClr val="F5F5F5"/>
                 </a:solidFill>
@@ -4528,9 +4828,9 @@
                 <a:ea typeface="Avenir Next" pitchFamily="34" charset="-122"/>
                 <a:cs typeface="Avenir Next" pitchFamily="34" charset="-120"/>
               </a:rPr>
-              <a:t>GPT-5.6 Sol</a:t>
-            </a:r>
-            <a:endParaRPr lang="en-US" sz="2000" dirty="0"/>
+              <a:t>ASP.NET Core</a:t>
+            </a:r>
+            <a:endParaRPr lang="en-US" sz="1900" dirty="0"/>
           </a:p>
         </p:txBody>
       </p:sp>
@@ -4542,8 +4842,8 @@
         </p:nvSpPr>
         <p:spPr>
           <a:xfrm>
-            <a:off x="2468880" y="1609344"/>
-            <a:ext cx="6089904" cy="219456"/>
+            <a:off x="4754880" y="1335024"/>
+            <a:ext cx="3803904" cy="292608"/>
           </a:xfrm>
           <a:prstGeom prst="rect">
             <a:avLst/>
@@ -4561,7 +4861,153 @@
               <a:buNone/>
             </a:pPr>
             <a:r>
-              <a:rPr lang="en-US" sz="1250" dirty="0">
+              <a:rPr lang="en-US" sz="1500" dirty="0">
+                <a:solidFill>
+                  <a:srgbClr val="F5F5F5"/>
+                </a:solidFill>
+                <a:latin typeface="Avenir Next" pitchFamily="34" charset="0"/>
+                <a:ea typeface="Avenir Next" pitchFamily="34" charset="-122"/>
+                <a:cs typeface="Avenir Next" pitchFamily="34" charset="-120"/>
+              </a:rPr>
+              <a:t>Compile-time checks but fewer examples</a:t>
+            </a:r>
+            <a:endParaRPr lang="en-US" sz="1500" dirty="0"/>
+          </a:p>
+        </p:txBody>
+      </p:sp>
+      <p:sp>
+        <p:nvSpPr>
+          <p:cNvPr id="8" name="Shape 5"/>
+          <p:cNvSpPr/>
+          <p:nvPr/>
+        </p:nvSpPr>
+        <p:spPr>
+          <a:xfrm>
+            <a:off x="585216" y="1755648"/>
+            <a:ext cx="7973568" cy="0"/>
+          </a:xfrm>
+          <a:prstGeom prst="line">
+            <a:avLst/>
+          </a:prstGeom>
+          <a:noFill/>
+          <a:ln w="9525">
+            <a:solidFill>
+              <a:srgbClr val="333333"/>
+            </a:solidFill>
+            <a:prstDash val="solid"/>
+          </a:ln>
+        </p:spPr>
+      </p:sp>
+      <p:sp>
+        <p:nvSpPr>
+          <p:cNvPr id="9" name="Text 6"/>
+          <p:cNvSpPr txBox="1"/>
+          <p:nvPr/>
+        </p:nvSpPr>
+        <p:spPr>
+          <a:xfrm>
+            <a:off x="585216" y="1956816"/>
+            <a:ext cx="1737360" cy="228600"/>
+          </a:xfrm>
+          <a:prstGeom prst="rect">
+            <a:avLst/>
+          </a:prstGeom>
+          <a:noFill/>
+          <a:ln/>
+        </p:spPr>
+        <p:txBody>
+          <a:bodyPr wrap="square" lIns="0" tIns="0" rIns="0" bIns="0" rtlCol="0" anchor="t">
+            <a:normAutofit/>
+          </a:bodyPr>
+          <a:lstStyle/>
+          <a:p>
+            <a:pPr indent="0" marL="0">
+              <a:buNone/>
+            </a:pPr>
+            <a:r>
+              <a:rPr lang="en-US" sz="1100" b="1" spc="160" kern="0" dirty="0">
+                <a:solidFill>
+                  <a:srgbClr val="F67F00"/>
+                </a:solidFill>
+                <a:latin typeface="Avenir Next" pitchFamily="34" charset="0"/>
+                <a:ea typeface="Avenir Next" pitchFamily="34" charset="-122"/>
+                <a:cs typeface="Avenir Next" pitchFamily="34" charset="-120"/>
+              </a:rPr>
+              <a:t>RUNNER-UP</a:t>
+            </a:r>
+            <a:endParaRPr lang="en-US" sz="1100" dirty="0"/>
+          </a:p>
+        </p:txBody>
+      </p:sp>
+      <p:sp>
+        <p:nvSpPr>
+          <p:cNvPr id="10" name="Text 7"/>
+          <p:cNvSpPr txBox="1"/>
+          <p:nvPr/>
+        </p:nvSpPr>
+        <p:spPr>
+          <a:xfrm>
+            <a:off x="2468880" y="1901952"/>
+            <a:ext cx="2286000" cy="329184"/>
+          </a:xfrm>
+          <a:prstGeom prst="rect">
+            <a:avLst/>
+          </a:prstGeom>
+          <a:noFill/>
+          <a:ln/>
+        </p:spPr>
+        <p:txBody>
+          <a:bodyPr wrap="square" lIns="0" tIns="0" rIns="0" bIns="0" rtlCol="0" anchor="t">
+            <a:normAutofit/>
+          </a:bodyPr>
+          <a:lstStyle/>
+          <a:p>
+            <a:pPr indent="0" marL="0">
+              <a:buNone/>
+            </a:pPr>
+            <a:r>
+              <a:rPr lang="en-US" sz="1900" b="1" dirty="0">
+                <a:solidFill>
+                  <a:srgbClr val="F5F5F5"/>
+                </a:solidFill>
+                <a:latin typeface="Avenir Next" pitchFamily="34" charset="0"/>
+                <a:ea typeface="Avenir Next" pitchFamily="34" charset="-122"/>
+                <a:cs typeface="Avenir Next" pitchFamily="34" charset="-120"/>
+              </a:rPr>
+              <a:t>Django</a:t>
+            </a:r>
+            <a:endParaRPr lang="en-US" sz="1900" dirty="0"/>
+          </a:p>
+        </p:txBody>
+      </p:sp>
+      <p:sp>
+        <p:nvSpPr>
+          <p:cNvPr id="11" name="Text 8"/>
+          <p:cNvSpPr txBox="1"/>
+          <p:nvPr/>
+        </p:nvSpPr>
+        <p:spPr>
+          <a:xfrm>
+            <a:off x="4754880" y="1938528"/>
+            <a:ext cx="3803904" cy="292608"/>
+          </a:xfrm>
+          <a:prstGeom prst="rect">
+            <a:avLst/>
+          </a:prstGeom>
+          <a:noFill/>
+          <a:ln/>
+        </p:spPr>
+        <p:txBody>
+          <a:bodyPr wrap="square" lIns="0" tIns="0" rIns="0" bIns="0" rtlCol="0" anchor="t">
+            <a:normAutofit/>
+          </a:bodyPr>
+          <a:lstStyle/>
+          <a:p>
+            <a:pPr indent="0" marL="0">
+              <a:buNone/>
+            </a:pPr>
+            <a:r>
+              <a:rPr lang="en-US" sz="1500" dirty="0">
                 <a:solidFill>
                   <a:srgbClr val="A9ADB3"/>
                 </a:solidFill>
@@ -4569,21 +5015,21 @@
                 <a:ea typeface="Avenir Next" pitchFamily="34" charset="-122"/>
                 <a:cs typeface="Avenir Next" pitchFamily="34" charset="-120"/>
               </a:rPr>
-              <a:t>I approved spec, plan, ADRs</a:t>
-            </a:r>
-            <a:endParaRPr lang="en-US" sz="1250" dirty="0"/>
-          </a:p>
-        </p:txBody>
-      </p:sp>
-      <p:sp>
-        <p:nvSpPr>
-          <p:cNvPr id="8" name="Shape 5"/>
+              <a:t>Most examples but runtime-only errors</a:t>
+            </a:r>
+            <a:endParaRPr lang="en-US" sz="1500" dirty="0"/>
+          </a:p>
+        </p:txBody>
+      </p:sp>
+      <p:sp>
+        <p:nvSpPr>
+          <p:cNvPr id="12" name="Shape 9"/>
           <p:cNvSpPr/>
           <p:nvPr/>
         </p:nvSpPr>
         <p:spPr>
           <a:xfrm>
-            <a:off x="585216" y="2066544"/>
+            <a:off x="585216" y="2359152"/>
             <a:ext cx="7973568" cy="0"/>
           </a:xfrm>
           <a:prstGeom prst="line">
@@ -4600,13 +5046,223 @@
       </p:sp>
       <p:sp>
         <p:nvSpPr>
-          <p:cNvPr id="9" name="Text 6"/>
+          <p:cNvPr id="13" name="Text 10"/>
           <p:cNvSpPr txBox="1"/>
           <p:nvPr/>
         </p:nvSpPr>
         <p:spPr>
           <a:xfrm>
-            <a:off x="585216" y="2322576"/>
+            <a:off x="2468880" y="2505456"/>
+            <a:ext cx="2286000" cy="329184"/>
+          </a:xfrm>
+          <a:prstGeom prst="rect">
+            <a:avLst/>
+          </a:prstGeom>
+          <a:noFill/>
+          <a:ln/>
+        </p:spPr>
+        <p:txBody>
+          <a:bodyPr wrap="square" lIns="0" tIns="0" rIns="0" bIns="0" rtlCol="0" anchor="t">
+            <a:normAutofit/>
+          </a:bodyPr>
+          <a:lstStyle/>
+          <a:p>
+            <a:pPr indent="0" marL="0">
+              <a:buNone/>
+            </a:pPr>
+            <a:r>
+              <a:rPr lang="en-US" sz="1900" b="1" dirty="0">
+                <a:solidFill>
+                  <a:srgbClr val="F5F5F5"/>
+                </a:solidFill>
+                <a:latin typeface="Avenir Next" pitchFamily="34" charset="0"/>
+                <a:ea typeface="Avenir Next" pitchFamily="34" charset="-122"/>
+                <a:cs typeface="Avenir Next" pitchFamily="34" charset="-120"/>
+              </a:rPr>
+              <a:t>Spring Boot</a:t>
+            </a:r>
+            <a:endParaRPr lang="en-US" sz="1900" dirty="0"/>
+          </a:p>
+        </p:txBody>
+      </p:sp>
+      <p:sp>
+        <p:nvSpPr>
+          <p:cNvPr id="14" name="Text 11"/>
+          <p:cNvSpPr txBox="1"/>
+          <p:nvPr/>
+        </p:nvSpPr>
+        <p:spPr>
+          <a:xfrm>
+            <a:off x="4754880" y="2542032"/>
+            <a:ext cx="3803904" cy="292608"/>
+          </a:xfrm>
+          <a:prstGeom prst="rect">
+            <a:avLst/>
+          </a:prstGeom>
+          <a:noFill/>
+          <a:ln/>
+        </p:spPr>
+        <p:txBody>
+          <a:bodyPr wrap="square" lIns="0" tIns="0" rIns="0" bIns="0" rtlCol="0" anchor="t">
+            <a:normAutofit/>
+          </a:bodyPr>
+          <a:lstStyle/>
+          <a:p>
+            <a:pPr indent="0" marL="0">
+              <a:buNone/>
+            </a:pPr>
+            <a:r>
+              <a:rPr lang="en-US" sz="1500" dirty="0">
+                <a:solidFill>
+                  <a:srgbClr val="A9ADB3"/>
+                </a:solidFill>
+                <a:latin typeface="Avenir Next" pitchFamily="34" charset="0"/>
+                <a:ea typeface="Avenir Next" pitchFamily="34" charset="-122"/>
+                <a:cs typeface="Avenir Next" pitchFamily="34" charset="-120"/>
+              </a:rPr>
+              <a:t>Typed but slow tests</a:t>
+            </a:r>
+            <a:endParaRPr lang="en-US" sz="1500" dirty="0"/>
+          </a:p>
+        </p:txBody>
+      </p:sp>
+      <p:sp>
+        <p:nvSpPr>
+          <p:cNvPr id="15" name="Shape 12"/>
+          <p:cNvSpPr/>
+          <p:nvPr/>
+        </p:nvSpPr>
+        <p:spPr>
+          <a:xfrm>
+            <a:off x="585216" y="2962656"/>
+            <a:ext cx="7973568" cy="0"/>
+          </a:xfrm>
+          <a:prstGeom prst="line">
+            <a:avLst/>
+          </a:prstGeom>
+          <a:noFill/>
+          <a:ln w="9525">
+            <a:solidFill>
+              <a:srgbClr val="333333"/>
+            </a:solidFill>
+            <a:prstDash val="solid"/>
+          </a:ln>
+        </p:spPr>
+      </p:sp>
+      <p:sp>
+        <p:nvSpPr>
+          <p:cNvPr id="16" name="Text 13"/>
+          <p:cNvSpPr txBox="1"/>
+          <p:nvPr/>
+        </p:nvSpPr>
+        <p:spPr>
+          <a:xfrm>
+            <a:off x="2468880" y="3108960"/>
+            <a:ext cx="2286000" cy="329184"/>
+          </a:xfrm>
+          <a:prstGeom prst="rect">
+            <a:avLst/>
+          </a:prstGeom>
+          <a:noFill/>
+          <a:ln/>
+        </p:spPr>
+        <p:txBody>
+          <a:bodyPr wrap="square" lIns="0" tIns="0" rIns="0" bIns="0" rtlCol="0" anchor="t">
+            <a:normAutofit/>
+          </a:bodyPr>
+          <a:lstStyle/>
+          <a:p>
+            <a:pPr indent="0" marL="0">
+              <a:buNone/>
+            </a:pPr>
+            <a:r>
+              <a:rPr lang="en-US" sz="1900" b="1" dirty="0">
+                <a:solidFill>
+                  <a:srgbClr val="F5F5F5"/>
+                </a:solidFill>
+                <a:latin typeface="Avenir Next" pitchFamily="34" charset="0"/>
+                <a:ea typeface="Avenir Next" pitchFamily="34" charset="-122"/>
+                <a:cs typeface="Avenir Next" pitchFamily="34" charset="-120"/>
+              </a:rPr>
+              <a:t>Node.js</a:t>
+            </a:r>
+            <a:endParaRPr lang="en-US" sz="1900" dirty="0"/>
+          </a:p>
+        </p:txBody>
+      </p:sp>
+      <p:sp>
+        <p:nvSpPr>
+          <p:cNvPr id="17" name="Text 14"/>
+          <p:cNvSpPr txBox="1"/>
+          <p:nvPr/>
+        </p:nvSpPr>
+        <p:spPr>
+          <a:xfrm>
+            <a:off x="4754880" y="3145536"/>
+            <a:ext cx="3803904" cy="292608"/>
+          </a:xfrm>
+          <a:prstGeom prst="rect">
+            <a:avLst/>
+          </a:prstGeom>
+          <a:noFill/>
+          <a:ln/>
+        </p:spPr>
+        <p:txBody>
+          <a:bodyPr wrap="square" lIns="0" tIns="0" rIns="0" bIns="0" rtlCol="0" anchor="t">
+            <a:normAutofit/>
+          </a:bodyPr>
+          <a:lstStyle/>
+          <a:p>
+            <a:pPr indent="0" marL="0">
+              <a:buNone/>
+            </a:pPr>
+            <a:r>
+              <a:rPr lang="en-US" sz="1500" dirty="0">
+                <a:solidFill>
+                  <a:srgbClr val="A9ADB3"/>
+                </a:solidFill>
+                <a:latin typeface="Avenir Next" pitchFamily="34" charset="0"/>
+                <a:ea typeface="Avenir Next" pitchFamily="34" charset="-122"/>
+                <a:cs typeface="Avenir Next" pitchFamily="34" charset="-120"/>
+              </a:rPr>
+              <a:t>Popular but fast-changing</a:t>
+            </a:r>
+            <a:endParaRPr lang="en-US" sz="1500" dirty="0"/>
+          </a:p>
+        </p:txBody>
+      </p:sp>
+      <p:sp>
+        <p:nvSpPr>
+          <p:cNvPr id="18" name="Shape 15"/>
+          <p:cNvSpPr/>
+          <p:nvPr/>
+        </p:nvSpPr>
+        <p:spPr>
+          <a:xfrm>
+            <a:off x="585216" y="3840480"/>
+            <a:ext cx="7973568" cy="0"/>
+          </a:xfrm>
+          <a:prstGeom prst="line">
+            <a:avLst/>
+          </a:prstGeom>
+          <a:noFill/>
+          <a:ln w="9525">
+            <a:solidFill>
+              <a:srgbClr val="A9ADB3"/>
+            </a:solidFill>
+            <a:prstDash val="solid"/>
+          </a:ln>
+        </p:spPr>
+      </p:sp>
+      <p:sp>
+        <p:nvSpPr>
+          <p:cNvPr id="19" name="Text 16"/>
+          <p:cNvSpPr txBox="1"/>
+          <p:nvPr/>
+        </p:nvSpPr>
+        <p:spPr>
+          <a:xfrm>
+            <a:off x="585216" y="4059936"/>
             <a:ext cx="1737360" cy="228600"/>
           </a:xfrm>
           <a:prstGeom prst="rect">
@@ -4633,7 +5289,7 @@
                 <a:ea typeface="Avenir Next" pitchFamily="34" charset="-122"/>
                 <a:cs typeface="Avenir Next" pitchFamily="34" charset="-120"/>
               </a:rPr>
-              <a:t>BUILD</a:t>
+              <a:t>RANKED BY</a:t>
             </a:r>
             <a:endParaRPr lang="en-US" sz="1100" dirty="0"/>
           </a:p>
@@ -4641,13 +5297,13 @@
       </p:sp>
       <p:sp>
         <p:nvSpPr>
-          <p:cNvPr id="10" name="Text 7"/>
+          <p:cNvPr id="20" name="Text 17"/>
           <p:cNvSpPr txBox="1"/>
           <p:nvPr/>
         </p:nvSpPr>
         <p:spPr>
           <a:xfrm>
-            <a:off x="2468880" y="2267712"/>
+            <a:off x="2468880" y="4005072"/>
             <a:ext cx="6089904" cy="329184"/>
           </a:xfrm>
           <a:prstGeom prst="rect">
@@ -4666,7 +5322,7 @@
               <a:buNone/>
             </a:pPr>
             <a:r>
-              <a:rPr lang="en-US" sz="2000" b="1" dirty="0">
+              <a:rPr lang="en-US" sz="1900" b="1" dirty="0">
                 <a:solidFill>
                   <a:srgbClr val="F5F5F5"/>
                 </a:solidFill>
@@ -4674,237 +5330,9 @@
                 <a:ea typeface="Avenir Next" pitchFamily="34" charset="-122"/>
                 <a:cs typeface="Avenir Next" pitchFamily="34" charset="-120"/>
               </a:rPr>
-              <a:t>Fable 5.1</a:t>
-            </a:r>
-            <a:endParaRPr lang="en-US" sz="2000" dirty="0"/>
-          </a:p>
-        </p:txBody>
-      </p:sp>
-      <p:sp>
-        <p:nvSpPr>
-          <p:cNvPr id="11" name="Text 8"/>
-          <p:cNvSpPr txBox="1"/>
-          <p:nvPr/>
-        </p:nvSpPr>
-        <p:spPr>
-          <a:xfrm>
-            <a:off x="2468880" y="2615184"/>
-            <a:ext cx="6089904" cy="219456"/>
-          </a:xfrm>
-          <a:prstGeom prst="rect">
-            <a:avLst/>
-          </a:prstGeom>
-          <a:noFill/>
-          <a:ln/>
-        </p:spPr>
-        <p:txBody>
-          <a:bodyPr wrap="square" lIns="0" tIns="0" rIns="0" bIns="0" rtlCol="0" anchor="t">
-            <a:normAutofit/>
-          </a:bodyPr>
-          <a:lstStyle/>
-          <a:p>
-            <a:pPr indent="0" marL="0">
-              <a:buNone/>
-            </a:pPr>
-            <a:r>
-              <a:rPr lang="en-US" sz="1250" dirty="0">
-                <a:solidFill>
-                  <a:srgbClr val="A9ADB3"/>
-                </a:solidFill>
-                <a:latin typeface="Avenir Next" pitchFamily="34" charset="0"/>
-                <a:ea typeface="Avenir Next" pitchFamily="34" charset="-122"/>
-                <a:cs typeface="Avenir Next" pitchFamily="34" charset="-120"/>
-              </a:rPr>
-              <a:t>Six phases, tests green per commit</a:t>
-            </a:r>
-            <a:endParaRPr lang="en-US" sz="1250" dirty="0"/>
-          </a:p>
-        </p:txBody>
-      </p:sp>
-      <p:sp>
-        <p:nvSpPr>
-          <p:cNvPr id="12" name="Text 9"/>
-          <p:cNvSpPr txBox="1"/>
-          <p:nvPr/>
-        </p:nvSpPr>
-        <p:spPr>
-          <a:xfrm>
-            <a:off x="2468880" y="2889504"/>
-            <a:ext cx="6089904" cy="219456"/>
-          </a:xfrm>
-          <a:prstGeom prst="rect">
-            <a:avLst/>
-          </a:prstGeom>
-          <a:noFill/>
-          <a:ln/>
-        </p:spPr>
-        <p:txBody>
-          <a:bodyPr wrap="square" lIns="0" tIns="0" rIns="0" bIns="0" rtlCol="0" anchor="t">
-            <a:normAutofit/>
-          </a:bodyPr>
-          <a:lstStyle/>
-          <a:p>
-            <a:pPr indent="0" marL="0">
-              <a:buNone/>
-            </a:pPr>
-            <a:r>
-              <a:rPr lang="en-US" sz="1250" b="1" dirty="0">
-                <a:solidFill>
-                  <a:srgbClr val="F67F00"/>
-                </a:solidFill>
-                <a:latin typeface="Avenir Next" pitchFamily="34" charset="0"/>
-                <a:ea typeface="Avenir Next" pitchFamily="34" charset="-122"/>
-                <a:cs typeface="Avenir Next" pitchFamily="34" charset="-120"/>
-              </a:rPr>
-              <a:t>Chose to minimize rework over tokens</a:t>
-            </a:r>
-            <a:endParaRPr lang="en-US" sz="1250" dirty="0"/>
-          </a:p>
-        </p:txBody>
-      </p:sp>
-      <p:sp>
-        <p:nvSpPr>
-          <p:cNvPr id="13" name="Shape 10"/>
-          <p:cNvSpPr/>
-          <p:nvPr/>
-        </p:nvSpPr>
-        <p:spPr>
-          <a:xfrm>
-            <a:off x="585216" y="3255264"/>
-            <a:ext cx="7973568" cy="0"/>
-          </a:xfrm>
-          <a:prstGeom prst="line">
-            <a:avLst/>
-          </a:prstGeom>
-          <a:noFill/>
-          <a:ln w="9525">
-            <a:solidFill>
-              <a:srgbClr val="333333"/>
-            </a:solidFill>
-            <a:prstDash val="solid"/>
-          </a:ln>
-        </p:spPr>
-      </p:sp>
-      <p:sp>
-        <p:nvSpPr>
-          <p:cNvPr id="14" name="Text 11"/>
-          <p:cNvSpPr txBox="1"/>
-          <p:nvPr/>
-        </p:nvSpPr>
-        <p:spPr>
-          <a:xfrm>
-            <a:off x="585216" y="3511296"/>
-            <a:ext cx="1737360" cy="228600"/>
-          </a:xfrm>
-          <a:prstGeom prst="rect">
-            <a:avLst/>
-          </a:prstGeom>
-          <a:noFill/>
-          <a:ln/>
-        </p:spPr>
-        <p:txBody>
-          <a:bodyPr wrap="square" lIns="0" tIns="0" rIns="0" bIns="0" rtlCol="0" anchor="t">
-            <a:normAutofit/>
-          </a:bodyPr>
-          <a:lstStyle/>
-          <a:p>
-            <a:pPr indent="0" marL="0">
-              <a:buNone/>
-            </a:pPr>
-            <a:r>
-              <a:rPr lang="en-US" sz="1100" b="1" spc="160" kern="0" dirty="0">
-                <a:solidFill>
-                  <a:srgbClr val="00F604"/>
-                </a:solidFill>
-                <a:latin typeface="Avenir Next" pitchFamily="34" charset="0"/>
-                <a:ea typeface="Avenir Next" pitchFamily="34" charset="-122"/>
-                <a:cs typeface="Avenir Next" pitchFamily="34" charset="-120"/>
-              </a:rPr>
-              <a:t>REFINE</a:t>
-            </a:r>
-            <a:endParaRPr lang="en-US" sz="1100" dirty="0"/>
-          </a:p>
-        </p:txBody>
-      </p:sp>
-      <p:sp>
-        <p:nvSpPr>
-          <p:cNvPr id="15" name="Text 12"/>
-          <p:cNvSpPr txBox="1"/>
-          <p:nvPr/>
-        </p:nvSpPr>
-        <p:spPr>
-          <a:xfrm>
-            <a:off x="2468880" y="3456432"/>
-            <a:ext cx="6089904" cy="329184"/>
-          </a:xfrm>
-          <a:prstGeom prst="rect">
-            <a:avLst/>
-          </a:prstGeom>
-          <a:noFill/>
-          <a:ln/>
-        </p:spPr>
-        <p:txBody>
-          <a:bodyPr wrap="square" lIns="0" tIns="0" rIns="0" bIns="0" rtlCol="0" anchor="t">
-            <a:normAutofit/>
-          </a:bodyPr>
-          <a:lstStyle/>
-          <a:p>
-            <a:pPr indent="0" marL="0">
-              <a:buNone/>
-            </a:pPr>
-            <a:r>
-              <a:rPr lang="en-US" sz="2000" b="1" dirty="0">
-                <a:solidFill>
-                  <a:srgbClr val="F5F5F5"/>
-                </a:solidFill>
-                <a:latin typeface="Avenir Next" pitchFamily="34" charset="0"/>
-                <a:ea typeface="Avenir Next" pitchFamily="34" charset="-122"/>
-                <a:cs typeface="Avenir Next" pitchFamily="34" charset="-120"/>
-              </a:rPr>
-              <a:t>Opus 5.5, GPT-6 Sol</a:t>
-            </a:r>
-            <a:endParaRPr lang="en-US" sz="2000" dirty="0"/>
-          </a:p>
-        </p:txBody>
-      </p:sp>
-      <p:sp>
-        <p:nvSpPr>
-          <p:cNvPr id="16" name="Text 13"/>
-          <p:cNvSpPr txBox="1"/>
-          <p:nvPr/>
-        </p:nvSpPr>
-        <p:spPr>
-          <a:xfrm>
-            <a:off x="2468880" y="3803904"/>
-            <a:ext cx="6089904" cy="219456"/>
-          </a:xfrm>
-          <a:prstGeom prst="rect">
-            <a:avLst/>
-          </a:prstGeom>
-          <a:noFill/>
-          <a:ln/>
-        </p:spPr>
-        <p:txBody>
-          <a:bodyPr wrap="square" lIns="0" tIns="0" rIns="0" bIns="0" rtlCol="0" anchor="t">
-            <a:normAutofit/>
-          </a:bodyPr>
-          <a:lstStyle/>
-          <a:p>
-            <a:pPr indent="0" marL="0">
-              <a:buNone/>
-            </a:pPr>
-            <a:r>
-              <a:rPr lang="en-US" sz="1250" dirty="0">
-                <a:solidFill>
-                  <a:srgbClr val="A9ADB3"/>
-                </a:solidFill>
-                <a:latin typeface="Avenir Next" pitchFamily="34" charset="0"/>
-                <a:ea typeface="Avenir Next" pitchFamily="34" charset="-122"/>
-                <a:cs typeface="Avenir Next" pitchFamily="34" charset="-120"/>
-              </a:rPr>
-              <a:t>Docs, deck, fixes</a:t>
-            </a:r>
-            <a:endParaRPr lang="en-US" sz="1250" dirty="0"/>
+              <a:t>How soon LLM mistakes surface</a:t>
+            </a:r>
+            <a:endParaRPr lang="en-US" sz="1900" dirty="0"/>
           </a:p>
         </p:txBody>
       </p:sp>
@@ -4919,6 +5347,562 @@
 <file path=ppt/slides/slide6.xml><?xml version="1.0" encoding="utf-8"?>
 <p:sld xmlns:a="http://schemas.openxmlformats.org/drawingml/2006/main" xmlns:r="http://schemas.openxmlformats.org/officeDocument/2006/relationships" xmlns:p="http://schemas.openxmlformats.org/presentationml/2006/main">
   <p:cSld name="Slide 6">
+    <p:bg>
+      <p:bgPr>
+        <a:solidFill>
+          <a:srgbClr val="121212"/>
+        </a:solidFill>
+      </p:bgPr>
+    </p:bg>
+    <p:spTree>
+      <p:nvGrpSpPr>
+        <p:cNvPr id="1" name=""/>
+        <p:cNvGrpSpPr/>
+        <p:nvPr/>
+      </p:nvGrpSpPr>
+      <p:grpSpPr>
+        <a:xfrm>
+          <a:off x="0" y="0"/>
+          <a:ext cx="0" cy="0"/>
+          <a:chOff x="0" y="0"/>
+          <a:chExt cx="0" cy="0"/>
+        </a:xfrm>
+      </p:grpSpPr>
+      <p:sp>
+        <p:nvSpPr>
+          <p:cNvPr id="2" name="Shape 0"/>
+          <p:cNvSpPr/>
+          <p:nvPr/>
+        </p:nvSpPr>
+        <p:spPr>
+          <a:xfrm>
+            <a:off x="585216" y="356616"/>
+            <a:ext cx="91440" cy="438912"/>
+          </a:xfrm>
+          <a:prstGeom prst="rect">
+            <a:avLst/>
+          </a:prstGeom>
+          <a:solidFill>
+            <a:srgbClr val="00F604"/>
+          </a:solidFill>
+          <a:ln w="12700">
+            <a:solidFill>
+              <a:srgbClr val="00F604">
+                <a:alpha val="0"/>
+              </a:srgbClr>
+            </a:solidFill>
+            <a:prstDash val="solid"/>
+          </a:ln>
+        </p:spPr>
+      </p:sp>
+      <p:sp>
+        <p:nvSpPr>
+          <p:cNvPr id="3" name="Text 1"/>
+          <p:cNvSpPr txBox="1"/>
+          <p:nvPr/>
+        </p:nvSpPr>
+        <p:spPr>
+          <a:xfrm>
+            <a:off x="832104" y="356616"/>
+            <a:ext cx="7726680" cy="512064"/>
+          </a:xfrm>
+          <a:prstGeom prst="rect">
+            <a:avLst/>
+          </a:prstGeom>
+          <a:noFill/>
+          <a:ln/>
+        </p:spPr>
+        <p:txBody>
+          <a:bodyPr wrap="square" lIns="0" tIns="0" rIns="0" bIns="0" rtlCol="0" anchor="t">
+            <a:normAutofit/>
+          </a:bodyPr>
+          <a:lstStyle/>
+          <a:p>
+            <a:pPr indent="0" marL="0">
+              <a:buNone/>
+            </a:pPr>
+            <a:r>
+              <a:rPr lang="en-US" sz="3200" b="1" dirty="0">
+                <a:solidFill>
+                  <a:srgbClr val="F5F5F5"/>
+                </a:solidFill>
+                <a:latin typeface="Avenir Next" pitchFamily="34" charset="0"/>
+                <a:ea typeface="Avenir Next" pitchFamily="34" charset="-122"/>
+                <a:cs typeface="Avenir Next" pitchFamily="34" charset="-120"/>
+              </a:rPr>
+              <a:t>How I AI'ed</a:t>
+            </a:r>
+            <a:endParaRPr lang="en-US" sz="3200" dirty="0"/>
+          </a:p>
+        </p:txBody>
+      </p:sp>
+      <p:sp>
+        <p:nvSpPr>
+          <p:cNvPr id="5" name="Text 2"/>
+          <p:cNvSpPr txBox="1"/>
+          <p:nvPr/>
+        </p:nvSpPr>
+        <p:spPr>
+          <a:xfrm>
+            <a:off x="585216" y="1316736"/>
+            <a:ext cx="1737360" cy="228600"/>
+          </a:xfrm>
+          <a:prstGeom prst="rect">
+            <a:avLst/>
+          </a:prstGeom>
+          <a:noFill/>
+          <a:ln/>
+        </p:spPr>
+        <p:txBody>
+          <a:bodyPr wrap="square" lIns="0" tIns="0" rIns="0" bIns="0" rtlCol="0" anchor="t">
+            <a:normAutofit/>
+          </a:bodyPr>
+          <a:lstStyle/>
+          <a:p>
+            <a:pPr indent="0" marL="0">
+              <a:buNone/>
+            </a:pPr>
+            <a:r>
+              <a:rPr lang="en-US" sz="1100" b="1" spc="160" kern="0" dirty="0">
+                <a:solidFill>
+                  <a:srgbClr val="00F604"/>
+                </a:solidFill>
+                <a:latin typeface="Avenir Next" pitchFamily="34" charset="0"/>
+                <a:ea typeface="Avenir Next" pitchFamily="34" charset="-122"/>
+                <a:cs typeface="Avenir Next" pitchFamily="34" charset="-120"/>
+              </a:rPr>
+              <a:t>FRAME</a:t>
+            </a:r>
+            <a:endParaRPr lang="en-US" sz="1100" dirty="0"/>
+          </a:p>
+        </p:txBody>
+      </p:sp>
+      <p:sp>
+        <p:nvSpPr>
+          <p:cNvPr id="6" name="Text 3"/>
+          <p:cNvSpPr txBox="1"/>
+          <p:nvPr/>
+        </p:nvSpPr>
+        <p:spPr>
+          <a:xfrm>
+            <a:off x="2468880" y="1261872"/>
+            <a:ext cx="6089904" cy="329184"/>
+          </a:xfrm>
+          <a:prstGeom prst="rect">
+            <a:avLst/>
+          </a:prstGeom>
+          <a:noFill/>
+          <a:ln/>
+        </p:spPr>
+        <p:txBody>
+          <a:bodyPr wrap="square" lIns="0" tIns="0" rIns="0" bIns="0" rtlCol="0" anchor="t">
+            <a:normAutofit/>
+          </a:bodyPr>
+          <a:lstStyle/>
+          <a:p>
+            <a:pPr indent="0" marL="0">
+              <a:buNone/>
+            </a:pPr>
+            <a:r>
+              <a:rPr lang="en-US" sz="2000" b="1" dirty="0">
+                <a:solidFill>
+                  <a:srgbClr val="F5F5F5"/>
+                </a:solidFill>
+                <a:latin typeface="Avenir Next" pitchFamily="34" charset="0"/>
+                <a:ea typeface="Avenir Next" pitchFamily="34" charset="-122"/>
+                <a:cs typeface="Avenir Next" pitchFamily="34" charset="-120"/>
+              </a:rPr>
+              <a:t>GPT-5.6 Sol</a:t>
+            </a:r>
+            <a:endParaRPr lang="en-US" sz="2000" dirty="0"/>
+          </a:p>
+        </p:txBody>
+      </p:sp>
+      <p:sp>
+        <p:nvSpPr>
+          <p:cNvPr id="7" name="Text 4"/>
+          <p:cNvSpPr txBox="1"/>
+          <p:nvPr/>
+        </p:nvSpPr>
+        <p:spPr>
+          <a:xfrm>
+            <a:off x="2468880" y="1609344"/>
+            <a:ext cx="6089904" cy="219456"/>
+          </a:xfrm>
+          <a:prstGeom prst="rect">
+            <a:avLst/>
+          </a:prstGeom>
+          <a:noFill/>
+          <a:ln/>
+        </p:spPr>
+        <p:txBody>
+          <a:bodyPr wrap="square" lIns="0" tIns="0" rIns="0" bIns="0" rtlCol="0" anchor="t">
+            <a:normAutofit/>
+          </a:bodyPr>
+          <a:lstStyle/>
+          <a:p>
+            <a:pPr indent="0" marL="0">
+              <a:buNone/>
+            </a:pPr>
+            <a:r>
+              <a:rPr lang="en-US" sz="1250" dirty="0">
+                <a:solidFill>
+                  <a:srgbClr val="A9ADB3"/>
+                </a:solidFill>
+                <a:latin typeface="Avenir Next" pitchFamily="34" charset="0"/>
+                <a:ea typeface="Avenir Next" pitchFamily="34" charset="-122"/>
+                <a:cs typeface="Avenir Next" pitchFamily="34" charset="-120"/>
+              </a:rPr>
+              <a:t>I approved spec, plan, ADRs</a:t>
+            </a:r>
+            <a:endParaRPr lang="en-US" sz="1250" dirty="0"/>
+          </a:p>
+        </p:txBody>
+      </p:sp>
+      <p:sp>
+        <p:nvSpPr>
+          <p:cNvPr id="8" name="Shape 5"/>
+          <p:cNvSpPr/>
+          <p:nvPr/>
+        </p:nvSpPr>
+        <p:spPr>
+          <a:xfrm>
+            <a:off x="585216" y="2066544"/>
+            <a:ext cx="7973568" cy="0"/>
+          </a:xfrm>
+          <a:prstGeom prst="line">
+            <a:avLst/>
+          </a:prstGeom>
+          <a:noFill/>
+          <a:ln w="9525">
+            <a:solidFill>
+              <a:srgbClr val="333333"/>
+            </a:solidFill>
+            <a:prstDash val="solid"/>
+          </a:ln>
+        </p:spPr>
+      </p:sp>
+      <p:sp>
+        <p:nvSpPr>
+          <p:cNvPr id="9" name="Text 6"/>
+          <p:cNvSpPr txBox="1"/>
+          <p:nvPr/>
+        </p:nvSpPr>
+        <p:spPr>
+          <a:xfrm>
+            <a:off x="585216" y="2322576"/>
+            <a:ext cx="1737360" cy="228600"/>
+          </a:xfrm>
+          <a:prstGeom prst="rect">
+            <a:avLst/>
+          </a:prstGeom>
+          <a:noFill/>
+          <a:ln/>
+        </p:spPr>
+        <p:txBody>
+          <a:bodyPr wrap="square" lIns="0" tIns="0" rIns="0" bIns="0" rtlCol="0" anchor="t">
+            <a:normAutofit/>
+          </a:bodyPr>
+          <a:lstStyle/>
+          <a:p>
+            <a:pPr indent="0" marL="0">
+              <a:buNone/>
+            </a:pPr>
+            <a:r>
+              <a:rPr lang="en-US" sz="1100" b="1" spc="160" kern="0" dirty="0">
+                <a:solidFill>
+                  <a:srgbClr val="00F604"/>
+                </a:solidFill>
+                <a:latin typeface="Avenir Next" pitchFamily="34" charset="0"/>
+                <a:ea typeface="Avenir Next" pitchFamily="34" charset="-122"/>
+                <a:cs typeface="Avenir Next" pitchFamily="34" charset="-120"/>
+              </a:rPr>
+              <a:t>BUILD</a:t>
+            </a:r>
+            <a:endParaRPr lang="en-US" sz="1100" dirty="0"/>
+          </a:p>
+        </p:txBody>
+      </p:sp>
+      <p:sp>
+        <p:nvSpPr>
+          <p:cNvPr id="10" name="Text 7"/>
+          <p:cNvSpPr txBox="1"/>
+          <p:nvPr/>
+        </p:nvSpPr>
+        <p:spPr>
+          <a:xfrm>
+            <a:off x="2468880" y="2267712"/>
+            <a:ext cx="6089904" cy="329184"/>
+          </a:xfrm>
+          <a:prstGeom prst="rect">
+            <a:avLst/>
+          </a:prstGeom>
+          <a:noFill/>
+          <a:ln/>
+        </p:spPr>
+        <p:txBody>
+          <a:bodyPr wrap="square" lIns="0" tIns="0" rIns="0" bIns="0" rtlCol="0" anchor="t">
+            <a:normAutofit/>
+          </a:bodyPr>
+          <a:lstStyle/>
+          <a:p>
+            <a:pPr indent="0" marL="0">
+              <a:buNone/>
+            </a:pPr>
+            <a:r>
+              <a:rPr lang="en-US" sz="2000" b="1" dirty="0">
+                <a:solidFill>
+                  <a:srgbClr val="F5F5F5"/>
+                </a:solidFill>
+                <a:latin typeface="Avenir Next" pitchFamily="34" charset="0"/>
+                <a:ea typeface="Avenir Next" pitchFamily="34" charset="-122"/>
+                <a:cs typeface="Avenir Next" pitchFamily="34" charset="-120"/>
+              </a:rPr>
+              <a:t>Fable 5.1</a:t>
+            </a:r>
+            <a:endParaRPr lang="en-US" sz="2000" dirty="0"/>
+          </a:p>
+        </p:txBody>
+      </p:sp>
+      <p:sp>
+        <p:nvSpPr>
+          <p:cNvPr id="11" name="Text 8"/>
+          <p:cNvSpPr txBox="1"/>
+          <p:nvPr/>
+        </p:nvSpPr>
+        <p:spPr>
+          <a:xfrm>
+            <a:off x="2468880" y="2615184"/>
+            <a:ext cx="6089904" cy="219456"/>
+          </a:xfrm>
+          <a:prstGeom prst="rect">
+            <a:avLst/>
+          </a:prstGeom>
+          <a:noFill/>
+          <a:ln/>
+        </p:spPr>
+        <p:txBody>
+          <a:bodyPr wrap="square" lIns="0" tIns="0" rIns="0" bIns="0" rtlCol="0" anchor="t">
+            <a:normAutofit/>
+          </a:bodyPr>
+          <a:lstStyle/>
+          <a:p>
+            <a:pPr indent="0" marL="0">
+              <a:buNone/>
+            </a:pPr>
+            <a:r>
+              <a:rPr lang="en-US" sz="1250" dirty="0">
+                <a:solidFill>
+                  <a:srgbClr val="A9ADB3"/>
+                </a:solidFill>
+                <a:latin typeface="Avenir Next" pitchFamily="34" charset="0"/>
+                <a:ea typeface="Avenir Next" pitchFamily="34" charset="-122"/>
+                <a:cs typeface="Avenir Next" pitchFamily="34" charset="-120"/>
+              </a:rPr>
+              <a:t>Six phases, tests green per commit</a:t>
+            </a:r>
+            <a:endParaRPr lang="en-US" sz="1250" dirty="0"/>
+          </a:p>
+        </p:txBody>
+      </p:sp>
+      <p:sp>
+        <p:nvSpPr>
+          <p:cNvPr id="12" name="Text 9"/>
+          <p:cNvSpPr txBox="1"/>
+          <p:nvPr/>
+        </p:nvSpPr>
+        <p:spPr>
+          <a:xfrm>
+            <a:off x="2468880" y="2889504"/>
+            <a:ext cx="6089904" cy="219456"/>
+          </a:xfrm>
+          <a:prstGeom prst="rect">
+            <a:avLst/>
+          </a:prstGeom>
+          <a:noFill/>
+          <a:ln/>
+        </p:spPr>
+        <p:txBody>
+          <a:bodyPr wrap="square" lIns="0" tIns="0" rIns="0" bIns="0" rtlCol="0" anchor="t">
+            <a:normAutofit/>
+          </a:bodyPr>
+          <a:lstStyle/>
+          <a:p>
+            <a:pPr indent="0" marL="0">
+              <a:buNone/>
+            </a:pPr>
+            <a:r>
+              <a:rPr lang="en-US" sz="1250" b="1" dirty="0">
+                <a:solidFill>
+                  <a:srgbClr val="F67F00"/>
+                </a:solidFill>
+                <a:latin typeface="Avenir Next" pitchFamily="34" charset="0"/>
+                <a:ea typeface="Avenir Next" pitchFamily="34" charset="-122"/>
+                <a:cs typeface="Avenir Next" pitchFamily="34" charset="-120"/>
+              </a:rPr>
+              <a:t>Chose to minimize rework over tokens</a:t>
+            </a:r>
+            <a:endParaRPr lang="en-US" sz="1250" dirty="0"/>
+          </a:p>
+        </p:txBody>
+      </p:sp>
+      <p:sp>
+        <p:nvSpPr>
+          <p:cNvPr id="13" name="Shape 10"/>
+          <p:cNvSpPr/>
+          <p:nvPr/>
+        </p:nvSpPr>
+        <p:spPr>
+          <a:xfrm>
+            <a:off x="585216" y="3255264"/>
+            <a:ext cx="7973568" cy="0"/>
+          </a:xfrm>
+          <a:prstGeom prst="line">
+            <a:avLst/>
+          </a:prstGeom>
+          <a:noFill/>
+          <a:ln w="9525">
+            <a:solidFill>
+              <a:srgbClr val="333333"/>
+            </a:solidFill>
+            <a:prstDash val="solid"/>
+          </a:ln>
+        </p:spPr>
+      </p:sp>
+      <p:sp>
+        <p:nvSpPr>
+          <p:cNvPr id="14" name="Text 11"/>
+          <p:cNvSpPr txBox="1"/>
+          <p:nvPr/>
+        </p:nvSpPr>
+        <p:spPr>
+          <a:xfrm>
+            <a:off x="585216" y="3511296"/>
+            <a:ext cx="1737360" cy="228600"/>
+          </a:xfrm>
+          <a:prstGeom prst="rect">
+            <a:avLst/>
+          </a:prstGeom>
+          <a:noFill/>
+          <a:ln/>
+        </p:spPr>
+        <p:txBody>
+          <a:bodyPr wrap="square" lIns="0" tIns="0" rIns="0" bIns="0" rtlCol="0" anchor="t">
+            <a:normAutofit/>
+          </a:bodyPr>
+          <a:lstStyle/>
+          <a:p>
+            <a:pPr indent="0" marL="0">
+              <a:buNone/>
+            </a:pPr>
+            <a:r>
+              <a:rPr lang="en-US" sz="1100" b="1" spc="160" kern="0" dirty="0">
+                <a:solidFill>
+                  <a:srgbClr val="00F604"/>
+                </a:solidFill>
+                <a:latin typeface="Avenir Next" pitchFamily="34" charset="0"/>
+                <a:ea typeface="Avenir Next" pitchFamily="34" charset="-122"/>
+                <a:cs typeface="Avenir Next" pitchFamily="34" charset="-120"/>
+              </a:rPr>
+              <a:t>REFINE</a:t>
+            </a:r>
+            <a:endParaRPr lang="en-US" sz="1100" dirty="0"/>
+          </a:p>
+        </p:txBody>
+      </p:sp>
+      <p:sp>
+        <p:nvSpPr>
+          <p:cNvPr id="15" name="Text 12"/>
+          <p:cNvSpPr txBox="1"/>
+          <p:nvPr/>
+        </p:nvSpPr>
+        <p:spPr>
+          <a:xfrm>
+            <a:off x="2468880" y="3456432"/>
+            <a:ext cx="6089904" cy="329184"/>
+          </a:xfrm>
+          <a:prstGeom prst="rect">
+            <a:avLst/>
+          </a:prstGeom>
+          <a:noFill/>
+          <a:ln/>
+        </p:spPr>
+        <p:txBody>
+          <a:bodyPr wrap="square" lIns="0" tIns="0" rIns="0" bIns="0" rtlCol="0" anchor="t">
+            <a:normAutofit/>
+          </a:bodyPr>
+          <a:lstStyle/>
+          <a:p>
+            <a:pPr indent="0" marL="0">
+              <a:buNone/>
+            </a:pPr>
+            <a:r>
+              <a:rPr lang="en-US" sz="2000" b="1" dirty="0">
+                <a:solidFill>
+                  <a:srgbClr val="F5F5F5"/>
+                </a:solidFill>
+                <a:latin typeface="Avenir Next" pitchFamily="34" charset="0"/>
+                <a:ea typeface="Avenir Next" pitchFamily="34" charset="-122"/>
+                <a:cs typeface="Avenir Next" pitchFamily="34" charset="-120"/>
+              </a:rPr>
+              <a:t>Opus 5.5, GPT-6 Sol</a:t>
+            </a:r>
+            <a:endParaRPr lang="en-US" sz="2000" dirty="0"/>
+          </a:p>
+        </p:txBody>
+      </p:sp>
+      <p:sp>
+        <p:nvSpPr>
+          <p:cNvPr id="16" name="Text 13"/>
+          <p:cNvSpPr txBox="1"/>
+          <p:nvPr/>
+        </p:nvSpPr>
+        <p:spPr>
+          <a:xfrm>
+            <a:off x="2468880" y="3803904"/>
+            <a:ext cx="6089904" cy="219456"/>
+          </a:xfrm>
+          <a:prstGeom prst="rect">
+            <a:avLst/>
+          </a:prstGeom>
+          <a:noFill/>
+          <a:ln/>
+        </p:spPr>
+        <p:txBody>
+          <a:bodyPr wrap="square" lIns="0" tIns="0" rIns="0" bIns="0" rtlCol="0" anchor="t">
+            <a:normAutofit/>
+          </a:bodyPr>
+          <a:lstStyle/>
+          <a:p>
+            <a:pPr indent="0" marL="0">
+              <a:buNone/>
+            </a:pPr>
+            <a:r>
+              <a:rPr lang="en-US" sz="1250" dirty="0">
+                <a:solidFill>
+                  <a:srgbClr val="A9ADB3"/>
+                </a:solidFill>
+                <a:latin typeface="Avenir Next" pitchFamily="34" charset="0"/>
+                <a:ea typeface="Avenir Next" pitchFamily="34" charset="-122"/>
+                <a:cs typeface="Avenir Next" pitchFamily="34" charset="-120"/>
+              </a:rPr>
+              <a:t>Docs, deck, fixes</a:t>
+            </a:r>
+            <a:endParaRPr lang="en-US" sz="1250" dirty="0"/>
+          </a:p>
+        </p:txBody>
+      </p:sp>
+    </p:spTree>
+  </p:cSld>
+  <p:clrMapOvr>
+    <a:masterClrMapping/>
+  </p:clrMapOvr>
+</p:sld>
+</file>
+
+<file path=ppt/slides/slide7.xml><?xml version="1.0" encoding="utf-8"?>
+<p:sld xmlns:a="http://schemas.openxmlformats.org/drawingml/2006/main" xmlns:r="http://schemas.openxmlformats.org/officeDocument/2006/relationships" xmlns:p="http://schemas.openxmlformats.org/presentationml/2006/main">
+  <p:cSld name="Slide 7">
     <p:bg>
       <p:bgPr>
         <a:solidFill>

</xml_diff>

<commit_message>
Make deck notes bullets consistent across all slides
Convert typed bullet characters on slides 4 and 6, and plain
paragraphs on slides 1-3, to the same real-bullet markup slides 5
and 7 already used. Add Chosen/Considered headers and bold option
names on slide 4 to match slide 5's layout.

Co-Authored-By: Claude Sonnet 5 <noreply@anthropic.com>
</commit_message>
<xml_diff>
--- a/design/atm-deck.pptx
+++ b/design/atm-deck.pptx
@@ -506,6 +506,10 @@
           <a:bodyPr/>
           <a:lstStyle/>
           <a:p>
+            <a:pPr marL="228600" lvl="0" indent="-228600">
+              <a:buFont typeface="Arial"/>
+              <a:buChar char="•"/>
+            </a:pPr>
             <a:r>
               <a:rPr lang="en-US" dirty="0"/>
               <a:t>Runs against a scratch SQLite database.</a:t>
@@ -513,9 +517,10 @@
             <a:endParaRPr lang="en-US" dirty="0"/>
           </a:p>
           <a:p>
-            <a:endParaRPr lang="en-US" dirty="0"/>
-          </a:p>
-          <a:p>
+            <a:pPr marL="228600" lvl="0" indent="-228600">
+              <a:buFont typeface="Arial"/>
+              <a:buChar char="•"/>
+            </a:pPr>
             <a:r>
               <a:rPr lang="en-US" dirty="0"/>
               <a:t>The intentionally narrow scope keeps the review on correctness, architectural boundaries, and evidence.</a:t>
@@ -523,9 +528,10 @@
             <a:endParaRPr lang="en-US" dirty="0"/>
           </a:p>
           <a:p>
-            <a:endParaRPr lang="en-US" dirty="0"/>
-          </a:p>
-          <a:p>
+            <a:pPr marL="228600" lvl="0" indent="-228600">
+              <a:buFont typeface="Arial"/>
+              <a:buChar char="•"/>
+            </a:pPr>
             <a:r>
               <a:rPr lang="en-US" dirty="0"/>
               <a:t>The Konami code is up, up, down, down, left, right, left, right, B, A.</a:t>
@@ -614,6 +620,10 @@
           <a:bodyPr/>
           <a:lstStyle/>
           <a:p>
+            <a:pPr marL="228600" lvl="0" indent="-228600">
+              <a:buFont typeface="Arial"/>
+              <a:buChar char="•"/>
+            </a:pPr>
             <a:r>
               <a:rPr lang="en-US" dirty="0"/>
               <a:t>Minimal dependencies: no client-side framework or npm packages.</a:t>
@@ -621,6 +631,10 @@
             <a:endParaRPr lang="en-US" dirty="0"/>
           </a:p>
           <a:p>
+            <a:pPr marL="457200" lvl="1" indent="-228600">
+              <a:buFont typeface="Arial"/>
+              <a:buChar char="–"/>
+            </a:pPr>
             <a:r>
               <a:rPr lang="en-US" dirty="0"/>
               <a:t>Pages are server-rendered Razor Pages with a small amount of vanilla JavaScript and one “hand-written” stylesheet.</a:t>
@@ -628,9 +642,10 @@
             <a:endParaRPr lang="en-US" dirty="0"/>
           </a:p>
           <a:p>
-            <a:endParaRPr lang="en-US" dirty="0"/>
-          </a:p>
-          <a:p>
+            <a:pPr marL="228600" lvl="0" indent="-228600">
+              <a:buFont typeface="Arial"/>
+              <a:buChar char="•"/>
+            </a:pPr>
             <a:r>
               <a:rPr lang="en-US" dirty="0"/>
               <a:t>The solution is a modular monolith of four projects (Domain, Application, Infrastructure, Web) with dependencies pointing inward, recorded in </a:t>
@@ -648,6 +663,10 @@
             <a:endParaRPr lang="en-US" dirty="0"/>
           </a:p>
           <a:p>
+            <a:pPr marL="457200" lvl="1" indent="-228600">
+              <a:buFont typeface="Arial"/>
+              <a:buChar char="–"/>
+            </a:pPr>
             <a:r>
               <a:rPr lang="en-US" dirty="0"/>
               <a:t>EF Core and SQLite live only in the Infrastructure project.</a:t>
@@ -655,9 +674,10 @@
             <a:endParaRPr lang="en-US" dirty="0"/>
           </a:p>
           <a:p>
-            <a:endParaRPr lang="en-US" dirty="0"/>
-          </a:p>
-          <a:p>
+            <a:pPr marL="228600" lvl="0" indent="-228600">
+              <a:buFont typeface="Arial"/>
+              <a:buChar char="•"/>
+            </a:pPr>
             <a:r>
               <a:rPr lang="en-US" dirty="0"/>
               <a:t>Tests use xUnit, WebApplicationFactory for in-process HTTP, and coverlet for coverage.</a:t>
@@ -763,6 +783,10 @@
             <a:endParaRPr lang="en-US" dirty="0"/>
           </a:p>
           <a:p>
+            <a:pPr marL="228600" lvl="0" indent="-228600">
+              <a:buFont typeface="Arial"/>
+              <a:buChar char="•"/>
+            </a:pPr>
             <a:r>
               <a:rPr lang="en-US" b="1" dirty="0"/>
               <a:t>Cost</a:t>
@@ -774,6 +798,10 @@
             <a:endParaRPr lang="en-US" dirty="0"/>
           </a:p>
           <a:p>
+            <a:pPr marL="228600" lvl="0" indent="-228600">
+              <a:buFont typeface="Arial"/>
+              <a:buChar char="•"/>
+            </a:pPr>
             <a:r>
               <a:rPr lang="en-US" dirty="0"/>
               <a:t>The server renders HTML with minimal JavaScript, so the whole app is written in C# and ships as a single unit. A separate JavaScript front end (e.g., a React single-page app) would add its own npm build and a JSON API for the browser to call, because the browser would fetch data instead of receiving finished pages.</a:t>
@@ -801,6 +829,10 @@
             <a:endParaRPr lang="en-US" dirty="0"/>
           </a:p>
           <a:p>
+            <a:pPr marL="228600" lvl="0" indent="-228600">
+              <a:buFont typeface="Arial"/>
+              <a:buChar char="•"/>
+            </a:pPr>
             <a:r>
               <a:rPr lang="en-US" b="1" dirty="0"/>
               <a:t>Cost</a:t>
@@ -812,6 +844,10 @@
             <a:endParaRPr lang="en-US" dirty="0"/>
           </a:p>
           <a:p>
+            <a:pPr marL="228600" lvl="0" indent="-228600">
+              <a:buFont typeface="Arial"/>
+              <a:buChar char="•"/>
+            </a:pPr>
             <a:r>
               <a:rPr lang="en-US" dirty="0"/>
               <a:t>The payoff is that business rules can be tested without the web host or the database. Microservices would add operational complexity with no payoff at this scope.</a:t>
@@ -839,6 +875,10 @@
             <a:endParaRPr lang="en-US" dirty="0"/>
           </a:p>
           <a:p>
+            <a:pPr marL="228600" lvl="0" indent="-228600">
+              <a:buFont typeface="Arial"/>
+              <a:buChar char="•"/>
+            </a:pPr>
             <a:r>
               <a:rPr lang="en-US" b="1" dirty="0"/>
               <a:t>Cost</a:t>
@@ -850,6 +890,10 @@
             <a:endParaRPr lang="en-US" dirty="0"/>
           </a:p>
           <a:p>
+            <a:pPr marL="228600" lvl="0" indent="-228600">
+              <a:buFont typeface="Arial"/>
+              <a:buChar char="•"/>
+            </a:pPr>
             <a:r>
               <a:rPr lang="en-US" dirty="0"/>
               <a:t>A server database is the upgrade path if concurrent load ever matters. The next slide covers the datastore choice.</a:t>
@@ -877,6 +921,10 @@
             <a:endParaRPr lang="en-US" dirty="0"/>
           </a:p>
           <a:p>
+            <a:pPr marL="228600" lvl="0" indent="-228600">
+              <a:buFont typeface="Arial"/>
+              <a:buChar char="•"/>
+            </a:pPr>
             <a:r>
               <a:rPr lang="en-US" b="1" dirty="0"/>
               <a:t>Cost</a:t>
@@ -888,6 +936,10 @@
             <a:endParaRPr lang="en-US" dirty="0"/>
           </a:p>
           <a:p>
+            <a:pPr marL="228600" lvl="0" indent="-228600">
+              <a:buFont typeface="Arial"/>
+              <a:buChar char="•"/>
+            </a:pPr>
             <a:r>
               <a:rPr lang="en-US" dirty="0"/>
               <a:t>Amounts are decimal with at most two fractional digits, which rules out floating-point error. The two-digit rule fits USD but not many other currencies.</a:t>
@@ -977,6 +1029,17 @@
           <a:lstStyle/>
           <a:p>
             <a:r>
+              <a:rPr lang="en-US" b="1" dirty="0"/>
+              <a:t>Chosen: SQLite + EF Core</a:t>
+            </a:r>
+            <a:endParaRPr lang="en-US" dirty="0"/>
+          </a:p>
+          <a:p>
+            <a:pPr marL="228600" lvl="0" indent="-228600">
+              <a:buFont typeface="Arial"/>
+              <a:buChar char="•"/>
+            </a:pPr>
+            <a:r>
               <a:rPr lang="en-US" dirty="0"/>
               <a:t>An in-memory store would have been enough. I chose a persistent one so balances and history survive restarts (</a:t>
             </a:r>
@@ -993,37 +1056,72 @@
             <a:endParaRPr lang="en-US" dirty="0"/>
           </a:p>
           <a:p>
-            <a:r>
-              <a:rPr lang="en-US" dirty="0"/>
-              <a:t>• SQLite – single-file DB with near-zero setup.</a:t>
-            </a:r>
-            <a:endParaRPr lang="en-US" dirty="0"/>
-          </a:p>
-          <a:p>
-            <a:r>
-              <a:rPr lang="en-US" dirty="0"/>
-              <a:t>• EF Core – the ORM (the .NET counterpart to Hibernate).</a:t>
-            </a:r>
-            <a:endParaRPr lang="en-US" dirty="0"/>
-          </a:p>
-          <a:p>
-            <a:r>
-              <a:rPr lang="en-US" dirty="0"/>
-              <a:t>   – Transactions: saves a transfer's debit, credit, and history rows in a single DB transaction, so they either commit or roll back as a unit.</a:t>
-            </a:r>
-            <a:endParaRPr lang="en-US" dirty="0"/>
-          </a:p>
-          <a:p>
-            <a:r>
-              <a:rPr lang="en-US" dirty="0"/>
-              <a:t>   – Optimistic concurrency: rejects a write based on an outdated balance, e.g., two tabs withdrawing against the same $1,000 and overdrawing it. Doesn't lock account rows; assumes conflicts are rare.</a:t>
-            </a:r>
-            <a:endParaRPr lang="en-US" dirty="0"/>
-          </a:p>
-          <a:p>
-            <a:endParaRPr lang="en-US" dirty="0"/>
-          </a:p>
-          <a:p>
+            <a:pPr marL="228600" lvl="0" indent="-228600">
+              <a:buFont typeface="Arial"/>
+              <a:buChar char="•"/>
+            </a:pPr>
+            <a:r>
+              <a:rPr lang="en-US" b="1" dirty="0"/>
+              <a:t>SQLite</a:t>
+            </a:r>
+            <a:r>
+              <a:rPr lang="en-US" dirty="0"/>
+              <a:t> – single-file DB with near-zero setup.</a:t>
+            </a:r>
+            <a:endParaRPr lang="en-US" dirty="0"/>
+          </a:p>
+          <a:p>
+            <a:pPr marL="228600" lvl="0" indent="-228600">
+              <a:buFont typeface="Arial"/>
+              <a:buChar char="•"/>
+            </a:pPr>
+            <a:r>
+              <a:rPr lang="en-US" b="1" dirty="0"/>
+              <a:t>EF Core</a:t>
+            </a:r>
+            <a:r>
+              <a:rPr lang="en-US" dirty="0"/>
+              <a:t> – the ORM (the .NET counterpart to Hibernate).</a:t>
+            </a:r>
+            <a:endParaRPr lang="en-US" dirty="0"/>
+          </a:p>
+          <a:p>
+            <a:pPr marL="457200" lvl="1" indent="-228600">
+              <a:buFont typeface="Arial"/>
+              <a:buChar char="–"/>
+            </a:pPr>
+            <a:r>
+              <a:rPr lang="en-US" dirty="0"/>
+              <a:t>Transactions: saves a transfer's debit, credit, and history rows in a single DB transaction, so they either commit or roll back as a unit.</a:t>
+            </a:r>
+            <a:endParaRPr lang="en-US" dirty="0"/>
+          </a:p>
+          <a:p>
+            <a:pPr marL="457200" lvl="1" indent="-228600">
+              <a:buFont typeface="Arial"/>
+              <a:buChar char="–"/>
+            </a:pPr>
+            <a:r>
+              <a:rPr lang="en-US" dirty="0"/>
+              <a:t>Optimistic concurrency: rejects a write based on an outdated balance, e.g., two tabs withdrawing against the same $1,000 and overdrawing it. Doesn't lock account rows; assumes conflicts are rare.</a:t>
+            </a:r>
+            <a:endParaRPr lang="en-US" dirty="0"/>
+          </a:p>
+          <a:p>
+            <a:endParaRPr lang="en-US" dirty="0"/>
+          </a:p>
+          <a:p>
+            <a:r>
+              <a:rPr lang="en-US" b="1" dirty="0"/>
+              <a:t>Considered</a:t>
+            </a:r>
+            <a:endParaRPr lang="en-US" dirty="0"/>
+          </a:p>
+          <a:p>
+            <a:pPr marL="228600" lvl="0" indent="-228600">
+              <a:buFont typeface="Arial"/>
+              <a:buChar char="•"/>
+            </a:pPr>
             <a:r>
               <a:rPr lang="en-US" dirty="0"/>
               <a:t>Every option sits behind the same Application ports, so switching is an Infrastructure-only change.</a:t>
@@ -1031,30 +1129,62 @@
             <a:endParaRPr lang="en-US" dirty="0"/>
           </a:p>
           <a:p>
-            <a:r>
-              <a:rPr lang="en-US" dirty="0"/>
-              <a:t>• SQLite in-memory – an in-memory connection string with one connection held open. Keeps EF Core, migrations, transactions, and constraints, but data is lost on restart. The best in-memory choice, e.g., for a demo mode.</a:t>
-            </a:r>
-            <a:endParaRPr lang="en-US" dirty="0"/>
-          </a:p>
-          <a:p>
-            <a:r>
-              <a:rPr lang="en-US" dirty="0"/>
-              <a:t>• Hand-written store – dictionaries behind a single lock. No dependencies, but the code itself must commit balance and history together instead of relying on a database transaction.</a:t>
-            </a:r>
-            <a:endParaRPr lang="en-US" dirty="0"/>
-          </a:p>
-          <a:p>
-            <a:r>
-              <a:rPr lang="en-US" dirty="0"/>
-              <a:t>• EF Core InMemory provider – discouraged by Microsoft. It isn't relational, ignores transactions, and enforces no constraints, so it can't prove the invariants.</a:t>
-            </a:r>
-            <a:endParaRPr lang="en-US" dirty="0"/>
-          </a:p>
-          <a:p>
-            <a:r>
-              <a:rPr lang="en-US" dirty="0"/>
-              <a:t>• Redis – a separate server process to install and run, and atomic transfers need MULTI/EXEC or Lua scripts. More operational machinery than this exercise needs, and still volatile unless its persistence is configured.</a:t>
+            <a:pPr marL="228600" lvl="0" indent="-228600">
+              <a:buFont typeface="Arial"/>
+              <a:buChar char="•"/>
+            </a:pPr>
+            <a:r>
+              <a:rPr lang="en-US" b="1" dirty="0"/>
+              <a:t>SQLite in-memory</a:t>
+            </a:r>
+            <a:r>
+              <a:rPr lang="en-US" dirty="0"/>
+              <a:t> – an in-memory connection string with one connection held open. Keeps EF Core, migrations, transactions, and constraints, but data is lost on restart. The best in-memory choice, e.g., for a demo mode.</a:t>
+            </a:r>
+            <a:endParaRPr lang="en-US" dirty="0"/>
+          </a:p>
+          <a:p>
+            <a:pPr marL="228600" lvl="0" indent="-228600">
+              <a:buFont typeface="Arial"/>
+              <a:buChar char="•"/>
+            </a:pPr>
+            <a:r>
+              <a:rPr lang="en-US" b="1" dirty="0"/>
+              <a:t>Hand-written store</a:t>
+            </a:r>
+            <a:r>
+              <a:rPr lang="en-US" dirty="0"/>
+              <a:t> – dictionaries behind a single lock. No dependencies, but the code itself must commit balance and history together instead of relying on a database transaction.</a:t>
+            </a:r>
+            <a:endParaRPr lang="en-US" dirty="0"/>
+          </a:p>
+          <a:p>
+            <a:pPr marL="228600" lvl="0" indent="-228600">
+              <a:buFont typeface="Arial"/>
+              <a:buChar char="•"/>
+            </a:pPr>
+            <a:r>
+              <a:rPr lang="en-US" b="1" dirty="0"/>
+              <a:t>EF Core InMemory provider</a:t>
+            </a:r>
+            <a:r>
+              <a:rPr lang="en-US" dirty="0"/>
+              <a:t> – discouraged by Microsoft. It isn't relational, ignores transactions, and enforces no constraints, so it can't prove the invariants.</a:t>
+            </a:r>
+            <a:endParaRPr lang="en-US" dirty="0"/>
+          </a:p>
+          <a:p>
+            <a:pPr marL="228600" lvl="0" indent="-228600">
+              <a:buFont typeface="Arial"/>
+              <a:buChar char="•"/>
+            </a:pPr>
+            <a:r>
+              <a:rPr lang="en-US" b="1" dirty="0"/>
+              <a:t>Redis</a:t>
+            </a:r>
+            <a:r>
+              <a:rPr lang="en-US" dirty="0"/>
+              <a:t> – a separate server process to install and run, and atomic transfers need MULTI/EXEC or Lua scripts. More operational machinery than this exercise needs, and still volatile unless its persistence is configured.</a:t>
             </a:r>
             <a:endParaRPr lang="en-US" dirty="0"/>
           </a:p>
@@ -1409,16 +1539,16 @@
           <a:lstStyle/>
           <a:p>
             <a:r>
-              <a:rPr lang="en-US" dirty="0"/>
+              <a:rPr lang="en-US" b="1" dirty="0"/>
               <a:t>Frame: GPT-5.6 Sol in Codex with my architect agent</a:t>
             </a:r>
             <a:endParaRPr lang="en-US" dirty="0"/>
           </a:p>
           <a:p>
-            <a:r>
-              <a:rPr lang="en-US" dirty="0"/>
-              <a:t>• </a:t>
-            </a:r>
+            <a:pPr marL="228600" lvl="0" indent="-228600">
+              <a:buFont typeface="Arial"/>
+              <a:buChar char="•"/>
+            </a:pPr>
             <a:r>
               <a:rPr lang="en-US" dirty="0">
                 <a:hlinkClick r:id="rId3"/>
@@ -1432,23 +1562,35 @@
             <a:endParaRPr lang="en-US" dirty="0"/>
           </a:p>
           <a:p>
-            <a:r>
-              <a:rPr lang="en-US" dirty="0"/>
-              <a:t>• Interviewed me on four open questions: time box, persistence, seed accounts, repo visibility.</a:t>
-            </a:r>
-            <a:endParaRPr lang="en-US" dirty="0"/>
-          </a:p>
-          <a:p>
-            <a:r>
-              <a:rPr lang="en-US" dirty="0"/>
-              <a:t>• The model proposed the stack; I approved it.</a:t>
-            </a:r>
-            <a:endParaRPr lang="en-US" dirty="0"/>
-          </a:p>
-          <a:p>
-            <a:r>
-              <a:rPr lang="en-US" dirty="0"/>
-              <a:t>• Scaffolded before any feature code: </a:t>
+            <a:pPr marL="228600" lvl="0" indent="-228600">
+              <a:buFont typeface="Arial"/>
+              <a:buChar char="•"/>
+            </a:pPr>
+            <a:r>
+              <a:rPr lang="en-US" dirty="0"/>
+              <a:t>Interviewed me on four open questions: time box, persistence, seed accounts, repo visibility.</a:t>
+            </a:r>
+            <a:endParaRPr lang="en-US" dirty="0"/>
+          </a:p>
+          <a:p>
+            <a:pPr marL="228600" lvl="0" indent="-228600">
+              <a:buFont typeface="Arial"/>
+              <a:buChar char="•"/>
+            </a:pPr>
+            <a:r>
+              <a:rPr lang="en-US" dirty="0"/>
+              <a:t>The model proposed the stack; I approved it.</a:t>
+            </a:r>
+            <a:endParaRPr lang="en-US" dirty="0"/>
+          </a:p>
+          <a:p>
+            <a:pPr marL="228600" lvl="0" indent="-228600">
+              <a:buFont typeface="Arial"/>
+              <a:buChar char="•"/>
+            </a:pPr>
+            <a:r>
+              <a:rPr lang="en-US" dirty="0"/>
+              <a:t>Scaffolded before any feature code: </a:t>
             </a:r>
             <a:r>
               <a:rPr lang="en-US" dirty="0">
@@ -1493,10 +1635,10 @@
             <a:endParaRPr lang="en-US" dirty="0"/>
           </a:p>
           <a:p>
-            <a:r>
-              <a:rPr lang="en-US" dirty="0"/>
-              <a:t>   – </a:t>
-            </a:r>
+            <a:pPr marL="457200" lvl="1" indent="-228600">
+              <a:buFont typeface="Arial"/>
+              <a:buChar char="–"/>
+            </a:pPr>
             <a:r>
               <a:rPr lang="en-US" dirty="0">
                 <a:hlinkClick r:id="rId8"/>
@@ -1514,46 +1656,62 @@
           </a:p>
           <a:p>
             <a:r>
-              <a:rPr lang="en-US" dirty="0"/>
+              <a:rPr lang="en-US" b="1" dirty="0"/>
               <a:t>Build: Fable 5.1 in Claude Code</a:t>
             </a:r>
             <a:endParaRPr lang="en-US" dirty="0"/>
           </a:p>
           <a:p>
-            <a:r>
-              <a:rPr lang="en-US" dirty="0"/>
-              <a:t>• Why Fable 5.1: I know the best approach is to plan with the strongest model and execute with cheaper ones, but when I reached the implementation phase, I was running short on time. Therefore, I chose the strongest end-to-end model at the time (a whopping week ago, before Opus 5.5 shipped).</a:t>
-            </a:r>
-            <a:endParaRPr lang="en-US" dirty="0"/>
-          </a:p>
-          <a:p>
-            <a:r>
-              <a:rPr lang="en-US" dirty="0"/>
-              <a:t>• Six phases in order: domain, application, persistence, web, HTTP tests and accessibility, deck.</a:t>
-            </a:r>
-            <a:endParaRPr lang="en-US" dirty="0"/>
-          </a:p>
-          <a:p>
-            <a:r>
-              <a:rPr lang="en-US" dirty="0"/>
-              <a:t>• Each phase committed only with the build and every test green; domain tests written first.</a:t>
-            </a:r>
-            <a:endParaRPr lang="en-US" dirty="0"/>
-          </a:p>
-          <a:p>
-            <a:endParaRPr lang="en-US" dirty="0"/>
-          </a:p>
-          <a:p>
-            <a:r>
-              <a:rPr lang="en-US" dirty="0"/>
+            <a:pPr marL="228600" lvl="0" indent="-228600">
+              <a:buFont typeface="Arial"/>
+              <a:buChar char="•"/>
+            </a:pPr>
+            <a:r>
+              <a:rPr lang="en-US" dirty="0"/>
+              <a:t>Why Fable 5.1: I know the best approach is to plan with the strongest model and execute with cheaper ones, but when I reached the implementation phase, I was running short on time. Therefore, I chose the strongest end-to-end model at the time (a whopping week ago, before Opus 5.5 shipped).</a:t>
+            </a:r>
+            <a:endParaRPr lang="en-US" dirty="0"/>
+          </a:p>
+          <a:p>
+            <a:pPr marL="228600" lvl="0" indent="-228600">
+              <a:buFont typeface="Arial"/>
+              <a:buChar char="•"/>
+            </a:pPr>
+            <a:r>
+              <a:rPr lang="en-US" dirty="0"/>
+              <a:t>Six phases in order: domain, application, persistence, web, HTTP tests and accessibility, deck.</a:t>
+            </a:r>
+            <a:endParaRPr lang="en-US" dirty="0"/>
+          </a:p>
+          <a:p>
+            <a:pPr marL="228600" lvl="0" indent="-228600">
+              <a:buFont typeface="Arial"/>
+              <a:buChar char="•"/>
+            </a:pPr>
+            <a:r>
+              <a:rPr lang="en-US" dirty="0"/>
+              <a:t>Each phase committed only with the build and every test green; domain tests written first.</a:t>
+            </a:r>
+            <a:endParaRPr lang="en-US" dirty="0"/>
+          </a:p>
+          <a:p>
+            <a:endParaRPr lang="en-US" dirty="0"/>
+          </a:p>
+          <a:p>
+            <a:r>
+              <a:rPr lang="en-US" b="1" dirty="0"/>
               <a:t>Refine: Opus 5.5 and GPT-6 Sol in Codex</a:t>
             </a:r>
             <a:endParaRPr lang="en-US" dirty="0"/>
           </a:p>
           <a:p>
-            <a:r>
-              <a:rPr lang="en-US" dirty="0"/>
-              <a:t>• Windows setup steps in </a:t>
+            <a:pPr marL="228600" lvl="0" indent="-228600">
+              <a:buFont typeface="Arial"/>
+              <a:buChar char="•"/>
+            </a:pPr>
+            <a:r>
+              <a:rPr lang="en-US" dirty="0"/>
+              <a:t>Windows setup steps in </a:t>
             </a:r>
             <a:r>
               <a:rPr lang="en-US" dirty="0">
@@ -1568,9 +1726,13 @@
             <a:endParaRPr lang="en-US" dirty="0"/>
           </a:p>
           <a:p>
-            <a:r>
-              <a:rPr lang="en-US" dirty="0"/>
-              <a:t>• The design direction came from </a:t>
+            <a:pPr marL="228600" lvl="0" indent="-228600">
+              <a:buFont typeface="Arial"/>
+              <a:buChar char="•"/>
+            </a:pPr>
+            <a:r>
+              <a:rPr lang="en-US" dirty="0"/>
+              <a:t>The design direction came from </a:t>
             </a:r>
             <a:r>
               <a:rPr lang="en-US" dirty="0">
@@ -1585,10 +1747,10 @@
             <a:endParaRPr lang="en-US" dirty="0"/>
           </a:p>
           <a:p>
-            <a:r>
-              <a:rPr lang="en-US" dirty="0"/>
-              <a:t>• </a:t>
-            </a:r>
+            <a:pPr marL="228600" lvl="0" indent="-228600">
+              <a:buFont typeface="Arial"/>
+              <a:buChar char="•"/>
+            </a:pPr>
             <a:r>
               <a:rPr lang="en-US" dirty="0">
                 <a:hlinkClick r:id="rId11"/>

</xml_diff>